<commit_message>
Update Robin intro slide with correct activity bullets
</commit_message>
<xml_diff>
--- a/Robin-Intro-Slide.pptx
+++ b/Robin-Intro-Slide.pptx
@@ -5007,7 +5007,7 @@
                   <a:srgbClr val="FFFFFF"/>
                 </a:solidFill>
               </a:rPr>
-              <a:t>Forecasting · Pipeline intelligence · Call grading · MSP prospecting · Competitive analysis · Briefings · Deck building — and getting smarter every week.</a:t>
+              <a:t>Built for the Rev.io sales team — automating intelligence, analysis, and execution so reps spend more time selling.</a:t>
             </a:r>
           </a:p>
         </p:txBody>
@@ -5224,12 +5224,12 @@
           <a:p>
             <a:pPr algn="l"/>
             <a:r>
-              <a:rPr sz="1100" b="1" i="0">
+              <a:rPr sz="1050" b="1" i="0">
                 <a:solidFill>
                   <a:srgbClr val="FFFFFF"/>
                 </a:solidFill>
               </a:rPr>
-              <a:t>• FORECAST DASHBOARD (LIVE SF DATA)</a:t>
+              <a:t>• TRACKING SALES TEAM ACTIVITY POINTS</a:t>
             </a:r>
           </a:p>
         </p:txBody>
@@ -5258,12 +5258,12 @@
           <a:p>
             <a:pPr algn="l"/>
             <a:r>
-              <a:rPr sz="1100" b="1" i="0">
+              <a:rPr sz="1050" b="1" i="0">
                 <a:solidFill>
                   <a:srgbClr val="FFFFFF"/>
                 </a:solidFill>
               </a:rPr>
-              <a:t>• WEEKLY PIPELINE INTELLIGENCE</a:t>
+              <a:t>• RUNNING WEEKLY CALL BLITZES</a:t>
             </a:r>
           </a:p>
         </p:txBody>
@@ -5292,12 +5292,12 @@
           <a:p>
             <a:pPr algn="l"/>
             <a:r>
-              <a:rPr sz="1100" b="1" i="0">
+              <a:rPr sz="1050" b="1" i="0">
                 <a:solidFill>
                   <a:srgbClr val="FFFFFF"/>
                 </a:solidFill>
               </a:rPr>
-              <a:t>• DISCOVERY CALL GRADING (BEACON)</a:t>
+              <a:t>• RESEARCHING NEW PROSPECTS NOT IN CRM</a:t>
             </a:r>
           </a:p>
         </p:txBody>
@@ -5326,12 +5326,12 @@
           <a:p>
             <a:pPr algn="l"/>
             <a:r>
-              <a:rPr sz="1100" b="1" i="0">
+              <a:rPr sz="1050" b="1" i="0">
                 <a:solidFill>
                   <a:srgbClr val="FFFFFF"/>
                 </a:solidFill>
               </a:rPr>
-              <a:t>• CLOSED LOSS ANALYSIS</a:t>
+              <a:t>• BUILT COMPETITOR BATTLECARD DASHBOARD</a:t>
             </a:r>
           </a:p>
         </p:txBody>
@@ -5360,12 +5360,12 @@
           <a:p>
             <a:pPr algn="l"/>
             <a:r>
-              <a:rPr sz="1100" b="1" i="0">
+              <a:rPr sz="1050" b="1" i="0">
                 <a:solidFill>
                   <a:srgbClr val="FFFFFF"/>
                 </a:solidFill>
               </a:rPr>
-              <a:t>• MSP PROSPECTING (DAILY)</a:t>
+              <a:t>• AUTOMATED WEEKLY FORECAST DECKS FOR ELT</a:t>
             </a:r>
           </a:p>
         </p:txBody>
@@ -5394,12 +5394,12 @@
           <a:p>
             <a:pPr algn="l"/>
             <a:r>
-              <a:rPr sz="1100" b="1" i="0">
+              <a:rPr sz="1050" b="1" i="0">
                 <a:solidFill>
                   <a:srgbClr val="FFFFFF"/>
                 </a:solidFill>
               </a:rPr>
-              <a:t>• MORNING BRIEFINGS</a:t>
+              <a:t>• DISCOVERY NO-SHOW TREND ANALYSIS</a:t>
             </a:r>
           </a:p>
         </p:txBody>
@@ -5428,12 +5428,12 @@
           <a:p>
             <a:pPr algn="l"/>
             <a:r>
-              <a:rPr sz="1100" b="1" i="0">
+              <a:rPr sz="1050" b="1" i="0">
                 <a:solidFill>
                   <a:srgbClr val="FFFFFF"/>
                 </a:solidFill>
               </a:rPr>
-              <a:t>• COMPETITIVE BATTLE CARDS</a:t>
+              <a:t>• SOFTWARE MISSING CAPABILITIES DEEP DIVE</a:t>
             </a:r>
           </a:p>
         </p:txBody>
@@ -5462,12 +5462,12 @@
           <a:p>
             <a:pPr algn="l"/>
             <a:r>
-              <a:rPr sz="1100" b="1" i="0">
+              <a:rPr sz="1050" b="1" i="0">
                 <a:solidFill>
                   <a:srgbClr val="FFFFFF"/>
                 </a:solidFill>
               </a:rPr>
-              <a:t>• MARKET &amp; PRODUCT RESEARCH</a:t>
+              <a:t>• MORNING BRIEFINGS &amp; PIPELINE INTELLIGENCE</a:t>
             </a:r>
           </a:p>
         </p:txBody>

</xml_diff>

<commit_message>
Robin intro slide v3 - matches marketing team format exactly
</commit_message>
<xml_diff>
--- a/Robin-Intro-Slide.pptx
+++ b/Robin-Intro-Slide.pptx
@@ -4798,8 +4798,8 @@
         </p:nvSpPr>
         <p:spPr>
           <a:xfrm>
-            <a:off x="365760" y="201168"/>
-            <a:ext cx="11430000" cy="777240"/>
+            <a:off x="365760" y="164592"/>
+            <a:ext cx="11430000" cy="713232"/>
           </a:xfrm>
           <a:prstGeom prst="rect">
             <a:avLst/>
@@ -4814,7 +4814,7 @@
           <a:p>
             <a:pPr algn="l"/>
             <a:r>
-              <a:rPr sz="4400" b="1" i="0">
+              <a:rPr sz="4600" b="1" i="0">
                 <a:solidFill>
                   <a:srgbClr val="FFFFFF"/>
                 </a:solidFill>
@@ -4832,8 +4832,8 @@
         </p:nvSpPr>
         <p:spPr>
           <a:xfrm>
-            <a:off x="365760" y="960120"/>
-            <a:ext cx="11430000" cy="347472"/>
+            <a:off x="365760" y="877824"/>
+            <a:ext cx="11430000" cy="310896"/>
           </a:xfrm>
           <a:prstGeom prst="rect">
             <a:avLst/>
@@ -4848,7 +4848,7 @@
           <a:p>
             <a:pPr algn="l"/>
             <a:r>
-              <a:rPr sz="1400" b="0" i="0">
+              <a:rPr sz="1300" b="0" i="0">
                 <a:solidFill>
                   <a:srgbClr val="8AA8C8"/>
                 </a:solidFill>
@@ -4866,14 +4866,14 @@
         </p:nvSpPr>
         <p:spPr>
           <a:xfrm>
-            <a:off x="365760" y="1417320"/>
-            <a:ext cx="11457432" cy="658368"/>
+            <a:off x="365760" y="1298448"/>
+            <a:ext cx="11457432" cy="713232"/>
           </a:xfrm>
           <a:prstGeom prst="rect">
             <a:avLst/>
           </a:prstGeom>
           <a:solidFill>
-            <a:srgbClr val="0F2A3A"/>
+            <a:srgbClr val="0A1E30"/>
           </a:solidFill>
           <a:ln>
             <a:noFill/>
@@ -4909,8 +4909,8 @@
         </p:nvSpPr>
         <p:spPr>
           <a:xfrm>
-            <a:off x="365760" y="1417320"/>
-            <a:ext cx="45720" cy="658368"/>
+            <a:off x="365760" y="1298448"/>
+            <a:ext cx="45720" cy="713232"/>
           </a:xfrm>
           <a:prstGeom prst="rect">
             <a:avLst/>
@@ -4952,8 +4952,8 @@
         </p:nvSpPr>
         <p:spPr>
           <a:xfrm>
-            <a:off x="502920" y="1453896"/>
-            <a:ext cx="3657600" cy="201168"/>
+            <a:off x="502920" y="1335024"/>
+            <a:ext cx="3200400" cy="182880"/>
           </a:xfrm>
           <a:prstGeom prst="rect">
             <a:avLst/>
@@ -4986,8 +4986,8 @@
         </p:nvSpPr>
         <p:spPr>
           <a:xfrm>
-            <a:off x="502920" y="1655064"/>
-            <a:ext cx="11155680" cy="347472"/>
+            <a:off x="502920" y="1517904"/>
+            <a:ext cx="11155680" cy="420624"/>
           </a:xfrm>
           <a:prstGeom prst="rect">
             <a:avLst/>
@@ -5002,12 +5002,12 @@
           <a:p>
             <a:pPr algn="l"/>
             <a:r>
-              <a:rPr sz="1100" b="0" i="0">
+              <a:rPr sz="1050" b="0" i="0">
                 <a:solidFill>
                   <a:srgbClr val="FFFFFF"/>
                 </a:solidFill>
               </a:rPr>
-              <a:t>Built for the Rev.io sales team — automating intelligence, analysis, and execution so reps spend more time selling.</a:t>
+              <a:t>Robin is focused on two things: accelerating revenue by giving the sales team better intelligence and tools — and improving efficiency by automating the work that shouldn't require a human.</a:t>
             </a:r>
           </a:p>
         </p:txBody>
@@ -5020,14 +5020,14 @@
         </p:nvSpPr>
         <p:spPr>
           <a:xfrm>
-            <a:off x="365760" y="2212848"/>
-            <a:ext cx="11457432" cy="4114800"/>
+            <a:off x="365760" y="2139696"/>
+            <a:ext cx="11457432" cy="4261104"/>
           </a:xfrm>
           <a:prstGeom prst="rect">
             <a:avLst/>
           </a:prstGeom>
           <a:solidFill>
-            <a:srgbClr val="0F2A3A"/>
+            <a:srgbClr val="0A1E30"/>
           </a:solidFill>
           <a:ln>
             <a:noFill/>
@@ -5063,8 +5063,8 @@
         </p:nvSpPr>
         <p:spPr>
           <a:xfrm>
-            <a:off x="365760" y="2212848"/>
-            <a:ext cx="45720" cy="4114800"/>
+            <a:off x="365760" y="2139696"/>
+            <a:ext cx="45720" cy="4261104"/>
           </a:xfrm>
           <a:prstGeom prst="rect">
             <a:avLst/>
@@ -5106,8 +5106,8 @@
         </p:nvSpPr>
         <p:spPr>
           <a:xfrm>
-            <a:off x="548640" y="2286000"/>
-            <a:ext cx="5486400" cy="502920"/>
+            <a:off x="566928" y="2267712"/>
+            <a:ext cx="7315200" cy="548640"/>
           </a:xfrm>
           <a:prstGeom prst="rect">
             <a:avLst/>
@@ -5122,7 +5122,7 @@
           <a:p>
             <a:pPr algn="l"/>
             <a:r>
-              <a:rPr sz="3400" b="1" i="0">
+              <a:rPr sz="3600" b="1" i="0">
                 <a:solidFill>
                   <a:srgbClr val="FFFFFF"/>
                 </a:solidFill>
@@ -5140,8 +5140,8 @@
         </p:nvSpPr>
         <p:spPr>
           <a:xfrm>
-            <a:off x="548640" y="2788920"/>
-            <a:ext cx="6400800" cy="274320"/>
+            <a:off x="566928" y="2816352"/>
+            <a:ext cx="8229600" cy="274320"/>
           </a:xfrm>
           <a:prstGeom prst="rect">
             <a:avLst/>
@@ -5156,7 +5156,7 @@
           <a:p>
             <a:pPr algn="l"/>
             <a:r>
-              <a:rPr sz="1400" b="0" i="0">
+              <a:rPr sz="1500" b="0" i="0">
                 <a:solidFill>
                   <a:srgbClr val="00D4D4"/>
                 </a:solidFill>
@@ -5174,8 +5174,8 @@
         </p:nvSpPr>
         <p:spPr>
           <a:xfrm>
-            <a:off x="548640" y="3090672"/>
-            <a:ext cx="5486400" cy="237744"/>
+            <a:off x="566928" y="3099815"/>
+            <a:ext cx="6400800" cy="237744"/>
           </a:xfrm>
           <a:prstGeom prst="rect">
             <a:avLst/>
@@ -5195,299 +5195,27 @@
                   <a:srgbClr val="8AA8C8"/>
                 </a:solidFill>
               </a:rPr>
-              <a:t>Built for Ryan Koontz · SVP of Sales</a:t>
-            </a:r>
-          </a:p>
-        </p:txBody>
-      </p:sp>
-      <p:sp>
-        <p:nvSpPr>
-          <p:cNvPr id="13" name="TextBox 12"/>
-          <p:cNvSpPr txBox="1"/>
-          <p:nvPr/>
-        </p:nvSpPr>
-        <p:spPr>
-          <a:xfrm>
-            <a:off x="548640" y="3493008"/>
-            <a:ext cx="5486400" cy="347472"/>
-          </a:xfrm>
-          <a:prstGeom prst="rect">
-            <a:avLst/>
-          </a:prstGeom>
-          <a:noFill/>
-        </p:spPr>
-        <p:txBody>
-          <a:bodyPr wrap="square">
-            <a:spAutoFit/>
-          </a:bodyPr>
-          <a:lstStyle/>
-          <a:p>
-            <a:pPr algn="l"/>
-            <a:r>
-              <a:rPr sz="1050" b="1" i="0">
-                <a:solidFill>
-                  <a:srgbClr val="FFFFFF"/>
-                </a:solidFill>
-              </a:rPr>
-              <a:t>• TRACKING SALES TEAM ACTIVITY POINTS</a:t>
-            </a:r>
-          </a:p>
-        </p:txBody>
-      </p:sp>
-      <p:sp>
-        <p:nvSpPr>
-          <p:cNvPr id="14" name="TextBox 13"/>
-          <p:cNvSpPr txBox="1"/>
-          <p:nvPr/>
-        </p:nvSpPr>
-        <p:spPr>
-          <a:xfrm>
-            <a:off x="548640" y="3904487"/>
-            <a:ext cx="5486400" cy="347472"/>
-          </a:xfrm>
-          <a:prstGeom prst="rect">
-            <a:avLst/>
-          </a:prstGeom>
-          <a:noFill/>
-        </p:spPr>
-        <p:txBody>
-          <a:bodyPr wrap="square">
-            <a:spAutoFit/>
-          </a:bodyPr>
-          <a:lstStyle/>
-          <a:p>
-            <a:pPr algn="l"/>
-            <a:r>
-              <a:rPr sz="1050" b="1" i="0">
-                <a:solidFill>
-                  <a:srgbClr val="FFFFFF"/>
-                </a:solidFill>
-              </a:rPr>
-              <a:t>• RUNNING WEEKLY CALL BLITZES</a:t>
-            </a:r>
-          </a:p>
-        </p:txBody>
-      </p:sp>
-      <p:sp>
-        <p:nvSpPr>
-          <p:cNvPr id="15" name="TextBox 14"/>
-          <p:cNvSpPr txBox="1"/>
-          <p:nvPr/>
-        </p:nvSpPr>
-        <p:spPr>
-          <a:xfrm>
-            <a:off x="548640" y="4315968"/>
-            <a:ext cx="5486400" cy="347472"/>
-          </a:xfrm>
-          <a:prstGeom prst="rect">
-            <a:avLst/>
-          </a:prstGeom>
-          <a:noFill/>
-        </p:spPr>
-        <p:txBody>
-          <a:bodyPr wrap="square">
-            <a:spAutoFit/>
-          </a:bodyPr>
-          <a:lstStyle/>
-          <a:p>
-            <a:pPr algn="l"/>
-            <a:r>
-              <a:rPr sz="1050" b="1" i="0">
-                <a:solidFill>
-                  <a:srgbClr val="FFFFFF"/>
-                </a:solidFill>
-              </a:rPr>
-              <a:t>• RESEARCHING NEW PROSPECTS NOT IN CRM</a:t>
-            </a:r>
-          </a:p>
-        </p:txBody>
-      </p:sp>
-      <p:sp>
-        <p:nvSpPr>
-          <p:cNvPr id="16" name="TextBox 15"/>
-          <p:cNvSpPr txBox="1"/>
-          <p:nvPr/>
-        </p:nvSpPr>
-        <p:spPr>
-          <a:xfrm>
-            <a:off x="548640" y="4727448"/>
-            <a:ext cx="5486400" cy="347472"/>
-          </a:xfrm>
-          <a:prstGeom prst="rect">
-            <a:avLst/>
-          </a:prstGeom>
-          <a:noFill/>
-        </p:spPr>
-        <p:txBody>
-          <a:bodyPr wrap="square">
-            <a:spAutoFit/>
-          </a:bodyPr>
-          <a:lstStyle/>
-          <a:p>
-            <a:pPr algn="l"/>
-            <a:r>
-              <a:rPr sz="1050" b="1" i="0">
-                <a:solidFill>
-                  <a:srgbClr val="FFFFFF"/>
-                </a:solidFill>
-              </a:rPr>
-              <a:t>• BUILT COMPETITOR BATTLECARD DASHBOARD</a:t>
-            </a:r>
-          </a:p>
-        </p:txBody>
-      </p:sp>
-      <p:sp>
-        <p:nvSpPr>
-          <p:cNvPr id="17" name="TextBox 16"/>
-          <p:cNvSpPr txBox="1"/>
-          <p:nvPr/>
-        </p:nvSpPr>
-        <p:spPr>
-          <a:xfrm>
-            <a:off x="6309360" y="3493008"/>
-            <a:ext cx="5577840" cy="347472"/>
-          </a:xfrm>
-          <a:prstGeom prst="rect">
-            <a:avLst/>
-          </a:prstGeom>
-          <a:noFill/>
-        </p:spPr>
-        <p:txBody>
-          <a:bodyPr wrap="square">
-            <a:spAutoFit/>
-          </a:bodyPr>
-          <a:lstStyle/>
-          <a:p>
-            <a:pPr algn="l"/>
-            <a:r>
-              <a:rPr sz="1050" b="1" i="0">
-                <a:solidFill>
-                  <a:srgbClr val="FFFFFF"/>
-                </a:solidFill>
-              </a:rPr>
-              <a:t>• AUTOMATED WEEKLY FORECAST DECKS FOR ELT</a:t>
-            </a:r>
-          </a:p>
-        </p:txBody>
-      </p:sp>
-      <p:sp>
-        <p:nvSpPr>
-          <p:cNvPr id="18" name="TextBox 17"/>
-          <p:cNvSpPr txBox="1"/>
-          <p:nvPr/>
-        </p:nvSpPr>
-        <p:spPr>
-          <a:xfrm>
-            <a:off x="6309360" y="3904487"/>
-            <a:ext cx="5577840" cy="347472"/>
-          </a:xfrm>
-          <a:prstGeom prst="rect">
-            <a:avLst/>
-          </a:prstGeom>
-          <a:noFill/>
-        </p:spPr>
-        <p:txBody>
-          <a:bodyPr wrap="square">
-            <a:spAutoFit/>
-          </a:bodyPr>
-          <a:lstStyle/>
-          <a:p>
-            <a:pPr algn="l"/>
-            <a:r>
-              <a:rPr sz="1050" b="1" i="0">
-                <a:solidFill>
-                  <a:srgbClr val="FFFFFF"/>
-                </a:solidFill>
-              </a:rPr>
-              <a:t>• DISCOVERY NO-SHOW TREND ANALYSIS</a:t>
-            </a:r>
-          </a:p>
-        </p:txBody>
-      </p:sp>
-      <p:sp>
-        <p:nvSpPr>
-          <p:cNvPr id="19" name="TextBox 18"/>
-          <p:cNvSpPr txBox="1"/>
-          <p:nvPr/>
-        </p:nvSpPr>
-        <p:spPr>
-          <a:xfrm>
-            <a:off x="6309360" y="4315968"/>
-            <a:ext cx="5577840" cy="347472"/>
-          </a:xfrm>
-          <a:prstGeom prst="rect">
-            <a:avLst/>
-          </a:prstGeom>
-          <a:noFill/>
-        </p:spPr>
-        <p:txBody>
-          <a:bodyPr wrap="square">
-            <a:spAutoFit/>
-          </a:bodyPr>
-          <a:lstStyle/>
-          <a:p>
-            <a:pPr algn="l"/>
-            <a:r>
-              <a:rPr sz="1050" b="1" i="0">
-                <a:solidFill>
-                  <a:srgbClr val="FFFFFF"/>
-                </a:solidFill>
-              </a:rPr>
-              <a:t>• SOFTWARE MISSING CAPABILITIES DEEP DIVE</a:t>
-            </a:r>
-          </a:p>
-        </p:txBody>
-      </p:sp>
-      <p:sp>
-        <p:nvSpPr>
-          <p:cNvPr id="20" name="TextBox 19"/>
-          <p:cNvSpPr txBox="1"/>
-          <p:nvPr/>
-        </p:nvSpPr>
-        <p:spPr>
-          <a:xfrm>
-            <a:off x="6309360" y="4727448"/>
-            <a:ext cx="5577840" cy="347472"/>
-          </a:xfrm>
-          <a:prstGeom prst="rect">
-            <a:avLst/>
-          </a:prstGeom>
-          <a:noFill/>
-        </p:spPr>
-        <p:txBody>
-          <a:bodyPr wrap="square">
-            <a:spAutoFit/>
-          </a:bodyPr>
-          <a:lstStyle/>
-          <a:p>
-            <a:pPr algn="l"/>
-            <a:r>
-              <a:rPr sz="1050" b="1" i="0">
-                <a:solidFill>
-                  <a:srgbClr val="FFFFFF"/>
-                </a:solidFill>
-              </a:rPr>
-              <a:t>• MORNING BRIEFINGS &amp; PIPELINE INTELLIGENCE</a:t>
-            </a:r>
-          </a:p>
-        </p:txBody>
-      </p:sp>
-      <p:sp>
-        <p:nvSpPr>
-          <p:cNvPr id="21" name="Rectangle 20"/>
+              <a:t>Built for Ryan Koontz  ·  SVP of Sales</a:t>
+            </a:r>
+          </a:p>
+        </p:txBody>
+      </p:sp>
+      <p:sp>
+        <p:nvSpPr>
+          <p:cNvPr id="13" name="Rectangle 12"/>
           <p:cNvSpPr/>
           <p:nvPr/>
         </p:nvSpPr>
         <p:spPr>
           <a:xfrm>
-            <a:off x="0" y="6675120"/>
-            <a:ext cx="12188952" cy="182880"/>
+            <a:off x="566928" y="3401568"/>
+            <a:ext cx="11055096" cy="18288"/>
           </a:xfrm>
           <a:prstGeom prst="rect">
             <a:avLst/>
           </a:prstGeom>
           <a:solidFill>
-            <a:srgbClr val="071220"/>
+            <a:srgbClr val="1A3555"/>
           </a:solidFill>
           <a:ln>
             <a:noFill/>
@@ -5517,7 +5245,322 @@
       </p:sp>
       <p:sp>
         <p:nvSpPr>
-          <p:cNvPr id="22" name="TextBox 21"/>
+          <p:cNvPr id="14" name="TextBox 13"/>
+          <p:cNvSpPr txBox="1"/>
+          <p:nvPr/>
+        </p:nvSpPr>
+        <p:spPr>
+          <a:xfrm>
+            <a:off x="566928" y="3511296"/>
+            <a:ext cx="5486400" cy="475488"/>
+          </a:xfrm>
+          <a:prstGeom prst="rect">
+            <a:avLst/>
+          </a:prstGeom>
+          <a:noFill/>
+        </p:spPr>
+        <p:txBody>
+          <a:bodyPr wrap="square">
+            <a:spAutoFit/>
+          </a:bodyPr>
+          <a:lstStyle/>
+          <a:p>
+            <a:pPr algn="l"/>
+            <a:r>
+              <a:rPr sz="1100" b="1" i="0">
+                <a:solidFill>
+                  <a:srgbClr val="FFFFFF"/>
+                </a:solidFill>
+              </a:rPr>
+              <a:t>• TRACKING SALES TEAM ACTIVITY POINTS</a:t>
+            </a:r>
+          </a:p>
+        </p:txBody>
+      </p:sp>
+      <p:sp>
+        <p:nvSpPr>
+          <p:cNvPr id="15" name="TextBox 14"/>
+          <p:cNvSpPr txBox="1"/>
+          <p:nvPr/>
+        </p:nvSpPr>
+        <p:spPr>
+          <a:xfrm>
+            <a:off x="566928" y="4105656"/>
+            <a:ext cx="5486400" cy="475488"/>
+          </a:xfrm>
+          <a:prstGeom prst="rect">
+            <a:avLst/>
+          </a:prstGeom>
+          <a:noFill/>
+        </p:spPr>
+        <p:txBody>
+          <a:bodyPr wrap="square">
+            <a:spAutoFit/>
+          </a:bodyPr>
+          <a:lstStyle/>
+          <a:p>
+            <a:pPr algn="l"/>
+            <a:r>
+              <a:rPr sz="1100" b="1" i="0">
+                <a:solidFill>
+                  <a:srgbClr val="FFFFFF"/>
+                </a:solidFill>
+              </a:rPr>
+              <a:t>• RUNNING WEEKLY CALL BLITZES</a:t>
+            </a:r>
+          </a:p>
+        </p:txBody>
+      </p:sp>
+      <p:sp>
+        <p:nvSpPr>
+          <p:cNvPr id="16" name="TextBox 15"/>
+          <p:cNvSpPr txBox="1"/>
+          <p:nvPr/>
+        </p:nvSpPr>
+        <p:spPr>
+          <a:xfrm>
+            <a:off x="566928" y="4700016"/>
+            <a:ext cx="5486400" cy="475488"/>
+          </a:xfrm>
+          <a:prstGeom prst="rect">
+            <a:avLst/>
+          </a:prstGeom>
+          <a:noFill/>
+        </p:spPr>
+        <p:txBody>
+          <a:bodyPr wrap="square">
+            <a:spAutoFit/>
+          </a:bodyPr>
+          <a:lstStyle/>
+          <a:p>
+            <a:pPr algn="l"/>
+            <a:r>
+              <a:rPr sz="1100" b="1" i="0">
+                <a:solidFill>
+                  <a:srgbClr val="FFFFFF"/>
+                </a:solidFill>
+              </a:rPr>
+              <a:t>• RESEARCHING NEW PROSPECTS NOT IN CRM</a:t>
+            </a:r>
+          </a:p>
+        </p:txBody>
+      </p:sp>
+      <p:sp>
+        <p:nvSpPr>
+          <p:cNvPr id="17" name="TextBox 16"/>
+          <p:cNvSpPr txBox="1"/>
+          <p:nvPr/>
+        </p:nvSpPr>
+        <p:spPr>
+          <a:xfrm>
+            <a:off x="566928" y="5294376"/>
+            <a:ext cx="5486400" cy="475488"/>
+          </a:xfrm>
+          <a:prstGeom prst="rect">
+            <a:avLst/>
+          </a:prstGeom>
+          <a:noFill/>
+        </p:spPr>
+        <p:txBody>
+          <a:bodyPr wrap="square">
+            <a:spAutoFit/>
+          </a:bodyPr>
+          <a:lstStyle/>
+          <a:p>
+            <a:pPr algn="l"/>
+            <a:r>
+              <a:rPr sz="1100" b="1" i="0">
+                <a:solidFill>
+                  <a:srgbClr val="FFFFFF"/>
+                </a:solidFill>
+              </a:rPr>
+              <a:t>• BUILT COMPETITOR BATTLECARD DASHBOARD</a:t>
+            </a:r>
+          </a:p>
+        </p:txBody>
+      </p:sp>
+      <p:sp>
+        <p:nvSpPr>
+          <p:cNvPr id="18" name="TextBox 17"/>
+          <p:cNvSpPr txBox="1"/>
+          <p:nvPr/>
+        </p:nvSpPr>
+        <p:spPr>
+          <a:xfrm>
+            <a:off x="6400800" y="3511296"/>
+            <a:ext cx="5577840" cy="475488"/>
+          </a:xfrm>
+          <a:prstGeom prst="rect">
+            <a:avLst/>
+          </a:prstGeom>
+          <a:noFill/>
+        </p:spPr>
+        <p:txBody>
+          <a:bodyPr wrap="square">
+            <a:spAutoFit/>
+          </a:bodyPr>
+          <a:lstStyle/>
+          <a:p>
+            <a:pPr algn="l"/>
+            <a:r>
+              <a:rPr sz="1100" b="1" i="0">
+                <a:solidFill>
+                  <a:srgbClr val="FFFFFF"/>
+                </a:solidFill>
+              </a:rPr>
+              <a:t>• AUTOMATED WEEKLY FORECAST DECKS FOR ELT</a:t>
+            </a:r>
+          </a:p>
+        </p:txBody>
+      </p:sp>
+      <p:sp>
+        <p:nvSpPr>
+          <p:cNvPr id="19" name="TextBox 18"/>
+          <p:cNvSpPr txBox="1"/>
+          <p:nvPr/>
+        </p:nvSpPr>
+        <p:spPr>
+          <a:xfrm>
+            <a:off x="6400800" y="4105656"/>
+            <a:ext cx="5577840" cy="475488"/>
+          </a:xfrm>
+          <a:prstGeom prst="rect">
+            <a:avLst/>
+          </a:prstGeom>
+          <a:noFill/>
+        </p:spPr>
+        <p:txBody>
+          <a:bodyPr wrap="square">
+            <a:spAutoFit/>
+          </a:bodyPr>
+          <a:lstStyle/>
+          <a:p>
+            <a:pPr algn="l"/>
+            <a:r>
+              <a:rPr sz="1100" b="1" i="0">
+                <a:solidFill>
+                  <a:srgbClr val="FFFFFF"/>
+                </a:solidFill>
+              </a:rPr>
+              <a:t>• DISCOVERY NO-SHOW TREND ANALYSIS</a:t>
+            </a:r>
+          </a:p>
+        </p:txBody>
+      </p:sp>
+      <p:sp>
+        <p:nvSpPr>
+          <p:cNvPr id="20" name="TextBox 19"/>
+          <p:cNvSpPr txBox="1"/>
+          <p:nvPr/>
+        </p:nvSpPr>
+        <p:spPr>
+          <a:xfrm>
+            <a:off x="6400800" y="4700016"/>
+            <a:ext cx="5577840" cy="475488"/>
+          </a:xfrm>
+          <a:prstGeom prst="rect">
+            <a:avLst/>
+          </a:prstGeom>
+          <a:noFill/>
+        </p:spPr>
+        <p:txBody>
+          <a:bodyPr wrap="square">
+            <a:spAutoFit/>
+          </a:bodyPr>
+          <a:lstStyle/>
+          <a:p>
+            <a:pPr algn="l"/>
+            <a:r>
+              <a:rPr sz="1100" b="1" i="0">
+                <a:solidFill>
+                  <a:srgbClr val="FFFFFF"/>
+                </a:solidFill>
+              </a:rPr>
+              <a:t>• SOFTWARE MISSING CAPABILITIES DEEP DIVE</a:t>
+            </a:r>
+          </a:p>
+        </p:txBody>
+      </p:sp>
+      <p:sp>
+        <p:nvSpPr>
+          <p:cNvPr id="21" name="TextBox 20"/>
+          <p:cNvSpPr txBox="1"/>
+          <p:nvPr/>
+        </p:nvSpPr>
+        <p:spPr>
+          <a:xfrm>
+            <a:off x="6400800" y="5294376"/>
+            <a:ext cx="5577840" cy="475488"/>
+          </a:xfrm>
+          <a:prstGeom prst="rect">
+            <a:avLst/>
+          </a:prstGeom>
+          <a:noFill/>
+        </p:spPr>
+        <p:txBody>
+          <a:bodyPr wrap="square">
+            <a:spAutoFit/>
+          </a:bodyPr>
+          <a:lstStyle/>
+          <a:p>
+            <a:pPr algn="l"/>
+            <a:r>
+              <a:rPr sz="1100" b="1" i="0">
+                <a:solidFill>
+                  <a:srgbClr val="FFFFFF"/>
+                </a:solidFill>
+              </a:rPr>
+              <a:t>• MORNING BRIEFINGS &amp; PIPELINE INTELLIGENCE</a:t>
+            </a:r>
+          </a:p>
+        </p:txBody>
+      </p:sp>
+      <p:sp>
+        <p:nvSpPr>
+          <p:cNvPr id="22" name="Rectangle 21"/>
+          <p:cNvSpPr/>
+          <p:nvPr/>
+        </p:nvSpPr>
+        <p:spPr>
+          <a:xfrm>
+            <a:off x="0" y="6675120"/>
+            <a:ext cx="12188952" cy="182880"/>
+          </a:xfrm>
+          <a:prstGeom prst="rect">
+            <a:avLst/>
+          </a:prstGeom>
+          <a:solidFill>
+            <a:srgbClr val="071220"/>
+          </a:solidFill>
+          <a:ln>
+            <a:noFill/>
+          </a:ln>
+        </p:spPr>
+        <p:style>
+          <a:lnRef idx="1">
+            <a:schemeClr val="accent1"/>
+          </a:lnRef>
+          <a:fillRef idx="3">
+            <a:schemeClr val="accent1"/>
+          </a:fillRef>
+          <a:effectRef idx="2">
+            <a:schemeClr val="accent1"/>
+          </a:effectRef>
+          <a:fontRef idx="minor">
+            <a:schemeClr val="lt1"/>
+          </a:fontRef>
+        </p:style>
+        <p:txBody>
+          <a:bodyPr rtlCol="0" anchor="ctr"/>
+          <a:lstStyle/>
+          <a:p>
+            <a:pPr algn="ctr"/>
+          </a:p>
+        </p:txBody>
+      </p:sp>
+      <p:sp>
+        <p:nvSpPr>
+          <p:cNvPr id="23" name="TextBox 22"/>
           <p:cNvSpPr txBox="1"/>
           <p:nvPr/>
         </p:nvSpPr>
@@ -5551,14 +5594,14 @@
       </p:sp>
       <p:sp>
         <p:nvSpPr>
-          <p:cNvPr id="23" name="TextBox 22"/>
+          <p:cNvPr id="24" name="TextBox 23"/>
           <p:cNvSpPr txBox="1"/>
           <p:nvPr/>
         </p:nvSpPr>
         <p:spPr>
           <a:xfrm>
-            <a:off x="8229600" y="6693408"/>
-            <a:ext cx="2286000" cy="146304"/>
+            <a:off x="8686800" y="6693408"/>
+            <a:ext cx="2011680" cy="146304"/>
           </a:xfrm>
           <a:prstGeom prst="rect">
             <a:avLst/>
@@ -5578,21 +5621,21 @@
                   <a:srgbClr val="FFFFFF"/>
                 </a:solidFill>
               </a:rPr>
-              <a:t>BUILT FOR TOMORROW.  </a:t>
-            </a:r>
-          </a:p>
-        </p:txBody>
-      </p:sp>
-      <p:sp>
-        <p:nvSpPr>
-          <p:cNvPr id="24" name="TextBox 23"/>
+              <a:t>BUILT FOR TOMORROW.</a:t>
+            </a:r>
+          </a:p>
+        </p:txBody>
+      </p:sp>
+      <p:sp>
+        <p:nvSpPr>
+          <p:cNvPr id="25" name="TextBox 24"/>
           <p:cNvSpPr txBox="1"/>
           <p:nvPr/>
         </p:nvSpPr>
         <p:spPr>
           <a:xfrm>
-            <a:off x="10515600" y="6693408"/>
-            <a:ext cx="1554480" cy="146304"/>
+            <a:off x="10698480" y="6693408"/>
+            <a:ext cx="1371600" cy="146304"/>
           </a:xfrm>
           <a:prstGeom prst="rect">
             <a:avLst/>

</xml_diff>

<commit_message>
Add Notion + Clay tool stack slide
</commit_message>
<xml_diff>
--- a/Robin-Intro-Slide.pptx
+++ b/Robin-Intro-Slide.pptx
@@ -9,6 +9,7 @@
   </p:notesMasterIdLst>
   <p:sldIdLst>
     <p:sldId id="828" r:id="rId9"/>
+    <p:sldId id="829" r:id="rId10"/>
   </p:sldIdLst>
   <p:sldSz cx="12192000" cy="6858000"/>
   <p:notesSz cx="6858000" cy="9144000"/>
@@ -4201,586 +4202,6 @@
 </file>
 
 <file path=ppt/slides/slide1.xml><?xml version="1.0" encoding="utf-8"?>
-<p:sld xmlns:a="http://schemas.openxmlformats.org/drawingml/2006/main" xmlns:r="http://schemas.openxmlformats.org/officeDocument/2006/relationships" xmlns:p="http://schemas.openxmlformats.org/presentationml/2006/main">
-  <p:cSld>
-    <p:spTree>
-      <p:nvGrpSpPr>
-        <p:cNvPr id="1" name=""/>
-        <p:cNvGrpSpPr/>
-        <p:nvPr/>
-      </p:nvGrpSpPr>
-      <p:grpSpPr>
-        <a:xfrm>
-          <a:off x="0" y="0"/>
-          <a:ext cx="0" cy="0"/>
-          <a:chOff x="0" y="0"/>
-          <a:chExt cx="0" cy="0"/>
-        </a:xfrm>
-      </p:grpSpPr>
-      <p:sp>
-        <p:nvSpPr>
-          <p:cNvPr id="2" name="Freeform 2"/>
-          <p:cNvSpPr/>
-          <p:nvPr/>
-        </p:nvSpPr>
-        <p:spPr>
-          <a:xfrm>
-            <a:off x="0" y="0"/>
-            <a:ext cx="12192000" cy="6858000"/>
-          </a:xfrm>
-          <a:custGeom>
-            <a:avLst/>
-            <a:gdLst/>
-            <a:ahLst/>
-            <a:cxnLst/>
-            <a:rect l="l" t="t" r="r" b="b"/>
-            <a:pathLst>
-              <a:path w="18288000" h="10287000">
-                <a:moveTo>
-                  <a:pt x="0" y="0"/>
-                </a:moveTo>
-                <a:lnTo>
-                  <a:pt x="18288000" y="0"/>
-                </a:lnTo>
-                <a:lnTo>
-                  <a:pt x="18288000" y="10287000"/>
-                </a:lnTo>
-                <a:lnTo>
-                  <a:pt x="0" y="10287000"/>
-                </a:lnTo>
-                <a:lnTo>
-                  <a:pt x="0" y="0"/>
-                </a:lnTo>
-                <a:close/>
-              </a:path>
-            </a:pathLst>
-          </a:custGeom>
-          <a:blipFill>
-            <a:blip r:embed="rId2"/>
-            <a:stretch>
-              <a:fillRect/>
-            </a:stretch>
-          </a:blipFill>
-        </p:spPr>
-        <p:txBody>
-          <a:bodyPr/>
-          <a:lstStyle/>
-          <a:p>
-            <a:endParaRPr lang="en-US"/>
-          </a:p>
-        </p:txBody>
-      </p:sp>
-      <p:sp>
-        <p:nvSpPr>
-          <p:cNvPr id="4" name="AutoShape 4"/>
-          <p:cNvSpPr/>
-          <p:nvPr/>
-        </p:nvSpPr>
-        <p:spPr>
-          <a:xfrm>
-            <a:off x="685800" y="3448050"/>
-            <a:ext cx="5560377" cy="0"/>
-          </a:xfrm>
-          <a:prstGeom prst="line">
-            <a:avLst/>
-          </a:prstGeom>
-          <a:ln w="57150" cap="rnd">
-            <a:gradFill>
-              <a:gsLst>
-                <a:gs pos="0">
-                  <a:srgbClr val="1667CC">
-                    <a:alpha val="100000"/>
-                  </a:srgbClr>
-                </a:gs>
-                <a:gs pos="100000">
-                  <a:srgbClr val="3DC570">
-                    <a:alpha val="100000"/>
-                  </a:srgbClr>
-                </a:gs>
-              </a:gsLst>
-              <a:lin ang="2700000"/>
-            </a:gradFill>
-            <a:prstDash val="solid"/>
-            <a:headEnd type="none" w="sm" len="sm"/>
-            <a:tailEnd type="none" w="sm" len="sm"/>
-          </a:ln>
-        </p:spPr>
-        <p:txBody>
-          <a:bodyPr/>
-          <a:lstStyle/>
-          <a:p>
-            <a:endParaRPr lang="en-US"/>
-          </a:p>
-        </p:txBody>
-      </p:sp>
-      <p:sp>
-        <p:nvSpPr>
-          <p:cNvPr id="5" name="TextBox 5"/>
-          <p:cNvSpPr txBox="1"/>
-          <p:nvPr/>
-        </p:nvSpPr>
-        <p:spPr>
-          <a:xfrm>
-            <a:off x="685800" y="1603623"/>
-            <a:ext cx="4975062" cy="1537216"/>
-          </a:xfrm>
-          <a:prstGeom prst="rect">
-            <a:avLst/>
-          </a:prstGeom>
-        </p:spPr>
-        <p:txBody>
-          <a:bodyPr wrap="square" lIns="0" tIns="0" rIns="0" bIns="0" rtlCol="0" anchor="t">
-            <a:spAutoFit/>
-          </a:bodyPr>
-          <a:lstStyle>
-            <a:defPPr>
-              <a:defRPr lang="en-US"/>
-            </a:defPPr>
-            <a:lvl1pPr marL="0" algn="l" defTabSz="609539" rtl="0" eaLnBrk="1" latinLnBrk="0" hangingPunct="1">
-              <a:defRPr sz="1200" kern="1200">
-                <a:solidFill>
-                  <a:schemeClr val="tx1"/>
-                </a:solidFill>
-                <a:latin typeface="+mn-lt"/>
-                <a:ea typeface="+mn-ea"/>
-                <a:cs typeface="+mn-cs"/>
-              </a:defRPr>
-            </a:lvl1pPr>
-            <a:lvl2pPr marL="304770" algn="l" defTabSz="609539" rtl="0" eaLnBrk="1" latinLnBrk="0" hangingPunct="1">
-              <a:defRPr sz="1200" kern="1200">
-                <a:solidFill>
-                  <a:schemeClr val="tx1"/>
-                </a:solidFill>
-                <a:latin typeface="+mn-lt"/>
-                <a:ea typeface="+mn-ea"/>
-                <a:cs typeface="+mn-cs"/>
-              </a:defRPr>
-            </a:lvl2pPr>
-            <a:lvl3pPr marL="609539" algn="l" defTabSz="609539" rtl="0" eaLnBrk="1" latinLnBrk="0" hangingPunct="1">
-              <a:defRPr sz="1200" kern="1200">
-                <a:solidFill>
-                  <a:schemeClr val="tx1"/>
-                </a:solidFill>
-                <a:latin typeface="+mn-lt"/>
-                <a:ea typeface="+mn-ea"/>
-                <a:cs typeface="+mn-cs"/>
-              </a:defRPr>
-            </a:lvl3pPr>
-            <a:lvl4pPr marL="914309" algn="l" defTabSz="609539" rtl="0" eaLnBrk="1" latinLnBrk="0" hangingPunct="1">
-              <a:defRPr sz="1200" kern="1200">
-                <a:solidFill>
-                  <a:schemeClr val="tx1"/>
-                </a:solidFill>
-                <a:latin typeface="+mn-lt"/>
-                <a:ea typeface="+mn-ea"/>
-                <a:cs typeface="+mn-cs"/>
-              </a:defRPr>
-            </a:lvl4pPr>
-            <a:lvl5pPr marL="1219078" algn="l" defTabSz="609539" rtl="0" eaLnBrk="1" latinLnBrk="0" hangingPunct="1">
-              <a:defRPr sz="1200" kern="1200">
-                <a:solidFill>
-                  <a:schemeClr val="tx1"/>
-                </a:solidFill>
-                <a:latin typeface="+mn-lt"/>
-                <a:ea typeface="+mn-ea"/>
-                <a:cs typeface="+mn-cs"/>
-              </a:defRPr>
-            </a:lvl5pPr>
-            <a:lvl6pPr marL="1523848" algn="l" defTabSz="609539" rtl="0" eaLnBrk="1" latinLnBrk="0" hangingPunct="1">
-              <a:defRPr sz="1200" kern="1200">
-                <a:solidFill>
-                  <a:schemeClr val="tx1"/>
-                </a:solidFill>
-                <a:latin typeface="+mn-lt"/>
-                <a:ea typeface="+mn-ea"/>
-                <a:cs typeface="+mn-cs"/>
-              </a:defRPr>
-            </a:lvl6pPr>
-            <a:lvl7pPr marL="1828617" algn="l" defTabSz="609539" rtl="0" eaLnBrk="1" latinLnBrk="0" hangingPunct="1">
-              <a:defRPr sz="1200" kern="1200">
-                <a:solidFill>
-                  <a:schemeClr val="tx1"/>
-                </a:solidFill>
-                <a:latin typeface="+mn-lt"/>
-                <a:ea typeface="+mn-ea"/>
-                <a:cs typeface="+mn-cs"/>
-              </a:defRPr>
-            </a:lvl7pPr>
-            <a:lvl8pPr marL="2133387" algn="l" defTabSz="609539" rtl="0" eaLnBrk="1" latinLnBrk="0" hangingPunct="1">
-              <a:defRPr sz="1200" kern="1200">
-                <a:solidFill>
-                  <a:schemeClr val="tx1"/>
-                </a:solidFill>
-                <a:latin typeface="+mn-lt"/>
-                <a:ea typeface="+mn-ea"/>
-                <a:cs typeface="+mn-cs"/>
-              </a:defRPr>
-            </a:lvl8pPr>
-            <a:lvl9pPr marL="2438156" algn="l" defTabSz="609539" rtl="0" eaLnBrk="1" latinLnBrk="0" hangingPunct="1">
-              <a:defRPr sz="1200" kern="1200">
-                <a:solidFill>
-                  <a:schemeClr val="tx1"/>
-                </a:solidFill>
-                <a:latin typeface="+mn-lt"/>
-                <a:ea typeface="+mn-ea"/>
-                <a:cs typeface="+mn-cs"/>
-              </a:defRPr>
-            </a:lvl9pPr>
-          </a:lstStyle>
-          <a:p>
-            <a:pPr>
-              <a:lnSpc>
-                <a:spcPts val="6160"/>
-              </a:lnSpc>
-              <a:spcBef>
-                <a:spcPct val="0"/>
-              </a:spcBef>
-            </a:pPr>
-            <a:r>
-              <a:rPr lang="en-US" sz="4350" b="1" dirty="0">
-                <a:solidFill>
-                  <a:srgbClr val="FFFFFF"/>
-                </a:solidFill>
-                <a:latin typeface="Montserrat Bold"/>
-                <a:sym typeface="Montserrat Bold"/>
-              </a:rPr>
-              <a:t>Sales </a:t>
-            </a:r>
-            <a:br>
-              <a:rPr lang="en-US" sz="4350" b="1" dirty="0">
-                <a:latin typeface="Montserrat Bold"/>
-              </a:rPr>
-            </a:br>
-            <a:r>
-              <a:rPr lang="en-US" sz="3600" b="1" dirty="0">
-                <a:solidFill>
-                  <a:srgbClr val="FFFFFF"/>
-                </a:solidFill>
-                <a:latin typeface="Montserrat Bold"/>
-                <a:sym typeface="Montserrat Bold"/>
-              </a:rPr>
-              <a:t>Primus Update</a:t>
-            </a:r>
-            <a:endParaRPr lang="en-US" sz="3600" dirty="0"/>
-          </a:p>
-        </p:txBody>
-      </p:sp>
-      <p:sp>
-        <p:nvSpPr>
-          <p:cNvPr id="7" name="TextBox 7"/>
-          <p:cNvSpPr txBox="1"/>
-          <p:nvPr/>
-        </p:nvSpPr>
-        <p:spPr>
-          <a:xfrm>
-            <a:off x="685800" y="3755262"/>
-            <a:ext cx="5410200" cy="287643"/>
-          </a:xfrm>
-          <a:prstGeom prst="rect">
-            <a:avLst/>
-          </a:prstGeom>
-        </p:spPr>
-        <p:txBody>
-          <a:bodyPr wrap="square" lIns="0" tIns="0" rIns="0" bIns="0" rtlCol="0" anchor="t">
-            <a:spAutoFit/>
-          </a:bodyPr>
-          <a:lstStyle>
-            <a:defPPr>
-              <a:defRPr lang="en-US"/>
-            </a:defPPr>
-            <a:lvl1pPr marL="0" algn="l" defTabSz="609539" rtl="0" eaLnBrk="1" latinLnBrk="0" hangingPunct="1">
-              <a:defRPr sz="1200" kern="1200">
-                <a:solidFill>
-                  <a:schemeClr val="tx1"/>
-                </a:solidFill>
-                <a:latin typeface="+mn-lt"/>
-                <a:ea typeface="+mn-ea"/>
-                <a:cs typeface="+mn-cs"/>
-              </a:defRPr>
-            </a:lvl1pPr>
-            <a:lvl2pPr marL="304770" algn="l" defTabSz="609539" rtl="0" eaLnBrk="1" latinLnBrk="0" hangingPunct="1">
-              <a:defRPr sz="1200" kern="1200">
-                <a:solidFill>
-                  <a:schemeClr val="tx1"/>
-                </a:solidFill>
-                <a:latin typeface="+mn-lt"/>
-                <a:ea typeface="+mn-ea"/>
-                <a:cs typeface="+mn-cs"/>
-              </a:defRPr>
-            </a:lvl2pPr>
-            <a:lvl3pPr marL="609539" algn="l" defTabSz="609539" rtl="0" eaLnBrk="1" latinLnBrk="0" hangingPunct="1">
-              <a:defRPr sz="1200" kern="1200">
-                <a:solidFill>
-                  <a:schemeClr val="tx1"/>
-                </a:solidFill>
-                <a:latin typeface="+mn-lt"/>
-                <a:ea typeface="+mn-ea"/>
-                <a:cs typeface="+mn-cs"/>
-              </a:defRPr>
-            </a:lvl3pPr>
-            <a:lvl4pPr marL="914309" algn="l" defTabSz="609539" rtl="0" eaLnBrk="1" latinLnBrk="0" hangingPunct="1">
-              <a:defRPr sz="1200" kern="1200">
-                <a:solidFill>
-                  <a:schemeClr val="tx1"/>
-                </a:solidFill>
-                <a:latin typeface="+mn-lt"/>
-                <a:ea typeface="+mn-ea"/>
-                <a:cs typeface="+mn-cs"/>
-              </a:defRPr>
-            </a:lvl4pPr>
-            <a:lvl5pPr marL="1219078" algn="l" defTabSz="609539" rtl="0" eaLnBrk="1" latinLnBrk="0" hangingPunct="1">
-              <a:defRPr sz="1200" kern="1200">
-                <a:solidFill>
-                  <a:schemeClr val="tx1"/>
-                </a:solidFill>
-                <a:latin typeface="+mn-lt"/>
-                <a:ea typeface="+mn-ea"/>
-                <a:cs typeface="+mn-cs"/>
-              </a:defRPr>
-            </a:lvl5pPr>
-            <a:lvl6pPr marL="1523848" algn="l" defTabSz="609539" rtl="0" eaLnBrk="1" latinLnBrk="0" hangingPunct="1">
-              <a:defRPr sz="1200" kern="1200">
-                <a:solidFill>
-                  <a:schemeClr val="tx1"/>
-                </a:solidFill>
-                <a:latin typeface="+mn-lt"/>
-                <a:ea typeface="+mn-ea"/>
-                <a:cs typeface="+mn-cs"/>
-              </a:defRPr>
-            </a:lvl6pPr>
-            <a:lvl7pPr marL="1828617" algn="l" defTabSz="609539" rtl="0" eaLnBrk="1" latinLnBrk="0" hangingPunct="1">
-              <a:defRPr sz="1200" kern="1200">
-                <a:solidFill>
-                  <a:schemeClr val="tx1"/>
-                </a:solidFill>
-                <a:latin typeface="+mn-lt"/>
-                <a:ea typeface="+mn-ea"/>
-                <a:cs typeface="+mn-cs"/>
-              </a:defRPr>
-            </a:lvl7pPr>
-            <a:lvl8pPr marL="2133387" algn="l" defTabSz="609539" rtl="0" eaLnBrk="1" latinLnBrk="0" hangingPunct="1">
-              <a:defRPr sz="1200" kern="1200">
-                <a:solidFill>
-                  <a:schemeClr val="tx1"/>
-                </a:solidFill>
-                <a:latin typeface="+mn-lt"/>
-                <a:ea typeface="+mn-ea"/>
-                <a:cs typeface="+mn-cs"/>
-              </a:defRPr>
-            </a:lvl8pPr>
-            <a:lvl9pPr marL="2438156" algn="l" defTabSz="609539" rtl="0" eaLnBrk="1" latinLnBrk="0" hangingPunct="1">
-              <a:defRPr sz="1200" kern="1200">
-                <a:solidFill>
-                  <a:schemeClr val="tx1"/>
-                </a:solidFill>
-                <a:latin typeface="+mn-lt"/>
-                <a:ea typeface="+mn-ea"/>
-                <a:cs typeface="+mn-cs"/>
-              </a:defRPr>
-            </a:lvl9pPr>
-          </a:lstStyle>
-          <a:p>
-            <a:pPr>
-              <a:lnSpc>
-                <a:spcPts val="2239"/>
-              </a:lnSpc>
-              <a:spcBef>
-                <a:spcPct val="0"/>
-              </a:spcBef>
-            </a:pPr>
-            <a:r>
-              <a:rPr lang="en-US" sz="2400" dirty="0">
-                <a:solidFill>
-                  <a:srgbClr val="FFFFFF"/>
-                </a:solidFill>
-                <a:latin typeface="Montserrat"/>
-                <a:ea typeface="Montserrat"/>
-                <a:cs typeface="Montserrat"/>
-                <a:sym typeface="Montserrat"/>
-              </a:rPr>
-              <a:t>1.26.26</a:t>
-            </a:r>
-          </a:p>
-        </p:txBody>
-      </p:sp>
-      <p:sp>
-        <p:nvSpPr>
-          <p:cNvPr id="9" name="Freeform 93">
-            <a:extLst>
-              <a:ext uri="{FF2B5EF4-FFF2-40B4-BE49-F238E27FC236}">
-                <a16:creationId xmlns:a16="http://schemas.microsoft.com/office/drawing/2014/main" id="{5CD82284-60FD-3FA7-2488-2D1D3581D7D7}"/>
-              </a:ext>
-            </a:extLst>
-          </p:cNvPr>
-          <p:cNvSpPr/>
-          <p:nvPr/>
-        </p:nvSpPr>
-        <p:spPr>
-          <a:xfrm>
-            <a:off x="10312439" y="6176179"/>
-            <a:ext cx="1547547" cy="388627"/>
-          </a:xfrm>
-          <a:custGeom>
-            <a:avLst/>
-            <a:gdLst/>
-            <a:ahLst/>
-            <a:cxnLst/>
-            <a:rect l="l" t="t" r="r" b="b"/>
-            <a:pathLst>
-              <a:path w="2586660" h="664583">
-                <a:moveTo>
-                  <a:pt x="0" y="0"/>
-                </a:moveTo>
-                <a:lnTo>
-                  <a:pt x="2586660" y="0"/>
-                </a:lnTo>
-                <a:lnTo>
-                  <a:pt x="2586660" y="664582"/>
-                </a:lnTo>
-                <a:lnTo>
-                  <a:pt x="0" y="664582"/>
-                </a:lnTo>
-                <a:lnTo>
-                  <a:pt x="0" y="0"/>
-                </a:lnTo>
-                <a:close/>
-              </a:path>
-            </a:pathLst>
-          </a:custGeom>
-          <a:blipFill>
-            <a:blip r:embed="rId3"/>
-            <a:stretch>
-              <a:fillRect/>
-            </a:stretch>
-          </a:blipFill>
-        </p:spPr>
-        <p:txBody>
-          <a:bodyPr/>
-          <a:lstStyle/>
-          <a:p>
-            <a:endParaRPr lang="en-US"/>
-          </a:p>
-        </p:txBody>
-      </p:sp>
-    </p:spTree>
-    <p:extLst>
-      <p:ext uri="{BB962C8B-B14F-4D97-AF65-F5344CB8AC3E}">
-        <p14:creationId xmlns:p14="http://schemas.microsoft.com/office/powerpoint/2010/main" val="2658078358"/>
-      </p:ext>
-    </p:extLst>
-  </p:cSld>
-  <p:clrMapOvr>
-    <a:masterClrMapping/>
-  </p:clrMapOvr>
-</p:sld>
-</file>
-
-<file path=ppt/slides/slide2.xml><?xml version="1.0" encoding="utf-8"?>
-<p:sld xmlns:a="http://schemas.openxmlformats.org/drawingml/2006/main" xmlns:r="http://schemas.openxmlformats.org/officeDocument/2006/relationships" xmlns:p="http://schemas.openxmlformats.org/presentationml/2006/main">
-  <p:cSld>
-    <p:spTree>
-      <p:nvGrpSpPr>
-        <p:cNvPr id="1" name=""/>
-        <p:cNvGrpSpPr/>
-        <p:nvPr/>
-      </p:nvGrpSpPr>
-      <p:grpSpPr>
-        <a:xfrm>
-          <a:off x="0" y="0"/>
-          <a:ext cx="0" cy="0"/>
-          <a:chOff x="0" y="0"/>
-          <a:chExt cx="0" cy="0"/>
-        </a:xfrm>
-      </p:grpSpPr>
-      <p:sp>
-        <p:nvSpPr>
-          <p:cNvPr id="2" name="Title 1">
-            <a:extLst>
-              <a:ext uri="{FF2B5EF4-FFF2-40B4-BE49-F238E27FC236}">
-                <a16:creationId xmlns:a16="http://schemas.microsoft.com/office/drawing/2014/main" id="{41D3548C-A52F-4422-99BB-66D5C688FC76}"/>
-              </a:ext>
-            </a:extLst>
-          </p:cNvPr>
-          <p:cNvSpPr>
-            <a:spLocks noGrp="1"/>
-          </p:cNvSpPr>
-          <p:nvPr>
-            <p:ph type="title"/>
-          </p:nvPr>
-        </p:nvSpPr>
-        <p:spPr/>
-        <p:txBody>
-          <a:bodyPr/>
-          <a:lstStyle/>
-          <a:p>
-            <a:endParaRPr lang="en-US"/>
-          </a:p>
-        </p:txBody>
-      </p:sp>
-      <p:sp>
-        <p:nvSpPr>
-          <p:cNvPr id="3" name="Content Placeholder 2">
-            <a:extLst>
-              <a:ext uri="{FF2B5EF4-FFF2-40B4-BE49-F238E27FC236}">
-                <a16:creationId xmlns:a16="http://schemas.microsoft.com/office/drawing/2014/main" id="{E5EEDD2B-DCB3-6765-DC8D-17DC3D99C103}"/>
-              </a:ext>
-            </a:extLst>
-          </p:cNvPr>
-          <p:cNvSpPr>
-            <a:spLocks noGrp="1"/>
-          </p:cNvSpPr>
-          <p:nvPr>
-            <p:ph sz="half" idx="2"/>
-          </p:nvPr>
-        </p:nvSpPr>
-        <p:spPr/>
-        <p:txBody>
-          <a:bodyPr/>
-          <a:lstStyle/>
-          <a:p>
-            <a:endParaRPr lang="en-US"/>
-          </a:p>
-        </p:txBody>
-      </p:sp>
-      <p:sp>
-        <p:nvSpPr>
-          <p:cNvPr id="4" name="Text Placeholder 3">
-            <a:extLst>
-              <a:ext uri="{FF2B5EF4-FFF2-40B4-BE49-F238E27FC236}">
-                <a16:creationId xmlns:a16="http://schemas.microsoft.com/office/drawing/2014/main" id="{20FC5147-5205-AA7D-70EA-CCE388E6F169}"/>
-              </a:ext>
-            </a:extLst>
-          </p:cNvPr>
-          <p:cNvSpPr>
-            <a:spLocks noGrp="1"/>
-          </p:cNvSpPr>
-          <p:nvPr>
-            <p:ph type="body" idx="1"/>
-          </p:nvPr>
-        </p:nvSpPr>
-        <p:spPr/>
-        <p:txBody>
-          <a:bodyPr/>
-          <a:lstStyle/>
-          <a:p>
-            <a:endParaRPr lang="en-US"/>
-          </a:p>
-        </p:txBody>
-      </p:sp>
-    </p:spTree>
-    <p:extLst>
-      <p:ext uri="{BB962C8B-B14F-4D97-AF65-F5344CB8AC3E}">
-        <p14:creationId xmlns:p14="http://schemas.microsoft.com/office/powerpoint/2010/main" val="3114367268"/>
-      </p:ext>
-    </p:extLst>
-  </p:cSld>
-  <p:clrMapOvr>
-    <a:masterClrMapping/>
-  </p:clrMapOvr>
-</p:sld>
-</file>
-
-<file path=ppt/slides/slide3.xml><?xml version="1.0" encoding="utf-8"?>
 <p:sld xmlns:a="http://schemas.openxmlformats.org/drawingml/2006/main" xmlns:p="http://schemas.openxmlformats.org/presentationml/2006/main" xmlns:r="http://schemas.openxmlformats.org/officeDocument/2006/relationships">
   <p:cSld>
     <p:spTree>
@@ -5629,6 +5050,3268 @@
       <p:sp>
         <p:nvSpPr>
           <p:cNvPr id="25" name="TextBox 24"/>
+          <p:cNvSpPr txBox="1"/>
+          <p:nvPr/>
+        </p:nvSpPr>
+        <p:spPr>
+          <a:xfrm>
+            <a:off x="10698480" y="6693408"/>
+            <a:ext cx="1371600" cy="146304"/>
+          </a:xfrm>
+          <a:prstGeom prst="rect">
+            <a:avLst/>
+          </a:prstGeom>
+          <a:noFill/>
+        </p:spPr>
+        <p:txBody>
+          <a:bodyPr wrap="square">
+            <a:spAutoFit/>
+          </a:bodyPr>
+          <a:lstStyle/>
+          <a:p>
+            <a:pPr algn="r"/>
+            <a:r>
+              <a:rPr sz="900" b="1" i="0">
+                <a:solidFill>
+                  <a:srgbClr val="3DC570"/>
+                </a:solidFill>
+              </a:rPr>
+              <a:t>READY FOR TODAY.</a:t>
+            </a:r>
+          </a:p>
+        </p:txBody>
+      </p:sp>
+    </p:spTree>
+  </p:cSld>
+  <p:clrMapOvr>
+    <a:masterClrMapping/>
+  </p:clrMapOvr>
+</p:sld>
+</file>
+
+<file path=ppt/slides/slide1.xml><?xml version="1.0" encoding="utf-8"?>
+<p:sld xmlns:a="http://schemas.openxmlformats.org/drawingml/2006/main" xmlns:p="http://schemas.openxmlformats.org/presentationml/2006/main" xmlns:r="http://schemas.openxmlformats.org/officeDocument/2006/relationships">
+  <p:cSld>
+    <p:spTree>
+      <p:nvGrpSpPr>
+        <p:cNvPr id="1" name=""/>
+        <p:cNvGrpSpPr/>
+        <p:nvPr/>
+      </p:nvGrpSpPr>
+      <p:grpSpPr/>
+      <p:sp>
+        <p:nvSpPr>
+          <p:cNvPr id="2" name="TextBox 1"/>
+          <p:cNvSpPr txBox="1"/>
+          <p:nvPr/>
+        </p:nvSpPr>
+        <p:spPr>
+          <a:xfrm>
+            <a:off x="365760" y="164592"/>
+            <a:ext cx="11430000" cy="713232"/>
+          </a:xfrm>
+          <a:prstGeom prst="rect">
+            <a:avLst/>
+          </a:prstGeom>
+          <a:noFill/>
+        </p:spPr>
+        <p:txBody>
+          <a:bodyPr wrap="square">
+            <a:spAutoFit/>
+          </a:bodyPr>
+          <a:lstStyle/>
+          <a:p>
+            <a:pPr algn="l"/>
+            <a:r>
+              <a:rPr sz="4600" b="1" i="0">
+                <a:solidFill>
+                  <a:srgbClr val="FFFFFF"/>
+                </a:solidFill>
+              </a:rPr>
+              <a:t>Meet Robin</a:t>
+            </a:r>
+          </a:p>
+        </p:txBody>
+      </p:sp>
+      <p:sp>
+        <p:nvSpPr>
+          <p:cNvPr id="3" name="TextBox 2"/>
+          <p:cNvSpPr txBox="1"/>
+          <p:nvPr/>
+        </p:nvSpPr>
+        <p:spPr>
+          <a:xfrm>
+            <a:off x="365760" y="877824"/>
+            <a:ext cx="11430000" cy="310896"/>
+          </a:xfrm>
+          <a:prstGeom prst="rect">
+            <a:avLst/>
+          </a:prstGeom>
+          <a:noFill/>
+        </p:spPr>
+        <p:txBody>
+          <a:bodyPr wrap="square">
+            <a:spAutoFit/>
+          </a:bodyPr>
+          <a:lstStyle/>
+          <a:p>
+            <a:pPr algn="l"/>
+            <a:r>
+              <a:rPr sz="1300" b="0" i="0">
+                <a:solidFill>
+                  <a:srgbClr val="8AA8C8"/>
+                </a:solidFill>
+              </a:rPr>
+              <a:t>Rev.io's AI Sales Assistant — running 24/7 to power the sales team.</a:t>
+            </a:r>
+          </a:p>
+        </p:txBody>
+      </p:sp>
+      <p:sp>
+        <p:nvSpPr>
+          <p:cNvPr id="4" name="Rectangle 3"/>
+          <p:cNvSpPr/>
+          <p:nvPr/>
+        </p:nvSpPr>
+        <p:spPr>
+          <a:xfrm>
+            <a:off x="365760" y="1298448"/>
+            <a:ext cx="11457432" cy="713232"/>
+          </a:xfrm>
+          <a:prstGeom prst="rect">
+            <a:avLst/>
+          </a:prstGeom>
+          <a:solidFill>
+            <a:srgbClr val="0A1E30"/>
+          </a:solidFill>
+          <a:ln>
+            <a:noFill/>
+          </a:ln>
+        </p:spPr>
+        <p:style>
+          <a:lnRef idx="1">
+            <a:schemeClr val="accent1"/>
+          </a:lnRef>
+          <a:fillRef idx="3">
+            <a:schemeClr val="accent1"/>
+          </a:fillRef>
+          <a:effectRef idx="2">
+            <a:schemeClr val="accent1"/>
+          </a:effectRef>
+          <a:fontRef idx="minor">
+            <a:schemeClr val="lt1"/>
+          </a:fontRef>
+        </p:style>
+        <p:txBody>
+          <a:bodyPr rtlCol="0" anchor="ctr"/>
+          <a:lstStyle/>
+          <a:p>
+            <a:pPr algn="ctr"/>
+          </a:p>
+        </p:txBody>
+      </p:sp>
+      <p:sp>
+        <p:nvSpPr>
+          <p:cNvPr id="5" name="Rectangle 4"/>
+          <p:cNvSpPr/>
+          <p:nvPr/>
+        </p:nvSpPr>
+        <p:spPr>
+          <a:xfrm>
+            <a:off x="365760" y="1298448"/>
+            <a:ext cx="45720" cy="713232"/>
+          </a:xfrm>
+          <a:prstGeom prst="rect">
+            <a:avLst/>
+          </a:prstGeom>
+          <a:solidFill>
+            <a:srgbClr val="00D4D4"/>
+          </a:solidFill>
+          <a:ln>
+            <a:noFill/>
+          </a:ln>
+        </p:spPr>
+        <p:style>
+          <a:lnRef idx="1">
+            <a:schemeClr val="accent1"/>
+          </a:lnRef>
+          <a:fillRef idx="3">
+            <a:schemeClr val="accent1"/>
+          </a:fillRef>
+          <a:effectRef idx="2">
+            <a:schemeClr val="accent1"/>
+          </a:effectRef>
+          <a:fontRef idx="minor">
+            <a:schemeClr val="lt1"/>
+          </a:fontRef>
+        </p:style>
+        <p:txBody>
+          <a:bodyPr rtlCol="0" anchor="ctr"/>
+          <a:lstStyle/>
+          <a:p>
+            <a:pPr algn="ctr"/>
+          </a:p>
+        </p:txBody>
+      </p:sp>
+      <p:sp>
+        <p:nvSpPr>
+          <p:cNvPr id="6" name="TextBox 5"/>
+          <p:cNvSpPr txBox="1"/>
+          <p:nvPr/>
+        </p:nvSpPr>
+        <p:spPr>
+          <a:xfrm>
+            <a:off x="502920" y="1335024"/>
+            <a:ext cx="3200400" cy="182880"/>
+          </a:xfrm>
+          <a:prstGeom prst="rect">
+            <a:avLst/>
+          </a:prstGeom>
+          <a:noFill/>
+        </p:spPr>
+        <p:txBody>
+          <a:bodyPr wrap="square">
+            <a:spAutoFit/>
+          </a:bodyPr>
+          <a:lstStyle/>
+          <a:p>
+            <a:pPr algn="l"/>
+            <a:r>
+              <a:rPr sz="800" b="1" i="0">
+                <a:solidFill>
+                  <a:srgbClr val="3DC570"/>
+                </a:solidFill>
+              </a:rPr>
+              <a:t>WHAT ROBIN DOES</a:t>
+            </a:r>
+          </a:p>
+        </p:txBody>
+      </p:sp>
+      <p:sp>
+        <p:nvSpPr>
+          <p:cNvPr id="7" name="TextBox 6"/>
+          <p:cNvSpPr txBox="1"/>
+          <p:nvPr/>
+        </p:nvSpPr>
+        <p:spPr>
+          <a:xfrm>
+            <a:off x="502920" y="1517904"/>
+            <a:ext cx="11155680" cy="420624"/>
+          </a:xfrm>
+          <a:prstGeom prst="rect">
+            <a:avLst/>
+          </a:prstGeom>
+          <a:noFill/>
+        </p:spPr>
+        <p:txBody>
+          <a:bodyPr wrap="square">
+            <a:spAutoFit/>
+          </a:bodyPr>
+          <a:lstStyle/>
+          <a:p>
+            <a:pPr algn="l"/>
+            <a:r>
+              <a:rPr sz="1050" b="0" i="0">
+                <a:solidFill>
+                  <a:srgbClr val="FFFFFF"/>
+                </a:solidFill>
+              </a:rPr>
+              <a:t>Robin is focused on two things: accelerating revenue by giving the sales team better intelligence and tools — and improving efficiency by automating the work that shouldn't require a human.</a:t>
+            </a:r>
+          </a:p>
+        </p:txBody>
+      </p:sp>
+      <p:sp>
+        <p:nvSpPr>
+          <p:cNvPr id="8" name="Rectangle 7"/>
+          <p:cNvSpPr/>
+          <p:nvPr/>
+        </p:nvSpPr>
+        <p:spPr>
+          <a:xfrm>
+            <a:off x="365760" y="2139696"/>
+            <a:ext cx="11457432" cy="4261104"/>
+          </a:xfrm>
+          <a:prstGeom prst="rect">
+            <a:avLst/>
+          </a:prstGeom>
+          <a:solidFill>
+            <a:srgbClr val="0A1E30"/>
+          </a:solidFill>
+          <a:ln>
+            <a:noFill/>
+          </a:ln>
+        </p:spPr>
+        <p:style>
+          <a:lnRef idx="1">
+            <a:schemeClr val="accent1"/>
+          </a:lnRef>
+          <a:fillRef idx="3">
+            <a:schemeClr val="accent1"/>
+          </a:fillRef>
+          <a:effectRef idx="2">
+            <a:schemeClr val="accent1"/>
+          </a:effectRef>
+          <a:fontRef idx="minor">
+            <a:schemeClr val="lt1"/>
+          </a:fontRef>
+        </p:style>
+        <p:txBody>
+          <a:bodyPr rtlCol="0" anchor="ctr"/>
+          <a:lstStyle/>
+          <a:p>
+            <a:pPr algn="ctr"/>
+          </a:p>
+        </p:txBody>
+      </p:sp>
+      <p:sp>
+        <p:nvSpPr>
+          <p:cNvPr id="9" name="Rectangle 8"/>
+          <p:cNvSpPr/>
+          <p:nvPr/>
+        </p:nvSpPr>
+        <p:spPr>
+          <a:xfrm>
+            <a:off x="365760" y="2139696"/>
+            <a:ext cx="45720" cy="4261104"/>
+          </a:xfrm>
+          <a:prstGeom prst="rect">
+            <a:avLst/>
+          </a:prstGeom>
+          <a:solidFill>
+            <a:srgbClr val="00D4D4"/>
+          </a:solidFill>
+          <a:ln>
+            <a:noFill/>
+          </a:ln>
+        </p:spPr>
+        <p:style>
+          <a:lnRef idx="1">
+            <a:schemeClr val="accent1"/>
+          </a:lnRef>
+          <a:fillRef idx="3">
+            <a:schemeClr val="accent1"/>
+          </a:fillRef>
+          <a:effectRef idx="2">
+            <a:schemeClr val="accent1"/>
+          </a:effectRef>
+          <a:fontRef idx="minor">
+            <a:schemeClr val="lt1"/>
+          </a:fontRef>
+        </p:style>
+        <p:txBody>
+          <a:bodyPr rtlCol="0" anchor="ctr"/>
+          <a:lstStyle/>
+          <a:p>
+            <a:pPr algn="ctr"/>
+          </a:p>
+        </p:txBody>
+      </p:sp>
+      <p:sp>
+        <p:nvSpPr>
+          <p:cNvPr id="10" name="TextBox 9"/>
+          <p:cNvSpPr txBox="1"/>
+          <p:nvPr/>
+        </p:nvSpPr>
+        <p:spPr>
+          <a:xfrm>
+            <a:off x="566928" y="2267712"/>
+            <a:ext cx="7315200" cy="548640"/>
+          </a:xfrm>
+          <a:prstGeom prst="rect">
+            <a:avLst/>
+          </a:prstGeom>
+          <a:noFill/>
+        </p:spPr>
+        <p:txBody>
+          <a:bodyPr wrap="square">
+            <a:spAutoFit/>
+          </a:bodyPr>
+          <a:lstStyle/>
+          <a:p>
+            <a:pPr algn="l"/>
+            <a:r>
+              <a:rPr sz="3600" b="1" i="0">
+                <a:solidFill>
+                  <a:srgbClr val="FFFFFF"/>
+                </a:solidFill>
+              </a:rPr>
+              <a:t>🦸🏻‍♂️  Robin</a:t>
+            </a:r>
+          </a:p>
+        </p:txBody>
+      </p:sp>
+      <p:sp>
+        <p:nvSpPr>
+          <p:cNvPr id="11" name="TextBox 10"/>
+          <p:cNvSpPr txBox="1"/>
+          <p:nvPr/>
+        </p:nvSpPr>
+        <p:spPr>
+          <a:xfrm>
+            <a:off x="566928" y="2816352"/>
+            <a:ext cx="8229600" cy="274320"/>
+          </a:xfrm>
+          <a:prstGeom prst="rect">
+            <a:avLst/>
+          </a:prstGeom>
+          <a:noFill/>
+        </p:spPr>
+        <p:txBody>
+          <a:bodyPr wrap="square">
+            <a:spAutoFit/>
+          </a:bodyPr>
+          <a:lstStyle/>
+          <a:p>
+            <a:pPr algn="l"/>
+            <a:r>
+              <a:rPr sz="1500" b="0" i="0">
+                <a:solidFill>
+                  <a:srgbClr val="00D4D4"/>
+                </a:solidFill>
+              </a:rPr>
+              <a:t>AI Sales Assistant &amp; Intelligence Engine</a:t>
+            </a:r>
+          </a:p>
+        </p:txBody>
+      </p:sp>
+      <p:sp>
+        <p:nvSpPr>
+          <p:cNvPr id="12" name="TextBox 11"/>
+          <p:cNvSpPr txBox="1"/>
+          <p:nvPr/>
+        </p:nvSpPr>
+        <p:spPr>
+          <a:xfrm>
+            <a:off x="566928" y="3099815"/>
+            <a:ext cx="6400800" cy="237744"/>
+          </a:xfrm>
+          <a:prstGeom prst="rect">
+            <a:avLst/>
+          </a:prstGeom>
+          <a:noFill/>
+        </p:spPr>
+        <p:txBody>
+          <a:bodyPr wrap="square">
+            <a:spAutoFit/>
+          </a:bodyPr>
+          <a:lstStyle/>
+          <a:p>
+            <a:pPr algn="l"/>
+            <a:r>
+              <a:rPr sz="1100" b="0" i="1">
+                <a:solidFill>
+                  <a:srgbClr val="8AA8C8"/>
+                </a:solidFill>
+              </a:rPr>
+              <a:t>Built for Ryan Koontz  ·  SVP of Sales</a:t>
+            </a:r>
+          </a:p>
+        </p:txBody>
+      </p:sp>
+      <p:sp>
+        <p:nvSpPr>
+          <p:cNvPr id="13" name="Rectangle 12"/>
+          <p:cNvSpPr/>
+          <p:nvPr/>
+        </p:nvSpPr>
+        <p:spPr>
+          <a:xfrm>
+            <a:off x="566928" y="3401568"/>
+            <a:ext cx="11055096" cy="18288"/>
+          </a:xfrm>
+          <a:prstGeom prst="rect">
+            <a:avLst/>
+          </a:prstGeom>
+          <a:solidFill>
+            <a:srgbClr val="1A3555"/>
+          </a:solidFill>
+          <a:ln>
+            <a:noFill/>
+          </a:ln>
+        </p:spPr>
+        <p:style>
+          <a:lnRef idx="1">
+            <a:schemeClr val="accent1"/>
+          </a:lnRef>
+          <a:fillRef idx="3">
+            <a:schemeClr val="accent1"/>
+          </a:fillRef>
+          <a:effectRef idx="2">
+            <a:schemeClr val="accent1"/>
+          </a:effectRef>
+          <a:fontRef idx="minor">
+            <a:schemeClr val="lt1"/>
+          </a:fontRef>
+        </p:style>
+        <p:txBody>
+          <a:bodyPr rtlCol="0" anchor="ctr"/>
+          <a:lstStyle/>
+          <a:p>
+            <a:pPr algn="ctr"/>
+          </a:p>
+        </p:txBody>
+      </p:sp>
+      <p:sp>
+        <p:nvSpPr>
+          <p:cNvPr id="14" name="TextBox 13"/>
+          <p:cNvSpPr txBox="1"/>
+          <p:nvPr/>
+        </p:nvSpPr>
+        <p:spPr>
+          <a:xfrm>
+            <a:off x="566928" y="3511296"/>
+            <a:ext cx="5486400" cy="475488"/>
+          </a:xfrm>
+          <a:prstGeom prst="rect">
+            <a:avLst/>
+          </a:prstGeom>
+          <a:noFill/>
+        </p:spPr>
+        <p:txBody>
+          <a:bodyPr wrap="square">
+            <a:spAutoFit/>
+          </a:bodyPr>
+          <a:lstStyle/>
+          <a:p>
+            <a:pPr algn="l"/>
+            <a:r>
+              <a:rPr sz="1100" b="1" i="0">
+                <a:solidFill>
+                  <a:srgbClr val="FFFFFF"/>
+                </a:solidFill>
+              </a:rPr>
+              <a:t>• TRACKING SALES TEAM ACTIVITY POINTS</a:t>
+            </a:r>
+          </a:p>
+        </p:txBody>
+      </p:sp>
+      <p:sp>
+        <p:nvSpPr>
+          <p:cNvPr id="15" name="TextBox 14"/>
+          <p:cNvSpPr txBox="1"/>
+          <p:nvPr/>
+        </p:nvSpPr>
+        <p:spPr>
+          <a:xfrm>
+            <a:off x="566928" y="4105656"/>
+            <a:ext cx="5486400" cy="475488"/>
+          </a:xfrm>
+          <a:prstGeom prst="rect">
+            <a:avLst/>
+          </a:prstGeom>
+          <a:noFill/>
+        </p:spPr>
+        <p:txBody>
+          <a:bodyPr wrap="square">
+            <a:spAutoFit/>
+          </a:bodyPr>
+          <a:lstStyle/>
+          <a:p>
+            <a:pPr algn="l"/>
+            <a:r>
+              <a:rPr sz="1100" b="1" i="0">
+                <a:solidFill>
+                  <a:srgbClr val="FFFFFF"/>
+                </a:solidFill>
+              </a:rPr>
+              <a:t>• RUNNING WEEKLY CALL BLITZES</a:t>
+            </a:r>
+          </a:p>
+        </p:txBody>
+      </p:sp>
+      <p:sp>
+        <p:nvSpPr>
+          <p:cNvPr id="16" name="TextBox 15"/>
+          <p:cNvSpPr txBox="1"/>
+          <p:nvPr/>
+        </p:nvSpPr>
+        <p:spPr>
+          <a:xfrm>
+            <a:off x="566928" y="4700016"/>
+            <a:ext cx="5486400" cy="475488"/>
+          </a:xfrm>
+          <a:prstGeom prst="rect">
+            <a:avLst/>
+          </a:prstGeom>
+          <a:noFill/>
+        </p:spPr>
+        <p:txBody>
+          <a:bodyPr wrap="square">
+            <a:spAutoFit/>
+          </a:bodyPr>
+          <a:lstStyle/>
+          <a:p>
+            <a:pPr algn="l"/>
+            <a:r>
+              <a:rPr sz="1100" b="1" i="0">
+                <a:solidFill>
+                  <a:srgbClr val="FFFFFF"/>
+                </a:solidFill>
+              </a:rPr>
+              <a:t>• RESEARCHING NEW PROSPECTS NOT IN CRM</a:t>
+            </a:r>
+          </a:p>
+        </p:txBody>
+      </p:sp>
+      <p:sp>
+        <p:nvSpPr>
+          <p:cNvPr id="17" name="TextBox 16"/>
+          <p:cNvSpPr txBox="1"/>
+          <p:nvPr/>
+        </p:nvSpPr>
+        <p:spPr>
+          <a:xfrm>
+            <a:off x="566928" y="5294376"/>
+            <a:ext cx="5486400" cy="475488"/>
+          </a:xfrm>
+          <a:prstGeom prst="rect">
+            <a:avLst/>
+          </a:prstGeom>
+          <a:noFill/>
+        </p:spPr>
+        <p:txBody>
+          <a:bodyPr wrap="square">
+            <a:spAutoFit/>
+          </a:bodyPr>
+          <a:lstStyle/>
+          <a:p>
+            <a:pPr algn="l"/>
+            <a:r>
+              <a:rPr sz="1100" b="1" i="0">
+                <a:solidFill>
+                  <a:srgbClr val="FFFFFF"/>
+                </a:solidFill>
+              </a:rPr>
+              <a:t>• BUILT COMPETITOR BATTLECARD DASHBOARD</a:t>
+            </a:r>
+          </a:p>
+        </p:txBody>
+      </p:sp>
+      <p:sp>
+        <p:nvSpPr>
+          <p:cNvPr id="18" name="TextBox 17"/>
+          <p:cNvSpPr txBox="1"/>
+          <p:nvPr/>
+        </p:nvSpPr>
+        <p:spPr>
+          <a:xfrm>
+            <a:off x="6400800" y="3511296"/>
+            <a:ext cx="5577840" cy="475488"/>
+          </a:xfrm>
+          <a:prstGeom prst="rect">
+            <a:avLst/>
+          </a:prstGeom>
+          <a:noFill/>
+        </p:spPr>
+        <p:txBody>
+          <a:bodyPr wrap="square">
+            <a:spAutoFit/>
+          </a:bodyPr>
+          <a:lstStyle/>
+          <a:p>
+            <a:pPr algn="l"/>
+            <a:r>
+              <a:rPr sz="1100" b="1" i="0">
+                <a:solidFill>
+                  <a:srgbClr val="FFFFFF"/>
+                </a:solidFill>
+              </a:rPr>
+              <a:t>• AUTOMATED WEEKLY FORECAST DECKS FOR ELT</a:t>
+            </a:r>
+          </a:p>
+        </p:txBody>
+      </p:sp>
+      <p:sp>
+        <p:nvSpPr>
+          <p:cNvPr id="19" name="TextBox 18"/>
+          <p:cNvSpPr txBox="1"/>
+          <p:nvPr/>
+        </p:nvSpPr>
+        <p:spPr>
+          <a:xfrm>
+            <a:off x="6400800" y="4105656"/>
+            <a:ext cx="5577840" cy="475488"/>
+          </a:xfrm>
+          <a:prstGeom prst="rect">
+            <a:avLst/>
+          </a:prstGeom>
+          <a:noFill/>
+        </p:spPr>
+        <p:txBody>
+          <a:bodyPr wrap="square">
+            <a:spAutoFit/>
+          </a:bodyPr>
+          <a:lstStyle/>
+          <a:p>
+            <a:pPr algn="l"/>
+            <a:r>
+              <a:rPr sz="1100" b="1" i="0">
+                <a:solidFill>
+                  <a:srgbClr val="FFFFFF"/>
+                </a:solidFill>
+              </a:rPr>
+              <a:t>• DISCOVERY NO-SHOW TREND ANALYSIS</a:t>
+            </a:r>
+          </a:p>
+        </p:txBody>
+      </p:sp>
+      <p:sp>
+        <p:nvSpPr>
+          <p:cNvPr id="20" name="TextBox 19"/>
+          <p:cNvSpPr txBox="1"/>
+          <p:nvPr/>
+        </p:nvSpPr>
+        <p:spPr>
+          <a:xfrm>
+            <a:off x="6400800" y="4700016"/>
+            <a:ext cx="5577840" cy="475488"/>
+          </a:xfrm>
+          <a:prstGeom prst="rect">
+            <a:avLst/>
+          </a:prstGeom>
+          <a:noFill/>
+        </p:spPr>
+        <p:txBody>
+          <a:bodyPr wrap="square">
+            <a:spAutoFit/>
+          </a:bodyPr>
+          <a:lstStyle/>
+          <a:p>
+            <a:pPr algn="l"/>
+            <a:r>
+              <a:rPr sz="1100" b="1" i="0">
+                <a:solidFill>
+                  <a:srgbClr val="FFFFFF"/>
+                </a:solidFill>
+              </a:rPr>
+              <a:t>• SOFTWARE MISSING CAPABILITIES DEEP DIVE</a:t>
+            </a:r>
+          </a:p>
+        </p:txBody>
+      </p:sp>
+      <p:sp>
+        <p:nvSpPr>
+          <p:cNvPr id="21" name="TextBox 20"/>
+          <p:cNvSpPr txBox="1"/>
+          <p:nvPr/>
+        </p:nvSpPr>
+        <p:spPr>
+          <a:xfrm>
+            <a:off x="6400800" y="5294376"/>
+            <a:ext cx="5577840" cy="475488"/>
+          </a:xfrm>
+          <a:prstGeom prst="rect">
+            <a:avLst/>
+          </a:prstGeom>
+          <a:noFill/>
+        </p:spPr>
+        <p:txBody>
+          <a:bodyPr wrap="square">
+            <a:spAutoFit/>
+          </a:bodyPr>
+          <a:lstStyle/>
+          <a:p>
+            <a:pPr algn="l"/>
+            <a:r>
+              <a:rPr sz="1100" b="1" i="0">
+                <a:solidFill>
+                  <a:srgbClr val="FFFFFF"/>
+                </a:solidFill>
+              </a:rPr>
+              <a:t>• MORNING BRIEFINGS &amp; PIPELINE INTELLIGENCE</a:t>
+            </a:r>
+          </a:p>
+        </p:txBody>
+      </p:sp>
+      <p:sp>
+        <p:nvSpPr>
+          <p:cNvPr id="22" name="Rectangle 21"/>
+          <p:cNvSpPr/>
+          <p:nvPr/>
+        </p:nvSpPr>
+        <p:spPr>
+          <a:xfrm>
+            <a:off x="0" y="6675120"/>
+            <a:ext cx="12188952" cy="182880"/>
+          </a:xfrm>
+          <a:prstGeom prst="rect">
+            <a:avLst/>
+          </a:prstGeom>
+          <a:solidFill>
+            <a:srgbClr val="071220"/>
+          </a:solidFill>
+          <a:ln>
+            <a:noFill/>
+          </a:ln>
+        </p:spPr>
+        <p:style>
+          <a:lnRef idx="1">
+            <a:schemeClr val="accent1"/>
+          </a:lnRef>
+          <a:fillRef idx="3">
+            <a:schemeClr val="accent1"/>
+          </a:fillRef>
+          <a:effectRef idx="2">
+            <a:schemeClr val="accent1"/>
+          </a:effectRef>
+          <a:fontRef idx="minor">
+            <a:schemeClr val="lt1"/>
+          </a:fontRef>
+        </p:style>
+        <p:txBody>
+          <a:bodyPr rtlCol="0" anchor="ctr"/>
+          <a:lstStyle/>
+          <a:p>
+            <a:pPr algn="ctr"/>
+          </a:p>
+        </p:txBody>
+      </p:sp>
+      <p:sp>
+        <p:nvSpPr>
+          <p:cNvPr id="23" name="TextBox 22"/>
+          <p:cNvSpPr txBox="1"/>
+          <p:nvPr/>
+        </p:nvSpPr>
+        <p:spPr>
+          <a:xfrm>
+            <a:off x="274320" y="6693408"/>
+            <a:ext cx="1828800" cy="146304"/>
+          </a:xfrm>
+          <a:prstGeom prst="rect">
+            <a:avLst/>
+          </a:prstGeom>
+          <a:noFill/>
+        </p:spPr>
+        <p:txBody>
+          <a:bodyPr wrap="square">
+            <a:spAutoFit/>
+          </a:bodyPr>
+          <a:lstStyle/>
+          <a:p>
+            <a:pPr algn="l"/>
+            <a:r>
+              <a:rPr sz="900" b="1" i="0">
+                <a:solidFill>
+                  <a:srgbClr val="FFFFFF"/>
+                </a:solidFill>
+              </a:rPr>
+              <a:t>• rev.io</a:t>
+            </a:r>
+          </a:p>
+        </p:txBody>
+      </p:sp>
+      <p:sp>
+        <p:nvSpPr>
+          <p:cNvPr id="24" name="TextBox 23"/>
+          <p:cNvSpPr txBox="1"/>
+          <p:nvPr/>
+        </p:nvSpPr>
+        <p:spPr>
+          <a:xfrm>
+            <a:off x="8686800" y="6693408"/>
+            <a:ext cx="2011680" cy="146304"/>
+          </a:xfrm>
+          <a:prstGeom prst="rect">
+            <a:avLst/>
+          </a:prstGeom>
+          <a:noFill/>
+        </p:spPr>
+        <p:txBody>
+          <a:bodyPr wrap="square">
+            <a:spAutoFit/>
+          </a:bodyPr>
+          <a:lstStyle/>
+          <a:p>
+            <a:pPr algn="r"/>
+            <a:r>
+              <a:rPr sz="900" b="1" i="0">
+                <a:solidFill>
+                  <a:srgbClr val="FFFFFF"/>
+                </a:solidFill>
+              </a:rPr>
+              <a:t>BUILT FOR TOMORROW.</a:t>
+            </a:r>
+          </a:p>
+        </p:txBody>
+      </p:sp>
+      <p:sp>
+        <p:nvSpPr>
+          <p:cNvPr id="25" name="TextBox 24"/>
+          <p:cNvSpPr txBox="1"/>
+          <p:nvPr/>
+        </p:nvSpPr>
+        <p:spPr>
+          <a:xfrm>
+            <a:off x="10698480" y="6693408"/>
+            <a:ext cx="1371600" cy="146304"/>
+          </a:xfrm>
+          <a:prstGeom prst="rect">
+            <a:avLst/>
+          </a:prstGeom>
+          <a:noFill/>
+        </p:spPr>
+        <p:txBody>
+          <a:bodyPr wrap="square">
+            <a:spAutoFit/>
+          </a:bodyPr>
+          <a:lstStyle/>
+          <a:p>
+            <a:pPr algn="r"/>
+            <a:r>
+              <a:rPr sz="900" b="1" i="0">
+                <a:solidFill>
+                  <a:srgbClr val="3DC570"/>
+                </a:solidFill>
+              </a:rPr>
+              <a:t>READY FOR TODAY.</a:t>
+            </a:r>
+          </a:p>
+        </p:txBody>
+      </p:sp>
+    </p:spTree>
+  </p:cSld>
+  <p:clrMapOvr>
+    <a:masterClrMapping/>
+  </p:clrMapOvr>
+</p:sld>
+</file>
+
+<file path=ppt/slides/slide2.xml><?xml version="1.0" encoding="utf-8"?>
+<p:sld xmlns:a="http://schemas.openxmlformats.org/drawingml/2006/main" xmlns:p="http://schemas.openxmlformats.org/presentationml/2006/main" xmlns:r="http://schemas.openxmlformats.org/officeDocument/2006/relationships">
+  <p:cSld>
+    <p:spTree>
+      <p:nvGrpSpPr>
+        <p:cNvPr id="1" name=""/>
+        <p:cNvGrpSpPr/>
+        <p:nvPr/>
+      </p:nvGrpSpPr>
+      <p:grpSpPr/>
+      <p:sp>
+        <p:nvSpPr>
+          <p:cNvPr id="2" name="TextBox 1"/>
+          <p:cNvSpPr txBox="1"/>
+          <p:nvPr/>
+        </p:nvSpPr>
+        <p:spPr>
+          <a:xfrm>
+            <a:off x="365760" y="164592"/>
+            <a:ext cx="11430000" cy="713232"/>
+          </a:xfrm>
+          <a:prstGeom prst="rect">
+            <a:avLst/>
+          </a:prstGeom>
+          <a:noFill/>
+        </p:spPr>
+        <p:txBody>
+          <a:bodyPr wrap="square">
+            <a:spAutoFit/>
+          </a:bodyPr>
+          <a:lstStyle/>
+          <a:p>
+            <a:pPr algn="l"/>
+            <a:r>
+              <a:rPr sz="4600" b="1" i="0">
+                <a:solidFill>
+                  <a:srgbClr val="FFFFFF"/>
+                </a:solidFill>
+              </a:rPr>
+              <a:t>Robin's Tool Stack</a:t>
+            </a:r>
+          </a:p>
+        </p:txBody>
+      </p:sp>
+      <p:sp>
+        <p:nvSpPr>
+          <p:cNvPr id="3" name="TextBox 2"/>
+          <p:cNvSpPr txBox="1"/>
+          <p:nvPr/>
+        </p:nvSpPr>
+        <p:spPr>
+          <a:xfrm>
+            <a:off x="365760" y="877824"/>
+            <a:ext cx="11430000" cy="310896"/>
+          </a:xfrm>
+          <a:prstGeom prst="rect">
+            <a:avLst/>
+          </a:prstGeom>
+          <a:noFill/>
+        </p:spPr>
+        <p:txBody>
+          <a:bodyPr wrap="square">
+            <a:spAutoFit/>
+          </a:bodyPr>
+          <a:lstStyle/>
+          <a:p>
+            <a:pPr algn="l"/>
+            <a:r>
+              <a:rPr sz="1300" b="0" i="0">
+                <a:solidFill>
+                  <a:srgbClr val="8AA8C8"/>
+                </a:solidFill>
+              </a:rPr>
+              <a:t>Integrated with best-in-class tools to automate sales workflows end-to-end.</a:t>
+            </a:r>
+          </a:p>
+        </p:txBody>
+      </p:sp>
+      <p:sp>
+        <p:nvSpPr>
+          <p:cNvPr id="4" name="Rectangle 3"/>
+          <p:cNvSpPr/>
+          <p:nvPr/>
+        </p:nvSpPr>
+        <p:spPr>
+          <a:xfrm>
+            <a:off x="365760" y="1298448"/>
+            <a:ext cx="11457432" cy="658368"/>
+          </a:xfrm>
+          <a:prstGeom prst="rect">
+            <a:avLst/>
+          </a:prstGeom>
+          <a:solidFill>
+            <a:srgbClr val="0A1E30"/>
+          </a:solidFill>
+          <a:ln>
+            <a:noFill/>
+          </a:ln>
+        </p:spPr>
+        <p:style>
+          <a:lnRef idx="1">
+            <a:schemeClr val="accent1"/>
+          </a:lnRef>
+          <a:fillRef idx="3">
+            <a:schemeClr val="accent1"/>
+          </a:fillRef>
+          <a:effectRef idx="2">
+            <a:schemeClr val="accent1"/>
+          </a:effectRef>
+          <a:fontRef idx="minor">
+            <a:schemeClr val="lt1"/>
+          </a:fontRef>
+        </p:style>
+        <p:txBody>
+          <a:bodyPr rtlCol="0" anchor="ctr"/>
+          <a:lstStyle/>
+          <a:p>
+            <a:pPr algn="ctr"/>
+          </a:p>
+        </p:txBody>
+      </p:sp>
+      <p:sp>
+        <p:nvSpPr>
+          <p:cNvPr id="5" name="Rectangle 4"/>
+          <p:cNvSpPr/>
+          <p:nvPr/>
+        </p:nvSpPr>
+        <p:spPr>
+          <a:xfrm>
+            <a:off x="365760" y="1298448"/>
+            <a:ext cx="45720" cy="658368"/>
+          </a:xfrm>
+          <a:prstGeom prst="rect">
+            <a:avLst/>
+          </a:prstGeom>
+          <a:solidFill>
+            <a:srgbClr val="00D4D4"/>
+          </a:solidFill>
+          <a:ln>
+            <a:noFill/>
+          </a:ln>
+        </p:spPr>
+        <p:style>
+          <a:lnRef idx="1">
+            <a:schemeClr val="accent1"/>
+          </a:lnRef>
+          <a:fillRef idx="3">
+            <a:schemeClr val="accent1"/>
+          </a:fillRef>
+          <a:effectRef idx="2">
+            <a:schemeClr val="accent1"/>
+          </a:effectRef>
+          <a:fontRef idx="minor">
+            <a:schemeClr val="lt1"/>
+          </a:fontRef>
+        </p:style>
+        <p:txBody>
+          <a:bodyPr rtlCol="0" anchor="ctr"/>
+          <a:lstStyle/>
+          <a:p>
+            <a:pPr algn="ctr"/>
+          </a:p>
+        </p:txBody>
+      </p:sp>
+      <p:sp>
+        <p:nvSpPr>
+          <p:cNvPr id="6" name="TextBox 5"/>
+          <p:cNvSpPr txBox="1"/>
+          <p:nvPr/>
+        </p:nvSpPr>
+        <p:spPr>
+          <a:xfrm>
+            <a:off x="502920" y="1335024"/>
+            <a:ext cx="3200400" cy="182880"/>
+          </a:xfrm>
+          <a:prstGeom prst="rect">
+            <a:avLst/>
+          </a:prstGeom>
+          <a:noFill/>
+        </p:spPr>
+        <p:txBody>
+          <a:bodyPr wrap="square">
+            <a:spAutoFit/>
+          </a:bodyPr>
+          <a:lstStyle/>
+          <a:p>
+            <a:pPr algn="l"/>
+            <a:r>
+              <a:rPr sz="800" b="1" i="0">
+                <a:solidFill>
+                  <a:srgbClr val="3DC570"/>
+                </a:solidFill>
+              </a:rPr>
+              <a:t>INTEGRATIONS</a:t>
+            </a:r>
+          </a:p>
+        </p:txBody>
+      </p:sp>
+      <p:sp>
+        <p:nvSpPr>
+          <p:cNvPr id="7" name="TextBox 6"/>
+          <p:cNvSpPr txBox="1"/>
+          <p:nvPr/>
+        </p:nvSpPr>
+        <p:spPr>
+          <a:xfrm>
+            <a:off x="502920" y="1517904"/>
+            <a:ext cx="11155680" cy="347472"/>
+          </a:xfrm>
+          <a:prstGeom prst="rect">
+            <a:avLst/>
+          </a:prstGeom>
+          <a:noFill/>
+        </p:spPr>
+        <p:txBody>
+          <a:bodyPr wrap="square">
+            <a:spAutoFit/>
+          </a:bodyPr>
+          <a:lstStyle/>
+          <a:p>
+            <a:pPr algn="l"/>
+            <a:r>
+              <a:rPr sz="1050" b="0" i="0">
+                <a:solidFill>
+                  <a:srgbClr val="FFFFFF"/>
+                </a:solidFill>
+              </a:rPr>
+              <a:t>Robin connects into Rev.io's existing tool stack — using AI to turn raw data and workflows into automated action at scale.</a:t>
+            </a:r>
+          </a:p>
+        </p:txBody>
+      </p:sp>
+      <p:sp>
+        <p:nvSpPr>
+          <p:cNvPr id="8" name="Rectangle 7"/>
+          <p:cNvSpPr/>
+          <p:nvPr/>
+        </p:nvSpPr>
+        <p:spPr>
+          <a:xfrm>
+            <a:off x="365760" y="2084831"/>
+            <a:ext cx="5623560" cy="4315968"/>
+          </a:xfrm>
+          <a:prstGeom prst="rect">
+            <a:avLst/>
+          </a:prstGeom>
+          <a:solidFill>
+            <a:srgbClr val="0A1E30"/>
+          </a:solidFill>
+          <a:ln>
+            <a:noFill/>
+          </a:ln>
+        </p:spPr>
+        <p:style>
+          <a:lnRef idx="1">
+            <a:schemeClr val="accent1"/>
+          </a:lnRef>
+          <a:fillRef idx="3">
+            <a:schemeClr val="accent1"/>
+          </a:fillRef>
+          <a:effectRef idx="2">
+            <a:schemeClr val="accent1"/>
+          </a:effectRef>
+          <a:fontRef idx="minor">
+            <a:schemeClr val="lt1"/>
+          </a:fontRef>
+        </p:style>
+        <p:txBody>
+          <a:bodyPr rtlCol="0" anchor="ctr"/>
+          <a:lstStyle/>
+          <a:p>
+            <a:pPr algn="ctr"/>
+          </a:p>
+        </p:txBody>
+      </p:sp>
+      <p:sp>
+        <p:nvSpPr>
+          <p:cNvPr id="9" name="Rectangle 8"/>
+          <p:cNvSpPr/>
+          <p:nvPr/>
+        </p:nvSpPr>
+        <p:spPr>
+          <a:xfrm>
+            <a:off x="365760" y="2084831"/>
+            <a:ext cx="45720" cy="4315968"/>
+          </a:xfrm>
+          <a:prstGeom prst="rect">
+            <a:avLst/>
+          </a:prstGeom>
+          <a:solidFill>
+            <a:srgbClr val="7C3AED"/>
+          </a:solidFill>
+          <a:ln>
+            <a:noFill/>
+          </a:ln>
+        </p:spPr>
+        <p:style>
+          <a:lnRef idx="1">
+            <a:schemeClr val="accent1"/>
+          </a:lnRef>
+          <a:fillRef idx="3">
+            <a:schemeClr val="accent1"/>
+          </a:fillRef>
+          <a:effectRef idx="2">
+            <a:schemeClr val="accent1"/>
+          </a:effectRef>
+          <a:fontRef idx="minor">
+            <a:schemeClr val="lt1"/>
+          </a:fontRef>
+        </p:style>
+        <p:txBody>
+          <a:bodyPr rtlCol="0" anchor="ctr"/>
+          <a:lstStyle/>
+          <a:p>
+            <a:pPr algn="ctr"/>
+          </a:p>
+        </p:txBody>
+      </p:sp>
+      <p:sp>
+        <p:nvSpPr>
+          <p:cNvPr id="10" name="TextBox 9"/>
+          <p:cNvSpPr txBox="1"/>
+          <p:nvPr/>
+        </p:nvSpPr>
+        <p:spPr>
+          <a:xfrm>
+            <a:off x="566928" y="2212848"/>
+            <a:ext cx="5029200" cy="502920"/>
+          </a:xfrm>
+          <a:prstGeom prst="rect">
+            <a:avLst/>
+          </a:prstGeom>
+          <a:noFill/>
+        </p:spPr>
+        <p:txBody>
+          <a:bodyPr wrap="square">
+            <a:spAutoFit/>
+          </a:bodyPr>
+          <a:lstStyle/>
+          <a:p>
+            <a:pPr algn="l"/>
+            <a:r>
+              <a:rPr sz="3400" b="1" i="0">
+                <a:solidFill>
+                  <a:srgbClr val="FFFFFF"/>
+                </a:solidFill>
+              </a:rPr>
+              <a:t>📓  Notion</a:t>
+            </a:r>
+          </a:p>
+        </p:txBody>
+      </p:sp>
+      <p:sp>
+        <p:nvSpPr>
+          <p:cNvPr id="11" name="TextBox 10"/>
+          <p:cNvSpPr txBox="1"/>
+          <p:nvPr/>
+        </p:nvSpPr>
+        <p:spPr>
+          <a:xfrm>
+            <a:off x="566928" y="2724911"/>
+            <a:ext cx="5212080" cy="274320"/>
+          </a:xfrm>
+          <a:prstGeom prst="rect">
+            <a:avLst/>
+          </a:prstGeom>
+          <a:noFill/>
+        </p:spPr>
+        <p:txBody>
+          <a:bodyPr wrap="square">
+            <a:spAutoFit/>
+          </a:bodyPr>
+          <a:lstStyle/>
+          <a:p>
+            <a:pPr algn="l"/>
+            <a:r>
+              <a:rPr sz="1300" b="0" i="0">
+                <a:solidFill>
+                  <a:srgbClr val="7C3AED"/>
+                </a:solidFill>
+              </a:rPr>
+              <a:t>AI-Powered Knowledge &amp; Workflow Automation</a:t>
+            </a:r>
+          </a:p>
+        </p:txBody>
+      </p:sp>
+      <p:sp>
+        <p:nvSpPr>
+          <p:cNvPr id="12" name="TextBox 11"/>
+          <p:cNvSpPr txBox="1"/>
+          <p:nvPr/>
+        </p:nvSpPr>
+        <p:spPr>
+          <a:xfrm>
+            <a:off x="566928" y="3017520"/>
+            <a:ext cx="5212080" cy="237744"/>
+          </a:xfrm>
+          <a:prstGeom prst="rect">
+            <a:avLst/>
+          </a:prstGeom>
+          <a:noFill/>
+        </p:spPr>
+        <p:txBody>
+          <a:bodyPr wrap="square">
+            <a:spAutoFit/>
+          </a:bodyPr>
+          <a:lstStyle/>
+          <a:p>
+            <a:pPr algn="l"/>
+            <a:r>
+              <a:rPr sz="1000" b="0" i="1">
+                <a:solidFill>
+                  <a:srgbClr val="8AA8C8"/>
+                </a:solidFill>
+              </a:rPr>
+              <a:t>Prospect research · Meeting intelligence · Follow-up</a:t>
+            </a:r>
+          </a:p>
+        </p:txBody>
+      </p:sp>
+      <p:sp>
+        <p:nvSpPr>
+          <p:cNvPr id="13" name="Rectangle 12"/>
+          <p:cNvSpPr/>
+          <p:nvPr/>
+        </p:nvSpPr>
+        <p:spPr>
+          <a:xfrm>
+            <a:off x="566928" y="3310128"/>
+            <a:ext cx="5221224" cy="18288"/>
+          </a:xfrm>
+          <a:prstGeom prst="rect">
+            <a:avLst/>
+          </a:prstGeom>
+          <a:solidFill>
+            <a:srgbClr val="1A3555"/>
+          </a:solidFill>
+          <a:ln>
+            <a:noFill/>
+          </a:ln>
+        </p:spPr>
+        <p:style>
+          <a:lnRef idx="1">
+            <a:schemeClr val="accent1"/>
+          </a:lnRef>
+          <a:fillRef idx="3">
+            <a:schemeClr val="accent1"/>
+          </a:fillRef>
+          <a:effectRef idx="2">
+            <a:schemeClr val="accent1"/>
+          </a:effectRef>
+          <a:fontRef idx="minor">
+            <a:schemeClr val="lt1"/>
+          </a:fontRef>
+        </p:style>
+        <p:txBody>
+          <a:bodyPr rtlCol="0" anchor="ctr"/>
+          <a:lstStyle/>
+          <a:p>
+            <a:pPr algn="ctr"/>
+          </a:p>
+        </p:txBody>
+      </p:sp>
+      <p:sp>
+        <p:nvSpPr>
+          <p:cNvPr id="14" name="TextBox 13"/>
+          <p:cNvSpPr txBox="1"/>
+          <p:nvPr/>
+        </p:nvSpPr>
+        <p:spPr>
+          <a:xfrm>
+            <a:off x="566928" y="3438144"/>
+            <a:ext cx="5212080" cy="237744"/>
+          </a:xfrm>
+          <a:prstGeom prst="rect">
+            <a:avLst/>
+          </a:prstGeom>
+          <a:noFill/>
+        </p:spPr>
+        <p:txBody>
+          <a:bodyPr wrap="square">
+            <a:spAutoFit/>
+          </a:bodyPr>
+          <a:lstStyle/>
+          <a:p>
+            <a:pPr algn="l"/>
+            <a:r>
+              <a:rPr sz="1050" b="1" i="0">
+                <a:solidFill>
+                  <a:srgbClr val="FFFFFF"/>
+                </a:solidFill>
+              </a:rPr>
+              <a:t>• MSP EMAIL PERSONALIZATION AT SCALE</a:t>
+            </a:r>
+          </a:p>
+        </p:txBody>
+      </p:sp>
+      <p:sp>
+        <p:nvSpPr>
+          <p:cNvPr id="15" name="TextBox 14"/>
+          <p:cNvSpPr txBox="1"/>
+          <p:nvPr/>
+        </p:nvSpPr>
+        <p:spPr>
+          <a:xfrm>
+            <a:off x="694944" y="3694176"/>
+            <a:ext cx="5074920" cy="347472"/>
+          </a:xfrm>
+          <a:prstGeom prst="rect">
+            <a:avLst/>
+          </a:prstGeom>
+          <a:noFill/>
+        </p:spPr>
+        <p:txBody>
+          <a:bodyPr wrap="square">
+            <a:spAutoFit/>
+          </a:bodyPr>
+          <a:lstStyle/>
+          <a:p>
+            <a:pPr algn="l"/>
+            <a:r>
+              <a:rPr sz="950" b="0" i="0">
+                <a:solidFill>
+                  <a:srgbClr val="8AA8C8"/>
+                </a:solidFill>
+              </a:rPr>
+              <a:t>Researches each prospect and writes personalized outreach automatically — no manual prep.</a:t>
+            </a:r>
+          </a:p>
+        </p:txBody>
+      </p:sp>
+      <p:sp>
+        <p:nvSpPr>
+          <p:cNvPr id="16" name="TextBox 15"/>
+          <p:cNvSpPr txBox="1"/>
+          <p:nvPr/>
+        </p:nvSpPr>
+        <p:spPr>
+          <a:xfrm>
+            <a:off x="566928" y="4352544"/>
+            <a:ext cx="5212080" cy="237744"/>
+          </a:xfrm>
+          <a:prstGeom prst="rect">
+            <a:avLst/>
+          </a:prstGeom>
+          <a:noFill/>
+        </p:spPr>
+        <p:txBody>
+          <a:bodyPr wrap="square">
+            <a:spAutoFit/>
+          </a:bodyPr>
+          <a:lstStyle/>
+          <a:p>
+            <a:pPr algn="l"/>
+            <a:r>
+              <a:rPr sz="1050" b="1" i="0">
+                <a:solidFill>
+                  <a:srgbClr val="FFFFFF"/>
+                </a:solidFill>
+              </a:rPr>
+              <a:t>• MEETING NOTE-TAKING &amp; TRANSCRIPTION</a:t>
+            </a:r>
+          </a:p>
+        </p:txBody>
+      </p:sp>
+      <p:sp>
+        <p:nvSpPr>
+          <p:cNvPr id="17" name="TextBox 16"/>
+          <p:cNvSpPr txBox="1"/>
+          <p:nvPr/>
+        </p:nvSpPr>
+        <p:spPr>
+          <a:xfrm>
+            <a:off x="694944" y="4608576"/>
+            <a:ext cx="5074920" cy="347472"/>
+          </a:xfrm>
+          <a:prstGeom prst="rect">
+            <a:avLst/>
+          </a:prstGeom>
+          <a:noFill/>
+        </p:spPr>
+        <p:txBody>
+          <a:bodyPr wrap="square">
+            <a:spAutoFit/>
+          </a:bodyPr>
+          <a:lstStyle/>
+          <a:p>
+            <a:pPr algn="l"/>
+            <a:r>
+              <a:rPr sz="950" b="0" i="0">
+                <a:solidFill>
+                  <a:srgbClr val="8AA8C8"/>
+                </a:solidFill>
+              </a:rPr>
+              <a:t>Captures full meeting notes, key takeaways, and action items from every prospect call.</a:t>
+            </a:r>
+          </a:p>
+        </p:txBody>
+      </p:sp>
+      <p:sp>
+        <p:nvSpPr>
+          <p:cNvPr id="18" name="TextBox 17"/>
+          <p:cNvSpPr txBox="1"/>
+          <p:nvPr/>
+        </p:nvSpPr>
+        <p:spPr>
+          <a:xfrm>
+            <a:off x="566928" y="5266944"/>
+            <a:ext cx="5212080" cy="237744"/>
+          </a:xfrm>
+          <a:prstGeom prst="rect">
+            <a:avLst/>
+          </a:prstGeom>
+          <a:noFill/>
+        </p:spPr>
+        <p:txBody>
+          <a:bodyPr wrap="square">
+            <a:spAutoFit/>
+          </a:bodyPr>
+          <a:lstStyle/>
+          <a:p>
+            <a:pPr algn="l"/>
+            <a:r>
+              <a:rPr sz="1050" b="1" i="0">
+                <a:solidFill>
+                  <a:srgbClr val="FFFFFF"/>
+                </a:solidFill>
+              </a:rPr>
+              <a:t>• POST-MEETING FOLLOW-UP EMAILS</a:t>
+            </a:r>
+          </a:p>
+        </p:txBody>
+      </p:sp>
+      <p:sp>
+        <p:nvSpPr>
+          <p:cNvPr id="19" name="TextBox 18"/>
+          <p:cNvSpPr txBox="1"/>
+          <p:nvPr/>
+        </p:nvSpPr>
+        <p:spPr>
+          <a:xfrm>
+            <a:off x="694944" y="5522976"/>
+            <a:ext cx="5074920" cy="347472"/>
+          </a:xfrm>
+          <a:prstGeom prst="rect">
+            <a:avLst/>
+          </a:prstGeom>
+          <a:noFill/>
+        </p:spPr>
+        <p:txBody>
+          <a:bodyPr wrap="square">
+            <a:spAutoFit/>
+          </a:bodyPr>
+          <a:lstStyle/>
+          <a:p>
+            <a:pPr algn="l"/>
+            <a:r>
+              <a:rPr sz="950" b="0" i="0">
+                <a:solidFill>
+                  <a:srgbClr val="8AA8C8"/>
+                </a:solidFill>
+              </a:rPr>
+              <a:t>Generates tailored follow-up emails and action item summaries immediately after each call.</a:t>
+            </a:r>
+          </a:p>
+        </p:txBody>
+      </p:sp>
+      <p:sp>
+        <p:nvSpPr>
+          <p:cNvPr id="20" name="Rectangle 19"/>
+          <p:cNvSpPr/>
+          <p:nvPr/>
+        </p:nvSpPr>
+        <p:spPr>
+          <a:xfrm>
+            <a:off x="6199632" y="2084831"/>
+            <a:ext cx="5623560" cy="4315968"/>
+          </a:xfrm>
+          <a:prstGeom prst="rect">
+            <a:avLst/>
+          </a:prstGeom>
+          <a:solidFill>
+            <a:srgbClr val="0A1E30"/>
+          </a:solidFill>
+          <a:ln>
+            <a:noFill/>
+          </a:ln>
+        </p:spPr>
+        <p:style>
+          <a:lnRef idx="1">
+            <a:schemeClr val="accent1"/>
+          </a:lnRef>
+          <a:fillRef idx="3">
+            <a:schemeClr val="accent1"/>
+          </a:fillRef>
+          <a:effectRef idx="2">
+            <a:schemeClr val="accent1"/>
+          </a:effectRef>
+          <a:fontRef idx="minor">
+            <a:schemeClr val="lt1"/>
+          </a:fontRef>
+        </p:style>
+        <p:txBody>
+          <a:bodyPr rtlCol="0" anchor="ctr"/>
+          <a:lstStyle/>
+          <a:p>
+            <a:pPr algn="ctr"/>
+          </a:p>
+        </p:txBody>
+      </p:sp>
+      <p:sp>
+        <p:nvSpPr>
+          <p:cNvPr id="21" name="Rectangle 20"/>
+          <p:cNvSpPr/>
+          <p:nvPr/>
+        </p:nvSpPr>
+        <p:spPr>
+          <a:xfrm>
+            <a:off x="6199632" y="2084831"/>
+            <a:ext cx="45720" cy="4315968"/>
+          </a:xfrm>
+          <a:prstGeom prst="rect">
+            <a:avLst/>
+          </a:prstGeom>
+          <a:solidFill>
+            <a:srgbClr val="F57C2A"/>
+          </a:solidFill>
+          <a:ln>
+            <a:noFill/>
+          </a:ln>
+        </p:spPr>
+        <p:style>
+          <a:lnRef idx="1">
+            <a:schemeClr val="accent1"/>
+          </a:lnRef>
+          <a:fillRef idx="3">
+            <a:schemeClr val="accent1"/>
+          </a:fillRef>
+          <a:effectRef idx="2">
+            <a:schemeClr val="accent1"/>
+          </a:effectRef>
+          <a:fontRef idx="minor">
+            <a:schemeClr val="lt1"/>
+          </a:fontRef>
+        </p:style>
+        <p:txBody>
+          <a:bodyPr rtlCol="0" anchor="ctr"/>
+          <a:lstStyle/>
+          <a:p>
+            <a:pPr algn="ctr"/>
+          </a:p>
+        </p:txBody>
+      </p:sp>
+      <p:sp>
+        <p:nvSpPr>
+          <p:cNvPr id="22" name="TextBox 21"/>
+          <p:cNvSpPr txBox="1"/>
+          <p:nvPr/>
+        </p:nvSpPr>
+        <p:spPr>
+          <a:xfrm>
+            <a:off x="6400800" y="2212848"/>
+            <a:ext cx="5029200" cy="502920"/>
+          </a:xfrm>
+          <a:prstGeom prst="rect">
+            <a:avLst/>
+          </a:prstGeom>
+          <a:noFill/>
+        </p:spPr>
+        <p:txBody>
+          <a:bodyPr wrap="square">
+            <a:spAutoFit/>
+          </a:bodyPr>
+          <a:lstStyle/>
+          <a:p>
+            <a:pPr algn="l"/>
+            <a:r>
+              <a:rPr sz="3400" b="1" i="0">
+                <a:solidFill>
+                  <a:srgbClr val="FFFFFF"/>
+                </a:solidFill>
+              </a:rPr>
+              <a:t>🏗️  Clay</a:t>
+            </a:r>
+          </a:p>
+        </p:txBody>
+      </p:sp>
+      <p:sp>
+        <p:nvSpPr>
+          <p:cNvPr id="23" name="TextBox 22"/>
+          <p:cNvSpPr txBox="1"/>
+          <p:nvPr/>
+        </p:nvSpPr>
+        <p:spPr>
+          <a:xfrm>
+            <a:off x="6400800" y="2724911"/>
+            <a:ext cx="5212080" cy="274320"/>
+          </a:xfrm>
+          <a:prstGeom prst="rect">
+            <a:avLst/>
+          </a:prstGeom>
+          <a:noFill/>
+        </p:spPr>
+        <p:txBody>
+          <a:bodyPr wrap="square">
+            <a:spAutoFit/>
+          </a:bodyPr>
+          <a:lstStyle/>
+          <a:p>
+            <a:pPr algn="l"/>
+            <a:r>
+              <a:rPr sz="1300" b="0" i="0">
+                <a:solidFill>
+                  <a:srgbClr val="F57C2A"/>
+                </a:solidFill>
+              </a:rPr>
+              <a:t>Custom AI Agent for Data Intelligence</a:t>
+            </a:r>
+          </a:p>
+        </p:txBody>
+      </p:sp>
+      <p:sp>
+        <p:nvSpPr>
+          <p:cNvPr id="24" name="TextBox 23"/>
+          <p:cNvSpPr txBox="1"/>
+          <p:nvPr/>
+        </p:nvSpPr>
+        <p:spPr>
+          <a:xfrm>
+            <a:off x="6400800" y="3017520"/>
+            <a:ext cx="5212080" cy="237744"/>
+          </a:xfrm>
+          <a:prstGeom prst="rect">
+            <a:avLst/>
+          </a:prstGeom>
+          <a:noFill/>
+        </p:spPr>
+        <p:txBody>
+          <a:bodyPr wrap="square">
+            <a:spAutoFit/>
+          </a:bodyPr>
+          <a:lstStyle/>
+          <a:p>
+            <a:pPr algn="l"/>
+            <a:r>
+              <a:rPr sz="1000" b="0" i="1">
+                <a:solidFill>
+                  <a:srgbClr val="8AA8C8"/>
+                </a:solidFill>
+              </a:rPr>
+              <a:t>Prospect enrichment · CRM data hygiene · Verification</a:t>
+            </a:r>
+          </a:p>
+        </p:txBody>
+      </p:sp>
+      <p:sp>
+        <p:nvSpPr>
+          <p:cNvPr id="25" name="Rectangle 24"/>
+          <p:cNvSpPr/>
+          <p:nvPr/>
+        </p:nvSpPr>
+        <p:spPr>
+          <a:xfrm>
+            <a:off x="6400800" y="3310128"/>
+            <a:ext cx="5221224" cy="18288"/>
+          </a:xfrm>
+          <a:prstGeom prst="rect">
+            <a:avLst/>
+          </a:prstGeom>
+          <a:solidFill>
+            <a:srgbClr val="1A3555"/>
+          </a:solidFill>
+          <a:ln>
+            <a:noFill/>
+          </a:ln>
+        </p:spPr>
+        <p:style>
+          <a:lnRef idx="1">
+            <a:schemeClr val="accent1"/>
+          </a:lnRef>
+          <a:fillRef idx="3">
+            <a:schemeClr val="accent1"/>
+          </a:fillRef>
+          <a:effectRef idx="2">
+            <a:schemeClr val="accent1"/>
+          </a:effectRef>
+          <a:fontRef idx="minor">
+            <a:schemeClr val="lt1"/>
+          </a:fontRef>
+        </p:style>
+        <p:txBody>
+          <a:bodyPr rtlCol="0" anchor="ctr"/>
+          <a:lstStyle/>
+          <a:p>
+            <a:pPr algn="ctr"/>
+          </a:p>
+        </p:txBody>
+      </p:sp>
+      <p:sp>
+        <p:nvSpPr>
+          <p:cNvPr id="26" name="TextBox 25"/>
+          <p:cNvSpPr txBox="1"/>
+          <p:nvPr/>
+        </p:nvSpPr>
+        <p:spPr>
+          <a:xfrm>
+            <a:off x="6400800" y="3438144"/>
+            <a:ext cx="5212080" cy="256032"/>
+          </a:xfrm>
+          <a:prstGeom prst="rect">
+            <a:avLst/>
+          </a:prstGeom>
+          <a:noFill/>
+        </p:spPr>
+        <p:txBody>
+          <a:bodyPr wrap="square">
+            <a:spAutoFit/>
+          </a:bodyPr>
+          <a:lstStyle/>
+          <a:p>
+            <a:pPr algn="l"/>
+            <a:r>
+              <a:rPr sz="1050" b="1" i="0">
+                <a:solidFill>
+                  <a:srgbClr val="FFFFFF"/>
+                </a:solidFill>
+              </a:rPr>
+              <a:t>• CUSTOM AGENT: PROSPECT INDUSTRY VERIFICATION</a:t>
+            </a:r>
+          </a:p>
+        </p:txBody>
+      </p:sp>
+      <p:sp>
+        <p:nvSpPr>
+          <p:cNvPr id="27" name="TextBox 26"/>
+          <p:cNvSpPr txBox="1"/>
+          <p:nvPr/>
+        </p:nvSpPr>
+        <p:spPr>
+          <a:xfrm>
+            <a:off x="6528816" y="3712463"/>
+            <a:ext cx="5074920" cy="457200"/>
+          </a:xfrm>
+          <a:prstGeom prst="rect">
+            <a:avLst/>
+          </a:prstGeom>
+          <a:noFill/>
+        </p:spPr>
+        <p:txBody>
+          <a:bodyPr wrap="square">
+            <a:spAutoFit/>
+          </a:bodyPr>
+          <a:lstStyle/>
+          <a:p>
+            <a:pPr algn="l"/>
+            <a:r>
+              <a:rPr sz="950" b="0" i="0">
+                <a:solidFill>
+                  <a:srgbClr val="8AA8C8"/>
+                </a:solidFill>
+              </a:rPr>
+              <a:t>Built a custom AI agent to verify and correct the industry field on prospect accounts in Salesforce.</a:t>
+            </a:r>
+          </a:p>
+        </p:txBody>
+      </p:sp>
+      <p:sp>
+        <p:nvSpPr>
+          <p:cNvPr id="28" name="TextBox 27"/>
+          <p:cNvSpPr txBox="1"/>
+          <p:nvPr/>
+        </p:nvSpPr>
+        <p:spPr>
+          <a:xfrm>
+            <a:off x="6400800" y="4443983"/>
+            <a:ext cx="5212080" cy="256032"/>
+          </a:xfrm>
+          <a:prstGeom prst="rect">
+            <a:avLst/>
+          </a:prstGeom>
+          <a:noFill/>
+        </p:spPr>
+        <p:txBody>
+          <a:bodyPr wrap="square">
+            <a:spAutoFit/>
+          </a:bodyPr>
+          <a:lstStyle/>
+          <a:p>
+            <a:pPr algn="l"/>
+            <a:r>
+              <a:rPr sz="1050" b="1" i="0">
+                <a:solidFill>
+                  <a:srgbClr val="FFFFFF"/>
+                </a:solidFill>
+              </a:rPr>
+              <a:t>• FOUND 11K INCORRECTLY TAGGED ACCOUNTS</a:t>
+            </a:r>
+          </a:p>
+        </p:txBody>
+      </p:sp>
+      <p:sp>
+        <p:nvSpPr>
+          <p:cNvPr id="29" name="TextBox 28"/>
+          <p:cNvSpPr txBox="1"/>
+          <p:nvPr/>
+        </p:nvSpPr>
+        <p:spPr>
+          <a:xfrm>
+            <a:off x="6528816" y="4718303"/>
+            <a:ext cx="5074920" cy="457200"/>
+          </a:xfrm>
+          <a:prstGeom prst="rect">
+            <a:avLst/>
+          </a:prstGeom>
+          <a:noFill/>
+        </p:spPr>
+        <p:txBody>
+          <a:bodyPr wrap="square">
+            <a:spAutoFit/>
+          </a:bodyPr>
+          <a:lstStyle/>
+          <a:p>
+            <a:pPr algn="l"/>
+            <a:r>
+              <a:rPr sz="950" b="0" i="0">
+                <a:solidFill>
+                  <a:srgbClr val="8AA8C8"/>
+                </a:solidFill>
+              </a:rPr>
+              <a:t>Identified 11,000+ accounts incorrectly marked as MSPs in the CRM — cleaning the foundation for better targeting.</a:t>
+            </a:r>
+          </a:p>
+        </p:txBody>
+      </p:sp>
+      <p:sp>
+        <p:nvSpPr>
+          <p:cNvPr id="30" name="Rectangle 29"/>
+          <p:cNvSpPr/>
+          <p:nvPr/>
+        </p:nvSpPr>
+        <p:spPr>
+          <a:xfrm>
+            <a:off x="0" y="6675120"/>
+            <a:ext cx="12188952" cy="182880"/>
+          </a:xfrm>
+          <a:prstGeom prst="rect">
+            <a:avLst/>
+          </a:prstGeom>
+          <a:solidFill>
+            <a:srgbClr val="071220"/>
+          </a:solidFill>
+          <a:ln>
+            <a:noFill/>
+          </a:ln>
+        </p:spPr>
+        <p:style>
+          <a:lnRef idx="1">
+            <a:schemeClr val="accent1"/>
+          </a:lnRef>
+          <a:fillRef idx="3">
+            <a:schemeClr val="accent1"/>
+          </a:fillRef>
+          <a:effectRef idx="2">
+            <a:schemeClr val="accent1"/>
+          </a:effectRef>
+          <a:fontRef idx="minor">
+            <a:schemeClr val="lt1"/>
+          </a:fontRef>
+        </p:style>
+        <p:txBody>
+          <a:bodyPr rtlCol="0" anchor="ctr"/>
+          <a:lstStyle/>
+          <a:p>
+            <a:pPr algn="ctr"/>
+          </a:p>
+        </p:txBody>
+      </p:sp>
+      <p:sp>
+        <p:nvSpPr>
+          <p:cNvPr id="31" name="TextBox 30"/>
+          <p:cNvSpPr txBox="1"/>
+          <p:nvPr/>
+        </p:nvSpPr>
+        <p:spPr>
+          <a:xfrm>
+            <a:off x="274320" y="6693408"/>
+            <a:ext cx="1828800" cy="146304"/>
+          </a:xfrm>
+          <a:prstGeom prst="rect">
+            <a:avLst/>
+          </a:prstGeom>
+          <a:noFill/>
+        </p:spPr>
+        <p:txBody>
+          <a:bodyPr wrap="square">
+            <a:spAutoFit/>
+          </a:bodyPr>
+          <a:lstStyle/>
+          <a:p>
+            <a:pPr algn="l"/>
+            <a:r>
+              <a:rPr sz="900" b="1" i="0">
+                <a:solidFill>
+                  <a:srgbClr val="FFFFFF"/>
+                </a:solidFill>
+              </a:rPr>
+              <a:t>• rev.io</a:t>
+            </a:r>
+          </a:p>
+        </p:txBody>
+      </p:sp>
+      <p:sp>
+        <p:nvSpPr>
+          <p:cNvPr id="32" name="TextBox 31"/>
+          <p:cNvSpPr txBox="1"/>
+          <p:nvPr/>
+        </p:nvSpPr>
+        <p:spPr>
+          <a:xfrm>
+            <a:off x="8686800" y="6693408"/>
+            <a:ext cx="2011680" cy="146304"/>
+          </a:xfrm>
+          <a:prstGeom prst="rect">
+            <a:avLst/>
+          </a:prstGeom>
+          <a:noFill/>
+        </p:spPr>
+        <p:txBody>
+          <a:bodyPr wrap="square">
+            <a:spAutoFit/>
+          </a:bodyPr>
+          <a:lstStyle/>
+          <a:p>
+            <a:pPr algn="r"/>
+            <a:r>
+              <a:rPr sz="900" b="1" i="0">
+                <a:solidFill>
+                  <a:srgbClr val="FFFFFF"/>
+                </a:solidFill>
+              </a:rPr>
+              <a:t>BUILT FOR TOMORROW.</a:t>
+            </a:r>
+          </a:p>
+        </p:txBody>
+      </p:sp>
+      <p:sp>
+        <p:nvSpPr>
+          <p:cNvPr id="33" name="TextBox 32"/>
+          <p:cNvSpPr txBox="1"/>
+          <p:nvPr/>
+        </p:nvSpPr>
+        <p:spPr>
+          <a:xfrm>
+            <a:off x="10698480" y="6693408"/>
+            <a:ext cx="1371600" cy="146304"/>
+          </a:xfrm>
+          <a:prstGeom prst="rect">
+            <a:avLst/>
+          </a:prstGeom>
+          <a:noFill/>
+        </p:spPr>
+        <p:txBody>
+          <a:bodyPr wrap="square">
+            <a:spAutoFit/>
+          </a:bodyPr>
+          <a:lstStyle/>
+          <a:p>
+            <a:pPr algn="r"/>
+            <a:r>
+              <a:rPr sz="900" b="1" i="0">
+                <a:solidFill>
+                  <a:srgbClr val="3DC570"/>
+                </a:solidFill>
+              </a:rPr>
+              <a:t>READY FOR TODAY.</a:t>
+            </a:r>
+          </a:p>
+        </p:txBody>
+      </p:sp>
+    </p:spTree>
+  </p:cSld>
+  <p:clrMapOvr>
+    <a:masterClrMapping/>
+  </p:clrMapOvr>
+</p:sld>
+</file>
+
+<file path=ppt/slides/slide2.xml><?xml version="1.0" encoding="utf-8"?>
+<p:sld xmlns:a="http://schemas.openxmlformats.org/drawingml/2006/main" xmlns:p="http://schemas.openxmlformats.org/presentationml/2006/main" xmlns:r="http://schemas.openxmlformats.org/officeDocument/2006/relationships">
+  <p:cSld>
+    <p:spTree>
+      <p:nvGrpSpPr>
+        <p:cNvPr id="1" name=""/>
+        <p:cNvGrpSpPr/>
+        <p:nvPr/>
+      </p:nvGrpSpPr>
+      <p:grpSpPr/>
+      <p:sp>
+        <p:nvSpPr>
+          <p:cNvPr id="2" name="TextBox 1"/>
+          <p:cNvSpPr txBox="1"/>
+          <p:nvPr/>
+        </p:nvSpPr>
+        <p:spPr>
+          <a:xfrm>
+            <a:off x="365760" y="164592"/>
+            <a:ext cx="11430000" cy="713232"/>
+          </a:xfrm>
+          <a:prstGeom prst="rect">
+            <a:avLst/>
+          </a:prstGeom>
+          <a:noFill/>
+        </p:spPr>
+        <p:txBody>
+          <a:bodyPr wrap="square">
+            <a:spAutoFit/>
+          </a:bodyPr>
+          <a:lstStyle/>
+          <a:p>
+            <a:pPr algn="l"/>
+            <a:r>
+              <a:rPr sz="4600" b="1" i="0">
+                <a:solidFill>
+                  <a:srgbClr val="FFFFFF"/>
+                </a:solidFill>
+              </a:rPr>
+              <a:t>Robin's Tool Stack</a:t>
+            </a:r>
+          </a:p>
+        </p:txBody>
+      </p:sp>
+      <p:sp>
+        <p:nvSpPr>
+          <p:cNvPr id="3" name="TextBox 2"/>
+          <p:cNvSpPr txBox="1"/>
+          <p:nvPr/>
+        </p:nvSpPr>
+        <p:spPr>
+          <a:xfrm>
+            <a:off x="365760" y="877824"/>
+            <a:ext cx="11430000" cy="310896"/>
+          </a:xfrm>
+          <a:prstGeom prst="rect">
+            <a:avLst/>
+          </a:prstGeom>
+          <a:noFill/>
+        </p:spPr>
+        <p:txBody>
+          <a:bodyPr wrap="square">
+            <a:spAutoFit/>
+          </a:bodyPr>
+          <a:lstStyle/>
+          <a:p>
+            <a:pPr algn="l"/>
+            <a:r>
+              <a:rPr sz="1300" b="0" i="0">
+                <a:solidFill>
+                  <a:srgbClr val="8AA8C8"/>
+                </a:solidFill>
+              </a:rPr>
+              <a:t>Integrated with best-in-class tools to automate sales workflows end-to-end.</a:t>
+            </a:r>
+          </a:p>
+        </p:txBody>
+      </p:sp>
+      <p:sp>
+        <p:nvSpPr>
+          <p:cNvPr id="4" name="Rectangle 3"/>
+          <p:cNvSpPr/>
+          <p:nvPr/>
+        </p:nvSpPr>
+        <p:spPr>
+          <a:xfrm>
+            <a:off x="365760" y="1298448"/>
+            <a:ext cx="11457432" cy="658368"/>
+          </a:xfrm>
+          <a:prstGeom prst="rect">
+            <a:avLst/>
+          </a:prstGeom>
+          <a:solidFill>
+            <a:srgbClr val="0A1E30"/>
+          </a:solidFill>
+          <a:ln>
+            <a:noFill/>
+          </a:ln>
+        </p:spPr>
+        <p:style>
+          <a:lnRef idx="1">
+            <a:schemeClr val="accent1"/>
+          </a:lnRef>
+          <a:fillRef idx="3">
+            <a:schemeClr val="accent1"/>
+          </a:fillRef>
+          <a:effectRef idx="2">
+            <a:schemeClr val="accent1"/>
+          </a:effectRef>
+          <a:fontRef idx="minor">
+            <a:schemeClr val="lt1"/>
+          </a:fontRef>
+        </p:style>
+        <p:txBody>
+          <a:bodyPr rtlCol="0" anchor="ctr"/>
+          <a:lstStyle/>
+          <a:p>
+            <a:pPr algn="ctr"/>
+          </a:p>
+        </p:txBody>
+      </p:sp>
+      <p:sp>
+        <p:nvSpPr>
+          <p:cNvPr id="5" name="Rectangle 4"/>
+          <p:cNvSpPr/>
+          <p:nvPr/>
+        </p:nvSpPr>
+        <p:spPr>
+          <a:xfrm>
+            <a:off x="365760" y="1298448"/>
+            <a:ext cx="45720" cy="658368"/>
+          </a:xfrm>
+          <a:prstGeom prst="rect">
+            <a:avLst/>
+          </a:prstGeom>
+          <a:solidFill>
+            <a:srgbClr val="00D4D4"/>
+          </a:solidFill>
+          <a:ln>
+            <a:noFill/>
+          </a:ln>
+        </p:spPr>
+        <p:style>
+          <a:lnRef idx="1">
+            <a:schemeClr val="accent1"/>
+          </a:lnRef>
+          <a:fillRef idx="3">
+            <a:schemeClr val="accent1"/>
+          </a:fillRef>
+          <a:effectRef idx="2">
+            <a:schemeClr val="accent1"/>
+          </a:effectRef>
+          <a:fontRef idx="minor">
+            <a:schemeClr val="lt1"/>
+          </a:fontRef>
+        </p:style>
+        <p:txBody>
+          <a:bodyPr rtlCol="0" anchor="ctr"/>
+          <a:lstStyle/>
+          <a:p>
+            <a:pPr algn="ctr"/>
+          </a:p>
+        </p:txBody>
+      </p:sp>
+      <p:sp>
+        <p:nvSpPr>
+          <p:cNvPr id="6" name="TextBox 5"/>
+          <p:cNvSpPr txBox="1"/>
+          <p:nvPr/>
+        </p:nvSpPr>
+        <p:spPr>
+          <a:xfrm>
+            <a:off x="502920" y="1335024"/>
+            <a:ext cx="3200400" cy="182880"/>
+          </a:xfrm>
+          <a:prstGeom prst="rect">
+            <a:avLst/>
+          </a:prstGeom>
+          <a:noFill/>
+        </p:spPr>
+        <p:txBody>
+          <a:bodyPr wrap="square">
+            <a:spAutoFit/>
+          </a:bodyPr>
+          <a:lstStyle/>
+          <a:p>
+            <a:pPr algn="l"/>
+            <a:r>
+              <a:rPr sz="800" b="1" i="0">
+                <a:solidFill>
+                  <a:srgbClr val="3DC570"/>
+                </a:solidFill>
+              </a:rPr>
+              <a:t>INTEGRATIONS</a:t>
+            </a:r>
+          </a:p>
+        </p:txBody>
+      </p:sp>
+      <p:sp>
+        <p:nvSpPr>
+          <p:cNvPr id="7" name="TextBox 6"/>
+          <p:cNvSpPr txBox="1"/>
+          <p:nvPr/>
+        </p:nvSpPr>
+        <p:spPr>
+          <a:xfrm>
+            <a:off x="502920" y="1517904"/>
+            <a:ext cx="11155680" cy="347472"/>
+          </a:xfrm>
+          <a:prstGeom prst="rect">
+            <a:avLst/>
+          </a:prstGeom>
+          <a:noFill/>
+        </p:spPr>
+        <p:txBody>
+          <a:bodyPr wrap="square">
+            <a:spAutoFit/>
+          </a:bodyPr>
+          <a:lstStyle/>
+          <a:p>
+            <a:pPr algn="l"/>
+            <a:r>
+              <a:rPr sz="1050" b="0" i="0">
+                <a:solidFill>
+                  <a:srgbClr val="FFFFFF"/>
+                </a:solidFill>
+              </a:rPr>
+              <a:t>Robin connects into Rev.io's existing tool stack — using AI to turn raw data and workflows into automated action at scale.</a:t>
+            </a:r>
+          </a:p>
+        </p:txBody>
+      </p:sp>
+      <p:sp>
+        <p:nvSpPr>
+          <p:cNvPr id="8" name="Rectangle 7"/>
+          <p:cNvSpPr/>
+          <p:nvPr/>
+        </p:nvSpPr>
+        <p:spPr>
+          <a:xfrm>
+            <a:off x="365760" y="2084831"/>
+            <a:ext cx="5623560" cy="4315968"/>
+          </a:xfrm>
+          <a:prstGeom prst="rect">
+            <a:avLst/>
+          </a:prstGeom>
+          <a:solidFill>
+            <a:srgbClr val="0A1E30"/>
+          </a:solidFill>
+          <a:ln>
+            <a:noFill/>
+          </a:ln>
+        </p:spPr>
+        <p:style>
+          <a:lnRef idx="1">
+            <a:schemeClr val="accent1"/>
+          </a:lnRef>
+          <a:fillRef idx="3">
+            <a:schemeClr val="accent1"/>
+          </a:fillRef>
+          <a:effectRef idx="2">
+            <a:schemeClr val="accent1"/>
+          </a:effectRef>
+          <a:fontRef idx="minor">
+            <a:schemeClr val="lt1"/>
+          </a:fontRef>
+        </p:style>
+        <p:txBody>
+          <a:bodyPr rtlCol="0" anchor="ctr"/>
+          <a:lstStyle/>
+          <a:p>
+            <a:pPr algn="ctr"/>
+          </a:p>
+        </p:txBody>
+      </p:sp>
+      <p:sp>
+        <p:nvSpPr>
+          <p:cNvPr id="9" name="Rectangle 8"/>
+          <p:cNvSpPr/>
+          <p:nvPr/>
+        </p:nvSpPr>
+        <p:spPr>
+          <a:xfrm>
+            <a:off x="365760" y="2084831"/>
+            <a:ext cx="45720" cy="4315968"/>
+          </a:xfrm>
+          <a:prstGeom prst="rect">
+            <a:avLst/>
+          </a:prstGeom>
+          <a:solidFill>
+            <a:srgbClr val="7C3AED"/>
+          </a:solidFill>
+          <a:ln>
+            <a:noFill/>
+          </a:ln>
+        </p:spPr>
+        <p:style>
+          <a:lnRef idx="1">
+            <a:schemeClr val="accent1"/>
+          </a:lnRef>
+          <a:fillRef idx="3">
+            <a:schemeClr val="accent1"/>
+          </a:fillRef>
+          <a:effectRef idx="2">
+            <a:schemeClr val="accent1"/>
+          </a:effectRef>
+          <a:fontRef idx="minor">
+            <a:schemeClr val="lt1"/>
+          </a:fontRef>
+        </p:style>
+        <p:txBody>
+          <a:bodyPr rtlCol="0" anchor="ctr"/>
+          <a:lstStyle/>
+          <a:p>
+            <a:pPr algn="ctr"/>
+          </a:p>
+        </p:txBody>
+      </p:sp>
+      <p:sp>
+        <p:nvSpPr>
+          <p:cNvPr id="10" name="TextBox 9"/>
+          <p:cNvSpPr txBox="1"/>
+          <p:nvPr/>
+        </p:nvSpPr>
+        <p:spPr>
+          <a:xfrm>
+            <a:off x="566928" y="2212848"/>
+            <a:ext cx="5029200" cy="502920"/>
+          </a:xfrm>
+          <a:prstGeom prst="rect">
+            <a:avLst/>
+          </a:prstGeom>
+          <a:noFill/>
+        </p:spPr>
+        <p:txBody>
+          <a:bodyPr wrap="square">
+            <a:spAutoFit/>
+          </a:bodyPr>
+          <a:lstStyle/>
+          <a:p>
+            <a:pPr algn="l"/>
+            <a:r>
+              <a:rPr sz="3400" b="1" i="0">
+                <a:solidFill>
+                  <a:srgbClr val="FFFFFF"/>
+                </a:solidFill>
+              </a:rPr>
+              <a:t>📓  Notion</a:t>
+            </a:r>
+          </a:p>
+        </p:txBody>
+      </p:sp>
+      <p:sp>
+        <p:nvSpPr>
+          <p:cNvPr id="11" name="TextBox 10"/>
+          <p:cNvSpPr txBox="1"/>
+          <p:nvPr/>
+        </p:nvSpPr>
+        <p:spPr>
+          <a:xfrm>
+            <a:off x="566928" y="2724911"/>
+            <a:ext cx="5212080" cy="274320"/>
+          </a:xfrm>
+          <a:prstGeom prst="rect">
+            <a:avLst/>
+          </a:prstGeom>
+          <a:noFill/>
+        </p:spPr>
+        <p:txBody>
+          <a:bodyPr wrap="square">
+            <a:spAutoFit/>
+          </a:bodyPr>
+          <a:lstStyle/>
+          <a:p>
+            <a:pPr algn="l"/>
+            <a:r>
+              <a:rPr sz="1300" b="0" i="0">
+                <a:solidFill>
+                  <a:srgbClr val="7C3AED"/>
+                </a:solidFill>
+              </a:rPr>
+              <a:t>AI-Powered Knowledge &amp; Workflow Automation</a:t>
+            </a:r>
+          </a:p>
+        </p:txBody>
+      </p:sp>
+      <p:sp>
+        <p:nvSpPr>
+          <p:cNvPr id="12" name="TextBox 11"/>
+          <p:cNvSpPr txBox="1"/>
+          <p:nvPr/>
+        </p:nvSpPr>
+        <p:spPr>
+          <a:xfrm>
+            <a:off x="566928" y="3017520"/>
+            <a:ext cx="5212080" cy="237744"/>
+          </a:xfrm>
+          <a:prstGeom prst="rect">
+            <a:avLst/>
+          </a:prstGeom>
+          <a:noFill/>
+        </p:spPr>
+        <p:txBody>
+          <a:bodyPr wrap="square">
+            <a:spAutoFit/>
+          </a:bodyPr>
+          <a:lstStyle/>
+          <a:p>
+            <a:pPr algn="l"/>
+            <a:r>
+              <a:rPr sz="1000" b="0" i="1">
+                <a:solidFill>
+                  <a:srgbClr val="8AA8C8"/>
+                </a:solidFill>
+              </a:rPr>
+              <a:t>Prospect research · Meeting intelligence · Follow-up</a:t>
+            </a:r>
+          </a:p>
+        </p:txBody>
+      </p:sp>
+      <p:sp>
+        <p:nvSpPr>
+          <p:cNvPr id="13" name="Rectangle 12"/>
+          <p:cNvSpPr/>
+          <p:nvPr/>
+        </p:nvSpPr>
+        <p:spPr>
+          <a:xfrm>
+            <a:off x="566928" y="3310128"/>
+            <a:ext cx="5221224" cy="18288"/>
+          </a:xfrm>
+          <a:prstGeom prst="rect">
+            <a:avLst/>
+          </a:prstGeom>
+          <a:solidFill>
+            <a:srgbClr val="1A3555"/>
+          </a:solidFill>
+          <a:ln>
+            <a:noFill/>
+          </a:ln>
+        </p:spPr>
+        <p:style>
+          <a:lnRef idx="1">
+            <a:schemeClr val="accent1"/>
+          </a:lnRef>
+          <a:fillRef idx="3">
+            <a:schemeClr val="accent1"/>
+          </a:fillRef>
+          <a:effectRef idx="2">
+            <a:schemeClr val="accent1"/>
+          </a:effectRef>
+          <a:fontRef idx="minor">
+            <a:schemeClr val="lt1"/>
+          </a:fontRef>
+        </p:style>
+        <p:txBody>
+          <a:bodyPr rtlCol="0" anchor="ctr"/>
+          <a:lstStyle/>
+          <a:p>
+            <a:pPr algn="ctr"/>
+          </a:p>
+        </p:txBody>
+      </p:sp>
+      <p:sp>
+        <p:nvSpPr>
+          <p:cNvPr id="14" name="TextBox 13"/>
+          <p:cNvSpPr txBox="1"/>
+          <p:nvPr/>
+        </p:nvSpPr>
+        <p:spPr>
+          <a:xfrm>
+            <a:off x="566928" y="3438144"/>
+            <a:ext cx="5212080" cy="237744"/>
+          </a:xfrm>
+          <a:prstGeom prst="rect">
+            <a:avLst/>
+          </a:prstGeom>
+          <a:noFill/>
+        </p:spPr>
+        <p:txBody>
+          <a:bodyPr wrap="square">
+            <a:spAutoFit/>
+          </a:bodyPr>
+          <a:lstStyle/>
+          <a:p>
+            <a:pPr algn="l"/>
+            <a:r>
+              <a:rPr sz="1050" b="1" i="0">
+                <a:solidFill>
+                  <a:srgbClr val="FFFFFF"/>
+                </a:solidFill>
+              </a:rPr>
+              <a:t>• MSP EMAIL PERSONALIZATION AT SCALE</a:t>
+            </a:r>
+          </a:p>
+        </p:txBody>
+      </p:sp>
+      <p:sp>
+        <p:nvSpPr>
+          <p:cNvPr id="15" name="TextBox 14"/>
+          <p:cNvSpPr txBox="1"/>
+          <p:nvPr/>
+        </p:nvSpPr>
+        <p:spPr>
+          <a:xfrm>
+            <a:off x="694944" y="3694176"/>
+            <a:ext cx="5074920" cy="347472"/>
+          </a:xfrm>
+          <a:prstGeom prst="rect">
+            <a:avLst/>
+          </a:prstGeom>
+          <a:noFill/>
+        </p:spPr>
+        <p:txBody>
+          <a:bodyPr wrap="square">
+            <a:spAutoFit/>
+          </a:bodyPr>
+          <a:lstStyle/>
+          <a:p>
+            <a:pPr algn="l"/>
+            <a:r>
+              <a:rPr sz="950" b="0" i="0">
+                <a:solidFill>
+                  <a:srgbClr val="8AA8C8"/>
+                </a:solidFill>
+              </a:rPr>
+              <a:t>Researches each prospect and writes personalized outreach automatically — no manual prep.</a:t>
+            </a:r>
+          </a:p>
+        </p:txBody>
+      </p:sp>
+      <p:sp>
+        <p:nvSpPr>
+          <p:cNvPr id="16" name="TextBox 15"/>
+          <p:cNvSpPr txBox="1"/>
+          <p:nvPr/>
+        </p:nvSpPr>
+        <p:spPr>
+          <a:xfrm>
+            <a:off x="566928" y="4352544"/>
+            <a:ext cx="5212080" cy="237744"/>
+          </a:xfrm>
+          <a:prstGeom prst="rect">
+            <a:avLst/>
+          </a:prstGeom>
+          <a:noFill/>
+        </p:spPr>
+        <p:txBody>
+          <a:bodyPr wrap="square">
+            <a:spAutoFit/>
+          </a:bodyPr>
+          <a:lstStyle/>
+          <a:p>
+            <a:pPr algn="l"/>
+            <a:r>
+              <a:rPr sz="1050" b="1" i="0">
+                <a:solidFill>
+                  <a:srgbClr val="FFFFFF"/>
+                </a:solidFill>
+              </a:rPr>
+              <a:t>• MEETING NOTE-TAKING &amp; TRANSCRIPTION</a:t>
+            </a:r>
+          </a:p>
+        </p:txBody>
+      </p:sp>
+      <p:sp>
+        <p:nvSpPr>
+          <p:cNvPr id="17" name="TextBox 16"/>
+          <p:cNvSpPr txBox="1"/>
+          <p:nvPr/>
+        </p:nvSpPr>
+        <p:spPr>
+          <a:xfrm>
+            <a:off x="694944" y="4608576"/>
+            <a:ext cx="5074920" cy="347472"/>
+          </a:xfrm>
+          <a:prstGeom prst="rect">
+            <a:avLst/>
+          </a:prstGeom>
+          <a:noFill/>
+        </p:spPr>
+        <p:txBody>
+          <a:bodyPr wrap="square">
+            <a:spAutoFit/>
+          </a:bodyPr>
+          <a:lstStyle/>
+          <a:p>
+            <a:pPr algn="l"/>
+            <a:r>
+              <a:rPr sz="950" b="0" i="0">
+                <a:solidFill>
+                  <a:srgbClr val="8AA8C8"/>
+                </a:solidFill>
+              </a:rPr>
+              <a:t>Captures full meeting notes, key takeaways, and action items from every prospect call.</a:t>
+            </a:r>
+          </a:p>
+        </p:txBody>
+      </p:sp>
+      <p:sp>
+        <p:nvSpPr>
+          <p:cNvPr id="18" name="TextBox 17"/>
+          <p:cNvSpPr txBox="1"/>
+          <p:nvPr/>
+        </p:nvSpPr>
+        <p:spPr>
+          <a:xfrm>
+            <a:off x="566928" y="5266944"/>
+            <a:ext cx="5212080" cy="237744"/>
+          </a:xfrm>
+          <a:prstGeom prst="rect">
+            <a:avLst/>
+          </a:prstGeom>
+          <a:noFill/>
+        </p:spPr>
+        <p:txBody>
+          <a:bodyPr wrap="square">
+            <a:spAutoFit/>
+          </a:bodyPr>
+          <a:lstStyle/>
+          <a:p>
+            <a:pPr algn="l"/>
+            <a:r>
+              <a:rPr sz="1050" b="1" i="0">
+                <a:solidFill>
+                  <a:srgbClr val="FFFFFF"/>
+                </a:solidFill>
+              </a:rPr>
+              <a:t>• POST-MEETING FOLLOW-UP EMAILS</a:t>
+            </a:r>
+          </a:p>
+        </p:txBody>
+      </p:sp>
+      <p:sp>
+        <p:nvSpPr>
+          <p:cNvPr id="19" name="TextBox 18"/>
+          <p:cNvSpPr txBox="1"/>
+          <p:nvPr/>
+        </p:nvSpPr>
+        <p:spPr>
+          <a:xfrm>
+            <a:off x="694944" y="5522976"/>
+            <a:ext cx="5074920" cy="347472"/>
+          </a:xfrm>
+          <a:prstGeom prst="rect">
+            <a:avLst/>
+          </a:prstGeom>
+          <a:noFill/>
+        </p:spPr>
+        <p:txBody>
+          <a:bodyPr wrap="square">
+            <a:spAutoFit/>
+          </a:bodyPr>
+          <a:lstStyle/>
+          <a:p>
+            <a:pPr algn="l"/>
+            <a:r>
+              <a:rPr sz="950" b="0" i="0">
+                <a:solidFill>
+                  <a:srgbClr val="8AA8C8"/>
+                </a:solidFill>
+              </a:rPr>
+              <a:t>Generates tailored follow-up emails and action item summaries immediately after each call.</a:t>
+            </a:r>
+          </a:p>
+        </p:txBody>
+      </p:sp>
+      <p:sp>
+        <p:nvSpPr>
+          <p:cNvPr id="20" name="Rectangle 19"/>
+          <p:cNvSpPr/>
+          <p:nvPr/>
+        </p:nvSpPr>
+        <p:spPr>
+          <a:xfrm>
+            <a:off x="6199632" y="2084831"/>
+            <a:ext cx="5623560" cy="4315968"/>
+          </a:xfrm>
+          <a:prstGeom prst="rect">
+            <a:avLst/>
+          </a:prstGeom>
+          <a:solidFill>
+            <a:srgbClr val="0A1E30"/>
+          </a:solidFill>
+          <a:ln>
+            <a:noFill/>
+          </a:ln>
+        </p:spPr>
+        <p:style>
+          <a:lnRef idx="1">
+            <a:schemeClr val="accent1"/>
+          </a:lnRef>
+          <a:fillRef idx="3">
+            <a:schemeClr val="accent1"/>
+          </a:fillRef>
+          <a:effectRef idx="2">
+            <a:schemeClr val="accent1"/>
+          </a:effectRef>
+          <a:fontRef idx="minor">
+            <a:schemeClr val="lt1"/>
+          </a:fontRef>
+        </p:style>
+        <p:txBody>
+          <a:bodyPr rtlCol="0" anchor="ctr"/>
+          <a:lstStyle/>
+          <a:p>
+            <a:pPr algn="ctr"/>
+          </a:p>
+        </p:txBody>
+      </p:sp>
+      <p:sp>
+        <p:nvSpPr>
+          <p:cNvPr id="21" name="Rectangle 20"/>
+          <p:cNvSpPr/>
+          <p:nvPr/>
+        </p:nvSpPr>
+        <p:spPr>
+          <a:xfrm>
+            <a:off x="6199632" y="2084831"/>
+            <a:ext cx="45720" cy="4315968"/>
+          </a:xfrm>
+          <a:prstGeom prst="rect">
+            <a:avLst/>
+          </a:prstGeom>
+          <a:solidFill>
+            <a:srgbClr val="F57C2A"/>
+          </a:solidFill>
+          <a:ln>
+            <a:noFill/>
+          </a:ln>
+        </p:spPr>
+        <p:style>
+          <a:lnRef idx="1">
+            <a:schemeClr val="accent1"/>
+          </a:lnRef>
+          <a:fillRef idx="3">
+            <a:schemeClr val="accent1"/>
+          </a:fillRef>
+          <a:effectRef idx="2">
+            <a:schemeClr val="accent1"/>
+          </a:effectRef>
+          <a:fontRef idx="minor">
+            <a:schemeClr val="lt1"/>
+          </a:fontRef>
+        </p:style>
+        <p:txBody>
+          <a:bodyPr rtlCol="0" anchor="ctr"/>
+          <a:lstStyle/>
+          <a:p>
+            <a:pPr algn="ctr"/>
+          </a:p>
+        </p:txBody>
+      </p:sp>
+      <p:sp>
+        <p:nvSpPr>
+          <p:cNvPr id="22" name="TextBox 21"/>
+          <p:cNvSpPr txBox="1"/>
+          <p:nvPr/>
+        </p:nvSpPr>
+        <p:spPr>
+          <a:xfrm>
+            <a:off x="6400800" y="2212848"/>
+            <a:ext cx="5029200" cy="502920"/>
+          </a:xfrm>
+          <a:prstGeom prst="rect">
+            <a:avLst/>
+          </a:prstGeom>
+          <a:noFill/>
+        </p:spPr>
+        <p:txBody>
+          <a:bodyPr wrap="square">
+            <a:spAutoFit/>
+          </a:bodyPr>
+          <a:lstStyle/>
+          <a:p>
+            <a:pPr algn="l"/>
+            <a:r>
+              <a:rPr sz="3400" b="1" i="0">
+                <a:solidFill>
+                  <a:srgbClr val="FFFFFF"/>
+                </a:solidFill>
+              </a:rPr>
+              <a:t>🏗️  Clay</a:t>
+            </a:r>
+          </a:p>
+        </p:txBody>
+      </p:sp>
+      <p:sp>
+        <p:nvSpPr>
+          <p:cNvPr id="23" name="TextBox 22"/>
+          <p:cNvSpPr txBox="1"/>
+          <p:nvPr/>
+        </p:nvSpPr>
+        <p:spPr>
+          <a:xfrm>
+            <a:off x="6400800" y="2724911"/>
+            <a:ext cx="5212080" cy="274320"/>
+          </a:xfrm>
+          <a:prstGeom prst="rect">
+            <a:avLst/>
+          </a:prstGeom>
+          <a:noFill/>
+        </p:spPr>
+        <p:txBody>
+          <a:bodyPr wrap="square">
+            <a:spAutoFit/>
+          </a:bodyPr>
+          <a:lstStyle/>
+          <a:p>
+            <a:pPr algn="l"/>
+            <a:r>
+              <a:rPr sz="1300" b="0" i="0">
+                <a:solidFill>
+                  <a:srgbClr val="F57C2A"/>
+                </a:solidFill>
+              </a:rPr>
+              <a:t>Custom AI Agent for Data Intelligence</a:t>
+            </a:r>
+          </a:p>
+        </p:txBody>
+      </p:sp>
+      <p:sp>
+        <p:nvSpPr>
+          <p:cNvPr id="24" name="TextBox 23"/>
+          <p:cNvSpPr txBox="1"/>
+          <p:nvPr/>
+        </p:nvSpPr>
+        <p:spPr>
+          <a:xfrm>
+            <a:off x="6400800" y="3017520"/>
+            <a:ext cx="5212080" cy="237744"/>
+          </a:xfrm>
+          <a:prstGeom prst="rect">
+            <a:avLst/>
+          </a:prstGeom>
+          <a:noFill/>
+        </p:spPr>
+        <p:txBody>
+          <a:bodyPr wrap="square">
+            <a:spAutoFit/>
+          </a:bodyPr>
+          <a:lstStyle/>
+          <a:p>
+            <a:pPr algn="l"/>
+            <a:r>
+              <a:rPr sz="1000" b="0" i="1">
+                <a:solidFill>
+                  <a:srgbClr val="8AA8C8"/>
+                </a:solidFill>
+              </a:rPr>
+              <a:t>Prospect enrichment · CRM data hygiene · Verification</a:t>
+            </a:r>
+          </a:p>
+        </p:txBody>
+      </p:sp>
+      <p:sp>
+        <p:nvSpPr>
+          <p:cNvPr id="25" name="Rectangle 24"/>
+          <p:cNvSpPr/>
+          <p:nvPr/>
+        </p:nvSpPr>
+        <p:spPr>
+          <a:xfrm>
+            <a:off x="6400800" y="3310128"/>
+            <a:ext cx="5221224" cy="18288"/>
+          </a:xfrm>
+          <a:prstGeom prst="rect">
+            <a:avLst/>
+          </a:prstGeom>
+          <a:solidFill>
+            <a:srgbClr val="1A3555"/>
+          </a:solidFill>
+          <a:ln>
+            <a:noFill/>
+          </a:ln>
+        </p:spPr>
+        <p:style>
+          <a:lnRef idx="1">
+            <a:schemeClr val="accent1"/>
+          </a:lnRef>
+          <a:fillRef idx="3">
+            <a:schemeClr val="accent1"/>
+          </a:fillRef>
+          <a:effectRef idx="2">
+            <a:schemeClr val="accent1"/>
+          </a:effectRef>
+          <a:fontRef idx="minor">
+            <a:schemeClr val="lt1"/>
+          </a:fontRef>
+        </p:style>
+        <p:txBody>
+          <a:bodyPr rtlCol="0" anchor="ctr"/>
+          <a:lstStyle/>
+          <a:p>
+            <a:pPr algn="ctr"/>
+          </a:p>
+        </p:txBody>
+      </p:sp>
+      <p:sp>
+        <p:nvSpPr>
+          <p:cNvPr id="26" name="TextBox 25"/>
+          <p:cNvSpPr txBox="1"/>
+          <p:nvPr/>
+        </p:nvSpPr>
+        <p:spPr>
+          <a:xfrm>
+            <a:off x="6400800" y="3438144"/>
+            <a:ext cx="5212080" cy="256032"/>
+          </a:xfrm>
+          <a:prstGeom prst="rect">
+            <a:avLst/>
+          </a:prstGeom>
+          <a:noFill/>
+        </p:spPr>
+        <p:txBody>
+          <a:bodyPr wrap="square">
+            <a:spAutoFit/>
+          </a:bodyPr>
+          <a:lstStyle/>
+          <a:p>
+            <a:pPr algn="l"/>
+            <a:r>
+              <a:rPr sz="1050" b="1" i="0">
+                <a:solidFill>
+                  <a:srgbClr val="FFFFFF"/>
+                </a:solidFill>
+              </a:rPr>
+              <a:t>• CUSTOM AGENT: PROSPECT INDUSTRY VERIFICATION</a:t>
+            </a:r>
+          </a:p>
+        </p:txBody>
+      </p:sp>
+      <p:sp>
+        <p:nvSpPr>
+          <p:cNvPr id="27" name="TextBox 26"/>
+          <p:cNvSpPr txBox="1"/>
+          <p:nvPr/>
+        </p:nvSpPr>
+        <p:spPr>
+          <a:xfrm>
+            <a:off x="6528816" y="3712463"/>
+            <a:ext cx="5074920" cy="457200"/>
+          </a:xfrm>
+          <a:prstGeom prst="rect">
+            <a:avLst/>
+          </a:prstGeom>
+          <a:noFill/>
+        </p:spPr>
+        <p:txBody>
+          <a:bodyPr wrap="square">
+            <a:spAutoFit/>
+          </a:bodyPr>
+          <a:lstStyle/>
+          <a:p>
+            <a:pPr algn="l"/>
+            <a:r>
+              <a:rPr sz="950" b="0" i="0">
+                <a:solidFill>
+                  <a:srgbClr val="8AA8C8"/>
+                </a:solidFill>
+              </a:rPr>
+              <a:t>Built a custom AI agent to verify and correct the industry field on prospect accounts in Salesforce.</a:t>
+            </a:r>
+          </a:p>
+        </p:txBody>
+      </p:sp>
+      <p:sp>
+        <p:nvSpPr>
+          <p:cNvPr id="28" name="TextBox 27"/>
+          <p:cNvSpPr txBox="1"/>
+          <p:nvPr/>
+        </p:nvSpPr>
+        <p:spPr>
+          <a:xfrm>
+            <a:off x="6400800" y="4443983"/>
+            <a:ext cx="5212080" cy="256032"/>
+          </a:xfrm>
+          <a:prstGeom prst="rect">
+            <a:avLst/>
+          </a:prstGeom>
+          <a:noFill/>
+        </p:spPr>
+        <p:txBody>
+          <a:bodyPr wrap="square">
+            <a:spAutoFit/>
+          </a:bodyPr>
+          <a:lstStyle/>
+          <a:p>
+            <a:pPr algn="l"/>
+            <a:r>
+              <a:rPr sz="1050" b="1" i="0">
+                <a:solidFill>
+                  <a:srgbClr val="FFFFFF"/>
+                </a:solidFill>
+              </a:rPr>
+              <a:t>• FOUND 11K INCORRECTLY TAGGED ACCOUNTS</a:t>
+            </a:r>
+          </a:p>
+        </p:txBody>
+      </p:sp>
+      <p:sp>
+        <p:nvSpPr>
+          <p:cNvPr id="29" name="TextBox 28"/>
+          <p:cNvSpPr txBox="1"/>
+          <p:nvPr/>
+        </p:nvSpPr>
+        <p:spPr>
+          <a:xfrm>
+            <a:off x="6528816" y="4718303"/>
+            <a:ext cx="5074920" cy="457200"/>
+          </a:xfrm>
+          <a:prstGeom prst="rect">
+            <a:avLst/>
+          </a:prstGeom>
+          <a:noFill/>
+        </p:spPr>
+        <p:txBody>
+          <a:bodyPr wrap="square">
+            <a:spAutoFit/>
+          </a:bodyPr>
+          <a:lstStyle/>
+          <a:p>
+            <a:pPr algn="l"/>
+            <a:r>
+              <a:rPr sz="950" b="0" i="0">
+                <a:solidFill>
+                  <a:srgbClr val="8AA8C8"/>
+                </a:solidFill>
+              </a:rPr>
+              <a:t>Identified 11,000+ accounts incorrectly marked as MSPs in the CRM — cleaning the foundation for better targeting.</a:t>
+            </a:r>
+          </a:p>
+        </p:txBody>
+      </p:sp>
+      <p:sp>
+        <p:nvSpPr>
+          <p:cNvPr id="30" name="Rectangle 29"/>
+          <p:cNvSpPr/>
+          <p:nvPr/>
+        </p:nvSpPr>
+        <p:spPr>
+          <a:xfrm>
+            <a:off x="0" y="6675120"/>
+            <a:ext cx="12188952" cy="182880"/>
+          </a:xfrm>
+          <a:prstGeom prst="rect">
+            <a:avLst/>
+          </a:prstGeom>
+          <a:solidFill>
+            <a:srgbClr val="071220"/>
+          </a:solidFill>
+          <a:ln>
+            <a:noFill/>
+          </a:ln>
+        </p:spPr>
+        <p:style>
+          <a:lnRef idx="1">
+            <a:schemeClr val="accent1"/>
+          </a:lnRef>
+          <a:fillRef idx="3">
+            <a:schemeClr val="accent1"/>
+          </a:fillRef>
+          <a:effectRef idx="2">
+            <a:schemeClr val="accent1"/>
+          </a:effectRef>
+          <a:fontRef idx="minor">
+            <a:schemeClr val="lt1"/>
+          </a:fontRef>
+        </p:style>
+        <p:txBody>
+          <a:bodyPr rtlCol="0" anchor="ctr"/>
+          <a:lstStyle/>
+          <a:p>
+            <a:pPr algn="ctr"/>
+          </a:p>
+        </p:txBody>
+      </p:sp>
+      <p:sp>
+        <p:nvSpPr>
+          <p:cNvPr id="31" name="TextBox 30"/>
+          <p:cNvSpPr txBox="1"/>
+          <p:nvPr/>
+        </p:nvSpPr>
+        <p:spPr>
+          <a:xfrm>
+            <a:off x="274320" y="6693408"/>
+            <a:ext cx="1828800" cy="146304"/>
+          </a:xfrm>
+          <a:prstGeom prst="rect">
+            <a:avLst/>
+          </a:prstGeom>
+          <a:noFill/>
+        </p:spPr>
+        <p:txBody>
+          <a:bodyPr wrap="square">
+            <a:spAutoFit/>
+          </a:bodyPr>
+          <a:lstStyle/>
+          <a:p>
+            <a:pPr algn="l"/>
+            <a:r>
+              <a:rPr sz="900" b="1" i="0">
+                <a:solidFill>
+                  <a:srgbClr val="FFFFFF"/>
+                </a:solidFill>
+              </a:rPr>
+              <a:t>• rev.io</a:t>
+            </a:r>
+          </a:p>
+        </p:txBody>
+      </p:sp>
+      <p:sp>
+        <p:nvSpPr>
+          <p:cNvPr id="32" name="TextBox 31"/>
+          <p:cNvSpPr txBox="1"/>
+          <p:nvPr/>
+        </p:nvSpPr>
+        <p:spPr>
+          <a:xfrm>
+            <a:off x="8686800" y="6693408"/>
+            <a:ext cx="2011680" cy="146304"/>
+          </a:xfrm>
+          <a:prstGeom prst="rect">
+            <a:avLst/>
+          </a:prstGeom>
+          <a:noFill/>
+        </p:spPr>
+        <p:txBody>
+          <a:bodyPr wrap="square">
+            <a:spAutoFit/>
+          </a:bodyPr>
+          <a:lstStyle/>
+          <a:p>
+            <a:pPr algn="r"/>
+            <a:r>
+              <a:rPr sz="900" b="1" i="0">
+                <a:solidFill>
+                  <a:srgbClr val="FFFFFF"/>
+                </a:solidFill>
+              </a:rPr>
+              <a:t>BUILT FOR TOMORROW.</a:t>
+            </a:r>
+          </a:p>
+        </p:txBody>
+      </p:sp>
+      <p:sp>
+        <p:nvSpPr>
+          <p:cNvPr id="33" name="TextBox 32"/>
           <p:cNvSpPr txBox="1"/>
           <p:nvPr/>
         </p:nvSpPr>

</xml_diff>

<commit_message>
Robin intro: 1 slide 3 columns (Robin, Notion, Clay)
</commit_message>
<xml_diff>
--- a/Robin-Intro-Slide.pptx
+++ b/Robin-Intro-Slide.pptx
@@ -9,7 +9,6 @@
   </p:notesMasterIdLst>
   <p:sldIdLst>
     <p:sldId id="828" r:id="rId9"/>
-    <p:sldId id="829" r:id="rId10"/>
   </p:sldIdLst>
   <p:sldSz cx="12192000" cy="6858000"/>
   <p:notesSz cx="6858000" cy="9144000"/>
@@ -4202,6 +4201,586 @@
 </file>
 
 <file path=ppt/slides/slide1.xml><?xml version="1.0" encoding="utf-8"?>
+<p:sld xmlns:a="http://schemas.openxmlformats.org/drawingml/2006/main" xmlns:r="http://schemas.openxmlformats.org/officeDocument/2006/relationships" xmlns:p="http://schemas.openxmlformats.org/presentationml/2006/main">
+  <p:cSld>
+    <p:spTree>
+      <p:nvGrpSpPr>
+        <p:cNvPr id="1" name=""/>
+        <p:cNvGrpSpPr/>
+        <p:nvPr/>
+      </p:nvGrpSpPr>
+      <p:grpSpPr>
+        <a:xfrm>
+          <a:off x="0" y="0"/>
+          <a:ext cx="0" cy="0"/>
+          <a:chOff x="0" y="0"/>
+          <a:chExt cx="0" cy="0"/>
+        </a:xfrm>
+      </p:grpSpPr>
+      <p:sp>
+        <p:nvSpPr>
+          <p:cNvPr id="2" name="Freeform 2"/>
+          <p:cNvSpPr/>
+          <p:nvPr/>
+        </p:nvSpPr>
+        <p:spPr>
+          <a:xfrm>
+            <a:off x="0" y="0"/>
+            <a:ext cx="12192000" cy="6858000"/>
+          </a:xfrm>
+          <a:custGeom>
+            <a:avLst/>
+            <a:gdLst/>
+            <a:ahLst/>
+            <a:cxnLst/>
+            <a:rect l="l" t="t" r="r" b="b"/>
+            <a:pathLst>
+              <a:path w="18288000" h="10287000">
+                <a:moveTo>
+                  <a:pt x="0" y="0"/>
+                </a:moveTo>
+                <a:lnTo>
+                  <a:pt x="18288000" y="0"/>
+                </a:lnTo>
+                <a:lnTo>
+                  <a:pt x="18288000" y="10287000"/>
+                </a:lnTo>
+                <a:lnTo>
+                  <a:pt x="0" y="10287000"/>
+                </a:lnTo>
+                <a:lnTo>
+                  <a:pt x="0" y="0"/>
+                </a:lnTo>
+                <a:close/>
+              </a:path>
+            </a:pathLst>
+          </a:custGeom>
+          <a:blipFill>
+            <a:blip r:embed="rId2"/>
+            <a:stretch>
+              <a:fillRect/>
+            </a:stretch>
+          </a:blipFill>
+        </p:spPr>
+        <p:txBody>
+          <a:bodyPr/>
+          <a:lstStyle/>
+          <a:p>
+            <a:endParaRPr lang="en-US"/>
+          </a:p>
+        </p:txBody>
+      </p:sp>
+      <p:sp>
+        <p:nvSpPr>
+          <p:cNvPr id="4" name="AutoShape 4"/>
+          <p:cNvSpPr/>
+          <p:nvPr/>
+        </p:nvSpPr>
+        <p:spPr>
+          <a:xfrm>
+            <a:off x="685800" y="3448050"/>
+            <a:ext cx="5560377" cy="0"/>
+          </a:xfrm>
+          <a:prstGeom prst="line">
+            <a:avLst/>
+          </a:prstGeom>
+          <a:ln w="57150" cap="rnd">
+            <a:gradFill>
+              <a:gsLst>
+                <a:gs pos="0">
+                  <a:srgbClr val="1667CC">
+                    <a:alpha val="100000"/>
+                  </a:srgbClr>
+                </a:gs>
+                <a:gs pos="100000">
+                  <a:srgbClr val="3DC570">
+                    <a:alpha val="100000"/>
+                  </a:srgbClr>
+                </a:gs>
+              </a:gsLst>
+              <a:lin ang="2700000"/>
+            </a:gradFill>
+            <a:prstDash val="solid"/>
+            <a:headEnd type="none" w="sm" len="sm"/>
+            <a:tailEnd type="none" w="sm" len="sm"/>
+          </a:ln>
+        </p:spPr>
+        <p:txBody>
+          <a:bodyPr/>
+          <a:lstStyle/>
+          <a:p>
+            <a:endParaRPr lang="en-US"/>
+          </a:p>
+        </p:txBody>
+      </p:sp>
+      <p:sp>
+        <p:nvSpPr>
+          <p:cNvPr id="5" name="TextBox 5"/>
+          <p:cNvSpPr txBox="1"/>
+          <p:nvPr/>
+        </p:nvSpPr>
+        <p:spPr>
+          <a:xfrm>
+            <a:off x="685800" y="1603623"/>
+            <a:ext cx="4975062" cy="1537216"/>
+          </a:xfrm>
+          <a:prstGeom prst="rect">
+            <a:avLst/>
+          </a:prstGeom>
+        </p:spPr>
+        <p:txBody>
+          <a:bodyPr wrap="square" lIns="0" tIns="0" rIns="0" bIns="0" rtlCol="0" anchor="t">
+            <a:spAutoFit/>
+          </a:bodyPr>
+          <a:lstStyle>
+            <a:defPPr>
+              <a:defRPr lang="en-US"/>
+            </a:defPPr>
+            <a:lvl1pPr marL="0" algn="l" defTabSz="609539" rtl="0" eaLnBrk="1" latinLnBrk="0" hangingPunct="1">
+              <a:defRPr sz="1200" kern="1200">
+                <a:solidFill>
+                  <a:schemeClr val="tx1"/>
+                </a:solidFill>
+                <a:latin typeface="+mn-lt"/>
+                <a:ea typeface="+mn-ea"/>
+                <a:cs typeface="+mn-cs"/>
+              </a:defRPr>
+            </a:lvl1pPr>
+            <a:lvl2pPr marL="304770" algn="l" defTabSz="609539" rtl="0" eaLnBrk="1" latinLnBrk="0" hangingPunct="1">
+              <a:defRPr sz="1200" kern="1200">
+                <a:solidFill>
+                  <a:schemeClr val="tx1"/>
+                </a:solidFill>
+                <a:latin typeface="+mn-lt"/>
+                <a:ea typeface="+mn-ea"/>
+                <a:cs typeface="+mn-cs"/>
+              </a:defRPr>
+            </a:lvl2pPr>
+            <a:lvl3pPr marL="609539" algn="l" defTabSz="609539" rtl="0" eaLnBrk="1" latinLnBrk="0" hangingPunct="1">
+              <a:defRPr sz="1200" kern="1200">
+                <a:solidFill>
+                  <a:schemeClr val="tx1"/>
+                </a:solidFill>
+                <a:latin typeface="+mn-lt"/>
+                <a:ea typeface="+mn-ea"/>
+                <a:cs typeface="+mn-cs"/>
+              </a:defRPr>
+            </a:lvl3pPr>
+            <a:lvl4pPr marL="914309" algn="l" defTabSz="609539" rtl="0" eaLnBrk="1" latinLnBrk="0" hangingPunct="1">
+              <a:defRPr sz="1200" kern="1200">
+                <a:solidFill>
+                  <a:schemeClr val="tx1"/>
+                </a:solidFill>
+                <a:latin typeface="+mn-lt"/>
+                <a:ea typeface="+mn-ea"/>
+                <a:cs typeface="+mn-cs"/>
+              </a:defRPr>
+            </a:lvl4pPr>
+            <a:lvl5pPr marL="1219078" algn="l" defTabSz="609539" rtl="0" eaLnBrk="1" latinLnBrk="0" hangingPunct="1">
+              <a:defRPr sz="1200" kern="1200">
+                <a:solidFill>
+                  <a:schemeClr val="tx1"/>
+                </a:solidFill>
+                <a:latin typeface="+mn-lt"/>
+                <a:ea typeface="+mn-ea"/>
+                <a:cs typeface="+mn-cs"/>
+              </a:defRPr>
+            </a:lvl5pPr>
+            <a:lvl6pPr marL="1523848" algn="l" defTabSz="609539" rtl="0" eaLnBrk="1" latinLnBrk="0" hangingPunct="1">
+              <a:defRPr sz="1200" kern="1200">
+                <a:solidFill>
+                  <a:schemeClr val="tx1"/>
+                </a:solidFill>
+                <a:latin typeface="+mn-lt"/>
+                <a:ea typeface="+mn-ea"/>
+                <a:cs typeface="+mn-cs"/>
+              </a:defRPr>
+            </a:lvl6pPr>
+            <a:lvl7pPr marL="1828617" algn="l" defTabSz="609539" rtl="0" eaLnBrk="1" latinLnBrk="0" hangingPunct="1">
+              <a:defRPr sz="1200" kern="1200">
+                <a:solidFill>
+                  <a:schemeClr val="tx1"/>
+                </a:solidFill>
+                <a:latin typeface="+mn-lt"/>
+                <a:ea typeface="+mn-ea"/>
+                <a:cs typeface="+mn-cs"/>
+              </a:defRPr>
+            </a:lvl7pPr>
+            <a:lvl8pPr marL="2133387" algn="l" defTabSz="609539" rtl="0" eaLnBrk="1" latinLnBrk="0" hangingPunct="1">
+              <a:defRPr sz="1200" kern="1200">
+                <a:solidFill>
+                  <a:schemeClr val="tx1"/>
+                </a:solidFill>
+                <a:latin typeface="+mn-lt"/>
+                <a:ea typeface="+mn-ea"/>
+                <a:cs typeface="+mn-cs"/>
+              </a:defRPr>
+            </a:lvl8pPr>
+            <a:lvl9pPr marL="2438156" algn="l" defTabSz="609539" rtl="0" eaLnBrk="1" latinLnBrk="0" hangingPunct="1">
+              <a:defRPr sz="1200" kern="1200">
+                <a:solidFill>
+                  <a:schemeClr val="tx1"/>
+                </a:solidFill>
+                <a:latin typeface="+mn-lt"/>
+                <a:ea typeface="+mn-ea"/>
+                <a:cs typeface="+mn-cs"/>
+              </a:defRPr>
+            </a:lvl9pPr>
+          </a:lstStyle>
+          <a:p>
+            <a:pPr>
+              <a:lnSpc>
+                <a:spcPts val="6160"/>
+              </a:lnSpc>
+              <a:spcBef>
+                <a:spcPct val="0"/>
+              </a:spcBef>
+            </a:pPr>
+            <a:r>
+              <a:rPr lang="en-US" sz="4350" b="1" dirty="0">
+                <a:solidFill>
+                  <a:srgbClr val="FFFFFF"/>
+                </a:solidFill>
+                <a:latin typeface="Montserrat Bold"/>
+                <a:sym typeface="Montserrat Bold"/>
+              </a:rPr>
+              <a:t>Sales </a:t>
+            </a:r>
+            <a:br>
+              <a:rPr lang="en-US" sz="4350" b="1" dirty="0">
+                <a:latin typeface="Montserrat Bold"/>
+              </a:rPr>
+            </a:br>
+            <a:r>
+              <a:rPr lang="en-US" sz="3600" b="1" dirty="0">
+                <a:solidFill>
+                  <a:srgbClr val="FFFFFF"/>
+                </a:solidFill>
+                <a:latin typeface="Montserrat Bold"/>
+                <a:sym typeface="Montserrat Bold"/>
+              </a:rPr>
+              <a:t>Primus Update</a:t>
+            </a:r>
+            <a:endParaRPr lang="en-US" sz="3600" dirty="0"/>
+          </a:p>
+        </p:txBody>
+      </p:sp>
+      <p:sp>
+        <p:nvSpPr>
+          <p:cNvPr id="7" name="TextBox 7"/>
+          <p:cNvSpPr txBox="1"/>
+          <p:nvPr/>
+        </p:nvSpPr>
+        <p:spPr>
+          <a:xfrm>
+            <a:off x="685800" y="3755262"/>
+            <a:ext cx="5410200" cy="287643"/>
+          </a:xfrm>
+          <a:prstGeom prst="rect">
+            <a:avLst/>
+          </a:prstGeom>
+        </p:spPr>
+        <p:txBody>
+          <a:bodyPr wrap="square" lIns="0" tIns="0" rIns="0" bIns="0" rtlCol="0" anchor="t">
+            <a:spAutoFit/>
+          </a:bodyPr>
+          <a:lstStyle>
+            <a:defPPr>
+              <a:defRPr lang="en-US"/>
+            </a:defPPr>
+            <a:lvl1pPr marL="0" algn="l" defTabSz="609539" rtl="0" eaLnBrk="1" latinLnBrk="0" hangingPunct="1">
+              <a:defRPr sz="1200" kern="1200">
+                <a:solidFill>
+                  <a:schemeClr val="tx1"/>
+                </a:solidFill>
+                <a:latin typeface="+mn-lt"/>
+                <a:ea typeface="+mn-ea"/>
+                <a:cs typeface="+mn-cs"/>
+              </a:defRPr>
+            </a:lvl1pPr>
+            <a:lvl2pPr marL="304770" algn="l" defTabSz="609539" rtl="0" eaLnBrk="1" latinLnBrk="0" hangingPunct="1">
+              <a:defRPr sz="1200" kern="1200">
+                <a:solidFill>
+                  <a:schemeClr val="tx1"/>
+                </a:solidFill>
+                <a:latin typeface="+mn-lt"/>
+                <a:ea typeface="+mn-ea"/>
+                <a:cs typeface="+mn-cs"/>
+              </a:defRPr>
+            </a:lvl2pPr>
+            <a:lvl3pPr marL="609539" algn="l" defTabSz="609539" rtl="0" eaLnBrk="1" latinLnBrk="0" hangingPunct="1">
+              <a:defRPr sz="1200" kern="1200">
+                <a:solidFill>
+                  <a:schemeClr val="tx1"/>
+                </a:solidFill>
+                <a:latin typeface="+mn-lt"/>
+                <a:ea typeface="+mn-ea"/>
+                <a:cs typeface="+mn-cs"/>
+              </a:defRPr>
+            </a:lvl3pPr>
+            <a:lvl4pPr marL="914309" algn="l" defTabSz="609539" rtl="0" eaLnBrk="1" latinLnBrk="0" hangingPunct="1">
+              <a:defRPr sz="1200" kern="1200">
+                <a:solidFill>
+                  <a:schemeClr val="tx1"/>
+                </a:solidFill>
+                <a:latin typeface="+mn-lt"/>
+                <a:ea typeface="+mn-ea"/>
+                <a:cs typeface="+mn-cs"/>
+              </a:defRPr>
+            </a:lvl4pPr>
+            <a:lvl5pPr marL="1219078" algn="l" defTabSz="609539" rtl="0" eaLnBrk="1" latinLnBrk="0" hangingPunct="1">
+              <a:defRPr sz="1200" kern="1200">
+                <a:solidFill>
+                  <a:schemeClr val="tx1"/>
+                </a:solidFill>
+                <a:latin typeface="+mn-lt"/>
+                <a:ea typeface="+mn-ea"/>
+                <a:cs typeface="+mn-cs"/>
+              </a:defRPr>
+            </a:lvl5pPr>
+            <a:lvl6pPr marL="1523848" algn="l" defTabSz="609539" rtl="0" eaLnBrk="1" latinLnBrk="0" hangingPunct="1">
+              <a:defRPr sz="1200" kern="1200">
+                <a:solidFill>
+                  <a:schemeClr val="tx1"/>
+                </a:solidFill>
+                <a:latin typeface="+mn-lt"/>
+                <a:ea typeface="+mn-ea"/>
+                <a:cs typeface="+mn-cs"/>
+              </a:defRPr>
+            </a:lvl6pPr>
+            <a:lvl7pPr marL="1828617" algn="l" defTabSz="609539" rtl="0" eaLnBrk="1" latinLnBrk="0" hangingPunct="1">
+              <a:defRPr sz="1200" kern="1200">
+                <a:solidFill>
+                  <a:schemeClr val="tx1"/>
+                </a:solidFill>
+                <a:latin typeface="+mn-lt"/>
+                <a:ea typeface="+mn-ea"/>
+                <a:cs typeface="+mn-cs"/>
+              </a:defRPr>
+            </a:lvl7pPr>
+            <a:lvl8pPr marL="2133387" algn="l" defTabSz="609539" rtl="0" eaLnBrk="1" latinLnBrk="0" hangingPunct="1">
+              <a:defRPr sz="1200" kern="1200">
+                <a:solidFill>
+                  <a:schemeClr val="tx1"/>
+                </a:solidFill>
+                <a:latin typeface="+mn-lt"/>
+                <a:ea typeface="+mn-ea"/>
+                <a:cs typeface="+mn-cs"/>
+              </a:defRPr>
+            </a:lvl8pPr>
+            <a:lvl9pPr marL="2438156" algn="l" defTabSz="609539" rtl="0" eaLnBrk="1" latinLnBrk="0" hangingPunct="1">
+              <a:defRPr sz="1200" kern="1200">
+                <a:solidFill>
+                  <a:schemeClr val="tx1"/>
+                </a:solidFill>
+                <a:latin typeface="+mn-lt"/>
+                <a:ea typeface="+mn-ea"/>
+                <a:cs typeface="+mn-cs"/>
+              </a:defRPr>
+            </a:lvl9pPr>
+          </a:lstStyle>
+          <a:p>
+            <a:pPr>
+              <a:lnSpc>
+                <a:spcPts val="2239"/>
+              </a:lnSpc>
+              <a:spcBef>
+                <a:spcPct val="0"/>
+              </a:spcBef>
+            </a:pPr>
+            <a:r>
+              <a:rPr lang="en-US" sz="2400" dirty="0">
+                <a:solidFill>
+                  <a:srgbClr val="FFFFFF"/>
+                </a:solidFill>
+                <a:latin typeface="Montserrat"/>
+                <a:ea typeface="Montserrat"/>
+                <a:cs typeface="Montserrat"/>
+                <a:sym typeface="Montserrat"/>
+              </a:rPr>
+              <a:t>1.26.26</a:t>
+            </a:r>
+          </a:p>
+        </p:txBody>
+      </p:sp>
+      <p:sp>
+        <p:nvSpPr>
+          <p:cNvPr id="9" name="Freeform 93">
+            <a:extLst>
+              <a:ext uri="{FF2B5EF4-FFF2-40B4-BE49-F238E27FC236}">
+                <a16:creationId xmlns:a16="http://schemas.microsoft.com/office/drawing/2014/main" id="{5CD82284-60FD-3FA7-2488-2D1D3581D7D7}"/>
+              </a:ext>
+            </a:extLst>
+          </p:cNvPr>
+          <p:cNvSpPr/>
+          <p:nvPr/>
+        </p:nvSpPr>
+        <p:spPr>
+          <a:xfrm>
+            <a:off x="10312439" y="6176179"/>
+            <a:ext cx="1547547" cy="388627"/>
+          </a:xfrm>
+          <a:custGeom>
+            <a:avLst/>
+            <a:gdLst/>
+            <a:ahLst/>
+            <a:cxnLst/>
+            <a:rect l="l" t="t" r="r" b="b"/>
+            <a:pathLst>
+              <a:path w="2586660" h="664583">
+                <a:moveTo>
+                  <a:pt x="0" y="0"/>
+                </a:moveTo>
+                <a:lnTo>
+                  <a:pt x="2586660" y="0"/>
+                </a:lnTo>
+                <a:lnTo>
+                  <a:pt x="2586660" y="664582"/>
+                </a:lnTo>
+                <a:lnTo>
+                  <a:pt x="0" y="664582"/>
+                </a:lnTo>
+                <a:lnTo>
+                  <a:pt x="0" y="0"/>
+                </a:lnTo>
+                <a:close/>
+              </a:path>
+            </a:pathLst>
+          </a:custGeom>
+          <a:blipFill>
+            <a:blip r:embed="rId3"/>
+            <a:stretch>
+              <a:fillRect/>
+            </a:stretch>
+          </a:blipFill>
+        </p:spPr>
+        <p:txBody>
+          <a:bodyPr/>
+          <a:lstStyle/>
+          <a:p>
+            <a:endParaRPr lang="en-US"/>
+          </a:p>
+        </p:txBody>
+      </p:sp>
+    </p:spTree>
+    <p:extLst>
+      <p:ext uri="{BB962C8B-B14F-4D97-AF65-F5344CB8AC3E}">
+        <p14:creationId xmlns:p14="http://schemas.microsoft.com/office/powerpoint/2010/main" val="2658078358"/>
+      </p:ext>
+    </p:extLst>
+  </p:cSld>
+  <p:clrMapOvr>
+    <a:masterClrMapping/>
+  </p:clrMapOvr>
+</p:sld>
+</file>
+
+<file path=ppt/slides/slide2.xml><?xml version="1.0" encoding="utf-8"?>
+<p:sld xmlns:a="http://schemas.openxmlformats.org/drawingml/2006/main" xmlns:r="http://schemas.openxmlformats.org/officeDocument/2006/relationships" xmlns:p="http://schemas.openxmlformats.org/presentationml/2006/main">
+  <p:cSld>
+    <p:spTree>
+      <p:nvGrpSpPr>
+        <p:cNvPr id="1" name=""/>
+        <p:cNvGrpSpPr/>
+        <p:nvPr/>
+      </p:nvGrpSpPr>
+      <p:grpSpPr>
+        <a:xfrm>
+          <a:off x="0" y="0"/>
+          <a:ext cx="0" cy="0"/>
+          <a:chOff x="0" y="0"/>
+          <a:chExt cx="0" cy="0"/>
+        </a:xfrm>
+      </p:grpSpPr>
+      <p:sp>
+        <p:nvSpPr>
+          <p:cNvPr id="2" name="Title 1">
+            <a:extLst>
+              <a:ext uri="{FF2B5EF4-FFF2-40B4-BE49-F238E27FC236}">
+                <a16:creationId xmlns:a16="http://schemas.microsoft.com/office/drawing/2014/main" id="{41D3548C-A52F-4422-99BB-66D5C688FC76}"/>
+              </a:ext>
+            </a:extLst>
+          </p:cNvPr>
+          <p:cNvSpPr>
+            <a:spLocks noGrp="1"/>
+          </p:cNvSpPr>
+          <p:nvPr>
+            <p:ph type="title"/>
+          </p:nvPr>
+        </p:nvSpPr>
+        <p:spPr/>
+        <p:txBody>
+          <a:bodyPr/>
+          <a:lstStyle/>
+          <a:p>
+            <a:endParaRPr lang="en-US"/>
+          </a:p>
+        </p:txBody>
+      </p:sp>
+      <p:sp>
+        <p:nvSpPr>
+          <p:cNvPr id="3" name="Content Placeholder 2">
+            <a:extLst>
+              <a:ext uri="{FF2B5EF4-FFF2-40B4-BE49-F238E27FC236}">
+                <a16:creationId xmlns:a16="http://schemas.microsoft.com/office/drawing/2014/main" id="{E5EEDD2B-DCB3-6765-DC8D-17DC3D99C103}"/>
+              </a:ext>
+            </a:extLst>
+          </p:cNvPr>
+          <p:cNvSpPr>
+            <a:spLocks noGrp="1"/>
+          </p:cNvSpPr>
+          <p:nvPr>
+            <p:ph sz="half" idx="2"/>
+          </p:nvPr>
+        </p:nvSpPr>
+        <p:spPr/>
+        <p:txBody>
+          <a:bodyPr/>
+          <a:lstStyle/>
+          <a:p>
+            <a:endParaRPr lang="en-US"/>
+          </a:p>
+        </p:txBody>
+      </p:sp>
+      <p:sp>
+        <p:nvSpPr>
+          <p:cNvPr id="4" name="Text Placeholder 3">
+            <a:extLst>
+              <a:ext uri="{FF2B5EF4-FFF2-40B4-BE49-F238E27FC236}">
+                <a16:creationId xmlns:a16="http://schemas.microsoft.com/office/drawing/2014/main" id="{20FC5147-5205-AA7D-70EA-CCE388E6F169}"/>
+              </a:ext>
+            </a:extLst>
+          </p:cNvPr>
+          <p:cNvSpPr>
+            <a:spLocks noGrp="1"/>
+          </p:cNvSpPr>
+          <p:nvPr>
+            <p:ph type="body" idx="1"/>
+          </p:nvPr>
+        </p:nvSpPr>
+        <p:spPr/>
+        <p:txBody>
+          <a:bodyPr/>
+          <a:lstStyle/>
+          <a:p>
+            <a:endParaRPr lang="en-US"/>
+          </a:p>
+        </p:txBody>
+      </p:sp>
+    </p:spTree>
+    <p:extLst>
+      <p:ext uri="{BB962C8B-B14F-4D97-AF65-F5344CB8AC3E}">
+        <p14:creationId xmlns:p14="http://schemas.microsoft.com/office/powerpoint/2010/main" val="3114367268"/>
+      </p:ext>
+    </p:extLst>
+  </p:cSld>
+  <p:clrMapOvr>
+    <a:masterClrMapping/>
+  </p:clrMapOvr>
+</p:sld>
+</file>
+
+<file path=ppt/slides/slide3.xml><?xml version="1.0" encoding="utf-8"?>
 <p:sld xmlns:a="http://schemas.openxmlformats.org/drawingml/2006/main" xmlns:p="http://schemas.openxmlformats.org/presentationml/2006/main" xmlns:r="http://schemas.openxmlformats.org/officeDocument/2006/relationships">
   <p:cSld>
     <p:spTree>
@@ -4220,7 +4799,7 @@
         <p:spPr>
           <a:xfrm>
             <a:off x="365760" y="164592"/>
-            <a:ext cx="11430000" cy="713232"/>
+            <a:ext cx="11430000" cy="658368"/>
           </a:xfrm>
           <a:prstGeom prst="rect">
             <a:avLst/>
@@ -4235,7 +4814,7 @@
           <a:p>
             <a:pPr algn="l"/>
             <a:r>
-              <a:rPr sz="4600" b="1" i="0">
+              <a:rPr sz="4400" b="1" i="0">
                 <a:solidFill>
                   <a:srgbClr val="FFFFFF"/>
                 </a:solidFill>
@@ -4253,8 +4832,8 @@
         </p:nvSpPr>
         <p:spPr>
           <a:xfrm>
-            <a:off x="365760" y="877824"/>
-            <a:ext cx="11430000" cy="310896"/>
+            <a:off x="365760" y="822960"/>
+            <a:ext cx="11430000" cy="274320"/>
           </a:xfrm>
           <a:prstGeom prst="rect">
             <a:avLst/>
@@ -4269,7 +4848,7 @@
           <a:p>
             <a:pPr algn="l"/>
             <a:r>
-              <a:rPr sz="1300" b="0" i="0">
+              <a:rPr sz="1250" b="0" i="0">
                 <a:solidFill>
                   <a:srgbClr val="8AA8C8"/>
                 </a:solidFill>
@@ -4287,8 +4866,8 @@
         </p:nvSpPr>
         <p:spPr>
           <a:xfrm>
-            <a:off x="365760" y="1298448"/>
-            <a:ext cx="11457432" cy="713232"/>
+            <a:off x="365760" y="1188720"/>
+            <a:ext cx="11457432" cy="603504"/>
           </a:xfrm>
           <a:prstGeom prst="rect">
             <a:avLst/>
@@ -4330,8 +4909,8 @@
         </p:nvSpPr>
         <p:spPr>
           <a:xfrm>
-            <a:off x="365760" y="1298448"/>
-            <a:ext cx="45720" cy="713232"/>
+            <a:off x="365760" y="1188720"/>
+            <a:ext cx="45720" cy="603504"/>
           </a:xfrm>
           <a:prstGeom prst="rect">
             <a:avLst/>
@@ -4373,7 +4952,7 @@
         </p:nvSpPr>
         <p:spPr>
           <a:xfrm>
-            <a:off x="502920" y="1335024"/>
+            <a:off x="502920" y="1225296"/>
             <a:ext cx="3200400" cy="182880"/>
           </a:xfrm>
           <a:prstGeom prst="rect">
@@ -4407,8 +4986,8 @@
         </p:nvSpPr>
         <p:spPr>
           <a:xfrm>
-            <a:off x="502920" y="1517904"/>
-            <a:ext cx="11155680" cy="420624"/>
+            <a:off x="502920" y="1389888"/>
+            <a:ext cx="11155680" cy="347472"/>
           </a:xfrm>
           <a:prstGeom prst="rect">
             <a:avLst/>
@@ -4428,7 +5007,7 @@
                   <a:srgbClr val="FFFFFF"/>
                 </a:solidFill>
               </a:rPr>
-              <a:t>Robin is focused on two things: accelerating revenue by giving the sales team better intelligence and tools — and improving efficiency by automating the work that shouldn't require a human.</a:t>
+              <a:t>Built for the Rev.io sales team — automating intelligence, research, and execution so reps spend more time selling and less time on manual work.</a:t>
             </a:r>
           </a:p>
         </p:txBody>
@@ -4441,8 +5020,8 @@
         </p:nvSpPr>
         <p:spPr>
           <a:xfrm>
-            <a:off x="365760" y="2139696"/>
-            <a:ext cx="11457432" cy="4261104"/>
+            <a:off x="365760" y="1901952"/>
+            <a:ext cx="3739896" cy="4590288"/>
           </a:xfrm>
           <a:prstGeom prst="rect">
             <a:avLst/>
@@ -4484,8 +5063,8 @@
         </p:nvSpPr>
         <p:spPr>
           <a:xfrm>
-            <a:off x="365760" y="2139696"/>
-            <a:ext cx="45720" cy="4261104"/>
+            <a:off x="365760" y="1901952"/>
+            <a:ext cx="45720" cy="4590288"/>
           </a:xfrm>
           <a:prstGeom prst="rect">
             <a:avLst/>
@@ -4527,8 +5106,8 @@
         </p:nvSpPr>
         <p:spPr>
           <a:xfrm>
-            <a:off x="566928" y="2267712"/>
-            <a:ext cx="7315200" cy="548640"/>
+            <a:off x="530352" y="2011680"/>
+            <a:ext cx="3511296" cy="457200"/>
           </a:xfrm>
           <a:prstGeom prst="rect">
             <a:avLst/>
@@ -4543,7 +5122,7 @@
           <a:p>
             <a:pPr algn="l"/>
             <a:r>
-              <a:rPr sz="3600" b="1" i="0">
+              <a:rPr sz="2200" b="1" i="0">
                 <a:solidFill>
                   <a:srgbClr val="FFFFFF"/>
                 </a:solidFill>
@@ -4561,8 +5140,8 @@
         </p:nvSpPr>
         <p:spPr>
           <a:xfrm>
-            <a:off x="566928" y="2816352"/>
-            <a:ext cx="8229600" cy="274320"/>
+            <a:off x="530352" y="2487168"/>
+            <a:ext cx="3511296" cy="347472"/>
           </a:xfrm>
           <a:prstGeom prst="rect">
             <a:avLst/>
@@ -4577,7 +5156,7 @@
           <a:p>
             <a:pPr algn="l"/>
             <a:r>
-              <a:rPr sz="1500" b="0" i="0">
+              <a:rPr sz="1000" b="0" i="0">
                 <a:solidFill>
                   <a:srgbClr val="00D4D4"/>
                 </a:solidFill>
@@ -4595,8 +5174,8 @@
         </p:nvSpPr>
         <p:spPr>
           <a:xfrm>
-            <a:off x="566928" y="3099815"/>
-            <a:ext cx="6400800" cy="237744"/>
+            <a:off x="530352" y="2834640"/>
+            <a:ext cx="3511296" cy="237744"/>
           </a:xfrm>
           <a:prstGeom prst="rect">
             <a:avLst/>
@@ -4611,7 +5190,7 @@
           <a:p>
             <a:pPr algn="l"/>
             <a:r>
-              <a:rPr sz="1100" b="0" i="1">
+              <a:rPr sz="900" b="0" i="1">
                 <a:solidFill>
                   <a:srgbClr val="8AA8C8"/>
                 </a:solidFill>
@@ -4629,8 +5208,8 @@
         </p:nvSpPr>
         <p:spPr>
           <a:xfrm>
-            <a:off x="566928" y="3401568"/>
-            <a:ext cx="11055096" cy="18288"/>
+            <a:off x="530352" y="3090672"/>
+            <a:ext cx="3465576" cy="18288"/>
           </a:xfrm>
           <a:prstGeom prst="rect">
             <a:avLst/>
@@ -4672,8 +5251,8 @@
         </p:nvSpPr>
         <p:spPr>
           <a:xfrm>
-            <a:off x="566928" y="3511296"/>
-            <a:ext cx="5486400" cy="475488"/>
+            <a:off x="530352" y="3200400"/>
+            <a:ext cx="3511296" cy="219456"/>
           </a:xfrm>
           <a:prstGeom prst="rect">
             <a:avLst/>
@@ -4688,12 +5267,12 @@
           <a:p>
             <a:pPr algn="l"/>
             <a:r>
-              <a:rPr sz="1100" b="1" i="0">
+              <a:rPr sz="950" b="1" i="0">
                 <a:solidFill>
                   <a:srgbClr val="FFFFFF"/>
                 </a:solidFill>
               </a:rPr>
-              <a:t>• TRACKING SALES TEAM ACTIVITY POINTS</a:t>
+              <a:t>• ACTIVITY POINT TRACKING</a:t>
             </a:r>
           </a:p>
         </p:txBody>
@@ -4706,8 +5285,8 @@
         </p:nvSpPr>
         <p:spPr>
           <a:xfrm>
-            <a:off x="566928" y="4105656"/>
-            <a:ext cx="5486400" cy="475488"/>
+            <a:off x="621792" y="3438144"/>
+            <a:ext cx="3419856" cy="457200"/>
           </a:xfrm>
           <a:prstGeom prst="rect">
             <a:avLst/>
@@ -4722,12 +5301,12 @@
           <a:p>
             <a:pPr algn="l"/>
             <a:r>
-              <a:rPr sz="1100" b="1" i="0">
-                <a:solidFill>
-                  <a:srgbClr val="FFFFFF"/>
+              <a:rPr sz="850" b="0" i="0">
+                <a:solidFill>
+                  <a:srgbClr val="8AA8C8"/>
                 </a:solidFill>
               </a:rPr>
-              <a:t>• RUNNING WEEKLY CALL BLITZES</a:t>
+              <a:t>Scores and monitors rep activity daily across calls, emails, meetings, and opps sourced.</a:t>
             </a:r>
           </a:p>
         </p:txBody>
@@ -4740,8 +5319,8 @@
         </p:nvSpPr>
         <p:spPr>
           <a:xfrm>
-            <a:off x="566928" y="4700016"/>
-            <a:ext cx="5486400" cy="475488"/>
+            <a:off x="530352" y="3977639"/>
+            <a:ext cx="3511296" cy="219456"/>
           </a:xfrm>
           <a:prstGeom prst="rect">
             <a:avLst/>
@@ -4756,12 +5335,12 @@
           <a:p>
             <a:pPr algn="l"/>
             <a:r>
-              <a:rPr sz="1100" b="1" i="0">
+              <a:rPr sz="950" b="1" i="0">
                 <a:solidFill>
                   <a:srgbClr val="FFFFFF"/>
                 </a:solidFill>
               </a:rPr>
-              <a:t>• RESEARCHING NEW PROSPECTS NOT IN CRM</a:t>
+              <a:t>• WEEKLY CALL BLITZES</a:t>
             </a:r>
           </a:p>
         </p:txBody>
@@ -4774,8 +5353,8 @@
         </p:nvSpPr>
         <p:spPr>
           <a:xfrm>
-            <a:off x="566928" y="5294376"/>
-            <a:ext cx="5486400" cy="475488"/>
+            <a:off x="621792" y="4215383"/>
+            <a:ext cx="3419856" cy="457200"/>
           </a:xfrm>
           <a:prstGeom prst="rect">
             <a:avLst/>
@@ -4790,12 +5369,12 @@
           <a:p>
             <a:pPr algn="l"/>
             <a:r>
-              <a:rPr sz="1100" b="1" i="0">
-                <a:solidFill>
-                  <a:srgbClr val="FFFFFF"/>
+              <a:rPr sz="850" b="0" i="0">
+                <a:solidFill>
+                  <a:srgbClr val="8AA8C8"/>
                 </a:solidFill>
               </a:rPr>
-              <a:t>• BUILT COMPETITOR BATTLECARD DASHBOARD</a:t>
+              <a:t>Runs structured call blitzes with live tracking and coaching nudges for the team.</a:t>
             </a:r>
           </a:p>
         </p:txBody>
@@ -4808,8 +5387,8 @@
         </p:nvSpPr>
         <p:spPr>
           <a:xfrm>
-            <a:off x="6400800" y="3511296"/>
-            <a:ext cx="5577840" cy="475488"/>
+            <a:off x="530352" y="4754880"/>
+            <a:ext cx="3511296" cy="219456"/>
           </a:xfrm>
           <a:prstGeom prst="rect">
             <a:avLst/>
@@ -4824,12 +5403,12 @@
           <a:p>
             <a:pPr algn="l"/>
             <a:r>
-              <a:rPr sz="1100" b="1" i="0">
+              <a:rPr sz="950" b="1" i="0">
                 <a:solidFill>
                   <a:srgbClr val="FFFFFF"/>
                 </a:solidFill>
               </a:rPr>
-              <a:t>• AUTOMATED WEEKLY FORECAST DECKS FOR ELT</a:t>
+              <a:t>• PROSPECT RESEARCH</a:t>
             </a:r>
           </a:p>
         </p:txBody>
@@ -4842,8 +5421,8 @@
         </p:nvSpPr>
         <p:spPr>
           <a:xfrm>
-            <a:off x="6400800" y="4105656"/>
-            <a:ext cx="5577840" cy="475488"/>
+            <a:off x="621792" y="4992624"/>
+            <a:ext cx="3419856" cy="457200"/>
           </a:xfrm>
           <a:prstGeom prst="rect">
             <a:avLst/>
@@ -4858,12 +5437,12 @@
           <a:p>
             <a:pPr algn="l"/>
             <a:r>
-              <a:rPr sz="1100" b="1" i="0">
-                <a:solidFill>
-                  <a:srgbClr val="FFFFFF"/>
+              <a:rPr sz="850" b="0" i="0">
+                <a:solidFill>
+                  <a:srgbClr val="8AA8C8"/>
                 </a:solidFill>
               </a:rPr>
-              <a:t>• DISCOVERY NO-SHOW TREND ANALYSIS</a:t>
+              <a:t>Finds net-new accounts not in the CRM — verified and enriched before reps see them.</a:t>
             </a:r>
           </a:p>
         </p:txBody>
@@ -4876,8 +5455,8 @@
         </p:nvSpPr>
         <p:spPr>
           <a:xfrm>
-            <a:off x="6400800" y="4700016"/>
-            <a:ext cx="5577840" cy="475488"/>
+            <a:off x="530352" y="5532120"/>
+            <a:ext cx="3511296" cy="219456"/>
           </a:xfrm>
           <a:prstGeom prst="rect">
             <a:avLst/>
@@ -4892,12 +5471,12 @@
           <a:p>
             <a:pPr algn="l"/>
             <a:r>
-              <a:rPr sz="1100" b="1" i="0">
+              <a:rPr sz="950" b="1" i="0">
                 <a:solidFill>
                   <a:srgbClr val="FFFFFF"/>
                 </a:solidFill>
               </a:rPr>
-              <a:t>• SOFTWARE MISSING CAPABILITIES DEEP DIVE</a:t>
+              <a:t>• FORECAST DECKS FOR ELT</a:t>
             </a:r>
           </a:p>
         </p:txBody>
@@ -4910,8 +5489,8 @@
         </p:nvSpPr>
         <p:spPr>
           <a:xfrm>
-            <a:off x="6400800" y="5294376"/>
-            <a:ext cx="5577840" cy="475488"/>
+            <a:off x="621792" y="5769864"/>
+            <a:ext cx="3419856" cy="457200"/>
           </a:xfrm>
           <a:prstGeom prst="rect">
             <a:avLst/>
@@ -4926,12 +5505,12 @@
           <a:p>
             <a:pPr algn="l"/>
             <a:r>
-              <a:rPr sz="1100" b="1" i="0">
-                <a:solidFill>
-                  <a:srgbClr val="FFFFFF"/>
+              <a:rPr sz="850" b="0" i="0">
+                <a:solidFill>
+                  <a:srgbClr val="8AA8C8"/>
                 </a:solidFill>
               </a:rPr>
-              <a:t>• MORNING BRIEFINGS &amp; PIPELINE INTELLIGENCE</a:t>
+              <a:t>Automated weekly forecast dashboard with live Salesforce data pushed to leadership.</a:t>
             </a:r>
           </a:p>
         </p:txBody>
@@ -4944,14 +5523,14 @@
         </p:nvSpPr>
         <p:spPr>
           <a:xfrm>
-            <a:off x="0" y="6675120"/>
-            <a:ext cx="12188952" cy="182880"/>
+            <a:off x="4224528" y="1901952"/>
+            <a:ext cx="3739896" cy="4590288"/>
           </a:xfrm>
           <a:prstGeom prst="rect">
             <a:avLst/>
           </a:prstGeom>
           <a:solidFill>
-            <a:srgbClr val="071220"/>
+            <a:srgbClr val="0A1E30"/>
           </a:solidFill>
           <a:ln>
             <a:noFill/>
@@ -4981,208 +5560,20 @@
       </p:sp>
       <p:sp>
         <p:nvSpPr>
-          <p:cNvPr id="23" name="TextBox 22"/>
-          <p:cNvSpPr txBox="1"/>
-          <p:nvPr/>
-        </p:nvSpPr>
-        <p:spPr>
-          <a:xfrm>
-            <a:off x="274320" y="6693408"/>
-            <a:ext cx="1828800" cy="146304"/>
-          </a:xfrm>
-          <a:prstGeom prst="rect">
-            <a:avLst/>
-          </a:prstGeom>
-          <a:noFill/>
-        </p:spPr>
-        <p:txBody>
-          <a:bodyPr wrap="square">
-            <a:spAutoFit/>
-          </a:bodyPr>
-          <a:lstStyle/>
-          <a:p>
-            <a:pPr algn="l"/>
-            <a:r>
-              <a:rPr sz="900" b="1" i="0">
-                <a:solidFill>
-                  <a:srgbClr val="FFFFFF"/>
-                </a:solidFill>
-              </a:rPr>
-              <a:t>• rev.io</a:t>
-            </a:r>
-          </a:p>
-        </p:txBody>
-      </p:sp>
-      <p:sp>
-        <p:nvSpPr>
-          <p:cNvPr id="24" name="TextBox 23"/>
-          <p:cNvSpPr txBox="1"/>
-          <p:nvPr/>
-        </p:nvSpPr>
-        <p:spPr>
-          <a:xfrm>
-            <a:off x="8686800" y="6693408"/>
-            <a:ext cx="2011680" cy="146304"/>
-          </a:xfrm>
-          <a:prstGeom prst="rect">
-            <a:avLst/>
-          </a:prstGeom>
-          <a:noFill/>
-        </p:spPr>
-        <p:txBody>
-          <a:bodyPr wrap="square">
-            <a:spAutoFit/>
-          </a:bodyPr>
-          <a:lstStyle/>
-          <a:p>
-            <a:pPr algn="r"/>
-            <a:r>
-              <a:rPr sz="900" b="1" i="0">
-                <a:solidFill>
-                  <a:srgbClr val="FFFFFF"/>
-                </a:solidFill>
-              </a:rPr>
-              <a:t>BUILT FOR TOMORROW.</a:t>
-            </a:r>
-          </a:p>
-        </p:txBody>
-      </p:sp>
-      <p:sp>
-        <p:nvSpPr>
-          <p:cNvPr id="25" name="TextBox 24"/>
-          <p:cNvSpPr txBox="1"/>
-          <p:nvPr/>
-        </p:nvSpPr>
-        <p:spPr>
-          <a:xfrm>
-            <a:off x="10698480" y="6693408"/>
-            <a:ext cx="1371600" cy="146304"/>
-          </a:xfrm>
-          <a:prstGeom prst="rect">
-            <a:avLst/>
-          </a:prstGeom>
-          <a:noFill/>
-        </p:spPr>
-        <p:txBody>
-          <a:bodyPr wrap="square">
-            <a:spAutoFit/>
-          </a:bodyPr>
-          <a:lstStyle/>
-          <a:p>
-            <a:pPr algn="r"/>
-            <a:r>
-              <a:rPr sz="900" b="1" i="0">
-                <a:solidFill>
-                  <a:srgbClr val="3DC570"/>
-                </a:solidFill>
-              </a:rPr>
-              <a:t>READY FOR TODAY.</a:t>
-            </a:r>
-          </a:p>
-        </p:txBody>
-      </p:sp>
-    </p:spTree>
-  </p:cSld>
-  <p:clrMapOvr>
-    <a:masterClrMapping/>
-  </p:clrMapOvr>
-</p:sld>
-</file>
-
-<file path=ppt/slides/slide1.xml><?xml version="1.0" encoding="utf-8"?>
-<p:sld xmlns:a="http://schemas.openxmlformats.org/drawingml/2006/main" xmlns:p="http://schemas.openxmlformats.org/presentationml/2006/main" xmlns:r="http://schemas.openxmlformats.org/officeDocument/2006/relationships">
-  <p:cSld>
-    <p:spTree>
-      <p:nvGrpSpPr>
-        <p:cNvPr id="1" name=""/>
-        <p:cNvGrpSpPr/>
-        <p:nvPr/>
-      </p:nvGrpSpPr>
-      <p:grpSpPr/>
-      <p:sp>
-        <p:nvSpPr>
-          <p:cNvPr id="2" name="TextBox 1"/>
-          <p:cNvSpPr txBox="1"/>
-          <p:nvPr/>
-        </p:nvSpPr>
-        <p:spPr>
-          <a:xfrm>
-            <a:off x="365760" y="164592"/>
-            <a:ext cx="11430000" cy="713232"/>
-          </a:xfrm>
-          <a:prstGeom prst="rect">
-            <a:avLst/>
-          </a:prstGeom>
-          <a:noFill/>
-        </p:spPr>
-        <p:txBody>
-          <a:bodyPr wrap="square">
-            <a:spAutoFit/>
-          </a:bodyPr>
-          <a:lstStyle/>
-          <a:p>
-            <a:pPr algn="l"/>
-            <a:r>
-              <a:rPr sz="4600" b="1" i="0">
-                <a:solidFill>
-                  <a:srgbClr val="FFFFFF"/>
-                </a:solidFill>
-              </a:rPr>
-              <a:t>Meet Robin</a:t>
-            </a:r>
-          </a:p>
-        </p:txBody>
-      </p:sp>
-      <p:sp>
-        <p:nvSpPr>
-          <p:cNvPr id="3" name="TextBox 2"/>
-          <p:cNvSpPr txBox="1"/>
-          <p:nvPr/>
-        </p:nvSpPr>
-        <p:spPr>
-          <a:xfrm>
-            <a:off x="365760" y="877824"/>
-            <a:ext cx="11430000" cy="310896"/>
-          </a:xfrm>
-          <a:prstGeom prst="rect">
-            <a:avLst/>
-          </a:prstGeom>
-          <a:noFill/>
-        </p:spPr>
-        <p:txBody>
-          <a:bodyPr wrap="square">
-            <a:spAutoFit/>
-          </a:bodyPr>
-          <a:lstStyle/>
-          <a:p>
-            <a:pPr algn="l"/>
-            <a:r>
-              <a:rPr sz="1300" b="0" i="0">
-                <a:solidFill>
-                  <a:srgbClr val="8AA8C8"/>
-                </a:solidFill>
-              </a:rPr>
-              <a:t>Rev.io's AI Sales Assistant — running 24/7 to power the sales team.</a:t>
-            </a:r>
-          </a:p>
-        </p:txBody>
-      </p:sp>
-      <p:sp>
-        <p:nvSpPr>
-          <p:cNvPr id="4" name="Rectangle 3"/>
+          <p:cNvPr id="23" name="Rectangle 22"/>
           <p:cNvSpPr/>
           <p:nvPr/>
         </p:nvSpPr>
         <p:spPr>
           <a:xfrm>
-            <a:off x="365760" y="1298448"/>
-            <a:ext cx="11457432" cy="713232"/>
+            <a:off x="4224528" y="1901952"/>
+            <a:ext cx="45720" cy="4590288"/>
           </a:xfrm>
           <a:prstGeom prst="rect">
             <a:avLst/>
           </a:prstGeom>
           <a:solidFill>
-            <a:srgbClr val="0A1E30"/>
+            <a:srgbClr val="7C3AED"/>
           </a:solidFill>
           <a:ln>
             <a:noFill/>
@@ -5212,20 +5603,122 @@
       </p:sp>
       <p:sp>
         <p:nvSpPr>
-          <p:cNvPr id="5" name="Rectangle 4"/>
+          <p:cNvPr id="24" name="TextBox 23"/>
+          <p:cNvSpPr txBox="1"/>
+          <p:nvPr/>
+        </p:nvSpPr>
+        <p:spPr>
+          <a:xfrm>
+            <a:off x="4389120" y="2011680"/>
+            <a:ext cx="3511296" cy="457200"/>
+          </a:xfrm>
+          <a:prstGeom prst="rect">
+            <a:avLst/>
+          </a:prstGeom>
+          <a:noFill/>
+        </p:spPr>
+        <p:txBody>
+          <a:bodyPr wrap="square">
+            <a:spAutoFit/>
+          </a:bodyPr>
+          <a:lstStyle/>
+          <a:p>
+            <a:pPr algn="l"/>
+            <a:r>
+              <a:rPr sz="2200" b="1" i="0">
+                <a:solidFill>
+                  <a:srgbClr val="FFFFFF"/>
+                </a:solidFill>
+              </a:rPr>
+              <a:t>📓  Notion</a:t>
+            </a:r>
+          </a:p>
+        </p:txBody>
+      </p:sp>
+      <p:sp>
+        <p:nvSpPr>
+          <p:cNvPr id="25" name="TextBox 24"/>
+          <p:cNvSpPr txBox="1"/>
+          <p:nvPr/>
+        </p:nvSpPr>
+        <p:spPr>
+          <a:xfrm>
+            <a:off x="4389120" y="2487168"/>
+            <a:ext cx="3511296" cy="347472"/>
+          </a:xfrm>
+          <a:prstGeom prst="rect">
+            <a:avLst/>
+          </a:prstGeom>
+          <a:noFill/>
+        </p:spPr>
+        <p:txBody>
+          <a:bodyPr wrap="square">
+            <a:spAutoFit/>
+          </a:bodyPr>
+          <a:lstStyle/>
+          <a:p>
+            <a:pPr algn="l"/>
+            <a:r>
+              <a:rPr sz="1000" b="0" i="0">
+                <a:solidFill>
+                  <a:srgbClr val="7C3AED"/>
+                </a:solidFill>
+              </a:rPr>
+              <a:t>AI-Powered Knowledge &amp; Workflow Automation</a:t>
+            </a:r>
+          </a:p>
+        </p:txBody>
+      </p:sp>
+      <p:sp>
+        <p:nvSpPr>
+          <p:cNvPr id="26" name="TextBox 25"/>
+          <p:cNvSpPr txBox="1"/>
+          <p:nvPr/>
+        </p:nvSpPr>
+        <p:spPr>
+          <a:xfrm>
+            <a:off x="4389120" y="2834640"/>
+            <a:ext cx="3511296" cy="237744"/>
+          </a:xfrm>
+          <a:prstGeom prst="rect">
+            <a:avLst/>
+          </a:prstGeom>
+          <a:noFill/>
+        </p:spPr>
+        <p:txBody>
+          <a:bodyPr wrap="square">
+            <a:spAutoFit/>
+          </a:bodyPr>
+          <a:lstStyle/>
+          <a:p>
+            <a:pPr algn="l"/>
+            <a:r>
+              <a:rPr sz="900" b="0" i="1">
+                <a:solidFill>
+                  <a:srgbClr val="8AA8C8"/>
+                </a:solidFill>
+              </a:rPr>
+              <a:t>Meeting intelligence · Personalization · Follow-up</a:t>
+            </a:r>
+          </a:p>
+        </p:txBody>
+      </p:sp>
+      <p:sp>
+        <p:nvSpPr>
+          <p:cNvPr id="27" name="Rectangle 26"/>
           <p:cNvSpPr/>
           <p:nvPr/>
         </p:nvSpPr>
         <p:spPr>
           <a:xfrm>
-            <a:off x="365760" y="1298448"/>
-            <a:ext cx="45720" cy="713232"/>
+            <a:off x="4389120" y="3090672"/>
+            <a:ext cx="3465576" cy="18288"/>
           </a:xfrm>
           <a:prstGeom prst="rect">
             <a:avLst/>
           </a:prstGeom>
           <a:solidFill>
-            <a:srgbClr val="00D4D4"/>
+            <a:srgbClr val="1A3555"/>
           </a:solidFill>
           <a:ln>
             <a:noFill/>
@@ -5255,14 +5748,14 @@
       </p:sp>
       <p:sp>
         <p:nvSpPr>
-          <p:cNvPr id="6" name="TextBox 5"/>
+          <p:cNvPr id="28" name="TextBox 27"/>
           <p:cNvSpPr txBox="1"/>
           <p:nvPr/>
         </p:nvSpPr>
         <p:spPr>
           <a:xfrm>
-            <a:off x="502920" y="1335024"/>
-            <a:ext cx="3200400" cy="182880"/>
+            <a:off x="4389120" y="3200400"/>
+            <a:ext cx="3511296" cy="219456"/>
           </a:xfrm>
           <a:prstGeom prst="rect">
             <a:avLst/>
@@ -5277,26 +5770,26 @@
           <a:p>
             <a:pPr algn="l"/>
             <a:r>
-              <a:rPr sz="800" b="1" i="0">
-                <a:solidFill>
-                  <a:srgbClr val="3DC570"/>
+              <a:rPr sz="950" b="1" i="0">
+                <a:solidFill>
+                  <a:srgbClr val="FFFFFF"/>
                 </a:solidFill>
               </a:rPr>
-              <a:t>WHAT ROBIN DOES</a:t>
-            </a:r>
-          </a:p>
-        </p:txBody>
-      </p:sp>
-      <p:sp>
-        <p:nvSpPr>
-          <p:cNvPr id="7" name="TextBox 6"/>
+              <a:t>• MSP EMAIL PERSONALIZATION</a:t>
+            </a:r>
+          </a:p>
+        </p:txBody>
+      </p:sp>
+      <p:sp>
+        <p:nvSpPr>
+          <p:cNvPr id="29" name="TextBox 28"/>
           <p:cNvSpPr txBox="1"/>
           <p:nvPr/>
         </p:nvSpPr>
         <p:spPr>
           <a:xfrm>
-            <a:off x="502920" y="1517904"/>
-            <a:ext cx="11155680" cy="420624"/>
+            <a:off x="4480560" y="3438144"/>
+            <a:ext cx="3419856" cy="457200"/>
           </a:xfrm>
           <a:prstGeom prst="rect">
             <a:avLst/>
@@ -5311,26 +5804,162 @@
           <a:p>
             <a:pPr algn="l"/>
             <a:r>
-              <a:rPr sz="1050" b="0" i="0">
+              <a:rPr sz="850" b="0" i="0">
+                <a:solidFill>
+                  <a:srgbClr val="8AA8C8"/>
+                </a:solidFill>
+              </a:rPr>
+              <a:t>Researches each prospect and writes personalized outreach automatically — no manual prep.</a:t>
+            </a:r>
+          </a:p>
+        </p:txBody>
+      </p:sp>
+      <p:sp>
+        <p:nvSpPr>
+          <p:cNvPr id="30" name="TextBox 29"/>
+          <p:cNvSpPr txBox="1"/>
+          <p:nvPr/>
+        </p:nvSpPr>
+        <p:spPr>
+          <a:xfrm>
+            <a:off x="4389120" y="3977639"/>
+            <a:ext cx="3511296" cy="219456"/>
+          </a:xfrm>
+          <a:prstGeom prst="rect">
+            <a:avLst/>
+          </a:prstGeom>
+          <a:noFill/>
+        </p:spPr>
+        <p:txBody>
+          <a:bodyPr wrap="square">
+            <a:spAutoFit/>
+          </a:bodyPr>
+          <a:lstStyle/>
+          <a:p>
+            <a:pPr algn="l"/>
+            <a:r>
+              <a:rPr sz="950" b="1" i="0">
                 <a:solidFill>
                   <a:srgbClr val="FFFFFF"/>
                 </a:solidFill>
               </a:rPr>
-              <a:t>Robin is focused on two things: accelerating revenue by giving the sales team better intelligence and tools — and improving efficiency by automating the work that shouldn't require a human.</a:t>
-            </a:r>
-          </a:p>
-        </p:txBody>
-      </p:sp>
-      <p:sp>
-        <p:nvSpPr>
-          <p:cNvPr id="8" name="Rectangle 7"/>
+              <a:t>• MEETING TRANSCRIPTION</a:t>
+            </a:r>
+          </a:p>
+        </p:txBody>
+      </p:sp>
+      <p:sp>
+        <p:nvSpPr>
+          <p:cNvPr id="31" name="TextBox 30"/>
+          <p:cNvSpPr txBox="1"/>
+          <p:nvPr/>
+        </p:nvSpPr>
+        <p:spPr>
+          <a:xfrm>
+            <a:off x="4480560" y="4215383"/>
+            <a:ext cx="3419856" cy="457200"/>
+          </a:xfrm>
+          <a:prstGeom prst="rect">
+            <a:avLst/>
+          </a:prstGeom>
+          <a:noFill/>
+        </p:spPr>
+        <p:txBody>
+          <a:bodyPr wrap="square">
+            <a:spAutoFit/>
+          </a:bodyPr>
+          <a:lstStyle/>
+          <a:p>
+            <a:pPr algn="l"/>
+            <a:r>
+              <a:rPr sz="850" b="0" i="0">
+                <a:solidFill>
+                  <a:srgbClr val="8AA8C8"/>
+                </a:solidFill>
+              </a:rPr>
+              <a:t>Captures full notes, key takeaways, and action items from every prospect call.</a:t>
+            </a:r>
+          </a:p>
+        </p:txBody>
+      </p:sp>
+      <p:sp>
+        <p:nvSpPr>
+          <p:cNvPr id="32" name="TextBox 31"/>
+          <p:cNvSpPr txBox="1"/>
+          <p:nvPr/>
+        </p:nvSpPr>
+        <p:spPr>
+          <a:xfrm>
+            <a:off x="4389120" y="4754880"/>
+            <a:ext cx="3511296" cy="219456"/>
+          </a:xfrm>
+          <a:prstGeom prst="rect">
+            <a:avLst/>
+          </a:prstGeom>
+          <a:noFill/>
+        </p:spPr>
+        <p:txBody>
+          <a:bodyPr wrap="square">
+            <a:spAutoFit/>
+          </a:bodyPr>
+          <a:lstStyle/>
+          <a:p>
+            <a:pPr algn="l"/>
+            <a:r>
+              <a:rPr sz="950" b="1" i="0">
+                <a:solidFill>
+                  <a:srgbClr val="FFFFFF"/>
+                </a:solidFill>
+              </a:rPr>
+              <a:t>• POST-MEETING FOLLOW-UPS</a:t>
+            </a:r>
+          </a:p>
+        </p:txBody>
+      </p:sp>
+      <p:sp>
+        <p:nvSpPr>
+          <p:cNvPr id="33" name="TextBox 32"/>
+          <p:cNvSpPr txBox="1"/>
+          <p:nvPr/>
+        </p:nvSpPr>
+        <p:spPr>
+          <a:xfrm>
+            <a:off x="4480560" y="4992624"/>
+            <a:ext cx="3419856" cy="457200"/>
+          </a:xfrm>
+          <a:prstGeom prst="rect">
+            <a:avLst/>
+          </a:prstGeom>
+          <a:noFill/>
+        </p:spPr>
+        <p:txBody>
+          <a:bodyPr wrap="square">
+            <a:spAutoFit/>
+          </a:bodyPr>
+          <a:lstStyle/>
+          <a:p>
+            <a:pPr algn="l"/>
+            <a:r>
+              <a:rPr sz="850" b="0" i="0">
+                <a:solidFill>
+                  <a:srgbClr val="8AA8C8"/>
+                </a:solidFill>
+              </a:rPr>
+              <a:t>Generates tailored follow-up emails and action item summaries right after each call.</a:t>
+            </a:r>
+          </a:p>
+        </p:txBody>
+      </p:sp>
+      <p:sp>
+        <p:nvSpPr>
+          <p:cNvPr id="34" name="Rectangle 33"/>
           <p:cNvSpPr/>
           <p:nvPr/>
         </p:nvSpPr>
         <p:spPr>
           <a:xfrm>
-            <a:off x="365760" y="2139696"/>
-            <a:ext cx="11457432" cy="4261104"/>
+            <a:off x="8083296" y="1901952"/>
+            <a:ext cx="3739896" cy="4590288"/>
           </a:xfrm>
           <a:prstGeom prst="rect">
             <a:avLst/>
@@ -5366,20 +5995,20 @@
       </p:sp>
       <p:sp>
         <p:nvSpPr>
-          <p:cNvPr id="9" name="Rectangle 8"/>
+          <p:cNvPr id="35" name="Rectangle 34"/>
           <p:cNvSpPr/>
           <p:nvPr/>
         </p:nvSpPr>
         <p:spPr>
           <a:xfrm>
-            <a:off x="365760" y="2139696"/>
-            <a:ext cx="45720" cy="4261104"/>
+            <a:off x="8083296" y="1901952"/>
+            <a:ext cx="45720" cy="4590288"/>
           </a:xfrm>
           <a:prstGeom prst="rect">
             <a:avLst/>
           </a:prstGeom>
           <a:solidFill>
-            <a:srgbClr val="00D4D4"/>
+            <a:srgbClr val="F57C2A"/>
           </a:solidFill>
           <a:ln>
             <a:noFill/>
@@ -5409,14 +6038,14 @@
       </p:sp>
       <p:sp>
         <p:nvSpPr>
-          <p:cNvPr id="10" name="TextBox 9"/>
+          <p:cNvPr id="36" name="TextBox 35"/>
           <p:cNvSpPr txBox="1"/>
           <p:nvPr/>
         </p:nvSpPr>
         <p:spPr>
           <a:xfrm>
-            <a:off x="566928" y="2267712"/>
-            <a:ext cx="7315200" cy="548640"/>
+            <a:off x="8247888" y="2011680"/>
+            <a:ext cx="3511296" cy="457200"/>
           </a:xfrm>
           <a:prstGeom prst="rect">
             <a:avLst/>
@@ -5431,26 +6060,26 @@
           <a:p>
             <a:pPr algn="l"/>
             <a:r>
-              <a:rPr sz="3600" b="1" i="0">
+              <a:rPr sz="2200" b="1" i="0">
                 <a:solidFill>
                   <a:srgbClr val="FFFFFF"/>
                 </a:solidFill>
               </a:rPr>
-              <a:t>🦸🏻‍♂️  Robin</a:t>
-            </a:r>
-          </a:p>
-        </p:txBody>
-      </p:sp>
-      <p:sp>
-        <p:nvSpPr>
-          <p:cNvPr id="11" name="TextBox 10"/>
+              <a:t>🏗️  Clay</a:t>
+            </a:r>
+          </a:p>
+        </p:txBody>
+      </p:sp>
+      <p:sp>
+        <p:nvSpPr>
+          <p:cNvPr id="37" name="TextBox 36"/>
           <p:cNvSpPr txBox="1"/>
           <p:nvPr/>
         </p:nvSpPr>
         <p:spPr>
           <a:xfrm>
-            <a:off x="566928" y="2816352"/>
-            <a:ext cx="8229600" cy="274320"/>
+            <a:off x="8247888" y="2487168"/>
+            <a:ext cx="3511296" cy="347472"/>
           </a:xfrm>
           <a:prstGeom prst="rect">
             <a:avLst/>
@@ -5465,26 +6094,26 @@
           <a:p>
             <a:pPr algn="l"/>
             <a:r>
-              <a:rPr sz="1500" b="0" i="0">
-                <a:solidFill>
-                  <a:srgbClr val="00D4D4"/>
+              <a:rPr sz="1000" b="0" i="0">
+                <a:solidFill>
+                  <a:srgbClr val="F57C2A"/>
                 </a:solidFill>
               </a:rPr>
-              <a:t>AI Sales Assistant &amp; Intelligence Engine</a:t>
-            </a:r>
-          </a:p>
-        </p:txBody>
-      </p:sp>
-      <p:sp>
-        <p:nvSpPr>
-          <p:cNvPr id="12" name="TextBox 11"/>
+              <a:t>Custom AI Agent for Data Intelligence</a:t>
+            </a:r>
+          </a:p>
+        </p:txBody>
+      </p:sp>
+      <p:sp>
+        <p:nvSpPr>
+          <p:cNvPr id="38" name="TextBox 37"/>
           <p:cNvSpPr txBox="1"/>
           <p:nvPr/>
         </p:nvSpPr>
         <p:spPr>
           <a:xfrm>
-            <a:off x="566928" y="3099815"/>
-            <a:ext cx="6400800" cy="237744"/>
+            <a:off x="8247888" y="2834640"/>
+            <a:ext cx="3511296" cy="237744"/>
           </a:xfrm>
           <a:prstGeom prst="rect">
             <a:avLst/>
@@ -5499,26 +6128,26 @@
           <a:p>
             <a:pPr algn="l"/>
             <a:r>
-              <a:rPr sz="1100" b="0" i="1">
+              <a:rPr sz="900" b="0" i="1">
                 <a:solidFill>
                   <a:srgbClr val="8AA8C8"/>
                 </a:solidFill>
               </a:rPr>
-              <a:t>Built for Ryan Koontz  ·  SVP of Sales</a:t>
-            </a:r>
-          </a:p>
-        </p:txBody>
-      </p:sp>
-      <p:sp>
-        <p:nvSpPr>
-          <p:cNvPr id="13" name="Rectangle 12"/>
+              <a:t>Prospect enrichment · CRM hygiene · Verification</a:t>
+            </a:r>
+          </a:p>
+        </p:txBody>
+      </p:sp>
+      <p:sp>
+        <p:nvSpPr>
+          <p:cNvPr id="39" name="Rectangle 38"/>
           <p:cNvSpPr/>
           <p:nvPr/>
         </p:nvSpPr>
         <p:spPr>
           <a:xfrm>
-            <a:off x="566928" y="3401568"/>
-            <a:ext cx="11055096" cy="18288"/>
+            <a:off x="8247888" y="3090672"/>
+            <a:ext cx="3465576" cy="18288"/>
           </a:xfrm>
           <a:prstGeom prst="rect">
             <a:avLst/>
@@ -5554,14 +6183,14 @@
       </p:sp>
       <p:sp>
         <p:nvSpPr>
-          <p:cNvPr id="14" name="TextBox 13"/>
+          <p:cNvPr id="40" name="TextBox 39"/>
           <p:cNvSpPr txBox="1"/>
           <p:nvPr/>
         </p:nvSpPr>
         <p:spPr>
           <a:xfrm>
-            <a:off x="566928" y="3511296"/>
-            <a:ext cx="5486400" cy="475488"/>
+            <a:off x="8247888" y="3200400"/>
+            <a:ext cx="3511296" cy="219456"/>
           </a:xfrm>
           <a:prstGeom prst="rect">
             <a:avLst/>
@@ -5576,26 +6205,26 @@
           <a:p>
             <a:pPr algn="l"/>
             <a:r>
-              <a:rPr sz="1100" b="1" i="0">
+              <a:rPr sz="950" b="1" i="0">
                 <a:solidFill>
                   <a:srgbClr val="FFFFFF"/>
                 </a:solidFill>
               </a:rPr>
-              <a:t>• TRACKING SALES TEAM ACTIVITY POINTS</a:t>
-            </a:r>
-          </a:p>
-        </p:txBody>
-      </p:sp>
-      <p:sp>
-        <p:nvSpPr>
-          <p:cNvPr id="15" name="TextBox 14"/>
+              <a:t>• INDUSTRY FIELD VERIFICATION</a:t>
+            </a:r>
+          </a:p>
+        </p:txBody>
+      </p:sp>
+      <p:sp>
+        <p:nvSpPr>
+          <p:cNvPr id="41" name="TextBox 40"/>
           <p:cNvSpPr txBox="1"/>
           <p:nvPr/>
         </p:nvSpPr>
         <p:spPr>
           <a:xfrm>
-            <a:off x="566928" y="4105656"/>
-            <a:ext cx="5486400" cy="475488"/>
+            <a:off x="8339327" y="3438144"/>
+            <a:ext cx="3419856" cy="457200"/>
           </a:xfrm>
           <a:prstGeom prst="rect">
             <a:avLst/>
@@ -5610,26 +6239,26 @@
           <a:p>
             <a:pPr algn="l"/>
             <a:r>
-              <a:rPr sz="1100" b="1" i="0">
-                <a:solidFill>
-                  <a:srgbClr val="FFFFFF"/>
+              <a:rPr sz="850" b="0" i="0">
+                <a:solidFill>
+                  <a:srgbClr val="8AA8C8"/>
                 </a:solidFill>
               </a:rPr>
-              <a:t>• RUNNING WEEKLY CALL BLITZES</a:t>
-            </a:r>
-          </a:p>
-        </p:txBody>
-      </p:sp>
-      <p:sp>
-        <p:nvSpPr>
-          <p:cNvPr id="16" name="TextBox 15"/>
+              <a:t>Built a custom AI agent to verify and correct the industry field on Salesforce accounts at scale.</a:t>
+            </a:r>
+          </a:p>
+        </p:txBody>
+      </p:sp>
+      <p:sp>
+        <p:nvSpPr>
+          <p:cNvPr id="42" name="TextBox 41"/>
           <p:cNvSpPr txBox="1"/>
           <p:nvPr/>
         </p:nvSpPr>
         <p:spPr>
           <a:xfrm>
-            <a:off x="566928" y="4700016"/>
-            <a:ext cx="5486400" cy="475488"/>
+            <a:off x="8247888" y="3977639"/>
+            <a:ext cx="3511296" cy="219456"/>
           </a:xfrm>
           <a:prstGeom prst="rect">
             <a:avLst/>
@@ -5644,26 +6273,26 @@
           <a:p>
             <a:pPr algn="l"/>
             <a:r>
-              <a:rPr sz="1100" b="1" i="0">
+              <a:rPr sz="950" b="1" i="0">
                 <a:solidFill>
                   <a:srgbClr val="FFFFFF"/>
                 </a:solidFill>
               </a:rPr>
-              <a:t>• RESEARCHING NEW PROSPECTS NOT IN CRM</a:t>
-            </a:r>
-          </a:p>
-        </p:txBody>
-      </p:sp>
-      <p:sp>
-        <p:nvSpPr>
-          <p:cNvPr id="17" name="TextBox 16"/>
+              <a:t>• 11K INCORRECTLY TAGGED ACCOUNTS</a:t>
+            </a:r>
+          </a:p>
+        </p:txBody>
+      </p:sp>
+      <p:sp>
+        <p:nvSpPr>
+          <p:cNvPr id="43" name="TextBox 42"/>
           <p:cNvSpPr txBox="1"/>
           <p:nvPr/>
         </p:nvSpPr>
         <p:spPr>
           <a:xfrm>
-            <a:off x="566928" y="5294376"/>
-            <a:ext cx="5486400" cy="475488"/>
+            <a:off x="8339327" y="4215383"/>
+            <a:ext cx="3419856" cy="457200"/>
           </a:xfrm>
           <a:prstGeom prst="rect">
             <a:avLst/>
@@ -5678,155 +6307,19 @@
           <a:p>
             <a:pPr algn="l"/>
             <a:r>
-              <a:rPr sz="1100" b="1" i="0">
-                <a:solidFill>
-                  <a:srgbClr val="FFFFFF"/>
+              <a:rPr sz="850" b="0" i="0">
+                <a:solidFill>
+                  <a:srgbClr val="8AA8C8"/>
                 </a:solidFill>
               </a:rPr>
-              <a:t>• BUILT COMPETITOR BATTLECARD DASHBOARD</a:t>
-            </a:r>
-          </a:p>
-        </p:txBody>
-      </p:sp>
-      <p:sp>
-        <p:nvSpPr>
-          <p:cNvPr id="18" name="TextBox 17"/>
-          <p:cNvSpPr txBox="1"/>
-          <p:nvPr/>
-        </p:nvSpPr>
-        <p:spPr>
-          <a:xfrm>
-            <a:off x="6400800" y="3511296"/>
-            <a:ext cx="5577840" cy="475488"/>
-          </a:xfrm>
-          <a:prstGeom prst="rect">
-            <a:avLst/>
-          </a:prstGeom>
-          <a:noFill/>
-        </p:spPr>
-        <p:txBody>
-          <a:bodyPr wrap="square">
-            <a:spAutoFit/>
-          </a:bodyPr>
-          <a:lstStyle/>
-          <a:p>
-            <a:pPr algn="l"/>
-            <a:r>
-              <a:rPr sz="1100" b="1" i="0">
-                <a:solidFill>
-                  <a:srgbClr val="FFFFFF"/>
-                </a:solidFill>
-              </a:rPr>
-              <a:t>• AUTOMATED WEEKLY FORECAST DECKS FOR ELT</a:t>
-            </a:r>
-          </a:p>
-        </p:txBody>
-      </p:sp>
-      <p:sp>
-        <p:nvSpPr>
-          <p:cNvPr id="19" name="TextBox 18"/>
-          <p:cNvSpPr txBox="1"/>
-          <p:nvPr/>
-        </p:nvSpPr>
-        <p:spPr>
-          <a:xfrm>
-            <a:off x="6400800" y="4105656"/>
-            <a:ext cx="5577840" cy="475488"/>
-          </a:xfrm>
-          <a:prstGeom prst="rect">
-            <a:avLst/>
-          </a:prstGeom>
-          <a:noFill/>
-        </p:spPr>
-        <p:txBody>
-          <a:bodyPr wrap="square">
-            <a:spAutoFit/>
-          </a:bodyPr>
-          <a:lstStyle/>
-          <a:p>
-            <a:pPr algn="l"/>
-            <a:r>
-              <a:rPr sz="1100" b="1" i="0">
-                <a:solidFill>
-                  <a:srgbClr val="FFFFFF"/>
-                </a:solidFill>
-              </a:rPr>
-              <a:t>• DISCOVERY NO-SHOW TREND ANALYSIS</a:t>
-            </a:r>
-          </a:p>
-        </p:txBody>
-      </p:sp>
-      <p:sp>
-        <p:nvSpPr>
-          <p:cNvPr id="20" name="TextBox 19"/>
-          <p:cNvSpPr txBox="1"/>
-          <p:nvPr/>
-        </p:nvSpPr>
-        <p:spPr>
-          <a:xfrm>
-            <a:off x="6400800" y="4700016"/>
-            <a:ext cx="5577840" cy="475488"/>
-          </a:xfrm>
-          <a:prstGeom prst="rect">
-            <a:avLst/>
-          </a:prstGeom>
-          <a:noFill/>
-        </p:spPr>
-        <p:txBody>
-          <a:bodyPr wrap="square">
-            <a:spAutoFit/>
-          </a:bodyPr>
-          <a:lstStyle/>
-          <a:p>
-            <a:pPr algn="l"/>
-            <a:r>
-              <a:rPr sz="1100" b="1" i="0">
-                <a:solidFill>
-                  <a:srgbClr val="FFFFFF"/>
-                </a:solidFill>
-              </a:rPr>
-              <a:t>• SOFTWARE MISSING CAPABILITIES DEEP DIVE</a:t>
-            </a:r>
-          </a:p>
-        </p:txBody>
-      </p:sp>
-      <p:sp>
-        <p:nvSpPr>
-          <p:cNvPr id="21" name="TextBox 20"/>
-          <p:cNvSpPr txBox="1"/>
-          <p:nvPr/>
-        </p:nvSpPr>
-        <p:spPr>
-          <a:xfrm>
-            <a:off x="6400800" y="5294376"/>
-            <a:ext cx="5577840" cy="475488"/>
-          </a:xfrm>
-          <a:prstGeom prst="rect">
-            <a:avLst/>
-          </a:prstGeom>
-          <a:noFill/>
-        </p:spPr>
-        <p:txBody>
-          <a:bodyPr wrap="square">
-            <a:spAutoFit/>
-          </a:bodyPr>
-          <a:lstStyle/>
-          <a:p>
-            <a:pPr algn="l"/>
-            <a:r>
-              <a:rPr sz="1100" b="1" i="0">
-                <a:solidFill>
-                  <a:srgbClr val="FFFFFF"/>
-                </a:solidFill>
-              </a:rPr>
-              <a:t>• MORNING BRIEFINGS &amp; PIPELINE INTELLIGENCE</a:t>
-            </a:r>
-          </a:p>
-        </p:txBody>
-      </p:sp>
-      <p:sp>
-        <p:nvSpPr>
-          <p:cNvPr id="22" name="Rectangle 21"/>
+              <a:t>Identified 11,000+ accounts incorrectly marked as MSPs — cleaning the CRM foundation for better targeting and scoring.</a:t>
+            </a:r>
+          </a:p>
+        </p:txBody>
+      </p:sp>
+      <p:sp>
+        <p:nvSpPr>
+          <p:cNvPr id="44" name="Rectangle 43"/>
           <p:cNvSpPr/>
           <p:nvPr/>
         </p:nvSpPr>
@@ -5869,7 +6362,7 @@
       </p:sp>
       <p:sp>
         <p:nvSpPr>
-          <p:cNvPr id="23" name="TextBox 22"/>
+          <p:cNvPr id="45" name="TextBox 44"/>
           <p:cNvSpPr txBox="1"/>
           <p:nvPr/>
         </p:nvSpPr>
@@ -5903,7 +6396,7 @@
       </p:sp>
       <p:sp>
         <p:nvSpPr>
-          <p:cNvPr id="24" name="TextBox 23"/>
+          <p:cNvPr id="46" name="TextBox 45"/>
           <p:cNvSpPr txBox="1"/>
           <p:nvPr/>
         </p:nvSpPr>
@@ -5937,2381 +6430,7 @@
       </p:sp>
       <p:sp>
         <p:nvSpPr>
-          <p:cNvPr id="25" name="TextBox 24"/>
-          <p:cNvSpPr txBox="1"/>
-          <p:nvPr/>
-        </p:nvSpPr>
-        <p:spPr>
-          <a:xfrm>
-            <a:off x="10698480" y="6693408"/>
-            <a:ext cx="1371600" cy="146304"/>
-          </a:xfrm>
-          <a:prstGeom prst="rect">
-            <a:avLst/>
-          </a:prstGeom>
-          <a:noFill/>
-        </p:spPr>
-        <p:txBody>
-          <a:bodyPr wrap="square">
-            <a:spAutoFit/>
-          </a:bodyPr>
-          <a:lstStyle/>
-          <a:p>
-            <a:pPr algn="r"/>
-            <a:r>
-              <a:rPr sz="900" b="1" i="0">
-                <a:solidFill>
-                  <a:srgbClr val="3DC570"/>
-                </a:solidFill>
-              </a:rPr>
-              <a:t>READY FOR TODAY.</a:t>
-            </a:r>
-          </a:p>
-        </p:txBody>
-      </p:sp>
-    </p:spTree>
-  </p:cSld>
-  <p:clrMapOvr>
-    <a:masterClrMapping/>
-  </p:clrMapOvr>
-</p:sld>
-</file>
-
-<file path=ppt/slides/slide2.xml><?xml version="1.0" encoding="utf-8"?>
-<p:sld xmlns:a="http://schemas.openxmlformats.org/drawingml/2006/main" xmlns:p="http://schemas.openxmlformats.org/presentationml/2006/main" xmlns:r="http://schemas.openxmlformats.org/officeDocument/2006/relationships">
-  <p:cSld>
-    <p:spTree>
-      <p:nvGrpSpPr>
-        <p:cNvPr id="1" name=""/>
-        <p:cNvGrpSpPr/>
-        <p:nvPr/>
-      </p:nvGrpSpPr>
-      <p:grpSpPr/>
-      <p:sp>
-        <p:nvSpPr>
-          <p:cNvPr id="2" name="TextBox 1"/>
-          <p:cNvSpPr txBox="1"/>
-          <p:nvPr/>
-        </p:nvSpPr>
-        <p:spPr>
-          <a:xfrm>
-            <a:off x="365760" y="164592"/>
-            <a:ext cx="11430000" cy="713232"/>
-          </a:xfrm>
-          <a:prstGeom prst="rect">
-            <a:avLst/>
-          </a:prstGeom>
-          <a:noFill/>
-        </p:spPr>
-        <p:txBody>
-          <a:bodyPr wrap="square">
-            <a:spAutoFit/>
-          </a:bodyPr>
-          <a:lstStyle/>
-          <a:p>
-            <a:pPr algn="l"/>
-            <a:r>
-              <a:rPr sz="4600" b="1" i="0">
-                <a:solidFill>
-                  <a:srgbClr val="FFFFFF"/>
-                </a:solidFill>
-              </a:rPr>
-              <a:t>Robin's Tool Stack</a:t>
-            </a:r>
-          </a:p>
-        </p:txBody>
-      </p:sp>
-      <p:sp>
-        <p:nvSpPr>
-          <p:cNvPr id="3" name="TextBox 2"/>
-          <p:cNvSpPr txBox="1"/>
-          <p:nvPr/>
-        </p:nvSpPr>
-        <p:spPr>
-          <a:xfrm>
-            <a:off x="365760" y="877824"/>
-            <a:ext cx="11430000" cy="310896"/>
-          </a:xfrm>
-          <a:prstGeom prst="rect">
-            <a:avLst/>
-          </a:prstGeom>
-          <a:noFill/>
-        </p:spPr>
-        <p:txBody>
-          <a:bodyPr wrap="square">
-            <a:spAutoFit/>
-          </a:bodyPr>
-          <a:lstStyle/>
-          <a:p>
-            <a:pPr algn="l"/>
-            <a:r>
-              <a:rPr sz="1300" b="0" i="0">
-                <a:solidFill>
-                  <a:srgbClr val="8AA8C8"/>
-                </a:solidFill>
-              </a:rPr>
-              <a:t>Integrated with best-in-class tools to automate sales workflows end-to-end.</a:t>
-            </a:r>
-          </a:p>
-        </p:txBody>
-      </p:sp>
-      <p:sp>
-        <p:nvSpPr>
-          <p:cNvPr id="4" name="Rectangle 3"/>
-          <p:cNvSpPr/>
-          <p:nvPr/>
-        </p:nvSpPr>
-        <p:spPr>
-          <a:xfrm>
-            <a:off x="365760" y="1298448"/>
-            <a:ext cx="11457432" cy="658368"/>
-          </a:xfrm>
-          <a:prstGeom prst="rect">
-            <a:avLst/>
-          </a:prstGeom>
-          <a:solidFill>
-            <a:srgbClr val="0A1E30"/>
-          </a:solidFill>
-          <a:ln>
-            <a:noFill/>
-          </a:ln>
-        </p:spPr>
-        <p:style>
-          <a:lnRef idx="1">
-            <a:schemeClr val="accent1"/>
-          </a:lnRef>
-          <a:fillRef idx="3">
-            <a:schemeClr val="accent1"/>
-          </a:fillRef>
-          <a:effectRef idx="2">
-            <a:schemeClr val="accent1"/>
-          </a:effectRef>
-          <a:fontRef idx="minor">
-            <a:schemeClr val="lt1"/>
-          </a:fontRef>
-        </p:style>
-        <p:txBody>
-          <a:bodyPr rtlCol="0" anchor="ctr"/>
-          <a:lstStyle/>
-          <a:p>
-            <a:pPr algn="ctr"/>
-          </a:p>
-        </p:txBody>
-      </p:sp>
-      <p:sp>
-        <p:nvSpPr>
-          <p:cNvPr id="5" name="Rectangle 4"/>
-          <p:cNvSpPr/>
-          <p:nvPr/>
-        </p:nvSpPr>
-        <p:spPr>
-          <a:xfrm>
-            <a:off x="365760" y="1298448"/>
-            <a:ext cx="45720" cy="658368"/>
-          </a:xfrm>
-          <a:prstGeom prst="rect">
-            <a:avLst/>
-          </a:prstGeom>
-          <a:solidFill>
-            <a:srgbClr val="00D4D4"/>
-          </a:solidFill>
-          <a:ln>
-            <a:noFill/>
-          </a:ln>
-        </p:spPr>
-        <p:style>
-          <a:lnRef idx="1">
-            <a:schemeClr val="accent1"/>
-          </a:lnRef>
-          <a:fillRef idx="3">
-            <a:schemeClr val="accent1"/>
-          </a:fillRef>
-          <a:effectRef idx="2">
-            <a:schemeClr val="accent1"/>
-          </a:effectRef>
-          <a:fontRef idx="minor">
-            <a:schemeClr val="lt1"/>
-          </a:fontRef>
-        </p:style>
-        <p:txBody>
-          <a:bodyPr rtlCol="0" anchor="ctr"/>
-          <a:lstStyle/>
-          <a:p>
-            <a:pPr algn="ctr"/>
-          </a:p>
-        </p:txBody>
-      </p:sp>
-      <p:sp>
-        <p:nvSpPr>
-          <p:cNvPr id="6" name="TextBox 5"/>
-          <p:cNvSpPr txBox="1"/>
-          <p:nvPr/>
-        </p:nvSpPr>
-        <p:spPr>
-          <a:xfrm>
-            <a:off x="502920" y="1335024"/>
-            <a:ext cx="3200400" cy="182880"/>
-          </a:xfrm>
-          <a:prstGeom prst="rect">
-            <a:avLst/>
-          </a:prstGeom>
-          <a:noFill/>
-        </p:spPr>
-        <p:txBody>
-          <a:bodyPr wrap="square">
-            <a:spAutoFit/>
-          </a:bodyPr>
-          <a:lstStyle/>
-          <a:p>
-            <a:pPr algn="l"/>
-            <a:r>
-              <a:rPr sz="800" b="1" i="0">
-                <a:solidFill>
-                  <a:srgbClr val="3DC570"/>
-                </a:solidFill>
-              </a:rPr>
-              <a:t>INTEGRATIONS</a:t>
-            </a:r>
-          </a:p>
-        </p:txBody>
-      </p:sp>
-      <p:sp>
-        <p:nvSpPr>
-          <p:cNvPr id="7" name="TextBox 6"/>
-          <p:cNvSpPr txBox="1"/>
-          <p:nvPr/>
-        </p:nvSpPr>
-        <p:spPr>
-          <a:xfrm>
-            <a:off x="502920" y="1517904"/>
-            <a:ext cx="11155680" cy="347472"/>
-          </a:xfrm>
-          <a:prstGeom prst="rect">
-            <a:avLst/>
-          </a:prstGeom>
-          <a:noFill/>
-        </p:spPr>
-        <p:txBody>
-          <a:bodyPr wrap="square">
-            <a:spAutoFit/>
-          </a:bodyPr>
-          <a:lstStyle/>
-          <a:p>
-            <a:pPr algn="l"/>
-            <a:r>
-              <a:rPr sz="1050" b="0" i="0">
-                <a:solidFill>
-                  <a:srgbClr val="FFFFFF"/>
-                </a:solidFill>
-              </a:rPr>
-              <a:t>Robin connects into Rev.io's existing tool stack — using AI to turn raw data and workflows into automated action at scale.</a:t>
-            </a:r>
-          </a:p>
-        </p:txBody>
-      </p:sp>
-      <p:sp>
-        <p:nvSpPr>
-          <p:cNvPr id="8" name="Rectangle 7"/>
-          <p:cNvSpPr/>
-          <p:nvPr/>
-        </p:nvSpPr>
-        <p:spPr>
-          <a:xfrm>
-            <a:off x="365760" y="2084831"/>
-            <a:ext cx="5623560" cy="4315968"/>
-          </a:xfrm>
-          <a:prstGeom prst="rect">
-            <a:avLst/>
-          </a:prstGeom>
-          <a:solidFill>
-            <a:srgbClr val="0A1E30"/>
-          </a:solidFill>
-          <a:ln>
-            <a:noFill/>
-          </a:ln>
-        </p:spPr>
-        <p:style>
-          <a:lnRef idx="1">
-            <a:schemeClr val="accent1"/>
-          </a:lnRef>
-          <a:fillRef idx="3">
-            <a:schemeClr val="accent1"/>
-          </a:fillRef>
-          <a:effectRef idx="2">
-            <a:schemeClr val="accent1"/>
-          </a:effectRef>
-          <a:fontRef idx="minor">
-            <a:schemeClr val="lt1"/>
-          </a:fontRef>
-        </p:style>
-        <p:txBody>
-          <a:bodyPr rtlCol="0" anchor="ctr"/>
-          <a:lstStyle/>
-          <a:p>
-            <a:pPr algn="ctr"/>
-          </a:p>
-        </p:txBody>
-      </p:sp>
-      <p:sp>
-        <p:nvSpPr>
-          <p:cNvPr id="9" name="Rectangle 8"/>
-          <p:cNvSpPr/>
-          <p:nvPr/>
-        </p:nvSpPr>
-        <p:spPr>
-          <a:xfrm>
-            <a:off x="365760" y="2084831"/>
-            <a:ext cx="45720" cy="4315968"/>
-          </a:xfrm>
-          <a:prstGeom prst="rect">
-            <a:avLst/>
-          </a:prstGeom>
-          <a:solidFill>
-            <a:srgbClr val="7C3AED"/>
-          </a:solidFill>
-          <a:ln>
-            <a:noFill/>
-          </a:ln>
-        </p:spPr>
-        <p:style>
-          <a:lnRef idx="1">
-            <a:schemeClr val="accent1"/>
-          </a:lnRef>
-          <a:fillRef idx="3">
-            <a:schemeClr val="accent1"/>
-          </a:fillRef>
-          <a:effectRef idx="2">
-            <a:schemeClr val="accent1"/>
-          </a:effectRef>
-          <a:fontRef idx="minor">
-            <a:schemeClr val="lt1"/>
-          </a:fontRef>
-        </p:style>
-        <p:txBody>
-          <a:bodyPr rtlCol="0" anchor="ctr"/>
-          <a:lstStyle/>
-          <a:p>
-            <a:pPr algn="ctr"/>
-          </a:p>
-        </p:txBody>
-      </p:sp>
-      <p:sp>
-        <p:nvSpPr>
-          <p:cNvPr id="10" name="TextBox 9"/>
-          <p:cNvSpPr txBox="1"/>
-          <p:nvPr/>
-        </p:nvSpPr>
-        <p:spPr>
-          <a:xfrm>
-            <a:off x="566928" y="2212848"/>
-            <a:ext cx="5029200" cy="502920"/>
-          </a:xfrm>
-          <a:prstGeom prst="rect">
-            <a:avLst/>
-          </a:prstGeom>
-          <a:noFill/>
-        </p:spPr>
-        <p:txBody>
-          <a:bodyPr wrap="square">
-            <a:spAutoFit/>
-          </a:bodyPr>
-          <a:lstStyle/>
-          <a:p>
-            <a:pPr algn="l"/>
-            <a:r>
-              <a:rPr sz="3400" b="1" i="0">
-                <a:solidFill>
-                  <a:srgbClr val="FFFFFF"/>
-                </a:solidFill>
-              </a:rPr>
-              <a:t>📓  Notion</a:t>
-            </a:r>
-          </a:p>
-        </p:txBody>
-      </p:sp>
-      <p:sp>
-        <p:nvSpPr>
-          <p:cNvPr id="11" name="TextBox 10"/>
-          <p:cNvSpPr txBox="1"/>
-          <p:nvPr/>
-        </p:nvSpPr>
-        <p:spPr>
-          <a:xfrm>
-            <a:off x="566928" y="2724911"/>
-            <a:ext cx="5212080" cy="274320"/>
-          </a:xfrm>
-          <a:prstGeom prst="rect">
-            <a:avLst/>
-          </a:prstGeom>
-          <a:noFill/>
-        </p:spPr>
-        <p:txBody>
-          <a:bodyPr wrap="square">
-            <a:spAutoFit/>
-          </a:bodyPr>
-          <a:lstStyle/>
-          <a:p>
-            <a:pPr algn="l"/>
-            <a:r>
-              <a:rPr sz="1300" b="0" i="0">
-                <a:solidFill>
-                  <a:srgbClr val="7C3AED"/>
-                </a:solidFill>
-              </a:rPr>
-              <a:t>AI-Powered Knowledge &amp; Workflow Automation</a:t>
-            </a:r>
-          </a:p>
-        </p:txBody>
-      </p:sp>
-      <p:sp>
-        <p:nvSpPr>
-          <p:cNvPr id="12" name="TextBox 11"/>
-          <p:cNvSpPr txBox="1"/>
-          <p:nvPr/>
-        </p:nvSpPr>
-        <p:spPr>
-          <a:xfrm>
-            <a:off x="566928" y="3017520"/>
-            <a:ext cx="5212080" cy="237744"/>
-          </a:xfrm>
-          <a:prstGeom prst="rect">
-            <a:avLst/>
-          </a:prstGeom>
-          <a:noFill/>
-        </p:spPr>
-        <p:txBody>
-          <a:bodyPr wrap="square">
-            <a:spAutoFit/>
-          </a:bodyPr>
-          <a:lstStyle/>
-          <a:p>
-            <a:pPr algn="l"/>
-            <a:r>
-              <a:rPr sz="1000" b="0" i="1">
-                <a:solidFill>
-                  <a:srgbClr val="8AA8C8"/>
-                </a:solidFill>
-              </a:rPr>
-              <a:t>Prospect research · Meeting intelligence · Follow-up</a:t>
-            </a:r>
-          </a:p>
-        </p:txBody>
-      </p:sp>
-      <p:sp>
-        <p:nvSpPr>
-          <p:cNvPr id="13" name="Rectangle 12"/>
-          <p:cNvSpPr/>
-          <p:nvPr/>
-        </p:nvSpPr>
-        <p:spPr>
-          <a:xfrm>
-            <a:off x="566928" y="3310128"/>
-            <a:ext cx="5221224" cy="18288"/>
-          </a:xfrm>
-          <a:prstGeom prst="rect">
-            <a:avLst/>
-          </a:prstGeom>
-          <a:solidFill>
-            <a:srgbClr val="1A3555"/>
-          </a:solidFill>
-          <a:ln>
-            <a:noFill/>
-          </a:ln>
-        </p:spPr>
-        <p:style>
-          <a:lnRef idx="1">
-            <a:schemeClr val="accent1"/>
-          </a:lnRef>
-          <a:fillRef idx="3">
-            <a:schemeClr val="accent1"/>
-          </a:fillRef>
-          <a:effectRef idx="2">
-            <a:schemeClr val="accent1"/>
-          </a:effectRef>
-          <a:fontRef idx="minor">
-            <a:schemeClr val="lt1"/>
-          </a:fontRef>
-        </p:style>
-        <p:txBody>
-          <a:bodyPr rtlCol="0" anchor="ctr"/>
-          <a:lstStyle/>
-          <a:p>
-            <a:pPr algn="ctr"/>
-          </a:p>
-        </p:txBody>
-      </p:sp>
-      <p:sp>
-        <p:nvSpPr>
-          <p:cNvPr id="14" name="TextBox 13"/>
-          <p:cNvSpPr txBox="1"/>
-          <p:nvPr/>
-        </p:nvSpPr>
-        <p:spPr>
-          <a:xfrm>
-            <a:off x="566928" y="3438144"/>
-            <a:ext cx="5212080" cy="237744"/>
-          </a:xfrm>
-          <a:prstGeom prst="rect">
-            <a:avLst/>
-          </a:prstGeom>
-          <a:noFill/>
-        </p:spPr>
-        <p:txBody>
-          <a:bodyPr wrap="square">
-            <a:spAutoFit/>
-          </a:bodyPr>
-          <a:lstStyle/>
-          <a:p>
-            <a:pPr algn="l"/>
-            <a:r>
-              <a:rPr sz="1050" b="1" i="0">
-                <a:solidFill>
-                  <a:srgbClr val="FFFFFF"/>
-                </a:solidFill>
-              </a:rPr>
-              <a:t>• MSP EMAIL PERSONALIZATION AT SCALE</a:t>
-            </a:r>
-          </a:p>
-        </p:txBody>
-      </p:sp>
-      <p:sp>
-        <p:nvSpPr>
-          <p:cNvPr id="15" name="TextBox 14"/>
-          <p:cNvSpPr txBox="1"/>
-          <p:nvPr/>
-        </p:nvSpPr>
-        <p:spPr>
-          <a:xfrm>
-            <a:off x="694944" y="3694176"/>
-            <a:ext cx="5074920" cy="347472"/>
-          </a:xfrm>
-          <a:prstGeom prst="rect">
-            <a:avLst/>
-          </a:prstGeom>
-          <a:noFill/>
-        </p:spPr>
-        <p:txBody>
-          <a:bodyPr wrap="square">
-            <a:spAutoFit/>
-          </a:bodyPr>
-          <a:lstStyle/>
-          <a:p>
-            <a:pPr algn="l"/>
-            <a:r>
-              <a:rPr sz="950" b="0" i="0">
-                <a:solidFill>
-                  <a:srgbClr val="8AA8C8"/>
-                </a:solidFill>
-              </a:rPr>
-              <a:t>Researches each prospect and writes personalized outreach automatically — no manual prep.</a:t>
-            </a:r>
-          </a:p>
-        </p:txBody>
-      </p:sp>
-      <p:sp>
-        <p:nvSpPr>
-          <p:cNvPr id="16" name="TextBox 15"/>
-          <p:cNvSpPr txBox="1"/>
-          <p:nvPr/>
-        </p:nvSpPr>
-        <p:spPr>
-          <a:xfrm>
-            <a:off x="566928" y="4352544"/>
-            <a:ext cx="5212080" cy="237744"/>
-          </a:xfrm>
-          <a:prstGeom prst="rect">
-            <a:avLst/>
-          </a:prstGeom>
-          <a:noFill/>
-        </p:spPr>
-        <p:txBody>
-          <a:bodyPr wrap="square">
-            <a:spAutoFit/>
-          </a:bodyPr>
-          <a:lstStyle/>
-          <a:p>
-            <a:pPr algn="l"/>
-            <a:r>
-              <a:rPr sz="1050" b="1" i="0">
-                <a:solidFill>
-                  <a:srgbClr val="FFFFFF"/>
-                </a:solidFill>
-              </a:rPr>
-              <a:t>• MEETING NOTE-TAKING &amp; TRANSCRIPTION</a:t>
-            </a:r>
-          </a:p>
-        </p:txBody>
-      </p:sp>
-      <p:sp>
-        <p:nvSpPr>
-          <p:cNvPr id="17" name="TextBox 16"/>
-          <p:cNvSpPr txBox="1"/>
-          <p:nvPr/>
-        </p:nvSpPr>
-        <p:spPr>
-          <a:xfrm>
-            <a:off x="694944" y="4608576"/>
-            <a:ext cx="5074920" cy="347472"/>
-          </a:xfrm>
-          <a:prstGeom prst="rect">
-            <a:avLst/>
-          </a:prstGeom>
-          <a:noFill/>
-        </p:spPr>
-        <p:txBody>
-          <a:bodyPr wrap="square">
-            <a:spAutoFit/>
-          </a:bodyPr>
-          <a:lstStyle/>
-          <a:p>
-            <a:pPr algn="l"/>
-            <a:r>
-              <a:rPr sz="950" b="0" i="0">
-                <a:solidFill>
-                  <a:srgbClr val="8AA8C8"/>
-                </a:solidFill>
-              </a:rPr>
-              <a:t>Captures full meeting notes, key takeaways, and action items from every prospect call.</a:t>
-            </a:r>
-          </a:p>
-        </p:txBody>
-      </p:sp>
-      <p:sp>
-        <p:nvSpPr>
-          <p:cNvPr id="18" name="TextBox 17"/>
-          <p:cNvSpPr txBox="1"/>
-          <p:nvPr/>
-        </p:nvSpPr>
-        <p:spPr>
-          <a:xfrm>
-            <a:off x="566928" y="5266944"/>
-            <a:ext cx="5212080" cy="237744"/>
-          </a:xfrm>
-          <a:prstGeom prst="rect">
-            <a:avLst/>
-          </a:prstGeom>
-          <a:noFill/>
-        </p:spPr>
-        <p:txBody>
-          <a:bodyPr wrap="square">
-            <a:spAutoFit/>
-          </a:bodyPr>
-          <a:lstStyle/>
-          <a:p>
-            <a:pPr algn="l"/>
-            <a:r>
-              <a:rPr sz="1050" b="1" i="0">
-                <a:solidFill>
-                  <a:srgbClr val="FFFFFF"/>
-                </a:solidFill>
-              </a:rPr>
-              <a:t>• POST-MEETING FOLLOW-UP EMAILS</a:t>
-            </a:r>
-          </a:p>
-        </p:txBody>
-      </p:sp>
-      <p:sp>
-        <p:nvSpPr>
-          <p:cNvPr id="19" name="TextBox 18"/>
-          <p:cNvSpPr txBox="1"/>
-          <p:nvPr/>
-        </p:nvSpPr>
-        <p:spPr>
-          <a:xfrm>
-            <a:off x="694944" y="5522976"/>
-            <a:ext cx="5074920" cy="347472"/>
-          </a:xfrm>
-          <a:prstGeom prst="rect">
-            <a:avLst/>
-          </a:prstGeom>
-          <a:noFill/>
-        </p:spPr>
-        <p:txBody>
-          <a:bodyPr wrap="square">
-            <a:spAutoFit/>
-          </a:bodyPr>
-          <a:lstStyle/>
-          <a:p>
-            <a:pPr algn="l"/>
-            <a:r>
-              <a:rPr sz="950" b="0" i="0">
-                <a:solidFill>
-                  <a:srgbClr val="8AA8C8"/>
-                </a:solidFill>
-              </a:rPr>
-              <a:t>Generates tailored follow-up emails and action item summaries immediately after each call.</a:t>
-            </a:r>
-          </a:p>
-        </p:txBody>
-      </p:sp>
-      <p:sp>
-        <p:nvSpPr>
-          <p:cNvPr id="20" name="Rectangle 19"/>
-          <p:cNvSpPr/>
-          <p:nvPr/>
-        </p:nvSpPr>
-        <p:spPr>
-          <a:xfrm>
-            <a:off x="6199632" y="2084831"/>
-            <a:ext cx="5623560" cy="4315968"/>
-          </a:xfrm>
-          <a:prstGeom prst="rect">
-            <a:avLst/>
-          </a:prstGeom>
-          <a:solidFill>
-            <a:srgbClr val="0A1E30"/>
-          </a:solidFill>
-          <a:ln>
-            <a:noFill/>
-          </a:ln>
-        </p:spPr>
-        <p:style>
-          <a:lnRef idx="1">
-            <a:schemeClr val="accent1"/>
-          </a:lnRef>
-          <a:fillRef idx="3">
-            <a:schemeClr val="accent1"/>
-          </a:fillRef>
-          <a:effectRef idx="2">
-            <a:schemeClr val="accent1"/>
-          </a:effectRef>
-          <a:fontRef idx="minor">
-            <a:schemeClr val="lt1"/>
-          </a:fontRef>
-        </p:style>
-        <p:txBody>
-          <a:bodyPr rtlCol="0" anchor="ctr"/>
-          <a:lstStyle/>
-          <a:p>
-            <a:pPr algn="ctr"/>
-          </a:p>
-        </p:txBody>
-      </p:sp>
-      <p:sp>
-        <p:nvSpPr>
-          <p:cNvPr id="21" name="Rectangle 20"/>
-          <p:cNvSpPr/>
-          <p:nvPr/>
-        </p:nvSpPr>
-        <p:spPr>
-          <a:xfrm>
-            <a:off x="6199632" y="2084831"/>
-            <a:ext cx="45720" cy="4315968"/>
-          </a:xfrm>
-          <a:prstGeom prst="rect">
-            <a:avLst/>
-          </a:prstGeom>
-          <a:solidFill>
-            <a:srgbClr val="F57C2A"/>
-          </a:solidFill>
-          <a:ln>
-            <a:noFill/>
-          </a:ln>
-        </p:spPr>
-        <p:style>
-          <a:lnRef idx="1">
-            <a:schemeClr val="accent1"/>
-          </a:lnRef>
-          <a:fillRef idx="3">
-            <a:schemeClr val="accent1"/>
-          </a:fillRef>
-          <a:effectRef idx="2">
-            <a:schemeClr val="accent1"/>
-          </a:effectRef>
-          <a:fontRef idx="minor">
-            <a:schemeClr val="lt1"/>
-          </a:fontRef>
-        </p:style>
-        <p:txBody>
-          <a:bodyPr rtlCol="0" anchor="ctr"/>
-          <a:lstStyle/>
-          <a:p>
-            <a:pPr algn="ctr"/>
-          </a:p>
-        </p:txBody>
-      </p:sp>
-      <p:sp>
-        <p:nvSpPr>
-          <p:cNvPr id="22" name="TextBox 21"/>
-          <p:cNvSpPr txBox="1"/>
-          <p:nvPr/>
-        </p:nvSpPr>
-        <p:spPr>
-          <a:xfrm>
-            <a:off x="6400800" y="2212848"/>
-            <a:ext cx="5029200" cy="502920"/>
-          </a:xfrm>
-          <a:prstGeom prst="rect">
-            <a:avLst/>
-          </a:prstGeom>
-          <a:noFill/>
-        </p:spPr>
-        <p:txBody>
-          <a:bodyPr wrap="square">
-            <a:spAutoFit/>
-          </a:bodyPr>
-          <a:lstStyle/>
-          <a:p>
-            <a:pPr algn="l"/>
-            <a:r>
-              <a:rPr sz="3400" b="1" i="0">
-                <a:solidFill>
-                  <a:srgbClr val="FFFFFF"/>
-                </a:solidFill>
-              </a:rPr>
-              <a:t>🏗️  Clay</a:t>
-            </a:r>
-          </a:p>
-        </p:txBody>
-      </p:sp>
-      <p:sp>
-        <p:nvSpPr>
-          <p:cNvPr id="23" name="TextBox 22"/>
-          <p:cNvSpPr txBox="1"/>
-          <p:nvPr/>
-        </p:nvSpPr>
-        <p:spPr>
-          <a:xfrm>
-            <a:off x="6400800" y="2724911"/>
-            <a:ext cx="5212080" cy="274320"/>
-          </a:xfrm>
-          <a:prstGeom prst="rect">
-            <a:avLst/>
-          </a:prstGeom>
-          <a:noFill/>
-        </p:spPr>
-        <p:txBody>
-          <a:bodyPr wrap="square">
-            <a:spAutoFit/>
-          </a:bodyPr>
-          <a:lstStyle/>
-          <a:p>
-            <a:pPr algn="l"/>
-            <a:r>
-              <a:rPr sz="1300" b="0" i="0">
-                <a:solidFill>
-                  <a:srgbClr val="F57C2A"/>
-                </a:solidFill>
-              </a:rPr>
-              <a:t>Custom AI Agent for Data Intelligence</a:t>
-            </a:r>
-          </a:p>
-        </p:txBody>
-      </p:sp>
-      <p:sp>
-        <p:nvSpPr>
-          <p:cNvPr id="24" name="TextBox 23"/>
-          <p:cNvSpPr txBox="1"/>
-          <p:nvPr/>
-        </p:nvSpPr>
-        <p:spPr>
-          <a:xfrm>
-            <a:off x="6400800" y="3017520"/>
-            <a:ext cx="5212080" cy="237744"/>
-          </a:xfrm>
-          <a:prstGeom prst="rect">
-            <a:avLst/>
-          </a:prstGeom>
-          <a:noFill/>
-        </p:spPr>
-        <p:txBody>
-          <a:bodyPr wrap="square">
-            <a:spAutoFit/>
-          </a:bodyPr>
-          <a:lstStyle/>
-          <a:p>
-            <a:pPr algn="l"/>
-            <a:r>
-              <a:rPr sz="1000" b="0" i="1">
-                <a:solidFill>
-                  <a:srgbClr val="8AA8C8"/>
-                </a:solidFill>
-              </a:rPr>
-              <a:t>Prospect enrichment · CRM data hygiene · Verification</a:t>
-            </a:r>
-          </a:p>
-        </p:txBody>
-      </p:sp>
-      <p:sp>
-        <p:nvSpPr>
-          <p:cNvPr id="25" name="Rectangle 24"/>
-          <p:cNvSpPr/>
-          <p:nvPr/>
-        </p:nvSpPr>
-        <p:spPr>
-          <a:xfrm>
-            <a:off x="6400800" y="3310128"/>
-            <a:ext cx="5221224" cy="18288"/>
-          </a:xfrm>
-          <a:prstGeom prst="rect">
-            <a:avLst/>
-          </a:prstGeom>
-          <a:solidFill>
-            <a:srgbClr val="1A3555"/>
-          </a:solidFill>
-          <a:ln>
-            <a:noFill/>
-          </a:ln>
-        </p:spPr>
-        <p:style>
-          <a:lnRef idx="1">
-            <a:schemeClr val="accent1"/>
-          </a:lnRef>
-          <a:fillRef idx="3">
-            <a:schemeClr val="accent1"/>
-          </a:fillRef>
-          <a:effectRef idx="2">
-            <a:schemeClr val="accent1"/>
-          </a:effectRef>
-          <a:fontRef idx="minor">
-            <a:schemeClr val="lt1"/>
-          </a:fontRef>
-        </p:style>
-        <p:txBody>
-          <a:bodyPr rtlCol="0" anchor="ctr"/>
-          <a:lstStyle/>
-          <a:p>
-            <a:pPr algn="ctr"/>
-          </a:p>
-        </p:txBody>
-      </p:sp>
-      <p:sp>
-        <p:nvSpPr>
-          <p:cNvPr id="26" name="TextBox 25"/>
-          <p:cNvSpPr txBox="1"/>
-          <p:nvPr/>
-        </p:nvSpPr>
-        <p:spPr>
-          <a:xfrm>
-            <a:off x="6400800" y="3438144"/>
-            <a:ext cx="5212080" cy="256032"/>
-          </a:xfrm>
-          <a:prstGeom prst="rect">
-            <a:avLst/>
-          </a:prstGeom>
-          <a:noFill/>
-        </p:spPr>
-        <p:txBody>
-          <a:bodyPr wrap="square">
-            <a:spAutoFit/>
-          </a:bodyPr>
-          <a:lstStyle/>
-          <a:p>
-            <a:pPr algn="l"/>
-            <a:r>
-              <a:rPr sz="1050" b="1" i="0">
-                <a:solidFill>
-                  <a:srgbClr val="FFFFFF"/>
-                </a:solidFill>
-              </a:rPr>
-              <a:t>• CUSTOM AGENT: PROSPECT INDUSTRY VERIFICATION</a:t>
-            </a:r>
-          </a:p>
-        </p:txBody>
-      </p:sp>
-      <p:sp>
-        <p:nvSpPr>
-          <p:cNvPr id="27" name="TextBox 26"/>
-          <p:cNvSpPr txBox="1"/>
-          <p:nvPr/>
-        </p:nvSpPr>
-        <p:spPr>
-          <a:xfrm>
-            <a:off x="6528816" y="3712463"/>
-            <a:ext cx="5074920" cy="457200"/>
-          </a:xfrm>
-          <a:prstGeom prst="rect">
-            <a:avLst/>
-          </a:prstGeom>
-          <a:noFill/>
-        </p:spPr>
-        <p:txBody>
-          <a:bodyPr wrap="square">
-            <a:spAutoFit/>
-          </a:bodyPr>
-          <a:lstStyle/>
-          <a:p>
-            <a:pPr algn="l"/>
-            <a:r>
-              <a:rPr sz="950" b="0" i="0">
-                <a:solidFill>
-                  <a:srgbClr val="8AA8C8"/>
-                </a:solidFill>
-              </a:rPr>
-              <a:t>Built a custom AI agent to verify and correct the industry field on prospect accounts in Salesforce.</a:t>
-            </a:r>
-          </a:p>
-        </p:txBody>
-      </p:sp>
-      <p:sp>
-        <p:nvSpPr>
-          <p:cNvPr id="28" name="TextBox 27"/>
-          <p:cNvSpPr txBox="1"/>
-          <p:nvPr/>
-        </p:nvSpPr>
-        <p:spPr>
-          <a:xfrm>
-            <a:off x="6400800" y="4443983"/>
-            <a:ext cx="5212080" cy="256032"/>
-          </a:xfrm>
-          <a:prstGeom prst="rect">
-            <a:avLst/>
-          </a:prstGeom>
-          <a:noFill/>
-        </p:spPr>
-        <p:txBody>
-          <a:bodyPr wrap="square">
-            <a:spAutoFit/>
-          </a:bodyPr>
-          <a:lstStyle/>
-          <a:p>
-            <a:pPr algn="l"/>
-            <a:r>
-              <a:rPr sz="1050" b="1" i="0">
-                <a:solidFill>
-                  <a:srgbClr val="FFFFFF"/>
-                </a:solidFill>
-              </a:rPr>
-              <a:t>• FOUND 11K INCORRECTLY TAGGED ACCOUNTS</a:t>
-            </a:r>
-          </a:p>
-        </p:txBody>
-      </p:sp>
-      <p:sp>
-        <p:nvSpPr>
-          <p:cNvPr id="29" name="TextBox 28"/>
-          <p:cNvSpPr txBox="1"/>
-          <p:nvPr/>
-        </p:nvSpPr>
-        <p:spPr>
-          <a:xfrm>
-            <a:off x="6528816" y="4718303"/>
-            <a:ext cx="5074920" cy="457200"/>
-          </a:xfrm>
-          <a:prstGeom prst="rect">
-            <a:avLst/>
-          </a:prstGeom>
-          <a:noFill/>
-        </p:spPr>
-        <p:txBody>
-          <a:bodyPr wrap="square">
-            <a:spAutoFit/>
-          </a:bodyPr>
-          <a:lstStyle/>
-          <a:p>
-            <a:pPr algn="l"/>
-            <a:r>
-              <a:rPr sz="950" b="0" i="0">
-                <a:solidFill>
-                  <a:srgbClr val="8AA8C8"/>
-                </a:solidFill>
-              </a:rPr>
-              <a:t>Identified 11,000+ accounts incorrectly marked as MSPs in the CRM — cleaning the foundation for better targeting.</a:t>
-            </a:r>
-          </a:p>
-        </p:txBody>
-      </p:sp>
-      <p:sp>
-        <p:nvSpPr>
-          <p:cNvPr id="30" name="Rectangle 29"/>
-          <p:cNvSpPr/>
-          <p:nvPr/>
-        </p:nvSpPr>
-        <p:spPr>
-          <a:xfrm>
-            <a:off x="0" y="6675120"/>
-            <a:ext cx="12188952" cy="182880"/>
-          </a:xfrm>
-          <a:prstGeom prst="rect">
-            <a:avLst/>
-          </a:prstGeom>
-          <a:solidFill>
-            <a:srgbClr val="071220"/>
-          </a:solidFill>
-          <a:ln>
-            <a:noFill/>
-          </a:ln>
-        </p:spPr>
-        <p:style>
-          <a:lnRef idx="1">
-            <a:schemeClr val="accent1"/>
-          </a:lnRef>
-          <a:fillRef idx="3">
-            <a:schemeClr val="accent1"/>
-          </a:fillRef>
-          <a:effectRef idx="2">
-            <a:schemeClr val="accent1"/>
-          </a:effectRef>
-          <a:fontRef idx="minor">
-            <a:schemeClr val="lt1"/>
-          </a:fontRef>
-        </p:style>
-        <p:txBody>
-          <a:bodyPr rtlCol="0" anchor="ctr"/>
-          <a:lstStyle/>
-          <a:p>
-            <a:pPr algn="ctr"/>
-          </a:p>
-        </p:txBody>
-      </p:sp>
-      <p:sp>
-        <p:nvSpPr>
-          <p:cNvPr id="31" name="TextBox 30"/>
-          <p:cNvSpPr txBox="1"/>
-          <p:nvPr/>
-        </p:nvSpPr>
-        <p:spPr>
-          <a:xfrm>
-            <a:off x="274320" y="6693408"/>
-            <a:ext cx="1828800" cy="146304"/>
-          </a:xfrm>
-          <a:prstGeom prst="rect">
-            <a:avLst/>
-          </a:prstGeom>
-          <a:noFill/>
-        </p:spPr>
-        <p:txBody>
-          <a:bodyPr wrap="square">
-            <a:spAutoFit/>
-          </a:bodyPr>
-          <a:lstStyle/>
-          <a:p>
-            <a:pPr algn="l"/>
-            <a:r>
-              <a:rPr sz="900" b="1" i="0">
-                <a:solidFill>
-                  <a:srgbClr val="FFFFFF"/>
-                </a:solidFill>
-              </a:rPr>
-              <a:t>• rev.io</a:t>
-            </a:r>
-          </a:p>
-        </p:txBody>
-      </p:sp>
-      <p:sp>
-        <p:nvSpPr>
-          <p:cNvPr id="32" name="TextBox 31"/>
-          <p:cNvSpPr txBox="1"/>
-          <p:nvPr/>
-        </p:nvSpPr>
-        <p:spPr>
-          <a:xfrm>
-            <a:off x="8686800" y="6693408"/>
-            <a:ext cx="2011680" cy="146304"/>
-          </a:xfrm>
-          <a:prstGeom prst="rect">
-            <a:avLst/>
-          </a:prstGeom>
-          <a:noFill/>
-        </p:spPr>
-        <p:txBody>
-          <a:bodyPr wrap="square">
-            <a:spAutoFit/>
-          </a:bodyPr>
-          <a:lstStyle/>
-          <a:p>
-            <a:pPr algn="r"/>
-            <a:r>
-              <a:rPr sz="900" b="1" i="0">
-                <a:solidFill>
-                  <a:srgbClr val="FFFFFF"/>
-                </a:solidFill>
-              </a:rPr>
-              <a:t>BUILT FOR TOMORROW.</a:t>
-            </a:r>
-          </a:p>
-        </p:txBody>
-      </p:sp>
-      <p:sp>
-        <p:nvSpPr>
-          <p:cNvPr id="33" name="TextBox 32"/>
-          <p:cNvSpPr txBox="1"/>
-          <p:nvPr/>
-        </p:nvSpPr>
-        <p:spPr>
-          <a:xfrm>
-            <a:off x="10698480" y="6693408"/>
-            <a:ext cx="1371600" cy="146304"/>
-          </a:xfrm>
-          <a:prstGeom prst="rect">
-            <a:avLst/>
-          </a:prstGeom>
-          <a:noFill/>
-        </p:spPr>
-        <p:txBody>
-          <a:bodyPr wrap="square">
-            <a:spAutoFit/>
-          </a:bodyPr>
-          <a:lstStyle/>
-          <a:p>
-            <a:pPr algn="r"/>
-            <a:r>
-              <a:rPr sz="900" b="1" i="0">
-                <a:solidFill>
-                  <a:srgbClr val="3DC570"/>
-                </a:solidFill>
-              </a:rPr>
-              <a:t>READY FOR TODAY.</a:t>
-            </a:r>
-          </a:p>
-        </p:txBody>
-      </p:sp>
-    </p:spTree>
-  </p:cSld>
-  <p:clrMapOvr>
-    <a:masterClrMapping/>
-  </p:clrMapOvr>
-</p:sld>
-</file>
-
-<file path=ppt/slides/slide2.xml><?xml version="1.0" encoding="utf-8"?>
-<p:sld xmlns:a="http://schemas.openxmlformats.org/drawingml/2006/main" xmlns:p="http://schemas.openxmlformats.org/presentationml/2006/main" xmlns:r="http://schemas.openxmlformats.org/officeDocument/2006/relationships">
-  <p:cSld>
-    <p:spTree>
-      <p:nvGrpSpPr>
-        <p:cNvPr id="1" name=""/>
-        <p:cNvGrpSpPr/>
-        <p:nvPr/>
-      </p:nvGrpSpPr>
-      <p:grpSpPr/>
-      <p:sp>
-        <p:nvSpPr>
-          <p:cNvPr id="2" name="TextBox 1"/>
-          <p:cNvSpPr txBox="1"/>
-          <p:nvPr/>
-        </p:nvSpPr>
-        <p:spPr>
-          <a:xfrm>
-            <a:off x="365760" y="164592"/>
-            <a:ext cx="11430000" cy="713232"/>
-          </a:xfrm>
-          <a:prstGeom prst="rect">
-            <a:avLst/>
-          </a:prstGeom>
-          <a:noFill/>
-        </p:spPr>
-        <p:txBody>
-          <a:bodyPr wrap="square">
-            <a:spAutoFit/>
-          </a:bodyPr>
-          <a:lstStyle/>
-          <a:p>
-            <a:pPr algn="l"/>
-            <a:r>
-              <a:rPr sz="4600" b="1" i="0">
-                <a:solidFill>
-                  <a:srgbClr val="FFFFFF"/>
-                </a:solidFill>
-              </a:rPr>
-              <a:t>Robin's Tool Stack</a:t>
-            </a:r>
-          </a:p>
-        </p:txBody>
-      </p:sp>
-      <p:sp>
-        <p:nvSpPr>
-          <p:cNvPr id="3" name="TextBox 2"/>
-          <p:cNvSpPr txBox="1"/>
-          <p:nvPr/>
-        </p:nvSpPr>
-        <p:spPr>
-          <a:xfrm>
-            <a:off x="365760" y="877824"/>
-            <a:ext cx="11430000" cy="310896"/>
-          </a:xfrm>
-          <a:prstGeom prst="rect">
-            <a:avLst/>
-          </a:prstGeom>
-          <a:noFill/>
-        </p:spPr>
-        <p:txBody>
-          <a:bodyPr wrap="square">
-            <a:spAutoFit/>
-          </a:bodyPr>
-          <a:lstStyle/>
-          <a:p>
-            <a:pPr algn="l"/>
-            <a:r>
-              <a:rPr sz="1300" b="0" i="0">
-                <a:solidFill>
-                  <a:srgbClr val="8AA8C8"/>
-                </a:solidFill>
-              </a:rPr>
-              <a:t>Integrated with best-in-class tools to automate sales workflows end-to-end.</a:t>
-            </a:r>
-          </a:p>
-        </p:txBody>
-      </p:sp>
-      <p:sp>
-        <p:nvSpPr>
-          <p:cNvPr id="4" name="Rectangle 3"/>
-          <p:cNvSpPr/>
-          <p:nvPr/>
-        </p:nvSpPr>
-        <p:spPr>
-          <a:xfrm>
-            <a:off x="365760" y="1298448"/>
-            <a:ext cx="11457432" cy="658368"/>
-          </a:xfrm>
-          <a:prstGeom prst="rect">
-            <a:avLst/>
-          </a:prstGeom>
-          <a:solidFill>
-            <a:srgbClr val="0A1E30"/>
-          </a:solidFill>
-          <a:ln>
-            <a:noFill/>
-          </a:ln>
-        </p:spPr>
-        <p:style>
-          <a:lnRef idx="1">
-            <a:schemeClr val="accent1"/>
-          </a:lnRef>
-          <a:fillRef idx="3">
-            <a:schemeClr val="accent1"/>
-          </a:fillRef>
-          <a:effectRef idx="2">
-            <a:schemeClr val="accent1"/>
-          </a:effectRef>
-          <a:fontRef idx="minor">
-            <a:schemeClr val="lt1"/>
-          </a:fontRef>
-        </p:style>
-        <p:txBody>
-          <a:bodyPr rtlCol="0" anchor="ctr"/>
-          <a:lstStyle/>
-          <a:p>
-            <a:pPr algn="ctr"/>
-          </a:p>
-        </p:txBody>
-      </p:sp>
-      <p:sp>
-        <p:nvSpPr>
-          <p:cNvPr id="5" name="Rectangle 4"/>
-          <p:cNvSpPr/>
-          <p:nvPr/>
-        </p:nvSpPr>
-        <p:spPr>
-          <a:xfrm>
-            <a:off x="365760" y="1298448"/>
-            <a:ext cx="45720" cy="658368"/>
-          </a:xfrm>
-          <a:prstGeom prst="rect">
-            <a:avLst/>
-          </a:prstGeom>
-          <a:solidFill>
-            <a:srgbClr val="00D4D4"/>
-          </a:solidFill>
-          <a:ln>
-            <a:noFill/>
-          </a:ln>
-        </p:spPr>
-        <p:style>
-          <a:lnRef idx="1">
-            <a:schemeClr val="accent1"/>
-          </a:lnRef>
-          <a:fillRef idx="3">
-            <a:schemeClr val="accent1"/>
-          </a:fillRef>
-          <a:effectRef idx="2">
-            <a:schemeClr val="accent1"/>
-          </a:effectRef>
-          <a:fontRef idx="minor">
-            <a:schemeClr val="lt1"/>
-          </a:fontRef>
-        </p:style>
-        <p:txBody>
-          <a:bodyPr rtlCol="0" anchor="ctr"/>
-          <a:lstStyle/>
-          <a:p>
-            <a:pPr algn="ctr"/>
-          </a:p>
-        </p:txBody>
-      </p:sp>
-      <p:sp>
-        <p:nvSpPr>
-          <p:cNvPr id="6" name="TextBox 5"/>
-          <p:cNvSpPr txBox="1"/>
-          <p:nvPr/>
-        </p:nvSpPr>
-        <p:spPr>
-          <a:xfrm>
-            <a:off x="502920" y="1335024"/>
-            <a:ext cx="3200400" cy="182880"/>
-          </a:xfrm>
-          <a:prstGeom prst="rect">
-            <a:avLst/>
-          </a:prstGeom>
-          <a:noFill/>
-        </p:spPr>
-        <p:txBody>
-          <a:bodyPr wrap="square">
-            <a:spAutoFit/>
-          </a:bodyPr>
-          <a:lstStyle/>
-          <a:p>
-            <a:pPr algn="l"/>
-            <a:r>
-              <a:rPr sz="800" b="1" i="0">
-                <a:solidFill>
-                  <a:srgbClr val="3DC570"/>
-                </a:solidFill>
-              </a:rPr>
-              <a:t>INTEGRATIONS</a:t>
-            </a:r>
-          </a:p>
-        </p:txBody>
-      </p:sp>
-      <p:sp>
-        <p:nvSpPr>
-          <p:cNvPr id="7" name="TextBox 6"/>
-          <p:cNvSpPr txBox="1"/>
-          <p:nvPr/>
-        </p:nvSpPr>
-        <p:spPr>
-          <a:xfrm>
-            <a:off x="502920" y="1517904"/>
-            <a:ext cx="11155680" cy="347472"/>
-          </a:xfrm>
-          <a:prstGeom prst="rect">
-            <a:avLst/>
-          </a:prstGeom>
-          <a:noFill/>
-        </p:spPr>
-        <p:txBody>
-          <a:bodyPr wrap="square">
-            <a:spAutoFit/>
-          </a:bodyPr>
-          <a:lstStyle/>
-          <a:p>
-            <a:pPr algn="l"/>
-            <a:r>
-              <a:rPr sz="1050" b="0" i="0">
-                <a:solidFill>
-                  <a:srgbClr val="FFFFFF"/>
-                </a:solidFill>
-              </a:rPr>
-              <a:t>Robin connects into Rev.io's existing tool stack — using AI to turn raw data and workflows into automated action at scale.</a:t>
-            </a:r>
-          </a:p>
-        </p:txBody>
-      </p:sp>
-      <p:sp>
-        <p:nvSpPr>
-          <p:cNvPr id="8" name="Rectangle 7"/>
-          <p:cNvSpPr/>
-          <p:nvPr/>
-        </p:nvSpPr>
-        <p:spPr>
-          <a:xfrm>
-            <a:off x="365760" y="2084831"/>
-            <a:ext cx="5623560" cy="4315968"/>
-          </a:xfrm>
-          <a:prstGeom prst="rect">
-            <a:avLst/>
-          </a:prstGeom>
-          <a:solidFill>
-            <a:srgbClr val="0A1E30"/>
-          </a:solidFill>
-          <a:ln>
-            <a:noFill/>
-          </a:ln>
-        </p:spPr>
-        <p:style>
-          <a:lnRef idx="1">
-            <a:schemeClr val="accent1"/>
-          </a:lnRef>
-          <a:fillRef idx="3">
-            <a:schemeClr val="accent1"/>
-          </a:fillRef>
-          <a:effectRef idx="2">
-            <a:schemeClr val="accent1"/>
-          </a:effectRef>
-          <a:fontRef idx="minor">
-            <a:schemeClr val="lt1"/>
-          </a:fontRef>
-        </p:style>
-        <p:txBody>
-          <a:bodyPr rtlCol="0" anchor="ctr"/>
-          <a:lstStyle/>
-          <a:p>
-            <a:pPr algn="ctr"/>
-          </a:p>
-        </p:txBody>
-      </p:sp>
-      <p:sp>
-        <p:nvSpPr>
-          <p:cNvPr id="9" name="Rectangle 8"/>
-          <p:cNvSpPr/>
-          <p:nvPr/>
-        </p:nvSpPr>
-        <p:spPr>
-          <a:xfrm>
-            <a:off x="365760" y="2084831"/>
-            <a:ext cx="45720" cy="4315968"/>
-          </a:xfrm>
-          <a:prstGeom prst="rect">
-            <a:avLst/>
-          </a:prstGeom>
-          <a:solidFill>
-            <a:srgbClr val="7C3AED"/>
-          </a:solidFill>
-          <a:ln>
-            <a:noFill/>
-          </a:ln>
-        </p:spPr>
-        <p:style>
-          <a:lnRef idx="1">
-            <a:schemeClr val="accent1"/>
-          </a:lnRef>
-          <a:fillRef idx="3">
-            <a:schemeClr val="accent1"/>
-          </a:fillRef>
-          <a:effectRef idx="2">
-            <a:schemeClr val="accent1"/>
-          </a:effectRef>
-          <a:fontRef idx="minor">
-            <a:schemeClr val="lt1"/>
-          </a:fontRef>
-        </p:style>
-        <p:txBody>
-          <a:bodyPr rtlCol="0" anchor="ctr"/>
-          <a:lstStyle/>
-          <a:p>
-            <a:pPr algn="ctr"/>
-          </a:p>
-        </p:txBody>
-      </p:sp>
-      <p:sp>
-        <p:nvSpPr>
-          <p:cNvPr id="10" name="TextBox 9"/>
-          <p:cNvSpPr txBox="1"/>
-          <p:nvPr/>
-        </p:nvSpPr>
-        <p:spPr>
-          <a:xfrm>
-            <a:off x="566928" y="2212848"/>
-            <a:ext cx="5029200" cy="502920"/>
-          </a:xfrm>
-          <a:prstGeom prst="rect">
-            <a:avLst/>
-          </a:prstGeom>
-          <a:noFill/>
-        </p:spPr>
-        <p:txBody>
-          <a:bodyPr wrap="square">
-            <a:spAutoFit/>
-          </a:bodyPr>
-          <a:lstStyle/>
-          <a:p>
-            <a:pPr algn="l"/>
-            <a:r>
-              <a:rPr sz="3400" b="1" i="0">
-                <a:solidFill>
-                  <a:srgbClr val="FFFFFF"/>
-                </a:solidFill>
-              </a:rPr>
-              <a:t>📓  Notion</a:t>
-            </a:r>
-          </a:p>
-        </p:txBody>
-      </p:sp>
-      <p:sp>
-        <p:nvSpPr>
-          <p:cNvPr id="11" name="TextBox 10"/>
-          <p:cNvSpPr txBox="1"/>
-          <p:nvPr/>
-        </p:nvSpPr>
-        <p:spPr>
-          <a:xfrm>
-            <a:off x="566928" y="2724911"/>
-            <a:ext cx="5212080" cy="274320"/>
-          </a:xfrm>
-          <a:prstGeom prst="rect">
-            <a:avLst/>
-          </a:prstGeom>
-          <a:noFill/>
-        </p:spPr>
-        <p:txBody>
-          <a:bodyPr wrap="square">
-            <a:spAutoFit/>
-          </a:bodyPr>
-          <a:lstStyle/>
-          <a:p>
-            <a:pPr algn="l"/>
-            <a:r>
-              <a:rPr sz="1300" b="0" i="0">
-                <a:solidFill>
-                  <a:srgbClr val="7C3AED"/>
-                </a:solidFill>
-              </a:rPr>
-              <a:t>AI-Powered Knowledge &amp; Workflow Automation</a:t>
-            </a:r>
-          </a:p>
-        </p:txBody>
-      </p:sp>
-      <p:sp>
-        <p:nvSpPr>
-          <p:cNvPr id="12" name="TextBox 11"/>
-          <p:cNvSpPr txBox="1"/>
-          <p:nvPr/>
-        </p:nvSpPr>
-        <p:spPr>
-          <a:xfrm>
-            <a:off x="566928" y="3017520"/>
-            <a:ext cx="5212080" cy="237744"/>
-          </a:xfrm>
-          <a:prstGeom prst="rect">
-            <a:avLst/>
-          </a:prstGeom>
-          <a:noFill/>
-        </p:spPr>
-        <p:txBody>
-          <a:bodyPr wrap="square">
-            <a:spAutoFit/>
-          </a:bodyPr>
-          <a:lstStyle/>
-          <a:p>
-            <a:pPr algn="l"/>
-            <a:r>
-              <a:rPr sz="1000" b="0" i="1">
-                <a:solidFill>
-                  <a:srgbClr val="8AA8C8"/>
-                </a:solidFill>
-              </a:rPr>
-              <a:t>Prospect research · Meeting intelligence · Follow-up</a:t>
-            </a:r>
-          </a:p>
-        </p:txBody>
-      </p:sp>
-      <p:sp>
-        <p:nvSpPr>
-          <p:cNvPr id="13" name="Rectangle 12"/>
-          <p:cNvSpPr/>
-          <p:nvPr/>
-        </p:nvSpPr>
-        <p:spPr>
-          <a:xfrm>
-            <a:off x="566928" y="3310128"/>
-            <a:ext cx="5221224" cy="18288"/>
-          </a:xfrm>
-          <a:prstGeom prst="rect">
-            <a:avLst/>
-          </a:prstGeom>
-          <a:solidFill>
-            <a:srgbClr val="1A3555"/>
-          </a:solidFill>
-          <a:ln>
-            <a:noFill/>
-          </a:ln>
-        </p:spPr>
-        <p:style>
-          <a:lnRef idx="1">
-            <a:schemeClr val="accent1"/>
-          </a:lnRef>
-          <a:fillRef idx="3">
-            <a:schemeClr val="accent1"/>
-          </a:fillRef>
-          <a:effectRef idx="2">
-            <a:schemeClr val="accent1"/>
-          </a:effectRef>
-          <a:fontRef idx="minor">
-            <a:schemeClr val="lt1"/>
-          </a:fontRef>
-        </p:style>
-        <p:txBody>
-          <a:bodyPr rtlCol="0" anchor="ctr"/>
-          <a:lstStyle/>
-          <a:p>
-            <a:pPr algn="ctr"/>
-          </a:p>
-        </p:txBody>
-      </p:sp>
-      <p:sp>
-        <p:nvSpPr>
-          <p:cNvPr id="14" name="TextBox 13"/>
-          <p:cNvSpPr txBox="1"/>
-          <p:nvPr/>
-        </p:nvSpPr>
-        <p:spPr>
-          <a:xfrm>
-            <a:off x="566928" y="3438144"/>
-            <a:ext cx="5212080" cy="237744"/>
-          </a:xfrm>
-          <a:prstGeom prst="rect">
-            <a:avLst/>
-          </a:prstGeom>
-          <a:noFill/>
-        </p:spPr>
-        <p:txBody>
-          <a:bodyPr wrap="square">
-            <a:spAutoFit/>
-          </a:bodyPr>
-          <a:lstStyle/>
-          <a:p>
-            <a:pPr algn="l"/>
-            <a:r>
-              <a:rPr sz="1050" b="1" i="0">
-                <a:solidFill>
-                  <a:srgbClr val="FFFFFF"/>
-                </a:solidFill>
-              </a:rPr>
-              <a:t>• MSP EMAIL PERSONALIZATION AT SCALE</a:t>
-            </a:r>
-          </a:p>
-        </p:txBody>
-      </p:sp>
-      <p:sp>
-        <p:nvSpPr>
-          <p:cNvPr id="15" name="TextBox 14"/>
-          <p:cNvSpPr txBox="1"/>
-          <p:nvPr/>
-        </p:nvSpPr>
-        <p:spPr>
-          <a:xfrm>
-            <a:off x="694944" y="3694176"/>
-            <a:ext cx="5074920" cy="347472"/>
-          </a:xfrm>
-          <a:prstGeom prst="rect">
-            <a:avLst/>
-          </a:prstGeom>
-          <a:noFill/>
-        </p:spPr>
-        <p:txBody>
-          <a:bodyPr wrap="square">
-            <a:spAutoFit/>
-          </a:bodyPr>
-          <a:lstStyle/>
-          <a:p>
-            <a:pPr algn="l"/>
-            <a:r>
-              <a:rPr sz="950" b="0" i="0">
-                <a:solidFill>
-                  <a:srgbClr val="8AA8C8"/>
-                </a:solidFill>
-              </a:rPr>
-              <a:t>Researches each prospect and writes personalized outreach automatically — no manual prep.</a:t>
-            </a:r>
-          </a:p>
-        </p:txBody>
-      </p:sp>
-      <p:sp>
-        <p:nvSpPr>
-          <p:cNvPr id="16" name="TextBox 15"/>
-          <p:cNvSpPr txBox="1"/>
-          <p:nvPr/>
-        </p:nvSpPr>
-        <p:spPr>
-          <a:xfrm>
-            <a:off x="566928" y="4352544"/>
-            <a:ext cx="5212080" cy="237744"/>
-          </a:xfrm>
-          <a:prstGeom prst="rect">
-            <a:avLst/>
-          </a:prstGeom>
-          <a:noFill/>
-        </p:spPr>
-        <p:txBody>
-          <a:bodyPr wrap="square">
-            <a:spAutoFit/>
-          </a:bodyPr>
-          <a:lstStyle/>
-          <a:p>
-            <a:pPr algn="l"/>
-            <a:r>
-              <a:rPr sz="1050" b="1" i="0">
-                <a:solidFill>
-                  <a:srgbClr val="FFFFFF"/>
-                </a:solidFill>
-              </a:rPr>
-              <a:t>• MEETING NOTE-TAKING &amp; TRANSCRIPTION</a:t>
-            </a:r>
-          </a:p>
-        </p:txBody>
-      </p:sp>
-      <p:sp>
-        <p:nvSpPr>
-          <p:cNvPr id="17" name="TextBox 16"/>
-          <p:cNvSpPr txBox="1"/>
-          <p:nvPr/>
-        </p:nvSpPr>
-        <p:spPr>
-          <a:xfrm>
-            <a:off x="694944" y="4608576"/>
-            <a:ext cx="5074920" cy="347472"/>
-          </a:xfrm>
-          <a:prstGeom prst="rect">
-            <a:avLst/>
-          </a:prstGeom>
-          <a:noFill/>
-        </p:spPr>
-        <p:txBody>
-          <a:bodyPr wrap="square">
-            <a:spAutoFit/>
-          </a:bodyPr>
-          <a:lstStyle/>
-          <a:p>
-            <a:pPr algn="l"/>
-            <a:r>
-              <a:rPr sz="950" b="0" i="0">
-                <a:solidFill>
-                  <a:srgbClr val="8AA8C8"/>
-                </a:solidFill>
-              </a:rPr>
-              <a:t>Captures full meeting notes, key takeaways, and action items from every prospect call.</a:t>
-            </a:r>
-          </a:p>
-        </p:txBody>
-      </p:sp>
-      <p:sp>
-        <p:nvSpPr>
-          <p:cNvPr id="18" name="TextBox 17"/>
-          <p:cNvSpPr txBox="1"/>
-          <p:nvPr/>
-        </p:nvSpPr>
-        <p:spPr>
-          <a:xfrm>
-            <a:off x="566928" y="5266944"/>
-            <a:ext cx="5212080" cy="237744"/>
-          </a:xfrm>
-          <a:prstGeom prst="rect">
-            <a:avLst/>
-          </a:prstGeom>
-          <a:noFill/>
-        </p:spPr>
-        <p:txBody>
-          <a:bodyPr wrap="square">
-            <a:spAutoFit/>
-          </a:bodyPr>
-          <a:lstStyle/>
-          <a:p>
-            <a:pPr algn="l"/>
-            <a:r>
-              <a:rPr sz="1050" b="1" i="0">
-                <a:solidFill>
-                  <a:srgbClr val="FFFFFF"/>
-                </a:solidFill>
-              </a:rPr>
-              <a:t>• POST-MEETING FOLLOW-UP EMAILS</a:t>
-            </a:r>
-          </a:p>
-        </p:txBody>
-      </p:sp>
-      <p:sp>
-        <p:nvSpPr>
-          <p:cNvPr id="19" name="TextBox 18"/>
-          <p:cNvSpPr txBox="1"/>
-          <p:nvPr/>
-        </p:nvSpPr>
-        <p:spPr>
-          <a:xfrm>
-            <a:off x="694944" y="5522976"/>
-            <a:ext cx="5074920" cy="347472"/>
-          </a:xfrm>
-          <a:prstGeom prst="rect">
-            <a:avLst/>
-          </a:prstGeom>
-          <a:noFill/>
-        </p:spPr>
-        <p:txBody>
-          <a:bodyPr wrap="square">
-            <a:spAutoFit/>
-          </a:bodyPr>
-          <a:lstStyle/>
-          <a:p>
-            <a:pPr algn="l"/>
-            <a:r>
-              <a:rPr sz="950" b="0" i="0">
-                <a:solidFill>
-                  <a:srgbClr val="8AA8C8"/>
-                </a:solidFill>
-              </a:rPr>
-              <a:t>Generates tailored follow-up emails and action item summaries immediately after each call.</a:t>
-            </a:r>
-          </a:p>
-        </p:txBody>
-      </p:sp>
-      <p:sp>
-        <p:nvSpPr>
-          <p:cNvPr id="20" name="Rectangle 19"/>
-          <p:cNvSpPr/>
-          <p:nvPr/>
-        </p:nvSpPr>
-        <p:spPr>
-          <a:xfrm>
-            <a:off x="6199632" y="2084831"/>
-            <a:ext cx="5623560" cy="4315968"/>
-          </a:xfrm>
-          <a:prstGeom prst="rect">
-            <a:avLst/>
-          </a:prstGeom>
-          <a:solidFill>
-            <a:srgbClr val="0A1E30"/>
-          </a:solidFill>
-          <a:ln>
-            <a:noFill/>
-          </a:ln>
-        </p:spPr>
-        <p:style>
-          <a:lnRef idx="1">
-            <a:schemeClr val="accent1"/>
-          </a:lnRef>
-          <a:fillRef idx="3">
-            <a:schemeClr val="accent1"/>
-          </a:fillRef>
-          <a:effectRef idx="2">
-            <a:schemeClr val="accent1"/>
-          </a:effectRef>
-          <a:fontRef idx="minor">
-            <a:schemeClr val="lt1"/>
-          </a:fontRef>
-        </p:style>
-        <p:txBody>
-          <a:bodyPr rtlCol="0" anchor="ctr"/>
-          <a:lstStyle/>
-          <a:p>
-            <a:pPr algn="ctr"/>
-          </a:p>
-        </p:txBody>
-      </p:sp>
-      <p:sp>
-        <p:nvSpPr>
-          <p:cNvPr id="21" name="Rectangle 20"/>
-          <p:cNvSpPr/>
-          <p:nvPr/>
-        </p:nvSpPr>
-        <p:spPr>
-          <a:xfrm>
-            <a:off x="6199632" y="2084831"/>
-            <a:ext cx="45720" cy="4315968"/>
-          </a:xfrm>
-          <a:prstGeom prst="rect">
-            <a:avLst/>
-          </a:prstGeom>
-          <a:solidFill>
-            <a:srgbClr val="F57C2A"/>
-          </a:solidFill>
-          <a:ln>
-            <a:noFill/>
-          </a:ln>
-        </p:spPr>
-        <p:style>
-          <a:lnRef idx="1">
-            <a:schemeClr val="accent1"/>
-          </a:lnRef>
-          <a:fillRef idx="3">
-            <a:schemeClr val="accent1"/>
-          </a:fillRef>
-          <a:effectRef idx="2">
-            <a:schemeClr val="accent1"/>
-          </a:effectRef>
-          <a:fontRef idx="minor">
-            <a:schemeClr val="lt1"/>
-          </a:fontRef>
-        </p:style>
-        <p:txBody>
-          <a:bodyPr rtlCol="0" anchor="ctr"/>
-          <a:lstStyle/>
-          <a:p>
-            <a:pPr algn="ctr"/>
-          </a:p>
-        </p:txBody>
-      </p:sp>
-      <p:sp>
-        <p:nvSpPr>
-          <p:cNvPr id="22" name="TextBox 21"/>
-          <p:cNvSpPr txBox="1"/>
-          <p:nvPr/>
-        </p:nvSpPr>
-        <p:spPr>
-          <a:xfrm>
-            <a:off x="6400800" y="2212848"/>
-            <a:ext cx="5029200" cy="502920"/>
-          </a:xfrm>
-          <a:prstGeom prst="rect">
-            <a:avLst/>
-          </a:prstGeom>
-          <a:noFill/>
-        </p:spPr>
-        <p:txBody>
-          <a:bodyPr wrap="square">
-            <a:spAutoFit/>
-          </a:bodyPr>
-          <a:lstStyle/>
-          <a:p>
-            <a:pPr algn="l"/>
-            <a:r>
-              <a:rPr sz="3400" b="1" i="0">
-                <a:solidFill>
-                  <a:srgbClr val="FFFFFF"/>
-                </a:solidFill>
-              </a:rPr>
-              <a:t>🏗️  Clay</a:t>
-            </a:r>
-          </a:p>
-        </p:txBody>
-      </p:sp>
-      <p:sp>
-        <p:nvSpPr>
-          <p:cNvPr id="23" name="TextBox 22"/>
-          <p:cNvSpPr txBox="1"/>
-          <p:nvPr/>
-        </p:nvSpPr>
-        <p:spPr>
-          <a:xfrm>
-            <a:off x="6400800" y="2724911"/>
-            <a:ext cx="5212080" cy="274320"/>
-          </a:xfrm>
-          <a:prstGeom prst="rect">
-            <a:avLst/>
-          </a:prstGeom>
-          <a:noFill/>
-        </p:spPr>
-        <p:txBody>
-          <a:bodyPr wrap="square">
-            <a:spAutoFit/>
-          </a:bodyPr>
-          <a:lstStyle/>
-          <a:p>
-            <a:pPr algn="l"/>
-            <a:r>
-              <a:rPr sz="1300" b="0" i="0">
-                <a:solidFill>
-                  <a:srgbClr val="F57C2A"/>
-                </a:solidFill>
-              </a:rPr>
-              <a:t>Custom AI Agent for Data Intelligence</a:t>
-            </a:r>
-          </a:p>
-        </p:txBody>
-      </p:sp>
-      <p:sp>
-        <p:nvSpPr>
-          <p:cNvPr id="24" name="TextBox 23"/>
-          <p:cNvSpPr txBox="1"/>
-          <p:nvPr/>
-        </p:nvSpPr>
-        <p:spPr>
-          <a:xfrm>
-            <a:off x="6400800" y="3017520"/>
-            <a:ext cx="5212080" cy="237744"/>
-          </a:xfrm>
-          <a:prstGeom prst="rect">
-            <a:avLst/>
-          </a:prstGeom>
-          <a:noFill/>
-        </p:spPr>
-        <p:txBody>
-          <a:bodyPr wrap="square">
-            <a:spAutoFit/>
-          </a:bodyPr>
-          <a:lstStyle/>
-          <a:p>
-            <a:pPr algn="l"/>
-            <a:r>
-              <a:rPr sz="1000" b="0" i="1">
-                <a:solidFill>
-                  <a:srgbClr val="8AA8C8"/>
-                </a:solidFill>
-              </a:rPr>
-              <a:t>Prospect enrichment · CRM data hygiene · Verification</a:t>
-            </a:r>
-          </a:p>
-        </p:txBody>
-      </p:sp>
-      <p:sp>
-        <p:nvSpPr>
-          <p:cNvPr id="25" name="Rectangle 24"/>
-          <p:cNvSpPr/>
-          <p:nvPr/>
-        </p:nvSpPr>
-        <p:spPr>
-          <a:xfrm>
-            <a:off x="6400800" y="3310128"/>
-            <a:ext cx="5221224" cy="18288"/>
-          </a:xfrm>
-          <a:prstGeom prst="rect">
-            <a:avLst/>
-          </a:prstGeom>
-          <a:solidFill>
-            <a:srgbClr val="1A3555"/>
-          </a:solidFill>
-          <a:ln>
-            <a:noFill/>
-          </a:ln>
-        </p:spPr>
-        <p:style>
-          <a:lnRef idx="1">
-            <a:schemeClr val="accent1"/>
-          </a:lnRef>
-          <a:fillRef idx="3">
-            <a:schemeClr val="accent1"/>
-          </a:fillRef>
-          <a:effectRef idx="2">
-            <a:schemeClr val="accent1"/>
-          </a:effectRef>
-          <a:fontRef idx="minor">
-            <a:schemeClr val="lt1"/>
-          </a:fontRef>
-        </p:style>
-        <p:txBody>
-          <a:bodyPr rtlCol="0" anchor="ctr"/>
-          <a:lstStyle/>
-          <a:p>
-            <a:pPr algn="ctr"/>
-          </a:p>
-        </p:txBody>
-      </p:sp>
-      <p:sp>
-        <p:nvSpPr>
-          <p:cNvPr id="26" name="TextBox 25"/>
-          <p:cNvSpPr txBox="1"/>
-          <p:nvPr/>
-        </p:nvSpPr>
-        <p:spPr>
-          <a:xfrm>
-            <a:off x="6400800" y="3438144"/>
-            <a:ext cx="5212080" cy="256032"/>
-          </a:xfrm>
-          <a:prstGeom prst="rect">
-            <a:avLst/>
-          </a:prstGeom>
-          <a:noFill/>
-        </p:spPr>
-        <p:txBody>
-          <a:bodyPr wrap="square">
-            <a:spAutoFit/>
-          </a:bodyPr>
-          <a:lstStyle/>
-          <a:p>
-            <a:pPr algn="l"/>
-            <a:r>
-              <a:rPr sz="1050" b="1" i="0">
-                <a:solidFill>
-                  <a:srgbClr val="FFFFFF"/>
-                </a:solidFill>
-              </a:rPr>
-              <a:t>• CUSTOM AGENT: PROSPECT INDUSTRY VERIFICATION</a:t>
-            </a:r>
-          </a:p>
-        </p:txBody>
-      </p:sp>
-      <p:sp>
-        <p:nvSpPr>
-          <p:cNvPr id="27" name="TextBox 26"/>
-          <p:cNvSpPr txBox="1"/>
-          <p:nvPr/>
-        </p:nvSpPr>
-        <p:spPr>
-          <a:xfrm>
-            <a:off x="6528816" y="3712463"/>
-            <a:ext cx="5074920" cy="457200"/>
-          </a:xfrm>
-          <a:prstGeom prst="rect">
-            <a:avLst/>
-          </a:prstGeom>
-          <a:noFill/>
-        </p:spPr>
-        <p:txBody>
-          <a:bodyPr wrap="square">
-            <a:spAutoFit/>
-          </a:bodyPr>
-          <a:lstStyle/>
-          <a:p>
-            <a:pPr algn="l"/>
-            <a:r>
-              <a:rPr sz="950" b="0" i="0">
-                <a:solidFill>
-                  <a:srgbClr val="8AA8C8"/>
-                </a:solidFill>
-              </a:rPr>
-              <a:t>Built a custom AI agent to verify and correct the industry field on prospect accounts in Salesforce.</a:t>
-            </a:r>
-          </a:p>
-        </p:txBody>
-      </p:sp>
-      <p:sp>
-        <p:nvSpPr>
-          <p:cNvPr id="28" name="TextBox 27"/>
-          <p:cNvSpPr txBox="1"/>
-          <p:nvPr/>
-        </p:nvSpPr>
-        <p:spPr>
-          <a:xfrm>
-            <a:off x="6400800" y="4443983"/>
-            <a:ext cx="5212080" cy="256032"/>
-          </a:xfrm>
-          <a:prstGeom prst="rect">
-            <a:avLst/>
-          </a:prstGeom>
-          <a:noFill/>
-        </p:spPr>
-        <p:txBody>
-          <a:bodyPr wrap="square">
-            <a:spAutoFit/>
-          </a:bodyPr>
-          <a:lstStyle/>
-          <a:p>
-            <a:pPr algn="l"/>
-            <a:r>
-              <a:rPr sz="1050" b="1" i="0">
-                <a:solidFill>
-                  <a:srgbClr val="FFFFFF"/>
-                </a:solidFill>
-              </a:rPr>
-              <a:t>• FOUND 11K INCORRECTLY TAGGED ACCOUNTS</a:t>
-            </a:r>
-          </a:p>
-        </p:txBody>
-      </p:sp>
-      <p:sp>
-        <p:nvSpPr>
-          <p:cNvPr id="29" name="TextBox 28"/>
-          <p:cNvSpPr txBox="1"/>
-          <p:nvPr/>
-        </p:nvSpPr>
-        <p:spPr>
-          <a:xfrm>
-            <a:off x="6528816" y="4718303"/>
-            <a:ext cx="5074920" cy="457200"/>
-          </a:xfrm>
-          <a:prstGeom prst="rect">
-            <a:avLst/>
-          </a:prstGeom>
-          <a:noFill/>
-        </p:spPr>
-        <p:txBody>
-          <a:bodyPr wrap="square">
-            <a:spAutoFit/>
-          </a:bodyPr>
-          <a:lstStyle/>
-          <a:p>
-            <a:pPr algn="l"/>
-            <a:r>
-              <a:rPr sz="950" b="0" i="0">
-                <a:solidFill>
-                  <a:srgbClr val="8AA8C8"/>
-                </a:solidFill>
-              </a:rPr>
-              <a:t>Identified 11,000+ accounts incorrectly marked as MSPs in the CRM — cleaning the foundation for better targeting.</a:t>
-            </a:r>
-          </a:p>
-        </p:txBody>
-      </p:sp>
-      <p:sp>
-        <p:nvSpPr>
-          <p:cNvPr id="30" name="Rectangle 29"/>
-          <p:cNvSpPr/>
-          <p:nvPr/>
-        </p:nvSpPr>
-        <p:spPr>
-          <a:xfrm>
-            <a:off x="0" y="6675120"/>
-            <a:ext cx="12188952" cy="182880"/>
-          </a:xfrm>
-          <a:prstGeom prst="rect">
-            <a:avLst/>
-          </a:prstGeom>
-          <a:solidFill>
-            <a:srgbClr val="071220"/>
-          </a:solidFill>
-          <a:ln>
-            <a:noFill/>
-          </a:ln>
-        </p:spPr>
-        <p:style>
-          <a:lnRef idx="1">
-            <a:schemeClr val="accent1"/>
-          </a:lnRef>
-          <a:fillRef idx="3">
-            <a:schemeClr val="accent1"/>
-          </a:fillRef>
-          <a:effectRef idx="2">
-            <a:schemeClr val="accent1"/>
-          </a:effectRef>
-          <a:fontRef idx="minor">
-            <a:schemeClr val="lt1"/>
-          </a:fontRef>
-        </p:style>
-        <p:txBody>
-          <a:bodyPr rtlCol="0" anchor="ctr"/>
-          <a:lstStyle/>
-          <a:p>
-            <a:pPr algn="ctr"/>
-          </a:p>
-        </p:txBody>
-      </p:sp>
-      <p:sp>
-        <p:nvSpPr>
-          <p:cNvPr id="31" name="TextBox 30"/>
-          <p:cNvSpPr txBox="1"/>
-          <p:nvPr/>
-        </p:nvSpPr>
-        <p:spPr>
-          <a:xfrm>
-            <a:off x="274320" y="6693408"/>
-            <a:ext cx="1828800" cy="146304"/>
-          </a:xfrm>
-          <a:prstGeom prst="rect">
-            <a:avLst/>
-          </a:prstGeom>
-          <a:noFill/>
-        </p:spPr>
-        <p:txBody>
-          <a:bodyPr wrap="square">
-            <a:spAutoFit/>
-          </a:bodyPr>
-          <a:lstStyle/>
-          <a:p>
-            <a:pPr algn="l"/>
-            <a:r>
-              <a:rPr sz="900" b="1" i="0">
-                <a:solidFill>
-                  <a:srgbClr val="FFFFFF"/>
-                </a:solidFill>
-              </a:rPr>
-              <a:t>• rev.io</a:t>
-            </a:r>
-          </a:p>
-        </p:txBody>
-      </p:sp>
-      <p:sp>
-        <p:nvSpPr>
-          <p:cNvPr id="32" name="TextBox 31"/>
-          <p:cNvSpPr txBox="1"/>
-          <p:nvPr/>
-        </p:nvSpPr>
-        <p:spPr>
-          <a:xfrm>
-            <a:off x="8686800" y="6693408"/>
-            <a:ext cx="2011680" cy="146304"/>
-          </a:xfrm>
-          <a:prstGeom prst="rect">
-            <a:avLst/>
-          </a:prstGeom>
-          <a:noFill/>
-        </p:spPr>
-        <p:txBody>
-          <a:bodyPr wrap="square">
-            <a:spAutoFit/>
-          </a:bodyPr>
-          <a:lstStyle/>
-          <a:p>
-            <a:pPr algn="r"/>
-            <a:r>
-              <a:rPr sz="900" b="1" i="0">
-                <a:solidFill>
-                  <a:srgbClr val="FFFFFF"/>
-                </a:solidFill>
-              </a:rPr>
-              <a:t>BUILT FOR TOMORROW.</a:t>
-            </a:r>
-          </a:p>
-        </p:txBody>
-      </p:sp>
-      <p:sp>
-        <p:nvSpPr>
-          <p:cNvPr id="33" name="TextBox 32"/>
+          <p:cNvPr id="47" name="TextBox 46"/>
           <p:cNvSpPr txBox="1"/>
           <p:nvPr/>
         </p:nvSpPr>

</xml_diff>

<commit_message>
Robin intro: wide Robin card with 5 categories, narrow Notion + Clay
</commit_message>
<xml_diff>
--- a/Robin-Intro-Slide.pptx
+++ b/Robin-Intro-Slide.pptx
@@ -4798,8 +4798,8 @@
         </p:nvSpPr>
         <p:spPr>
           <a:xfrm>
-            <a:off x="365760" y="164592"/>
-            <a:ext cx="11430000" cy="658368"/>
+            <a:off x="274320" y="137160"/>
+            <a:ext cx="11612880" cy="621792"/>
           </a:xfrm>
           <a:prstGeom prst="rect">
             <a:avLst/>
@@ -4814,7 +4814,7 @@
           <a:p>
             <a:pPr algn="l"/>
             <a:r>
-              <a:rPr sz="4400" b="1" i="0">
+              <a:rPr sz="4200" b="1" i="0">
                 <a:solidFill>
                   <a:srgbClr val="FFFFFF"/>
                 </a:solidFill>
@@ -4832,8 +4832,8 @@
         </p:nvSpPr>
         <p:spPr>
           <a:xfrm>
-            <a:off x="365760" y="822960"/>
-            <a:ext cx="11430000" cy="274320"/>
+            <a:off x="274320" y="758952"/>
+            <a:ext cx="11612880" cy="256032"/>
           </a:xfrm>
           <a:prstGeom prst="rect">
             <a:avLst/>
@@ -4848,7 +4848,7 @@
           <a:p>
             <a:pPr algn="l"/>
             <a:r>
-              <a:rPr sz="1250" b="0" i="0">
+              <a:rPr sz="1200" b="0" i="0">
                 <a:solidFill>
                   <a:srgbClr val="8AA8C8"/>
                 </a:solidFill>
@@ -4866,8 +4866,8 @@
         </p:nvSpPr>
         <p:spPr>
           <a:xfrm>
-            <a:off x="365760" y="1188720"/>
-            <a:ext cx="11457432" cy="603504"/>
+            <a:off x="274320" y="1078992"/>
+            <a:ext cx="11640312" cy="512064"/>
           </a:xfrm>
           <a:prstGeom prst="rect">
             <a:avLst/>
@@ -4909,8 +4909,8 @@
         </p:nvSpPr>
         <p:spPr>
           <a:xfrm>
-            <a:off x="365760" y="1188720"/>
-            <a:ext cx="45720" cy="603504"/>
+            <a:off x="274320" y="1078992"/>
+            <a:ext cx="45720" cy="512064"/>
           </a:xfrm>
           <a:prstGeom prst="rect">
             <a:avLst/>
@@ -4952,8 +4952,8 @@
         </p:nvSpPr>
         <p:spPr>
           <a:xfrm>
-            <a:off x="502920" y="1225296"/>
-            <a:ext cx="3200400" cy="182880"/>
+            <a:off x="402336" y="1106424"/>
+            <a:ext cx="3200400" cy="164592"/>
           </a:xfrm>
           <a:prstGeom prst="rect">
             <a:avLst/>
@@ -4968,7 +4968,7 @@
           <a:p>
             <a:pPr algn="l"/>
             <a:r>
-              <a:rPr sz="800" b="1" i="0">
+              <a:rPr sz="750" b="1" i="0">
                 <a:solidFill>
                   <a:srgbClr val="3DC570"/>
                 </a:solidFill>
@@ -4986,8 +4986,8 @@
         </p:nvSpPr>
         <p:spPr>
           <a:xfrm>
-            <a:off x="502920" y="1389888"/>
-            <a:ext cx="11155680" cy="347472"/>
+            <a:off x="402336" y="1271016"/>
+            <a:ext cx="11155680" cy="274320"/>
           </a:xfrm>
           <a:prstGeom prst="rect">
             <a:avLst/>
@@ -5002,12 +5002,12 @@
           <a:p>
             <a:pPr algn="l"/>
             <a:r>
-              <a:rPr sz="1050" b="0" i="0">
+              <a:rPr sz="1000" b="0" i="0">
                 <a:solidFill>
                   <a:srgbClr val="FFFFFF"/>
                 </a:solidFill>
               </a:rPr>
-              <a:t>Built for the Rev.io sales team — automating intelligence, research, and execution so reps spend more time selling and less time on manual work.</a:t>
+              <a:t>Built for the Rev.io sales team — automating intelligence, research, and execution so reps spend more time selling.</a:t>
             </a:r>
           </a:p>
         </p:txBody>
@@ -5020,8 +5020,8 @@
         </p:nvSpPr>
         <p:spPr>
           <a:xfrm>
-            <a:off x="365760" y="1901952"/>
-            <a:ext cx="3739896" cy="4590288"/>
+            <a:off x="274320" y="1682496"/>
+            <a:ext cx="6492240" cy="4992624"/>
           </a:xfrm>
           <a:prstGeom prst="rect">
             <a:avLst/>
@@ -5063,8 +5063,8 @@
         </p:nvSpPr>
         <p:spPr>
           <a:xfrm>
-            <a:off x="365760" y="1901952"/>
-            <a:ext cx="45720" cy="4590288"/>
+            <a:off x="274320" y="1682496"/>
+            <a:ext cx="45720" cy="4992624"/>
           </a:xfrm>
           <a:prstGeom prst="rect">
             <a:avLst/>
@@ -5106,8 +5106,8 @@
         </p:nvSpPr>
         <p:spPr>
           <a:xfrm>
-            <a:off x="530352" y="2011680"/>
-            <a:ext cx="3511296" cy="457200"/>
+            <a:off x="438912" y="1773936"/>
+            <a:ext cx="6263640" cy="457200"/>
           </a:xfrm>
           <a:prstGeom prst="rect">
             <a:avLst/>
@@ -5122,7 +5122,7 @@
           <a:p>
             <a:pPr algn="l"/>
             <a:r>
-              <a:rPr sz="2200" b="1" i="0">
+              <a:rPr sz="2800" b="1" i="0">
                 <a:solidFill>
                   <a:srgbClr val="FFFFFF"/>
                 </a:solidFill>
@@ -5140,8 +5140,8 @@
         </p:nvSpPr>
         <p:spPr>
           <a:xfrm>
-            <a:off x="530352" y="2487168"/>
-            <a:ext cx="3511296" cy="347472"/>
+            <a:off x="438912" y="2249424"/>
+            <a:ext cx="6263640" cy="256032"/>
           </a:xfrm>
           <a:prstGeom prst="rect">
             <a:avLst/>
@@ -5156,7 +5156,7 @@
           <a:p>
             <a:pPr algn="l"/>
             <a:r>
-              <a:rPr sz="1000" b="0" i="0">
+              <a:rPr sz="1200" b="0" i="0">
                 <a:solidFill>
                   <a:srgbClr val="00D4D4"/>
                 </a:solidFill>
@@ -5174,8 +5174,8 @@
         </p:nvSpPr>
         <p:spPr>
           <a:xfrm>
-            <a:off x="530352" y="2834640"/>
-            <a:ext cx="3511296" cy="237744"/>
+            <a:off x="438912" y="2505456"/>
+            <a:ext cx="6263640" cy="201168"/>
           </a:xfrm>
           <a:prstGeom prst="rect">
             <a:avLst/>
@@ -5190,7 +5190,7 @@
           <a:p>
             <a:pPr algn="l"/>
             <a:r>
-              <a:rPr sz="900" b="0" i="1">
+              <a:rPr sz="950" b="0" i="1">
                 <a:solidFill>
                   <a:srgbClr val="8AA8C8"/>
                 </a:solidFill>
@@ -5208,8 +5208,8 @@
         </p:nvSpPr>
         <p:spPr>
           <a:xfrm>
-            <a:off x="530352" y="3090672"/>
-            <a:ext cx="3465576" cy="18288"/>
+            <a:off x="438912" y="2724912"/>
+            <a:ext cx="6217920" cy="18288"/>
           </a:xfrm>
           <a:prstGeom prst="rect">
             <a:avLst/>
@@ -5251,8 +5251,8 @@
         </p:nvSpPr>
         <p:spPr>
           <a:xfrm>
-            <a:off x="530352" y="3200400"/>
-            <a:ext cx="3511296" cy="219456"/>
+            <a:off x="438912" y="2779776"/>
+            <a:ext cx="3017520" cy="182880"/>
           </a:xfrm>
           <a:prstGeom prst="rect">
             <a:avLst/>
@@ -5267,12 +5267,12 @@
           <a:p>
             <a:pPr algn="l"/>
             <a:r>
-              <a:rPr sz="950" b="1" i="0">
-                <a:solidFill>
-                  <a:srgbClr val="FFFFFF"/>
+              <a:rPr sz="800" b="1" i="0">
+                <a:solidFill>
+                  <a:srgbClr val="3DC570"/>
                 </a:solidFill>
               </a:rPr>
-              <a:t>• ACTIVITY POINT TRACKING</a:t>
+              <a:t>PIPELINE &amp; FORECASTING</a:t>
             </a:r>
           </a:p>
         </p:txBody>
@@ -5285,8 +5285,8 @@
         </p:nvSpPr>
         <p:spPr>
           <a:xfrm>
-            <a:off x="621792" y="3438144"/>
-            <a:ext cx="3419856" cy="457200"/>
+            <a:off x="493776" y="2980944"/>
+            <a:ext cx="2944368" cy="219456"/>
           </a:xfrm>
           <a:prstGeom prst="rect">
             <a:avLst/>
@@ -5301,12 +5301,12 @@
           <a:p>
             <a:pPr algn="l"/>
             <a:r>
-              <a:rPr sz="850" b="0" i="0">
-                <a:solidFill>
-                  <a:srgbClr val="8AA8C8"/>
+              <a:rPr sz="780" b="0" i="0">
+                <a:solidFill>
+                  <a:srgbClr val="FFFFFF"/>
                 </a:solidFill>
               </a:rPr>
-              <a:t>Scores and monitors rep activity daily across calls, emails, meetings, and opps sourced.</a:t>
+              <a:t>· Daily forecast dashboard — live SF data, scenarios, marketing attribution</a:t>
             </a:r>
           </a:p>
         </p:txBody>
@@ -5319,8 +5319,8 @@
         </p:nvSpPr>
         <p:spPr>
           <a:xfrm>
-            <a:off x="530352" y="3977639"/>
-            <a:ext cx="3511296" cy="219456"/>
+            <a:off x="493776" y="3209544"/>
+            <a:ext cx="2944368" cy="219456"/>
           </a:xfrm>
           <a:prstGeom prst="rect">
             <a:avLst/>
@@ -5335,12 +5335,12 @@
           <a:p>
             <a:pPr algn="l"/>
             <a:r>
-              <a:rPr sz="950" b="1" i="0">
+              <a:rPr sz="780" b="0" i="0">
                 <a:solidFill>
                   <a:srgbClr val="FFFFFF"/>
                 </a:solidFill>
               </a:rPr>
-              <a:t>• WEEKLY CALL BLITZES</a:t>
+              <a:t>· Weekly forecast emails to Evan &amp; Brent every Monday</a:t>
             </a:r>
           </a:p>
         </p:txBody>
@@ -5353,8 +5353,8 @@
         </p:nvSpPr>
         <p:spPr>
           <a:xfrm>
-            <a:off x="621792" y="4215383"/>
-            <a:ext cx="3419856" cy="457200"/>
+            <a:off x="493776" y="3438144"/>
+            <a:ext cx="2944368" cy="219456"/>
           </a:xfrm>
           <a:prstGeom prst="rect">
             <a:avLst/>
@@ -5369,12 +5369,12 @@
           <a:p>
             <a:pPr algn="l"/>
             <a:r>
-              <a:rPr sz="850" b="0" i="0">
-                <a:solidFill>
-                  <a:srgbClr val="8AA8C8"/>
+              <a:rPr sz="780" b="0" i="0">
+                <a:solidFill>
+                  <a:srgbClr val="FFFFFF"/>
                 </a:solidFill>
               </a:rPr>
-              <a:t>Runs structured call blitzes with live tracking and coaching nudges for the team.</a:t>
+              <a:t>· Per-product Q1 tracking vs quota</a:t>
             </a:r>
           </a:p>
         </p:txBody>
@@ -5387,8 +5387,8 @@
         </p:nvSpPr>
         <p:spPr>
           <a:xfrm>
-            <a:off x="530352" y="4754880"/>
-            <a:ext cx="3511296" cy="219456"/>
+            <a:off x="438912" y="3776472"/>
+            <a:ext cx="3017520" cy="182880"/>
           </a:xfrm>
           <a:prstGeom prst="rect">
             <a:avLst/>
@@ -5403,12 +5403,12 @@
           <a:p>
             <a:pPr algn="l"/>
             <a:r>
-              <a:rPr sz="950" b="1" i="0">
-                <a:solidFill>
-                  <a:srgbClr val="FFFFFF"/>
+              <a:rPr sz="800" b="1" i="0">
+                <a:solidFill>
+                  <a:srgbClr val="3DC570"/>
                 </a:solidFill>
               </a:rPr>
-              <a:t>• PROSPECT RESEARCH</a:t>
+              <a:t>SALES ACTIVITY</a:t>
             </a:r>
           </a:p>
         </p:txBody>
@@ -5421,8 +5421,8 @@
         </p:nvSpPr>
         <p:spPr>
           <a:xfrm>
-            <a:off x="621792" y="4992624"/>
-            <a:ext cx="3419856" cy="457200"/>
+            <a:off x="493776" y="3977639"/>
+            <a:ext cx="2944368" cy="219456"/>
           </a:xfrm>
           <a:prstGeom prst="rect">
             <a:avLst/>
@@ -5437,12 +5437,12 @@
           <a:p>
             <a:pPr algn="l"/>
             <a:r>
-              <a:rPr sz="850" b="0" i="0">
-                <a:solidFill>
-                  <a:srgbClr val="8AA8C8"/>
+              <a:rPr sz="780" b="0" i="0">
+                <a:solidFill>
+                  <a:srgbClr val="FFFFFF"/>
                 </a:solidFill>
               </a:rPr>
-              <a:t>Finds net-new accounts not in the CRM — verified and enriched before reps see them.</a:t>
+              <a:t>· Daily activity scorecard — calls, emails, meetings, opps sourced (Tue–Fri)</a:t>
             </a:r>
           </a:p>
         </p:txBody>
@@ -5455,8 +5455,8 @@
         </p:nvSpPr>
         <p:spPr>
           <a:xfrm>
-            <a:off x="530352" y="5532120"/>
-            <a:ext cx="3511296" cy="219456"/>
+            <a:off x="493776" y="4206240"/>
+            <a:ext cx="2944368" cy="219456"/>
           </a:xfrm>
           <a:prstGeom prst="rect">
             <a:avLst/>
@@ -5471,12 +5471,12 @@
           <a:p>
             <a:pPr algn="l"/>
             <a:r>
-              <a:rPr sz="950" b="1" i="0">
+              <a:rPr sz="780" b="0" i="0">
                 <a:solidFill>
                   <a:srgbClr val="FFFFFF"/>
                 </a:solidFill>
               </a:rPr>
-              <a:t>• FORECAST DECKS FOR ELT</a:t>
+              <a:t>· AE capacity dashboard — prospect meetings MTD vs projected</a:t>
             </a:r>
           </a:p>
         </p:txBody>
@@ -5489,8 +5489,8 @@
         </p:nvSpPr>
         <p:spPr>
           <a:xfrm>
-            <a:off x="621792" y="5769864"/>
-            <a:ext cx="3419856" cy="457200"/>
+            <a:off x="493776" y="4434840"/>
+            <a:ext cx="2944368" cy="219456"/>
           </a:xfrm>
           <a:prstGeom prst="rect">
             <a:avLst/>
@@ -5505,26 +5505,434 @@
           <a:p>
             <a:pPr algn="l"/>
             <a:r>
-              <a:rPr sz="850" b="0" i="0">
-                <a:solidFill>
-                  <a:srgbClr val="8AA8C8"/>
+              <a:rPr sz="780" b="0" i="0">
+                <a:solidFill>
+                  <a:srgbClr val="FFFFFF"/>
                 </a:solidFill>
               </a:rPr>
-              <a:t>Automated weekly forecast dashboard with live Salesforce data pushed to leadership.</a:t>
-            </a:r>
-          </a:p>
-        </p:txBody>
-      </p:sp>
-      <p:sp>
-        <p:nvSpPr>
-          <p:cNvPr id="22" name="Rectangle 21"/>
+              <a:t>· Weekly call blitz support</a:t>
+            </a:r>
+          </a:p>
+        </p:txBody>
+      </p:sp>
+      <p:sp>
+        <p:nvSpPr>
+          <p:cNvPr id="22" name="TextBox 21"/>
+          <p:cNvSpPr txBox="1"/>
+          <p:nvPr/>
+        </p:nvSpPr>
+        <p:spPr>
+          <a:xfrm>
+            <a:off x="438912" y="4773168"/>
+            <a:ext cx="3017520" cy="182880"/>
+          </a:xfrm>
+          <a:prstGeom prst="rect">
+            <a:avLst/>
+          </a:prstGeom>
+          <a:noFill/>
+        </p:spPr>
+        <p:txBody>
+          <a:bodyPr wrap="square">
+            <a:spAutoFit/>
+          </a:bodyPr>
+          <a:lstStyle/>
+          <a:p>
+            <a:pPr algn="l"/>
+            <a:r>
+              <a:rPr sz="800" b="1" i="0">
+                <a:solidFill>
+                  <a:srgbClr val="3DC570"/>
+                </a:solidFill>
+              </a:rPr>
+              <a:t>PROSPECTING &amp; INTELLIGENCE</a:t>
+            </a:r>
+          </a:p>
+        </p:txBody>
+      </p:sp>
+      <p:sp>
+        <p:nvSpPr>
+          <p:cNvPr id="23" name="TextBox 22"/>
+          <p:cNvSpPr txBox="1"/>
+          <p:nvPr/>
+        </p:nvSpPr>
+        <p:spPr>
+          <a:xfrm>
+            <a:off x="493776" y="4974336"/>
+            <a:ext cx="2944368" cy="219456"/>
+          </a:xfrm>
+          <a:prstGeom prst="rect">
+            <a:avLst/>
+          </a:prstGeom>
+          <a:noFill/>
+        </p:spPr>
+        <p:txBody>
+          <a:bodyPr wrap="square">
+            <a:spAutoFit/>
+          </a:bodyPr>
+          <a:lstStyle/>
+          <a:p>
+            <a:pPr algn="l"/>
+            <a:r>
+              <a:rPr sz="780" b="0" i="0">
+                <a:solidFill>
+                  <a:srgbClr val="FFFFFF"/>
+                </a:solidFill>
+              </a:rPr>
+              <a:t>· Daily MSP prospector — 5 net-new accounts every morning not in SF</a:t>
+            </a:r>
+          </a:p>
+        </p:txBody>
+      </p:sp>
+      <p:sp>
+        <p:nvSpPr>
+          <p:cNvPr id="24" name="TextBox 23"/>
+          <p:cNvSpPr txBox="1"/>
+          <p:nvPr/>
+        </p:nvSpPr>
+        <p:spPr>
+          <a:xfrm>
+            <a:off x="493776" y="5202936"/>
+            <a:ext cx="2944368" cy="219456"/>
+          </a:xfrm>
+          <a:prstGeom prst="rect">
+            <a:avLst/>
+          </a:prstGeom>
+          <a:noFill/>
+        </p:spPr>
+        <p:txBody>
+          <a:bodyPr wrap="square">
+            <a:spAutoFit/>
+          </a:bodyPr>
+          <a:lstStyle/>
+          <a:p>
+            <a:pPr algn="l"/>
+            <a:r>
+              <a:rPr sz="780" b="0" i="0">
+                <a:solidFill>
+                  <a:srgbClr val="FFFFFF"/>
+                </a:solidFill>
+              </a:rPr>
+              <a:t>· Rev.io mention monitor — daily web scan, pings Ryan if noteworthy</a:t>
+            </a:r>
+          </a:p>
+        </p:txBody>
+      </p:sp>
+      <p:sp>
+        <p:nvSpPr>
+          <p:cNvPr id="25" name="TextBox 24"/>
+          <p:cNvSpPr txBox="1"/>
+          <p:nvPr/>
+        </p:nvSpPr>
+        <p:spPr>
+          <a:xfrm>
+            <a:off x="493776" y="5431536"/>
+            <a:ext cx="2944368" cy="219456"/>
+          </a:xfrm>
+          <a:prstGeom prst="rect">
+            <a:avLst/>
+          </a:prstGeom>
+          <a:noFill/>
+        </p:spPr>
+        <p:txBody>
+          <a:bodyPr wrap="square">
+            <a:spAutoFit/>
+          </a:bodyPr>
+          <a:lstStyle/>
+          <a:p>
+            <a:pPr algn="l"/>
+            <a:r>
+              <a:rPr sz="780" b="0" i="0">
+                <a:solidFill>
+                  <a:srgbClr val="FFFFFF"/>
+                </a:solidFill>
+              </a:rPr>
+              <a:t>· Morning briefings Mon–Fri — schedule + weather</a:t>
+            </a:r>
+          </a:p>
+        </p:txBody>
+      </p:sp>
+      <p:sp>
+        <p:nvSpPr>
+          <p:cNvPr id="26" name="TextBox 25"/>
+          <p:cNvSpPr txBox="1"/>
+          <p:nvPr/>
+        </p:nvSpPr>
+        <p:spPr>
+          <a:xfrm>
+            <a:off x="3566160" y="2779776"/>
+            <a:ext cx="3017520" cy="182880"/>
+          </a:xfrm>
+          <a:prstGeom prst="rect">
+            <a:avLst/>
+          </a:prstGeom>
+          <a:noFill/>
+        </p:spPr>
+        <p:txBody>
+          <a:bodyPr wrap="square">
+            <a:spAutoFit/>
+          </a:bodyPr>
+          <a:lstStyle/>
+          <a:p>
+            <a:pPr algn="l"/>
+            <a:r>
+              <a:rPr sz="800" b="1" i="0">
+                <a:solidFill>
+                  <a:srgbClr val="3DC570"/>
+                </a:solidFill>
+              </a:rPr>
+              <a:t>COACHING &amp; ANALYTICS</a:t>
+            </a:r>
+          </a:p>
+        </p:txBody>
+      </p:sp>
+      <p:sp>
+        <p:nvSpPr>
+          <p:cNvPr id="27" name="TextBox 26"/>
+          <p:cNvSpPr txBox="1"/>
+          <p:nvPr/>
+        </p:nvSpPr>
+        <p:spPr>
+          <a:xfrm>
+            <a:off x="3621024" y="2980944"/>
+            <a:ext cx="2944368" cy="219456"/>
+          </a:xfrm>
+          <a:prstGeom prst="rect">
+            <a:avLst/>
+          </a:prstGeom>
+          <a:noFill/>
+        </p:spPr>
+        <p:txBody>
+          <a:bodyPr wrap="square">
+            <a:spAutoFit/>
+          </a:bodyPr>
+          <a:lstStyle/>
+          <a:p>
+            <a:pPr algn="l"/>
+            <a:r>
+              <a:rPr sz="780" b="0" i="0">
+                <a:solidFill>
+                  <a:srgbClr val="FFFFFF"/>
+                </a:solidFill>
+              </a:rPr>
+              <a:t>· Discovery call grading — BEACON framework, 6 categories, 100 pts</a:t>
+            </a:r>
+          </a:p>
+        </p:txBody>
+      </p:sp>
+      <p:sp>
+        <p:nvSpPr>
+          <p:cNvPr id="28" name="TextBox 27"/>
+          <p:cNvSpPr txBox="1"/>
+          <p:nvPr/>
+        </p:nvSpPr>
+        <p:spPr>
+          <a:xfrm>
+            <a:off x="3621024" y="3209544"/>
+            <a:ext cx="2944368" cy="219456"/>
+          </a:xfrm>
+          <a:prstGeom prst="rect">
+            <a:avLst/>
+          </a:prstGeom>
+          <a:noFill/>
+        </p:spPr>
+        <p:txBody>
+          <a:bodyPr wrap="square">
+            <a:spAutoFit/>
+          </a:bodyPr>
+          <a:lstStyle/>
+          <a:p>
+            <a:pPr algn="l"/>
+            <a:r>
+              <a:rPr sz="780" b="0" i="0">
+                <a:solidFill>
+                  <a:srgbClr val="FFFFFF"/>
+                </a:solidFill>
+              </a:rPr>
+              <a:t>· Closed loss analysis — Feb vs March trends + coaching actions</a:t>
+            </a:r>
+          </a:p>
+        </p:txBody>
+      </p:sp>
+      <p:sp>
+        <p:nvSpPr>
+          <p:cNvPr id="29" name="TextBox 28"/>
+          <p:cNvSpPr txBox="1"/>
+          <p:nvPr/>
+        </p:nvSpPr>
+        <p:spPr>
+          <a:xfrm>
+            <a:off x="3621024" y="3438144"/>
+            <a:ext cx="2944368" cy="219456"/>
+          </a:xfrm>
+          <a:prstGeom prst="rect">
+            <a:avLst/>
+          </a:prstGeom>
+          <a:noFill/>
+        </p:spPr>
+        <p:txBody>
+          <a:bodyPr wrap="square">
+            <a:spAutoFit/>
+          </a:bodyPr>
+          <a:lstStyle/>
+          <a:p>
+            <a:pPr algn="l"/>
+            <a:r>
+              <a:rPr sz="780" b="0" i="0">
+                <a:solidFill>
+                  <a:srgbClr val="FFFFFF"/>
+                </a:solidFill>
+              </a:rPr>
+              <a:t>· Loss reason deep dives — no-show, missing capabilities</a:t>
+            </a:r>
+          </a:p>
+        </p:txBody>
+      </p:sp>
+      <p:sp>
+        <p:nvSpPr>
+          <p:cNvPr id="30" name="TextBox 29"/>
+          <p:cNvSpPr txBox="1"/>
+          <p:nvPr/>
+        </p:nvSpPr>
+        <p:spPr>
+          <a:xfrm>
+            <a:off x="3566160" y="3776472"/>
+            <a:ext cx="3017520" cy="182880"/>
+          </a:xfrm>
+          <a:prstGeom prst="rect">
+            <a:avLst/>
+          </a:prstGeom>
+          <a:noFill/>
+        </p:spPr>
+        <p:txBody>
+          <a:bodyPr wrap="square">
+            <a:spAutoFit/>
+          </a:bodyPr>
+          <a:lstStyle/>
+          <a:p>
+            <a:pPr algn="l"/>
+            <a:r>
+              <a:rPr sz="800" b="1" i="0">
+                <a:solidFill>
+                  <a:srgbClr val="3DC570"/>
+                </a:solidFill>
+              </a:rPr>
+              <a:t>RESEARCH &amp; CONTENT</a:t>
+            </a:r>
+          </a:p>
+        </p:txBody>
+      </p:sp>
+      <p:sp>
+        <p:nvSpPr>
+          <p:cNvPr id="31" name="TextBox 30"/>
+          <p:cNvSpPr txBox="1"/>
+          <p:nvPr/>
+        </p:nvSpPr>
+        <p:spPr>
+          <a:xfrm>
+            <a:off x="3621024" y="3977639"/>
+            <a:ext cx="2944368" cy="219456"/>
+          </a:xfrm>
+          <a:prstGeom prst="rect">
+            <a:avLst/>
+          </a:prstGeom>
+          <a:noFill/>
+        </p:spPr>
+        <p:txBody>
+          <a:bodyPr wrap="square">
+            <a:spAutoFit/>
+          </a:bodyPr>
+          <a:lstStyle/>
+          <a:p>
+            <a:pPr algn="l"/>
+            <a:r>
+              <a:rPr sz="780" b="0" i="0">
+                <a:solidFill>
+                  <a:srgbClr val="FFFFFF"/>
+                </a:solidFill>
+              </a:rPr>
+              <a:t>· Competitive battle card dashboard</a:t>
+            </a:r>
+          </a:p>
+        </p:txBody>
+      </p:sp>
+      <p:sp>
+        <p:nvSpPr>
+          <p:cNvPr id="32" name="TextBox 31"/>
+          <p:cNvSpPr txBox="1"/>
+          <p:nvPr/>
+        </p:nvSpPr>
+        <p:spPr>
+          <a:xfrm>
+            <a:off x="3621024" y="4206240"/>
+            <a:ext cx="2944368" cy="219456"/>
+          </a:xfrm>
+          <a:prstGeom prst="rect">
+            <a:avLst/>
+          </a:prstGeom>
+          <a:noFill/>
+        </p:spPr>
+        <p:txBody>
+          <a:bodyPr wrap="square">
+            <a:spAutoFit/>
+          </a:bodyPr>
+          <a:lstStyle/>
+          <a:p>
+            <a:pPr algn="l"/>
+            <a:r>
+              <a:rPr sz="780" b="0" i="0">
+                <a:solidFill>
+                  <a:srgbClr val="FFFFFF"/>
+                </a:solidFill>
+              </a:rPr>
+              <a:t>· MSP PSA requirements deck</a:t>
+            </a:r>
+          </a:p>
+        </p:txBody>
+      </p:sp>
+      <p:sp>
+        <p:nvSpPr>
+          <p:cNvPr id="33" name="TextBox 32"/>
+          <p:cNvSpPr txBox="1"/>
+          <p:nvPr/>
+        </p:nvSpPr>
+        <p:spPr>
+          <a:xfrm>
+            <a:off x="3621024" y="4434840"/>
+            <a:ext cx="2944368" cy="219456"/>
+          </a:xfrm>
+          <a:prstGeom prst="rect">
+            <a:avLst/>
+          </a:prstGeom>
+          <a:noFill/>
+        </p:spPr>
+        <p:txBody>
+          <a:bodyPr wrap="square">
+            <a:spAutoFit/>
+          </a:bodyPr>
+          <a:lstStyle/>
+          <a:p>
+            <a:pPr algn="l"/>
+            <a:r>
+              <a:rPr sz="780" b="0" i="0">
+                <a:solidFill>
+                  <a:srgbClr val="FFFFFF"/>
+                </a:solidFill>
+              </a:rPr>
+              <a:t>· Custom decks and analysis on demand</a:t>
+            </a:r>
+          </a:p>
+        </p:txBody>
+      </p:sp>
+      <p:sp>
+        <p:nvSpPr>
+          <p:cNvPr id="34" name="Rectangle 33"/>
           <p:cNvSpPr/>
           <p:nvPr/>
         </p:nvSpPr>
         <p:spPr>
           <a:xfrm>
-            <a:off x="4224528" y="1901952"/>
-            <a:ext cx="3739896" cy="4590288"/>
+            <a:off x="6885431" y="1682496"/>
+            <a:ext cx="2423160" cy="4992624"/>
           </a:xfrm>
           <a:prstGeom prst="rect">
             <a:avLst/>
@@ -5560,14 +5968,14 @@
       </p:sp>
       <p:sp>
         <p:nvSpPr>
-          <p:cNvPr id="23" name="Rectangle 22"/>
+          <p:cNvPr id="35" name="Rectangle 34"/>
           <p:cNvSpPr/>
           <p:nvPr/>
         </p:nvSpPr>
         <p:spPr>
           <a:xfrm>
-            <a:off x="4224528" y="1901952"/>
-            <a:ext cx="45720" cy="4590288"/>
+            <a:off x="6885431" y="1682496"/>
+            <a:ext cx="45720" cy="4992624"/>
           </a:xfrm>
           <a:prstGeom prst="rect">
             <a:avLst/>
@@ -5603,14 +6011,14 @@
       </p:sp>
       <p:sp>
         <p:nvSpPr>
-          <p:cNvPr id="24" name="TextBox 23"/>
+          <p:cNvPr id="36" name="TextBox 35"/>
           <p:cNvSpPr txBox="1"/>
           <p:nvPr/>
         </p:nvSpPr>
         <p:spPr>
           <a:xfrm>
-            <a:off x="4389120" y="2011680"/>
-            <a:ext cx="3511296" cy="457200"/>
+            <a:off x="7022592" y="1773936"/>
+            <a:ext cx="2240279" cy="402336"/>
           </a:xfrm>
           <a:prstGeom prst="rect">
             <a:avLst/>
@@ -5625,7 +6033,7 @@
           <a:p>
             <a:pPr algn="l"/>
             <a:r>
-              <a:rPr sz="2200" b="1" i="0">
+              <a:rPr sz="1800" b="1" i="0">
                 <a:solidFill>
                   <a:srgbClr val="FFFFFF"/>
                 </a:solidFill>
@@ -5637,14 +6045,14 @@
       </p:sp>
       <p:sp>
         <p:nvSpPr>
-          <p:cNvPr id="25" name="TextBox 24"/>
+          <p:cNvPr id="37" name="TextBox 36"/>
           <p:cNvSpPr txBox="1"/>
           <p:nvPr/>
         </p:nvSpPr>
         <p:spPr>
           <a:xfrm>
-            <a:off x="4389120" y="2487168"/>
-            <a:ext cx="3511296" cy="347472"/>
+            <a:off x="7022592" y="2194560"/>
+            <a:ext cx="2240279" cy="292608"/>
           </a:xfrm>
           <a:prstGeom prst="rect">
             <a:avLst/>
@@ -5659,26 +6067,26 @@
           <a:p>
             <a:pPr algn="l"/>
             <a:r>
-              <a:rPr sz="1000" b="0" i="0">
+              <a:rPr sz="850" b="0" i="0">
                 <a:solidFill>
                   <a:srgbClr val="7C3AED"/>
                 </a:solidFill>
               </a:rPr>
-              <a:t>AI-Powered Knowledge &amp; Workflow Automation</a:t>
-            </a:r>
-          </a:p>
-        </p:txBody>
-      </p:sp>
-      <p:sp>
-        <p:nvSpPr>
-          <p:cNvPr id="26" name="TextBox 25"/>
+              <a:t>Knowledge &amp; Workflow Automation</a:t>
+            </a:r>
+          </a:p>
+        </p:txBody>
+      </p:sp>
+      <p:sp>
+        <p:nvSpPr>
+          <p:cNvPr id="38" name="TextBox 37"/>
           <p:cNvSpPr txBox="1"/>
           <p:nvPr/>
         </p:nvSpPr>
         <p:spPr>
           <a:xfrm>
-            <a:off x="4389120" y="2834640"/>
-            <a:ext cx="3511296" cy="237744"/>
+            <a:off x="7022592" y="2487168"/>
+            <a:ext cx="2240279" cy="201168"/>
           </a:xfrm>
           <a:prstGeom prst="rect">
             <a:avLst/>
@@ -5693,26 +6101,26 @@
           <a:p>
             <a:pPr algn="l"/>
             <a:r>
-              <a:rPr sz="900" b="0" i="1">
+              <a:rPr sz="750" b="0" i="1">
                 <a:solidFill>
                   <a:srgbClr val="8AA8C8"/>
                 </a:solidFill>
               </a:rPr>
-              <a:t>Meeting intelligence · Personalization · Follow-up</a:t>
-            </a:r>
-          </a:p>
-        </p:txBody>
-      </p:sp>
-      <p:sp>
-        <p:nvSpPr>
-          <p:cNvPr id="27" name="Rectangle 26"/>
+              <a:t>Personalization · Transcription · Follow-up</a:t>
+            </a:r>
+          </a:p>
+        </p:txBody>
+      </p:sp>
+      <p:sp>
+        <p:nvSpPr>
+          <p:cNvPr id="39" name="Rectangle 38"/>
           <p:cNvSpPr/>
           <p:nvPr/>
         </p:nvSpPr>
         <p:spPr>
           <a:xfrm>
-            <a:off x="4389120" y="3090672"/>
-            <a:ext cx="3465576" cy="18288"/>
+            <a:off x="7022592" y="2706624"/>
+            <a:ext cx="2194560" cy="18288"/>
           </a:xfrm>
           <a:prstGeom prst="rect">
             <a:avLst/>
@@ -5748,14 +6156,14 @@
       </p:sp>
       <p:sp>
         <p:nvSpPr>
-          <p:cNvPr id="28" name="TextBox 27"/>
+          <p:cNvPr id="40" name="TextBox 39"/>
           <p:cNvSpPr txBox="1"/>
           <p:nvPr/>
         </p:nvSpPr>
         <p:spPr>
           <a:xfrm>
-            <a:off x="4389120" y="3200400"/>
-            <a:ext cx="3511296" cy="219456"/>
+            <a:off x="7022592" y="2779776"/>
+            <a:ext cx="2221991" cy="201168"/>
           </a:xfrm>
           <a:prstGeom prst="rect">
             <a:avLst/>
@@ -5770,7 +6178,7 @@
           <a:p>
             <a:pPr algn="l"/>
             <a:r>
-              <a:rPr sz="950" b="1" i="0">
+              <a:rPr sz="750" b="1" i="0">
                 <a:solidFill>
                   <a:srgbClr val="FFFFFF"/>
                 </a:solidFill>
@@ -5782,14 +6190,14 @@
       </p:sp>
       <p:sp>
         <p:nvSpPr>
-          <p:cNvPr id="29" name="TextBox 28"/>
+          <p:cNvPr id="41" name="TextBox 40"/>
           <p:cNvSpPr txBox="1"/>
           <p:nvPr/>
         </p:nvSpPr>
         <p:spPr>
           <a:xfrm>
-            <a:off x="4480560" y="3438144"/>
-            <a:ext cx="3419856" cy="457200"/>
+            <a:off x="7086599" y="2990088"/>
+            <a:ext cx="2167128" cy="347472"/>
           </a:xfrm>
           <a:prstGeom prst="rect">
             <a:avLst/>
@@ -5804,26 +6212,26 @@
           <a:p>
             <a:pPr algn="l"/>
             <a:r>
-              <a:rPr sz="850" b="0" i="0">
+              <a:rPr sz="750" b="0" i="0">
                 <a:solidFill>
                   <a:srgbClr val="8AA8C8"/>
                 </a:solidFill>
               </a:rPr>
-              <a:t>Researches each prospect and writes personalized outreach automatically — no manual prep.</a:t>
-            </a:r>
-          </a:p>
-        </p:txBody>
-      </p:sp>
-      <p:sp>
-        <p:nvSpPr>
-          <p:cNvPr id="30" name="TextBox 29"/>
+              <a:t>Researches each prospect and writes personalized outreach automatically.</a:t>
+            </a:r>
+          </a:p>
+        </p:txBody>
+      </p:sp>
+      <p:sp>
+        <p:nvSpPr>
+          <p:cNvPr id="42" name="TextBox 41"/>
           <p:cNvSpPr txBox="1"/>
           <p:nvPr/>
         </p:nvSpPr>
         <p:spPr>
           <a:xfrm>
-            <a:off x="4389120" y="3977639"/>
-            <a:ext cx="3511296" cy="219456"/>
+            <a:off x="7022592" y="3438144"/>
+            <a:ext cx="2221991" cy="201168"/>
           </a:xfrm>
           <a:prstGeom prst="rect">
             <a:avLst/>
@@ -5838,7 +6246,7 @@
           <a:p>
             <a:pPr algn="l"/>
             <a:r>
-              <a:rPr sz="950" b="1" i="0">
+              <a:rPr sz="750" b="1" i="0">
                 <a:solidFill>
                   <a:srgbClr val="FFFFFF"/>
                 </a:solidFill>
@@ -5850,14 +6258,14 @@
       </p:sp>
       <p:sp>
         <p:nvSpPr>
-          <p:cNvPr id="31" name="TextBox 30"/>
+          <p:cNvPr id="43" name="TextBox 42"/>
           <p:cNvSpPr txBox="1"/>
           <p:nvPr/>
         </p:nvSpPr>
         <p:spPr>
           <a:xfrm>
-            <a:off x="4480560" y="4215383"/>
-            <a:ext cx="3419856" cy="457200"/>
+            <a:off x="7086599" y="3648456"/>
+            <a:ext cx="2167128" cy="347472"/>
           </a:xfrm>
           <a:prstGeom prst="rect">
             <a:avLst/>
@@ -5872,26 +6280,26 @@
           <a:p>
             <a:pPr algn="l"/>
             <a:r>
-              <a:rPr sz="850" b="0" i="0">
+              <a:rPr sz="750" b="0" i="0">
                 <a:solidFill>
                   <a:srgbClr val="8AA8C8"/>
                 </a:solidFill>
               </a:rPr>
-              <a:t>Captures full notes, key takeaways, and action items from every prospect call.</a:t>
-            </a:r>
-          </a:p>
-        </p:txBody>
-      </p:sp>
-      <p:sp>
-        <p:nvSpPr>
-          <p:cNvPr id="32" name="TextBox 31"/>
+              <a:t>Captures full notes, takeaways, and action items from every prospect call.</a:t>
+            </a:r>
+          </a:p>
+        </p:txBody>
+      </p:sp>
+      <p:sp>
+        <p:nvSpPr>
+          <p:cNvPr id="44" name="TextBox 43"/>
           <p:cNvSpPr txBox="1"/>
           <p:nvPr/>
         </p:nvSpPr>
         <p:spPr>
           <a:xfrm>
-            <a:off x="4389120" y="4754880"/>
-            <a:ext cx="3511296" cy="219456"/>
+            <a:off x="7022592" y="4096511"/>
+            <a:ext cx="2221991" cy="201168"/>
           </a:xfrm>
           <a:prstGeom prst="rect">
             <a:avLst/>
@@ -5906,7 +6314,7 @@
           <a:p>
             <a:pPr algn="l"/>
             <a:r>
-              <a:rPr sz="950" b="1" i="0">
+              <a:rPr sz="750" b="1" i="0">
                 <a:solidFill>
                   <a:srgbClr val="FFFFFF"/>
                 </a:solidFill>
@@ -5918,14 +6326,14 @@
       </p:sp>
       <p:sp>
         <p:nvSpPr>
-          <p:cNvPr id="33" name="TextBox 32"/>
+          <p:cNvPr id="45" name="TextBox 44"/>
           <p:cNvSpPr txBox="1"/>
           <p:nvPr/>
         </p:nvSpPr>
         <p:spPr>
           <a:xfrm>
-            <a:off x="4480560" y="4992624"/>
-            <a:ext cx="3419856" cy="457200"/>
+            <a:off x="7086599" y="4306824"/>
+            <a:ext cx="2167128" cy="347472"/>
           </a:xfrm>
           <a:prstGeom prst="rect">
             <a:avLst/>
@@ -5940,26 +6348,26 @@
           <a:p>
             <a:pPr algn="l"/>
             <a:r>
-              <a:rPr sz="850" b="0" i="0">
+              <a:rPr sz="750" b="0" i="0">
                 <a:solidFill>
                   <a:srgbClr val="8AA8C8"/>
                 </a:solidFill>
               </a:rPr>
-              <a:t>Generates tailored follow-up emails and action item summaries right after each call.</a:t>
-            </a:r>
-          </a:p>
-        </p:txBody>
-      </p:sp>
-      <p:sp>
-        <p:nvSpPr>
-          <p:cNvPr id="34" name="Rectangle 33"/>
+              <a:t>Generates tailored follow-up emails right after each call.</a:t>
+            </a:r>
+          </a:p>
+        </p:txBody>
+      </p:sp>
+      <p:sp>
+        <p:nvSpPr>
+          <p:cNvPr id="46" name="Rectangle 45"/>
           <p:cNvSpPr/>
           <p:nvPr/>
         </p:nvSpPr>
         <p:spPr>
           <a:xfrm>
-            <a:off x="8083296" y="1901952"/>
-            <a:ext cx="3739896" cy="4590288"/>
+            <a:off x="9427464" y="1682496"/>
+            <a:ext cx="2423160" cy="4992624"/>
           </a:xfrm>
           <a:prstGeom prst="rect">
             <a:avLst/>
@@ -5995,14 +6403,14 @@
       </p:sp>
       <p:sp>
         <p:nvSpPr>
-          <p:cNvPr id="35" name="Rectangle 34"/>
+          <p:cNvPr id="47" name="Rectangle 46"/>
           <p:cNvSpPr/>
           <p:nvPr/>
         </p:nvSpPr>
         <p:spPr>
           <a:xfrm>
-            <a:off x="8083296" y="1901952"/>
-            <a:ext cx="45720" cy="4590288"/>
+            <a:off x="9427464" y="1682496"/>
+            <a:ext cx="45720" cy="4992624"/>
           </a:xfrm>
           <a:prstGeom prst="rect">
             <a:avLst/>
@@ -6038,14 +6446,14 @@
       </p:sp>
       <p:sp>
         <p:nvSpPr>
-          <p:cNvPr id="36" name="TextBox 35"/>
+          <p:cNvPr id="48" name="TextBox 47"/>
           <p:cNvSpPr txBox="1"/>
           <p:nvPr/>
         </p:nvSpPr>
         <p:spPr>
           <a:xfrm>
-            <a:off x="8247888" y="2011680"/>
-            <a:ext cx="3511296" cy="457200"/>
+            <a:off x="9564624" y="1773936"/>
+            <a:ext cx="2240279" cy="402336"/>
           </a:xfrm>
           <a:prstGeom prst="rect">
             <a:avLst/>
@@ -6060,7 +6468,7 @@
           <a:p>
             <a:pPr algn="l"/>
             <a:r>
-              <a:rPr sz="2200" b="1" i="0">
+              <a:rPr sz="1800" b="1" i="0">
                 <a:solidFill>
                   <a:srgbClr val="FFFFFF"/>
                 </a:solidFill>
@@ -6072,14 +6480,14 @@
       </p:sp>
       <p:sp>
         <p:nvSpPr>
-          <p:cNvPr id="37" name="TextBox 36"/>
+          <p:cNvPr id="49" name="TextBox 48"/>
           <p:cNvSpPr txBox="1"/>
           <p:nvPr/>
         </p:nvSpPr>
         <p:spPr>
           <a:xfrm>
-            <a:off x="8247888" y="2487168"/>
-            <a:ext cx="3511296" cy="347472"/>
+            <a:off x="9564624" y="2194560"/>
+            <a:ext cx="2240279" cy="292608"/>
           </a:xfrm>
           <a:prstGeom prst="rect">
             <a:avLst/>
@@ -6094,26 +6502,26 @@
           <a:p>
             <a:pPr algn="l"/>
             <a:r>
-              <a:rPr sz="1000" b="0" i="0">
+              <a:rPr sz="850" b="0" i="0">
                 <a:solidFill>
                   <a:srgbClr val="F57C2A"/>
                 </a:solidFill>
               </a:rPr>
-              <a:t>Custom AI Agent for Data Intelligence</a:t>
-            </a:r>
-          </a:p>
-        </p:txBody>
-      </p:sp>
-      <p:sp>
-        <p:nvSpPr>
-          <p:cNvPr id="38" name="TextBox 37"/>
+              <a:t>Custom AI for Data Intelligence</a:t>
+            </a:r>
+          </a:p>
+        </p:txBody>
+      </p:sp>
+      <p:sp>
+        <p:nvSpPr>
+          <p:cNvPr id="50" name="TextBox 49"/>
           <p:cNvSpPr txBox="1"/>
           <p:nvPr/>
         </p:nvSpPr>
         <p:spPr>
           <a:xfrm>
-            <a:off x="8247888" y="2834640"/>
-            <a:ext cx="3511296" cy="237744"/>
+            <a:off x="9564624" y="2487168"/>
+            <a:ext cx="2240279" cy="201168"/>
           </a:xfrm>
           <a:prstGeom prst="rect">
             <a:avLst/>
@@ -6128,26 +6536,26 @@
           <a:p>
             <a:pPr algn="l"/>
             <a:r>
-              <a:rPr sz="900" b="0" i="1">
+              <a:rPr sz="750" b="0" i="1">
                 <a:solidFill>
                   <a:srgbClr val="8AA8C8"/>
                 </a:solidFill>
               </a:rPr>
-              <a:t>Prospect enrichment · CRM hygiene · Verification</a:t>
-            </a:r>
-          </a:p>
-        </p:txBody>
-      </p:sp>
-      <p:sp>
-        <p:nvSpPr>
-          <p:cNvPr id="39" name="Rectangle 38"/>
+              <a:t>Enrichment · CRM hygiene · Verification</a:t>
+            </a:r>
+          </a:p>
+        </p:txBody>
+      </p:sp>
+      <p:sp>
+        <p:nvSpPr>
+          <p:cNvPr id="51" name="Rectangle 50"/>
           <p:cNvSpPr/>
           <p:nvPr/>
         </p:nvSpPr>
         <p:spPr>
           <a:xfrm>
-            <a:off x="8247888" y="3090672"/>
-            <a:ext cx="3465576" cy="18288"/>
+            <a:off x="9564624" y="2706624"/>
+            <a:ext cx="2194560" cy="18288"/>
           </a:xfrm>
           <a:prstGeom prst="rect">
             <a:avLst/>
@@ -6183,14 +6591,14 @@
       </p:sp>
       <p:sp>
         <p:nvSpPr>
-          <p:cNvPr id="40" name="TextBox 39"/>
+          <p:cNvPr id="52" name="TextBox 51"/>
           <p:cNvSpPr txBox="1"/>
           <p:nvPr/>
         </p:nvSpPr>
         <p:spPr>
           <a:xfrm>
-            <a:off x="8247888" y="3200400"/>
-            <a:ext cx="3511296" cy="219456"/>
+            <a:off x="9564624" y="2779776"/>
+            <a:ext cx="2221991" cy="201168"/>
           </a:xfrm>
           <a:prstGeom prst="rect">
             <a:avLst/>
@@ -6205,7 +6613,7 @@
           <a:p>
             <a:pPr algn="l"/>
             <a:r>
-              <a:rPr sz="950" b="1" i="0">
+              <a:rPr sz="750" b="1" i="0">
                 <a:solidFill>
                   <a:srgbClr val="FFFFFF"/>
                 </a:solidFill>
@@ -6217,14 +6625,14 @@
       </p:sp>
       <p:sp>
         <p:nvSpPr>
-          <p:cNvPr id="41" name="TextBox 40"/>
+          <p:cNvPr id="53" name="TextBox 52"/>
           <p:cNvSpPr txBox="1"/>
           <p:nvPr/>
         </p:nvSpPr>
         <p:spPr>
           <a:xfrm>
-            <a:off x="8339327" y="3438144"/>
-            <a:ext cx="3419856" cy="457200"/>
+            <a:off x="9628632" y="2990088"/>
+            <a:ext cx="2167128" cy="457200"/>
           </a:xfrm>
           <a:prstGeom prst="rect">
             <a:avLst/>
@@ -6239,26 +6647,26 @@
           <a:p>
             <a:pPr algn="l"/>
             <a:r>
-              <a:rPr sz="850" b="0" i="0">
+              <a:rPr sz="750" b="0" i="0">
                 <a:solidFill>
                   <a:srgbClr val="8AA8C8"/>
                 </a:solidFill>
               </a:rPr>
-              <a:t>Built a custom AI agent to verify and correct the industry field on Salesforce accounts at scale.</a:t>
-            </a:r>
-          </a:p>
-        </p:txBody>
-      </p:sp>
-      <p:sp>
-        <p:nvSpPr>
-          <p:cNvPr id="42" name="TextBox 41"/>
+              <a:t>Built a custom AI agent to verify and correct the industry field on SF accounts at scale.</a:t>
+            </a:r>
+          </a:p>
+        </p:txBody>
+      </p:sp>
+      <p:sp>
+        <p:nvSpPr>
+          <p:cNvPr id="54" name="TextBox 53"/>
           <p:cNvSpPr txBox="1"/>
           <p:nvPr/>
         </p:nvSpPr>
         <p:spPr>
           <a:xfrm>
-            <a:off x="8247888" y="3977639"/>
-            <a:ext cx="3511296" cy="219456"/>
+            <a:off x="9564624" y="3584448"/>
+            <a:ext cx="2221991" cy="201168"/>
           </a:xfrm>
           <a:prstGeom prst="rect">
             <a:avLst/>
@@ -6273,26 +6681,26 @@
           <a:p>
             <a:pPr algn="l"/>
             <a:r>
-              <a:rPr sz="950" b="1" i="0">
+              <a:rPr sz="750" b="1" i="0">
                 <a:solidFill>
                   <a:srgbClr val="FFFFFF"/>
                 </a:solidFill>
               </a:rPr>
-              <a:t>• 11K INCORRECTLY TAGGED ACCOUNTS</a:t>
-            </a:r>
-          </a:p>
-        </p:txBody>
-      </p:sp>
-      <p:sp>
-        <p:nvSpPr>
-          <p:cNvPr id="43" name="TextBox 42"/>
+              <a:t>• 11K BAD ACCOUNTS FOUND</a:t>
+            </a:r>
+          </a:p>
+        </p:txBody>
+      </p:sp>
+      <p:sp>
+        <p:nvSpPr>
+          <p:cNvPr id="55" name="TextBox 54"/>
           <p:cNvSpPr txBox="1"/>
           <p:nvPr/>
         </p:nvSpPr>
         <p:spPr>
           <a:xfrm>
-            <a:off x="8339327" y="4215383"/>
-            <a:ext cx="3419856" cy="457200"/>
+            <a:off x="9628632" y="3794760"/>
+            <a:ext cx="2167128" cy="457200"/>
           </a:xfrm>
           <a:prstGeom prst="rect">
             <a:avLst/>
@@ -6307,19 +6715,19 @@
           <a:p>
             <a:pPr algn="l"/>
             <a:r>
-              <a:rPr sz="850" b="0" i="0">
+              <a:rPr sz="750" b="0" i="0">
                 <a:solidFill>
                   <a:srgbClr val="8AA8C8"/>
                 </a:solidFill>
               </a:rPr>
-              <a:t>Identified 11,000+ accounts incorrectly marked as MSPs — cleaning the CRM foundation for better targeting and scoring.</a:t>
-            </a:r>
-          </a:p>
-        </p:txBody>
-      </p:sp>
-      <p:sp>
-        <p:nvSpPr>
-          <p:cNvPr id="44" name="Rectangle 43"/>
+              <a:t>Identified 11,000+ accounts incorrectly marked as MSPs — cleaning the CRM for better targeting.</a:t>
+            </a:r>
+          </a:p>
+        </p:txBody>
+      </p:sp>
+      <p:sp>
+        <p:nvSpPr>
+          <p:cNvPr id="56" name="Rectangle 55"/>
           <p:cNvSpPr/>
           <p:nvPr/>
         </p:nvSpPr>
@@ -6362,7 +6770,7 @@
       </p:sp>
       <p:sp>
         <p:nvSpPr>
-          <p:cNvPr id="45" name="TextBox 44"/>
+          <p:cNvPr id="57" name="TextBox 56"/>
           <p:cNvSpPr txBox="1"/>
           <p:nvPr/>
         </p:nvSpPr>
@@ -6396,7 +6804,7 @@
       </p:sp>
       <p:sp>
         <p:nvSpPr>
-          <p:cNvPr id="46" name="TextBox 45"/>
+          <p:cNvPr id="58" name="TextBox 57"/>
           <p:cNvSpPr txBox="1"/>
           <p:nvPr/>
         </p:nvSpPr>
@@ -6430,7 +6838,7 @@
       </p:sp>
       <p:sp>
         <p:nvSpPr>
-          <p:cNvPr id="47" name="TextBox 46"/>
+          <p:cNvPr id="59" name="TextBox 58"/>
           <p:cNvSpPr txBox="1"/>
           <p:nvPr/>
         </p:nvSpPr>

</xml_diff>

<commit_message>
Robin intro: 2 slides - Robin full width + Tool Stack (Notion/Clay/Outreach)
</commit_message>
<xml_diff>
--- a/Robin-Intro-Slide.pptx
+++ b/Robin-Intro-Slide.pptx
@@ -9,6 +9,7 @@
   </p:notesMasterIdLst>
   <p:sldIdLst>
     <p:sldId id="828" r:id="rId9"/>
+    <p:sldId id="829" r:id="rId10"/>
   </p:sldIdLst>
   <p:sldSz cx="12192000" cy="6858000"/>
   <p:notesSz cx="6858000" cy="9144000"/>
@@ -4798,8 +4799,8 @@
         </p:nvSpPr>
         <p:spPr>
           <a:xfrm>
-            <a:off x="274320" y="137160"/>
-            <a:ext cx="11612880" cy="621792"/>
+            <a:off x="365760" y="164592"/>
+            <a:ext cx="11430000" cy="658368"/>
           </a:xfrm>
           <a:prstGeom prst="rect">
             <a:avLst/>
@@ -4814,7 +4815,7 @@
           <a:p>
             <a:pPr algn="l"/>
             <a:r>
-              <a:rPr sz="4200" b="1" i="0">
+              <a:rPr sz="4400" b="1" i="0">
                 <a:solidFill>
                   <a:srgbClr val="FFFFFF"/>
                 </a:solidFill>
@@ -4832,8 +4833,8 @@
         </p:nvSpPr>
         <p:spPr>
           <a:xfrm>
-            <a:off x="274320" y="758952"/>
-            <a:ext cx="11612880" cy="256032"/>
+            <a:off x="365760" y="822960"/>
+            <a:ext cx="11430000" cy="274320"/>
           </a:xfrm>
           <a:prstGeom prst="rect">
             <a:avLst/>
@@ -4848,7 +4849,7 @@
           <a:p>
             <a:pPr algn="l"/>
             <a:r>
-              <a:rPr sz="1200" b="0" i="0">
+              <a:rPr sz="1250" b="0" i="0">
                 <a:solidFill>
                   <a:srgbClr val="8AA8C8"/>
                 </a:solidFill>
@@ -4866,8 +4867,8 @@
         </p:nvSpPr>
         <p:spPr>
           <a:xfrm>
-            <a:off x="274320" y="1078992"/>
-            <a:ext cx="11640312" cy="512064"/>
+            <a:off x="365760" y="1188720"/>
+            <a:ext cx="11457432" cy="566928"/>
           </a:xfrm>
           <a:prstGeom prst="rect">
             <a:avLst/>
@@ -4909,8 +4910,8 @@
         </p:nvSpPr>
         <p:spPr>
           <a:xfrm>
-            <a:off x="274320" y="1078992"/>
-            <a:ext cx="45720" cy="512064"/>
+            <a:off x="365760" y="1188720"/>
+            <a:ext cx="45720" cy="566928"/>
           </a:xfrm>
           <a:prstGeom prst="rect">
             <a:avLst/>
@@ -4952,8 +4953,8 @@
         </p:nvSpPr>
         <p:spPr>
           <a:xfrm>
-            <a:off x="402336" y="1106424"/>
-            <a:ext cx="3200400" cy="164592"/>
+            <a:off x="502920" y="1216152"/>
+            <a:ext cx="3200400" cy="182880"/>
           </a:xfrm>
           <a:prstGeom prst="rect">
             <a:avLst/>
@@ -4968,7 +4969,7 @@
           <a:p>
             <a:pPr algn="l"/>
             <a:r>
-              <a:rPr sz="750" b="1" i="0">
+              <a:rPr sz="800" b="1" i="0">
                 <a:solidFill>
                   <a:srgbClr val="3DC570"/>
                 </a:solidFill>
@@ -4986,8 +4987,8 @@
         </p:nvSpPr>
         <p:spPr>
           <a:xfrm>
-            <a:off x="402336" y="1271016"/>
-            <a:ext cx="11155680" cy="274320"/>
+            <a:off x="502920" y="1380744"/>
+            <a:ext cx="11155680" cy="310896"/>
           </a:xfrm>
           <a:prstGeom prst="rect">
             <a:avLst/>
@@ -5002,7 +5003,7 @@
           <a:p>
             <a:pPr algn="l"/>
             <a:r>
-              <a:rPr sz="1000" b="0" i="0">
+              <a:rPr sz="1050" b="0" i="0">
                 <a:solidFill>
                   <a:srgbClr val="FFFFFF"/>
                 </a:solidFill>
@@ -5020,8 +5021,8 @@
         </p:nvSpPr>
         <p:spPr>
           <a:xfrm>
-            <a:off x="274320" y="1682496"/>
-            <a:ext cx="6492240" cy="4992624"/>
+            <a:off x="365760" y="1865376"/>
+            <a:ext cx="11457432" cy="4809744"/>
           </a:xfrm>
           <a:prstGeom prst="rect">
             <a:avLst/>
@@ -5063,8 +5064,8 @@
         </p:nvSpPr>
         <p:spPr>
           <a:xfrm>
-            <a:off x="274320" y="1682496"/>
-            <a:ext cx="45720" cy="4992624"/>
+            <a:off x="365760" y="1865376"/>
+            <a:ext cx="45720" cy="4809744"/>
           </a:xfrm>
           <a:prstGeom prst="rect">
             <a:avLst/>
@@ -5106,8 +5107,8 @@
         </p:nvSpPr>
         <p:spPr>
           <a:xfrm>
-            <a:off x="438912" y="1773936"/>
-            <a:ext cx="6263640" cy="457200"/>
+            <a:off x="566928" y="1975104"/>
+            <a:ext cx="7315200" cy="475488"/>
           </a:xfrm>
           <a:prstGeom prst="rect">
             <a:avLst/>
@@ -5122,7 +5123,7 @@
           <a:p>
             <a:pPr algn="l"/>
             <a:r>
-              <a:rPr sz="2800" b="1" i="0">
+              <a:rPr sz="3200" b="1" i="0">
                 <a:solidFill>
                   <a:srgbClr val="FFFFFF"/>
                 </a:solidFill>
@@ -5140,8 +5141,8 @@
         </p:nvSpPr>
         <p:spPr>
           <a:xfrm>
-            <a:off x="438912" y="2249424"/>
-            <a:ext cx="6263640" cy="256032"/>
+            <a:off x="566928" y="2468880"/>
+            <a:ext cx="8229600" cy="256032"/>
           </a:xfrm>
           <a:prstGeom prst="rect">
             <a:avLst/>
@@ -5156,7 +5157,7 @@
           <a:p>
             <a:pPr algn="l"/>
             <a:r>
-              <a:rPr sz="1200" b="0" i="0">
+              <a:rPr sz="1300" b="0" i="0">
                 <a:solidFill>
                   <a:srgbClr val="00D4D4"/>
                 </a:solidFill>
@@ -5174,8 +5175,8 @@
         </p:nvSpPr>
         <p:spPr>
           <a:xfrm>
-            <a:off x="438912" y="2505456"/>
-            <a:ext cx="6263640" cy="201168"/>
+            <a:off x="566928" y="2734056"/>
+            <a:ext cx="6400800" cy="219456"/>
           </a:xfrm>
           <a:prstGeom prst="rect">
             <a:avLst/>
@@ -5190,7 +5191,7 @@
           <a:p>
             <a:pPr algn="l"/>
             <a:r>
-              <a:rPr sz="950" b="0" i="1">
+              <a:rPr sz="1000" b="0" i="1">
                 <a:solidFill>
                   <a:srgbClr val="8AA8C8"/>
                 </a:solidFill>
@@ -5208,8 +5209,8 @@
         </p:nvSpPr>
         <p:spPr>
           <a:xfrm>
-            <a:off x="438912" y="2724912"/>
-            <a:ext cx="6217920" cy="18288"/>
+            <a:off x="566928" y="2980944"/>
+            <a:ext cx="11055096" cy="18288"/>
           </a:xfrm>
           <a:prstGeom prst="rect">
             <a:avLst/>
@@ -5251,8 +5252,8 @@
         </p:nvSpPr>
         <p:spPr>
           <a:xfrm>
-            <a:off x="438912" y="2779776"/>
-            <a:ext cx="3017520" cy="182880"/>
+            <a:off x="566928" y="3054096"/>
+            <a:ext cx="5500116" cy="182880"/>
           </a:xfrm>
           <a:prstGeom prst="rect">
             <a:avLst/>
@@ -5285,8 +5286,8 @@
         </p:nvSpPr>
         <p:spPr>
           <a:xfrm>
-            <a:off x="493776" y="2980944"/>
-            <a:ext cx="2944368" cy="219456"/>
+            <a:off x="621792" y="3255264"/>
+            <a:ext cx="5408676" cy="219456"/>
           </a:xfrm>
           <a:prstGeom prst="rect">
             <a:avLst/>
@@ -5301,7 +5302,7 @@
           <a:p>
             <a:pPr algn="l"/>
             <a:r>
-              <a:rPr sz="780" b="0" i="0">
+              <a:rPr sz="800" b="0" i="0">
                 <a:solidFill>
                   <a:srgbClr val="FFFFFF"/>
                 </a:solidFill>
@@ -5319,8 +5320,8 @@
         </p:nvSpPr>
         <p:spPr>
           <a:xfrm>
-            <a:off x="493776" y="3209544"/>
-            <a:ext cx="2944368" cy="219456"/>
+            <a:off x="621792" y="3493008"/>
+            <a:ext cx="5408676" cy="219456"/>
           </a:xfrm>
           <a:prstGeom prst="rect">
             <a:avLst/>
@@ -5335,7 +5336,7 @@
           <a:p>
             <a:pPr algn="l"/>
             <a:r>
-              <a:rPr sz="780" b="0" i="0">
+              <a:rPr sz="800" b="0" i="0">
                 <a:solidFill>
                   <a:srgbClr val="FFFFFF"/>
                 </a:solidFill>
@@ -5353,8 +5354,8 @@
         </p:nvSpPr>
         <p:spPr>
           <a:xfrm>
-            <a:off x="493776" y="3438144"/>
-            <a:ext cx="2944368" cy="219456"/>
+            <a:off x="621792" y="3730752"/>
+            <a:ext cx="5408676" cy="219456"/>
           </a:xfrm>
           <a:prstGeom prst="rect">
             <a:avLst/>
@@ -5369,7 +5370,7 @@
           <a:p>
             <a:pPr algn="l"/>
             <a:r>
-              <a:rPr sz="780" b="0" i="0">
+              <a:rPr sz="800" b="0" i="0">
                 <a:solidFill>
                   <a:srgbClr val="FFFFFF"/>
                 </a:solidFill>
@@ -5387,8 +5388,8 @@
         </p:nvSpPr>
         <p:spPr>
           <a:xfrm>
-            <a:off x="438912" y="3776472"/>
-            <a:ext cx="3017520" cy="182880"/>
+            <a:off x="566928" y="4059935"/>
+            <a:ext cx="5500116" cy="182880"/>
           </a:xfrm>
           <a:prstGeom prst="rect">
             <a:avLst/>
@@ -5421,8 +5422,8 @@
         </p:nvSpPr>
         <p:spPr>
           <a:xfrm>
-            <a:off x="493776" y="3977639"/>
-            <a:ext cx="2944368" cy="219456"/>
+            <a:off x="621792" y="4261103"/>
+            <a:ext cx="5408676" cy="219456"/>
           </a:xfrm>
           <a:prstGeom prst="rect">
             <a:avLst/>
@@ -5437,7 +5438,7 @@
           <a:p>
             <a:pPr algn="l"/>
             <a:r>
-              <a:rPr sz="780" b="0" i="0">
+              <a:rPr sz="800" b="0" i="0">
                 <a:solidFill>
                   <a:srgbClr val="FFFFFF"/>
                 </a:solidFill>
@@ -5455,8 +5456,8 @@
         </p:nvSpPr>
         <p:spPr>
           <a:xfrm>
-            <a:off x="493776" y="4206240"/>
-            <a:ext cx="2944368" cy="219456"/>
+            <a:off x="621792" y="4498847"/>
+            <a:ext cx="5408676" cy="219456"/>
           </a:xfrm>
           <a:prstGeom prst="rect">
             <a:avLst/>
@@ -5471,7 +5472,7 @@
           <a:p>
             <a:pPr algn="l"/>
             <a:r>
-              <a:rPr sz="780" b="0" i="0">
+              <a:rPr sz="800" b="0" i="0">
                 <a:solidFill>
                   <a:srgbClr val="FFFFFF"/>
                 </a:solidFill>
@@ -5489,8 +5490,8 @@
         </p:nvSpPr>
         <p:spPr>
           <a:xfrm>
-            <a:off x="493776" y="4434840"/>
-            <a:ext cx="2944368" cy="219456"/>
+            <a:off x="621792" y="4736591"/>
+            <a:ext cx="5408676" cy="219456"/>
           </a:xfrm>
           <a:prstGeom prst="rect">
             <a:avLst/>
@@ -5505,7 +5506,7 @@
           <a:p>
             <a:pPr algn="l"/>
             <a:r>
-              <a:rPr sz="780" b="0" i="0">
+              <a:rPr sz="800" b="0" i="0">
                 <a:solidFill>
                   <a:srgbClr val="FFFFFF"/>
                 </a:solidFill>
@@ -5523,8 +5524,8 @@
         </p:nvSpPr>
         <p:spPr>
           <a:xfrm>
-            <a:off x="438912" y="4773168"/>
-            <a:ext cx="3017520" cy="182880"/>
+            <a:off x="566928" y="5065775"/>
+            <a:ext cx="5500116" cy="182880"/>
           </a:xfrm>
           <a:prstGeom prst="rect">
             <a:avLst/>
@@ -5557,8 +5558,8 @@
         </p:nvSpPr>
         <p:spPr>
           <a:xfrm>
-            <a:off x="493776" y="4974336"/>
-            <a:ext cx="2944368" cy="219456"/>
+            <a:off x="621792" y="5266943"/>
+            <a:ext cx="5408676" cy="219456"/>
           </a:xfrm>
           <a:prstGeom prst="rect">
             <a:avLst/>
@@ -5573,7 +5574,7 @@
           <a:p>
             <a:pPr algn="l"/>
             <a:r>
-              <a:rPr sz="780" b="0" i="0">
+              <a:rPr sz="800" b="0" i="0">
                 <a:solidFill>
                   <a:srgbClr val="FFFFFF"/>
                 </a:solidFill>
@@ -5591,8 +5592,8 @@
         </p:nvSpPr>
         <p:spPr>
           <a:xfrm>
-            <a:off x="493776" y="5202936"/>
-            <a:ext cx="2944368" cy="219456"/>
+            <a:off x="621792" y="5504687"/>
+            <a:ext cx="5408676" cy="219456"/>
           </a:xfrm>
           <a:prstGeom prst="rect">
             <a:avLst/>
@@ -5607,12 +5608,12 @@
           <a:p>
             <a:pPr algn="l"/>
             <a:r>
-              <a:rPr sz="780" b="0" i="0">
+              <a:rPr sz="800" b="0" i="0">
                 <a:solidFill>
                   <a:srgbClr val="FFFFFF"/>
                 </a:solidFill>
               </a:rPr>
-              <a:t>· Rev.io mention monitor — daily web scan, pings Ryan if noteworthy</a:t>
+              <a:t>· Rev.io mention monitor — daily web scan, alerts on noteworthy coverage</a:t>
             </a:r>
           </a:p>
         </p:txBody>
@@ -5625,8 +5626,8 @@
         </p:nvSpPr>
         <p:spPr>
           <a:xfrm>
-            <a:off x="493776" y="5431536"/>
-            <a:ext cx="2944368" cy="219456"/>
+            <a:off x="621792" y="5742431"/>
+            <a:ext cx="5408676" cy="219456"/>
           </a:xfrm>
           <a:prstGeom prst="rect">
             <a:avLst/>
@@ -5641,7 +5642,7 @@
           <a:p>
             <a:pPr algn="l"/>
             <a:r>
-              <a:rPr sz="780" b="0" i="0">
+              <a:rPr sz="800" b="0" i="0">
                 <a:solidFill>
                   <a:srgbClr val="FFFFFF"/>
                 </a:solidFill>
@@ -5659,8 +5660,8 @@
         </p:nvSpPr>
         <p:spPr>
           <a:xfrm>
-            <a:off x="3566160" y="2779776"/>
-            <a:ext cx="3017520" cy="182880"/>
+            <a:off x="6158483" y="3054096"/>
+            <a:ext cx="5500116" cy="182880"/>
           </a:xfrm>
           <a:prstGeom prst="rect">
             <a:avLst/>
@@ -5693,8 +5694,8 @@
         </p:nvSpPr>
         <p:spPr>
           <a:xfrm>
-            <a:off x="3621024" y="2980944"/>
-            <a:ext cx="2944368" cy="219456"/>
+            <a:off x="6213347" y="3255264"/>
+            <a:ext cx="5408676" cy="219456"/>
           </a:xfrm>
           <a:prstGeom prst="rect">
             <a:avLst/>
@@ -5709,7 +5710,7 @@
           <a:p>
             <a:pPr algn="l"/>
             <a:r>
-              <a:rPr sz="780" b="0" i="0">
+              <a:rPr sz="800" b="0" i="0">
                 <a:solidFill>
                   <a:srgbClr val="FFFFFF"/>
                 </a:solidFill>
@@ -5727,8 +5728,8 @@
         </p:nvSpPr>
         <p:spPr>
           <a:xfrm>
-            <a:off x="3621024" y="3209544"/>
-            <a:ext cx="2944368" cy="219456"/>
+            <a:off x="6213347" y="3493008"/>
+            <a:ext cx="5408676" cy="219456"/>
           </a:xfrm>
           <a:prstGeom prst="rect">
             <a:avLst/>
@@ -5743,7 +5744,7 @@
           <a:p>
             <a:pPr algn="l"/>
             <a:r>
-              <a:rPr sz="780" b="0" i="0">
+              <a:rPr sz="800" b="0" i="0">
                 <a:solidFill>
                   <a:srgbClr val="FFFFFF"/>
                 </a:solidFill>
@@ -5761,8 +5762,8 @@
         </p:nvSpPr>
         <p:spPr>
           <a:xfrm>
-            <a:off x="3621024" y="3438144"/>
-            <a:ext cx="2944368" cy="219456"/>
+            <a:off x="6213347" y="3730752"/>
+            <a:ext cx="5408676" cy="219456"/>
           </a:xfrm>
           <a:prstGeom prst="rect">
             <a:avLst/>
@@ -5777,7 +5778,7 @@
           <a:p>
             <a:pPr algn="l"/>
             <a:r>
-              <a:rPr sz="780" b="0" i="0">
+              <a:rPr sz="800" b="0" i="0">
                 <a:solidFill>
                   <a:srgbClr val="FFFFFF"/>
                 </a:solidFill>
@@ -5795,8 +5796,8 @@
         </p:nvSpPr>
         <p:spPr>
           <a:xfrm>
-            <a:off x="3566160" y="3776472"/>
-            <a:ext cx="3017520" cy="182880"/>
+            <a:off x="6158483" y="4059935"/>
+            <a:ext cx="5500116" cy="182880"/>
           </a:xfrm>
           <a:prstGeom prst="rect">
             <a:avLst/>
@@ -5829,8 +5830,8 @@
         </p:nvSpPr>
         <p:spPr>
           <a:xfrm>
-            <a:off x="3621024" y="3977639"/>
-            <a:ext cx="2944368" cy="219456"/>
+            <a:off x="6213347" y="4261103"/>
+            <a:ext cx="5408676" cy="219456"/>
           </a:xfrm>
           <a:prstGeom prst="rect">
             <a:avLst/>
@@ -5845,7 +5846,7 @@
           <a:p>
             <a:pPr algn="l"/>
             <a:r>
-              <a:rPr sz="780" b="0" i="0">
+              <a:rPr sz="800" b="0" i="0">
                 <a:solidFill>
                   <a:srgbClr val="FFFFFF"/>
                 </a:solidFill>
@@ -5863,8 +5864,8 @@
         </p:nvSpPr>
         <p:spPr>
           <a:xfrm>
-            <a:off x="3621024" y="4206240"/>
-            <a:ext cx="2944368" cy="219456"/>
+            <a:off x="6213347" y="4498847"/>
+            <a:ext cx="5408676" cy="219456"/>
           </a:xfrm>
           <a:prstGeom prst="rect">
             <a:avLst/>
@@ -5879,7 +5880,7 @@
           <a:p>
             <a:pPr algn="l"/>
             <a:r>
-              <a:rPr sz="780" b="0" i="0">
+              <a:rPr sz="800" b="0" i="0">
                 <a:solidFill>
                   <a:srgbClr val="FFFFFF"/>
                 </a:solidFill>
@@ -5897,8 +5898,8 @@
         </p:nvSpPr>
         <p:spPr>
           <a:xfrm>
-            <a:off x="3621024" y="4434840"/>
-            <a:ext cx="2944368" cy="219456"/>
+            <a:off x="6213347" y="4736591"/>
+            <a:ext cx="5408676" cy="219456"/>
           </a:xfrm>
           <a:prstGeom prst="rect">
             <a:avLst/>
@@ -5913,7 +5914,7 @@
           <a:p>
             <a:pPr algn="l"/>
             <a:r>
-              <a:rPr sz="780" b="0" i="0">
+              <a:rPr sz="800" b="0" i="0">
                 <a:solidFill>
                   <a:srgbClr val="FFFFFF"/>
                 </a:solidFill>
@@ -5931,14 +5932,14 @@
         </p:nvSpPr>
         <p:spPr>
           <a:xfrm>
-            <a:off x="6885431" y="1682496"/>
-            <a:ext cx="2423160" cy="4992624"/>
+            <a:off x="0" y="6675120"/>
+            <a:ext cx="12188952" cy="182880"/>
           </a:xfrm>
           <a:prstGeom prst="rect">
             <a:avLst/>
           </a:prstGeom>
           <a:solidFill>
-            <a:srgbClr val="0A1E30"/>
+            <a:srgbClr val="071220"/>
           </a:solidFill>
           <a:ln>
             <a:noFill/>
@@ -5968,20 +5969,208 @@
       </p:sp>
       <p:sp>
         <p:nvSpPr>
-          <p:cNvPr id="35" name="Rectangle 34"/>
+          <p:cNvPr id="35" name="TextBox 34"/>
+          <p:cNvSpPr txBox="1"/>
+          <p:nvPr/>
+        </p:nvSpPr>
+        <p:spPr>
+          <a:xfrm>
+            <a:off x="274320" y="6693408"/>
+            <a:ext cx="1828800" cy="146304"/>
+          </a:xfrm>
+          <a:prstGeom prst="rect">
+            <a:avLst/>
+          </a:prstGeom>
+          <a:noFill/>
+        </p:spPr>
+        <p:txBody>
+          <a:bodyPr wrap="square">
+            <a:spAutoFit/>
+          </a:bodyPr>
+          <a:lstStyle/>
+          <a:p>
+            <a:pPr algn="l"/>
+            <a:r>
+              <a:rPr sz="900" b="1" i="0">
+                <a:solidFill>
+                  <a:srgbClr val="FFFFFF"/>
+                </a:solidFill>
+              </a:rPr>
+              <a:t>• rev.io</a:t>
+            </a:r>
+          </a:p>
+        </p:txBody>
+      </p:sp>
+      <p:sp>
+        <p:nvSpPr>
+          <p:cNvPr id="36" name="TextBox 35"/>
+          <p:cNvSpPr txBox="1"/>
+          <p:nvPr/>
+        </p:nvSpPr>
+        <p:spPr>
+          <a:xfrm>
+            <a:off x="8686800" y="6693408"/>
+            <a:ext cx="2011680" cy="146304"/>
+          </a:xfrm>
+          <a:prstGeom prst="rect">
+            <a:avLst/>
+          </a:prstGeom>
+          <a:noFill/>
+        </p:spPr>
+        <p:txBody>
+          <a:bodyPr wrap="square">
+            <a:spAutoFit/>
+          </a:bodyPr>
+          <a:lstStyle/>
+          <a:p>
+            <a:pPr algn="r"/>
+            <a:r>
+              <a:rPr sz="900" b="1" i="0">
+                <a:solidFill>
+                  <a:srgbClr val="FFFFFF"/>
+                </a:solidFill>
+              </a:rPr>
+              <a:t>BUILT FOR TOMORROW.</a:t>
+            </a:r>
+          </a:p>
+        </p:txBody>
+      </p:sp>
+      <p:sp>
+        <p:nvSpPr>
+          <p:cNvPr id="37" name="TextBox 36"/>
+          <p:cNvSpPr txBox="1"/>
+          <p:nvPr/>
+        </p:nvSpPr>
+        <p:spPr>
+          <a:xfrm>
+            <a:off x="10698480" y="6693408"/>
+            <a:ext cx="1371600" cy="146304"/>
+          </a:xfrm>
+          <a:prstGeom prst="rect">
+            <a:avLst/>
+          </a:prstGeom>
+          <a:noFill/>
+        </p:spPr>
+        <p:txBody>
+          <a:bodyPr wrap="square">
+            <a:spAutoFit/>
+          </a:bodyPr>
+          <a:lstStyle/>
+          <a:p>
+            <a:pPr algn="r"/>
+            <a:r>
+              <a:rPr sz="900" b="1" i="0">
+                <a:solidFill>
+                  <a:srgbClr val="3DC570"/>
+                </a:solidFill>
+              </a:rPr>
+              <a:t>READY FOR TODAY.</a:t>
+            </a:r>
+          </a:p>
+        </p:txBody>
+      </p:sp>
+    </p:spTree>
+  </p:cSld>
+  <p:clrMapOvr>
+    <a:masterClrMapping/>
+  </p:clrMapOvr>
+</p:sld>
+</file>
+
+<file path=ppt/slides/slide4.xml><?xml version="1.0" encoding="utf-8"?>
+<p:sld xmlns:a="http://schemas.openxmlformats.org/drawingml/2006/main" xmlns:p="http://schemas.openxmlformats.org/presentationml/2006/main" xmlns:r="http://schemas.openxmlformats.org/officeDocument/2006/relationships">
+  <p:cSld>
+    <p:spTree>
+      <p:nvGrpSpPr>
+        <p:cNvPr id="1" name=""/>
+        <p:cNvGrpSpPr/>
+        <p:nvPr/>
+      </p:nvGrpSpPr>
+      <p:grpSpPr/>
+      <p:sp>
+        <p:nvSpPr>
+          <p:cNvPr id="2" name="TextBox 1"/>
+          <p:cNvSpPr txBox="1"/>
+          <p:nvPr/>
+        </p:nvSpPr>
+        <p:spPr>
+          <a:xfrm>
+            <a:off x="365760" y="164592"/>
+            <a:ext cx="11430000" cy="658368"/>
+          </a:xfrm>
+          <a:prstGeom prst="rect">
+            <a:avLst/>
+          </a:prstGeom>
+          <a:noFill/>
+        </p:spPr>
+        <p:txBody>
+          <a:bodyPr wrap="square">
+            <a:spAutoFit/>
+          </a:bodyPr>
+          <a:lstStyle/>
+          <a:p>
+            <a:pPr algn="l"/>
+            <a:r>
+              <a:rPr sz="4400" b="1" i="0">
+                <a:solidFill>
+                  <a:srgbClr val="FFFFFF"/>
+                </a:solidFill>
+              </a:rPr>
+              <a:t>Robin's Tool Stack</a:t>
+            </a:r>
+          </a:p>
+        </p:txBody>
+      </p:sp>
+      <p:sp>
+        <p:nvSpPr>
+          <p:cNvPr id="3" name="TextBox 2"/>
+          <p:cNvSpPr txBox="1"/>
+          <p:nvPr/>
+        </p:nvSpPr>
+        <p:spPr>
+          <a:xfrm>
+            <a:off x="365760" y="822960"/>
+            <a:ext cx="11430000" cy="274320"/>
+          </a:xfrm>
+          <a:prstGeom prst="rect">
+            <a:avLst/>
+          </a:prstGeom>
+          <a:noFill/>
+        </p:spPr>
+        <p:txBody>
+          <a:bodyPr wrap="square">
+            <a:spAutoFit/>
+          </a:bodyPr>
+          <a:lstStyle/>
+          <a:p>
+            <a:pPr algn="l"/>
+            <a:r>
+              <a:rPr sz="1250" b="0" i="0">
+                <a:solidFill>
+                  <a:srgbClr val="8AA8C8"/>
+                </a:solidFill>
+              </a:rPr>
+              <a:t>Integrated with best-in-class tools to automate the full sales workflow end-to-end.</a:t>
+            </a:r>
+          </a:p>
+        </p:txBody>
+      </p:sp>
+      <p:sp>
+        <p:nvSpPr>
+          <p:cNvPr id="4" name="Rectangle 3"/>
           <p:cNvSpPr/>
           <p:nvPr/>
         </p:nvSpPr>
         <p:spPr>
           <a:xfrm>
-            <a:off x="6885431" y="1682496"/>
-            <a:ext cx="45720" cy="4992624"/>
+            <a:off x="365760" y="1188720"/>
+            <a:ext cx="11457432" cy="566928"/>
           </a:xfrm>
           <a:prstGeom prst="rect">
             <a:avLst/>
           </a:prstGeom>
           <a:solidFill>
-            <a:srgbClr val="7C3AED"/>
+            <a:srgbClr val="0A1E30"/>
           </a:solidFill>
           <a:ln>
             <a:noFill/>
@@ -6011,122 +6200,20 @@
       </p:sp>
       <p:sp>
         <p:nvSpPr>
-          <p:cNvPr id="36" name="TextBox 35"/>
-          <p:cNvSpPr txBox="1"/>
-          <p:nvPr/>
-        </p:nvSpPr>
-        <p:spPr>
-          <a:xfrm>
-            <a:off x="7022592" y="1773936"/>
-            <a:ext cx="2240279" cy="402336"/>
-          </a:xfrm>
-          <a:prstGeom prst="rect">
-            <a:avLst/>
-          </a:prstGeom>
-          <a:noFill/>
-        </p:spPr>
-        <p:txBody>
-          <a:bodyPr wrap="square">
-            <a:spAutoFit/>
-          </a:bodyPr>
-          <a:lstStyle/>
-          <a:p>
-            <a:pPr algn="l"/>
-            <a:r>
-              <a:rPr sz="1800" b="1" i="0">
-                <a:solidFill>
-                  <a:srgbClr val="FFFFFF"/>
-                </a:solidFill>
-              </a:rPr>
-              <a:t>📓  Notion</a:t>
-            </a:r>
-          </a:p>
-        </p:txBody>
-      </p:sp>
-      <p:sp>
-        <p:nvSpPr>
-          <p:cNvPr id="37" name="TextBox 36"/>
-          <p:cNvSpPr txBox="1"/>
-          <p:nvPr/>
-        </p:nvSpPr>
-        <p:spPr>
-          <a:xfrm>
-            <a:off x="7022592" y="2194560"/>
-            <a:ext cx="2240279" cy="292608"/>
-          </a:xfrm>
-          <a:prstGeom prst="rect">
-            <a:avLst/>
-          </a:prstGeom>
-          <a:noFill/>
-        </p:spPr>
-        <p:txBody>
-          <a:bodyPr wrap="square">
-            <a:spAutoFit/>
-          </a:bodyPr>
-          <a:lstStyle/>
-          <a:p>
-            <a:pPr algn="l"/>
-            <a:r>
-              <a:rPr sz="850" b="0" i="0">
-                <a:solidFill>
-                  <a:srgbClr val="7C3AED"/>
-                </a:solidFill>
-              </a:rPr>
-              <a:t>Knowledge &amp; Workflow Automation</a:t>
-            </a:r>
-          </a:p>
-        </p:txBody>
-      </p:sp>
-      <p:sp>
-        <p:nvSpPr>
-          <p:cNvPr id="38" name="TextBox 37"/>
-          <p:cNvSpPr txBox="1"/>
-          <p:nvPr/>
-        </p:nvSpPr>
-        <p:spPr>
-          <a:xfrm>
-            <a:off x="7022592" y="2487168"/>
-            <a:ext cx="2240279" cy="201168"/>
-          </a:xfrm>
-          <a:prstGeom prst="rect">
-            <a:avLst/>
-          </a:prstGeom>
-          <a:noFill/>
-        </p:spPr>
-        <p:txBody>
-          <a:bodyPr wrap="square">
-            <a:spAutoFit/>
-          </a:bodyPr>
-          <a:lstStyle/>
-          <a:p>
-            <a:pPr algn="l"/>
-            <a:r>
-              <a:rPr sz="750" b="0" i="1">
-                <a:solidFill>
-                  <a:srgbClr val="8AA8C8"/>
-                </a:solidFill>
-              </a:rPr>
-              <a:t>Personalization · Transcription · Follow-up</a:t>
-            </a:r>
-          </a:p>
-        </p:txBody>
-      </p:sp>
-      <p:sp>
-        <p:nvSpPr>
-          <p:cNvPr id="39" name="Rectangle 38"/>
+          <p:cNvPr id="5" name="Rectangle 4"/>
           <p:cNvSpPr/>
           <p:nvPr/>
         </p:nvSpPr>
         <p:spPr>
           <a:xfrm>
-            <a:off x="7022592" y="2706624"/>
-            <a:ext cx="2194560" cy="18288"/>
+            <a:off x="365760" y="1188720"/>
+            <a:ext cx="45720" cy="566928"/>
           </a:xfrm>
           <a:prstGeom prst="rect">
             <a:avLst/>
           </a:prstGeom>
           <a:solidFill>
-            <a:srgbClr val="1A3555"/>
+            <a:srgbClr val="00D4D4"/>
           </a:solidFill>
           <a:ln>
             <a:noFill/>
@@ -6156,14 +6243,14 @@
       </p:sp>
       <p:sp>
         <p:nvSpPr>
-          <p:cNvPr id="40" name="TextBox 39"/>
+          <p:cNvPr id="6" name="TextBox 5"/>
           <p:cNvSpPr txBox="1"/>
           <p:nvPr/>
         </p:nvSpPr>
         <p:spPr>
           <a:xfrm>
-            <a:off x="7022592" y="2779776"/>
-            <a:ext cx="2221991" cy="201168"/>
+            <a:off x="502920" y="1216152"/>
+            <a:ext cx="3200400" cy="182880"/>
           </a:xfrm>
           <a:prstGeom prst="rect">
             <a:avLst/>
@@ -6178,26 +6265,26 @@
           <a:p>
             <a:pPr algn="l"/>
             <a:r>
-              <a:rPr sz="750" b="1" i="0">
-                <a:solidFill>
-                  <a:srgbClr val="FFFFFF"/>
+              <a:rPr sz="800" b="1" i="0">
+                <a:solidFill>
+                  <a:srgbClr val="3DC570"/>
                 </a:solidFill>
               </a:rPr>
-              <a:t>• MSP EMAIL PERSONALIZATION</a:t>
-            </a:r>
-          </a:p>
-        </p:txBody>
-      </p:sp>
-      <p:sp>
-        <p:nvSpPr>
-          <p:cNvPr id="41" name="TextBox 40"/>
+              <a:t>INTEGRATIONS</a:t>
+            </a:r>
+          </a:p>
+        </p:txBody>
+      </p:sp>
+      <p:sp>
+        <p:nvSpPr>
+          <p:cNvPr id="7" name="TextBox 6"/>
           <p:cNvSpPr txBox="1"/>
           <p:nvPr/>
         </p:nvSpPr>
         <p:spPr>
           <a:xfrm>
-            <a:off x="7086599" y="2990088"/>
-            <a:ext cx="2167128" cy="347472"/>
+            <a:off x="502920" y="1380744"/>
+            <a:ext cx="11155680" cy="310896"/>
           </a:xfrm>
           <a:prstGeom prst="rect">
             <a:avLst/>
@@ -6212,162 +6299,26 @@
           <a:p>
             <a:pPr algn="l"/>
             <a:r>
-              <a:rPr sz="750" b="0" i="0">
-                <a:solidFill>
-                  <a:srgbClr val="8AA8C8"/>
+              <a:rPr sz="1050" b="0" i="0">
+                <a:solidFill>
+                  <a:srgbClr val="FFFFFF"/>
                 </a:solidFill>
               </a:rPr>
-              <a:t>Researches each prospect and writes personalized outreach automatically.</a:t>
-            </a:r>
-          </a:p>
-        </p:txBody>
-      </p:sp>
-      <p:sp>
-        <p:nvSpPr>
-          <p:cNvPr id="42" name="TextBox 41"/>
-          <p:cNvSpPr txBox="1"/>
-          <p:nvPr/>
-        </p:nvSpPr>
-        <p:spPr>
-          <a:xfrm>
-            <a:off x="7022592" y="3438144"/>
-            <a:ext cx="2221991" cy="201168"/>
-          </a:xfrm>
-          <a:prstGeom prst="rect">
-            <a:avLst/>
-          </a:prstGeom>
-          <a:noFill/>
-        </p:spPr>
-        <p:txBody>
-          <a:bodyPr wrap="square">
-            <a:spAutoFit/>
-          </a:bodyPr>
-          <a:lstStyle/>
-          <a:p>
-            <a:pPr algn="l"/>
-            <a:r>
-              <a:rPr sz="750" b="1" i="0">
-                <a:solidFill>
-                  <a:srgbClr val="FFFFFF"/>
-                </a:solidFill>
-              </a:rPr>
-              <a:t>• MEETING TRANSCRIPTION</a:t>
-            </a:r>
-          </a:p>
-        </p:txBody>
-      </p:sp>
-      <p:sp>
-        <p:nvSpPr>
-          <p:cNvPr id="43" name="TextBox 42"/>
-          <p:cNvSpPr txBox="1"/>
-          <p:nvPr/>
-        </p:nvSpPr>
-        <p:spPr>
-          <a:xfrm>
-            <a:off x="7086599" y="3648456"/>
-            <a:ext cx="2167128" cy="347472"/>
-          </a:xfrm>
-          <a:prstGeom prst="rect">
-            <a:avLst/>
-          </a:prstGeom>
-          <a:noFill/>
-        </p:spPr>
-        <p:txBody>
-          <a:bodyPr wrap="square">
-            <a:spAutoFit/>
-          </a:bodyPr>
-          <a:lstStyle/>
-          <a:p>
-            <a:pPr algn="l"/>
-            <a:r>
-              <a:rPr sz="750" b="0" i="0">
-                <a:solidFill>
-                  <a:srgbClr val="8AA8C8"/>
-                </a:solidFill>
-              </a:rPr>
-              <a:t>Captures full notes, takeaways, and action items from every prospect call.</a:t>
-            </a:r>
-          </a:p>
-        </p:txBody>
-      </p:sp>
-      <p:sp>
-        <p:nvSpPr>
-          <p:cNvPr id="44" name="TextBox 43"/>
-          <p:cNvSpPr txBox="1"/>
-          <p:nvPr/>
-        </p:nvSpPr>
-        <p:spPr>
-          <a:xfrm>
-            <a:off x="7022592" y="4096511"/>
-            <a:ext cx="2221991" cy="201168"/>
-          </a:xfrm>
-          <a:prstGeom prst="rect">
-            <a:avLst/>
-          </a:prstGeom>
-          <a:noFill/>
-        </p:spPr>
-        <p:txBody>
-          <a:bodyPr wrap="square">
-            <a:spAutoFit/>
-          </a:bodyPr>
-          <a:lstStyle/>
-          <a:p>
-            <a:pPr algn="l"/>
-            <a:r>
-              <a:rPr sz="750" b="1" i="0">
-                <a:solidFill>
-                  <a:srgbClr val="FFFFFF"/>
-                </a:solidFill>
-              </a:rPr>
-              <a:t>• POST-MEETING FOLLOW-UPS</a:t>
-            </a:r>
-          </a:p>
-        </p:txBody>
-      </p:sp>
-      <p:sp>
-        <p:nvSpPr>
-          <p:cNvPr id="45" name="TextBox 44"/>
-          <p:cNvSpPr txBox="1"/>
-          <p:nvPr/>
-        </p:nvSpPr>
-        <p:spPr>
-          <a:xfrm>
-            <a:off x="7086599" y="4306824"/>
-            <a:ext cx="2167128" cy="347472"/>
-          </a:xfrm>
-          <a:prstGeom prst="rect">
-            <a:avLst/>
-          </a:prstGeom>
-          <a:noFill/>
-        </p:spPr>
-        <p:txBody>
-          <a:bodyPr wrap="square">
-            <a:spAutoFit/>
-          </a:bodyPr>
-          <a:lstStyle/>
-          <a:p>
-            <a:pPr algn="l"/>
-            <a:r>
-              <a:rPr sz="750" b="0" i="0">
-                <a:solidFill>
-                  <a:srgbClr val="8AA8C8"/>
-                </a:solidFill>
-              </a:rPr>
-              <a:t>Generates tailored follow-up emails right after each call.</a:t>
-            </a:r>
-          </a:p>
-        </p:txBody>
-      </p:sp>
-      <p:sp>
-        <p:nvSpPr>
-          <p:cNvPr id="46" name="Rectangle 45"/>
+              <a:t>Robin connects into Rev.io's existing tool stack — using AI to turn raw data and workflows into automated action at scale.</a:t>
+            </a:r>
+          </a:p>
+        </p:txBody>
+      </p:sp>
+      <p:sp>
+        <p:nvSpPr>
+          <p:cNvPr id="8" name="Rectangle 7"/>
           <p:cNvSpPr/>
           <p:nvPr/>
         </p:nvSpPr>
         <p:spPr>
           <a:xfrm>
-            <a:off x="9427464" y="1682496"/>
-            <a:ext cx="2423160" cy="4992624"/>
+            <a:off x="365760" y="1865376"/>
+            <a:ext cx="3739896" cy="4809744"/>
           </a:xfrm>
           <a:prstGeom prst="rect">
             <a:avLst/>
@@ -6403,20 +6354,20 @@
       </p:sp>
       <p:sp>
         <p:nvSpPr>
-          <p:cNvPr id="47" name="Rectangle 46"/>
+          <p:cNvPr id="9" name="Rectangle 8"/>
           <p:cNvSpPr/>
           <p:nvPr/>
         </p:nvSpPr>
         <p:spPr>
           <a:xfrm>
-            <a:off x="9427464" y="1682496"/>
-            <a:ext cx="45720" cy="4992624"/>
+            <a:off x="365760" y="1865376"/>
+            <a:ext cx="45720" cy="4809744"/>
           </a:xfrm>
           <a:prstGeom prst="rect">
             <a:avLst/>
           </a:prstGeom>
           <a:solidFill>
-            <a:srgbClr val="F57C2A"/>
+            <a:srgbClr val="7C3AED"/>
           </a:solidFill>
           <a:ln>
             <a:noFill/>
@@ -6446,14 +6397,14 @@
       </p:sp>
       <p:sp>
         <p:nvSpPr>
-          <p:cNvPr id="48" name="TextBox 47"/>
+          <p:cNvPr id="10" name="TextBox 9"/>
           <p:cNvSpPr txBox="1"/>
           <p:nvPr/>
         </p:nvSpPr>
         <p:spPr>
           <a:xfrm>
-            <a:off x="9564624" y="1773936"/>
-            <a:ext cx="2240279" cy="402336"/>
+            <a:off x="530352" y="1975104"/>
+            <a:ext cx="3511296" cy="438912"/>
           </a:xfrm>
           <a:prstGeom prst="rect">
             <a:avLst/>
@@ -6468,26 +6419,26 @@
           <a:p>
             <a:pPr algn="l"/>
             <a:r>
-              <a:rPr sz="1800" b="1" i="0">
+              <a:rPr sz="2000" b="1" i="0">
                 <a:solidFill>
                   <a:srgbClr val="FFFFFF"/>
                 </a:solidFill>
               </a:rPr>
-              <a:t>🏗️  Clay</a:t>
-            </a:r>
-          </a:p>
-        </p:txBody>
-      </p:sp>
-      <p:sp>
-        <p:nvSpPr>
-          <p:cNvPr id="49" name="TextBox 48"/>
+              <a:t>📓  Notion</a:t>
+            </a:r>
+          </a:p>
+        </p:txBody>
+      </p:sp>
+      <p:sp>
+        <p:nvSpPr>
+          <p:cNvPr id="11" name="TextBox 10"/>
           <p:cNvSpPr txBox="1"/>
           <p:nvPr/>
         </p:nvSpPr>
         <p:spPr>
           <a:xfrm>
-            <a:off x="9564624" y="2194560"/>
-            <a:ext cx="2240279" cy="292608"/>
+            <a:off x="530352" y="2432304"/>
+            <a:ext cx="3511296" cy="292608"/>
           </a:xfrm>
           <a:prstGeom prst="rect">
             <a:avLst/>
@@ -6502,26 +6453,26 @@
           <a:p>
             <a:pPr algn="l"/>
             <a:r>
-              <a:rPr sz="850" b="0" i="0">
-                <a:solidFill>
-                  <a:srgbClr val="F57C2A"/>
+              <a:rPr sz="950" b="0" i="0">
+                <a:solidFill>
+                  <a:srgbClr val="7C3AED"/>
                 </a:solidFill>
               </a:rPr>
-              <a:t>Custom AI for Data Intelligence</a:t>
-            </a:r>
-          </a:p>
-        </p:txBody>
-      </p:sp>
-      <p:sp>
-        <p:nvSpPr>
-          <p:cNvPr id="50" name="TextBox 49"/>
+              <a:t>AI Knowledge &amp; Workflow Automation</a:t>
+            </a:r>
+          </a:p>
+        </p:txBody>
+      </p:sp>
+      <p:sp>
+        <p:nvSpPr>
+          <p:cNvPr id="12" name="TextBox 11"/>
           <p:cNvSpPr txBox="1"/>
           <p:nvPr/>
         </p:nvSpPr>
         <p:spPr>
           <a:xfrm>
-            <a:off x="9564624" y="2487168"/>
-            <a:ext cx="2240279" cy="201168"/>
+            <a:off x="530352" y="2724912"/>
+            <a:ext cx="3511296" cy="201168"/>
           </a:xfrm>
           <a:prstGeom prst="rect">
             <a:avLst/>
@@ -6536,26 +6487,26 @@
           <a:p>
             <a:pPr algn="l"/>
             <a:r>
-              <a:rPr sz="750" b="0" i="1">
+              <a:rPr sz="850" b="0" i="1">
                 <a:solidFill>
                   <a:srgbClr val="8AA8C8"/>
                 </a:solidFill>
               </a:rPr>
-              <a:t>Enrichment · CRM hygiene · Verification</a:t>
-            </a:r>
-          </a:p>
-        </p:txBody>
-      </p:sp>
-      <p:sp>
-        <p:nvSpPr>
-          <p:cNvPr id="51" name="Rectangle 50"/>
+              <a:t>Personalization · Transcription · Follow-up</a:t>
+            </a:r>
+          </a:p>
+        </p:txBody>
+      </p:sp>
+      <p:sp>
+        <p:nvSpPr>
+          <p:cNvPr id="13" name="Rectangle 12"/>
           <p:cNvSpPr/>
           <p:nvPr/>
         </p:nvSpPr>
         <p:spPr>
           <a:xfrm>
-            <a:off x="9564624" y="2706624"/>
-            <a:ext cx="2194560" cy="18288"/>
+            <a:off x="530352" y="2944368"/>
+            <a:ext cx="3465576" cy="18288"/>
           </a:xfrm>
           <a:prstGeom prst="rect">
             <a:avLst/>
@@ -6591,14 +6542,14 @@
       </p:sp>
       <p:sp>
         <p:nvSpPr>
-          <p:cNvPr id="52" name="TextBox 51"/>
+          <p:cNvPr id="14" name="TextBox 13"/>
           <p:cNvSpPr txBox="1"/>
           <p:nvPr/>
         </p:nvSpPr>
         <p:spPr>
           <a:xfrm>
-            <a:off x="9564624" y="2779776"/>
-            <a:ext cx="2221991" cy="201168"/>
+            <a:off x="530352" y="3035808"/>
+            <a:ext cx="3511296" cy="201168"/>
           </a:xfrm>
           <a:prstGeom prst="rect">
             <a:avLst/>
@@ -6613,26 +6564,26 @@
           <a:p>
             <a:pPr algn="l"/>
             <a:r>
-              <a:rPr sz="750" b="1" i="0">
+              <a:rPr sz="850" b="1" i="0">
                 <a:solidFill>
                   <a:srgbClr val="FFFFFF"/>
                 </a:solidFill>
               </a:rPr>
-              <a:t>• INDUSTRY FIELD VERIFICATION</a:t>
-            </a:r>
-          </a:p>
-        </p:txBody>
-      </p:sp>
-      <p:sp>
-        <p:nvSpPr>
-          <p:cNvPr id="53" name="TextBox 52"/>
+              <a:t>• MSP EMAIL PERSONALIZATION AT SCALE</a:t>
+            </a:r>
+          </a:p>
+        </p:txBody>
+      </p:sp>
+      <p:sp>
+        <p:nvSpPr>
+          <p:cNvPr id="15" name="TextBox 14"/>
           <p:cNvSpPr txBox="1"/>
           <p:nvPr/>
         </p:nvSpPr>
         <p:spPr>
           <a:xfrm>
-            <a:off x="9628632" y="2990088"/>
-            <a:ext cx="2167128" cy="457200"/>
+            <a:off x="603504" y="3255264"/>
+            <a:ext cx="3447288" cy="512064"/>
           </a:xfrm>
           <a:prstGeom prst="rect">
             <a:avLst/>
@@ -6647,26 +6598,26 @@
           <a:p>
             <a:pPr algn="l"/>
             <a:r>
-              <a:rPr sz="750" b="0" i="0">
+              <a:rPr sz="850" b="0" i="0">
                 <a:solidFill>
                   <a:srgbClr val="8AA8C8"/>
                 </a:solidFill>
               </a:rPr>
-              <a:t>Built a custom AI agent to verify and correct the industry field on SF accounts at scale.</a:t>
-            </a:r>
-          </a:p>
-        </p:txBody>
-      </p:sp>
-      <p:sp>
-        <p:nvSpPr>
-          <p:cNvPr id="54" name="TextBox 53"/>
+              <a:t>Researches each prospect and writes personalized outreach automatically — no manual prep required.</a:t>
+            </a:r>
+          </a:p>
+        </p:txBody>
+      </p:sp>
+      <p:sp>
+        <p:nvSpPr>
+          <p:cNvPr id="16" name="TextBox 15"/>
           <p:cNvSpPr txBox="1"/>
           <p:nvPr/>
         </p:nvSpPr>
         <p:spPr>
           <a:xfrm>
-            <a:off x="9564624" y="3584448"/>
-            <a:ext cx="2221991" cy="201168"/>
+            <a:off x="530352" y="3904488"/>
+            <a:ext cx="3511296" cy="201168"/>
           </a:xfrm>
           <a:prstGeom prst="rect">
             <a:avLst/>
@@ -6681,26 +6632,26 @@
           <a:p>
             <a:pPr algn="l"/>
             <a:r>
-              <a:rPr sz="750" b="1" i="0">
+              <a:rPr sz="850" b="1" i="0">
                 <a:solidFill>
                   <a:srgbClr val="FFFFFF"/>
                 </a:solidFill>
               </a:rPr>
-              <a:t>• 11K BAD ACCOUNTS FOUND</a:t>
-            </a:r>
-          </a:p>
-        </p:txBody>
-      </p:sp>
-      <p:sp>
-        <p:nvSpPr>
-          <p:cNvPr id="55" name="TextBox 54"/>
+              <a:t>• MEETING NOTE-TAKING &amp; TRANSCRIPTION</a:t>
+            </a:r>
+          </a:p>
+        </p:txBody>
+      </p:sp>
+      <p:sp>
+        <p:nvSpPr>
+          <p:cNvPr id="17" name="TextBox 16"/>
           <p:cNvSpPr txBox="1"/>
           <p:nvPr/>
         </p:nvSpPr>
         <p:spPr>
           <a:xfrm>
-            <a:off x="9628632" y="3794760"/>
-            <a:ext cx="2167128" cy="457200"/>
+            <a:off x="603504" y="4123944"/>
+            <a:ext cx="3447288" cy="512064"/>
           </a:xfrm>
           <a:prstGeom prst="rect">
             <a:avLst/>
@@ -6715,32 +6666,100 @@
           <a:p>
             <a:pPr algn="l"/>
             <a:r>
-              <a:rPr sz="750" b="0" i="0">
+              <a:rPr sz="850" b="0" i="0">
                 <a:solidFill>
                   <a:srgbClr val="8AA8C8"/>
                 </a:solidFill>
               </a:rPr>
-              <a:t>Identified 11,000+ accounts incorrectly marked as MSPs — cleaning the CRM for better targeting.</a:t>
-            </a:r>
-          </a:p>
-        </p:txBody>
-      </p:sp>
-      <p:sp>
-        <p:nvSpPr>
-          <p:cNvPr id="56" name="Rectangle 55"/>
+              <a:t>Captures full meeting notes, key takeaways, and action items from every prospect call.</a:t>
+            </a:r>
+          </a:p>
+        </p:txBody>
+      </p:sp>
+      <p:sp>
+        <p:nvSpPr>
+          <p:cNvPr id="18" name="TextBox 17"/>
+          <p:cNvSpPr txBox="1"/>
+          <p:nvPr/>
+        </p:nvSpPr>
+        <p:spPr>
+          <a:xfrm>
+            <a:off x="530352" y="4773168"/>
+            <a:ext cx="3511296" cy="201168"/>
+          </a:xfrm>
+          <a:prstGeom prst="rect">
+            <a:avLst/>
+          </a:prstGeom>
+          <a:noFill/>
+        </p:spPr>
+        <p:txBody>
+          <a:bodyPr wrap="square">
+            <a:spAutoFit/>
+          </a:bodyPr>
+          <a:lstStyle/>
+          <a:p>
+            <a:pPr algn="l"/>
+            <a:r>
+              <a:rPr sz="850" b="1" i="0">
+                <a:solidFill>
+                  <a:srgbClr val="FFFFFF"/>
+                </a:solidFill>
+              </a:rPr>
+              <a:t>• POST-MEETING FOLLOW-UP EMAILS</a:t>
+            </a:r>
+          </a:p>
+        </p:txBody>
+      </p:sp>
+      <p:sp>
+        <p:nvSpPr>
+          <p:cNvPr id="19" name="TextBox 18"/>
+          <p:cNvSpPr txBox="1"/>
+          <p:nvPr/>
+        </p:nvSpPr>
+        <p:spPr>
+          <a:xfrm>
+            <a:off x="603504" y="4992624"/>
+            <a:ext cx="3447288" cy="512064"/>
+          </a:xfrm>
+          <a:prstGeom prst="rect">
+            <a:avLst/>
+          </a:prstGeom>
+          <a:noFill/>
+        </p:spPr>
+        <p:txBody>
+          <a:bodyPr wrap="square">
+            <a:spAutoFit/>
+          </a:bodyPr>
+          <a:lstStyle/>
+          <a:p>
+            <a:pPr algn="l"/>
+            <a:r>
+              <a:rPr sz="850" b="0" i="0">
+                <a:solidFill>
+                  <a:srgbClr val="8AA8C8"/>
+                </a:solidFill>
+              </a:rPr>
+              <a:t>Generates tailored follow-up emails and action item summaries immediately after each call.</a:t>
+            </a:r>
+          </a:p>
+        </p:txBody>
+      </p:sp>
+      <p:sp>
+        <p:nvSpPr>
+          <p:cNvPr id="20" name="Rectangle 19"/>
           <p:cNvSpPr/>
           <p:nvPr/>
         </p:nvSpPr>
         <p:spPr>
           <a:xfrm>
-            <a:off x="0" y="6675120"/>
-            <a:ext cx="12188952" cy="182880"/>
+            <a:off x="4224528" y="1865376"/>
+            <a:ext cx="3739896" cy="4809744"/>
           </a:xfrm>
           <a:prstGeom prst="rect">
             <a:avLst/>
           </a:prstGeom>
           <a:solidFill>
-            <a:srgbClr val="071220"/>
+            <a:srgbClr val="0A1E30"/>
           </a:solidFill>
           <a:ln>
             <a:noFill/>
@@ -6770,14 +6789,57 @@
       </p:sp>
       <p:sp>
         <p:nvSpPr>
-          <p:cNvPr id="57" name="TextBox 56"/>
+          <p:cNvPr id="21" name="Rectangle 20"/>
+          <p:cNvSpPr/>
+          <p:nvPr/>
+        </p:nvSpPr>
+        <p:spPr>
+          <a:xfrm>
+            <a:off x="4224528" y="1865376"/>
+            <a:ext cx="45720" cy="4809744"/>
+          </a:xfrm>
+          <a:prstGeom prst="rect">
+            <a:avLst/>
+          </a:prstGeom>
+          <a:solidFill>
+            <a:srgbClr val="F57C2A"/>
+          </a:solidFill>
+          <a:ln>
+            <a:noFill/>
+          </a:ln>
+        </p:spPr>
+        <p:style>
+          <a:lnRef idx="1">
+            <a:schemeClr val="accent1"/>
+          </a:lnRef>
+          <a:fillRef idx="3">
+            <a:schemeClr val="accent1"/>
+          </a:fillRef>
+          <a:effectRef idx="2">
+            <a:schemeClr val="accent1"/>
+          </a:effectRef>
+          <a:fontRef idx="minor">
+            <a:schemeClr val="lt1"/>
+          </a:fontRef>
+        </p:style>
+        <p:txBody>
+          <a:bodyPr rtlCol="0" anchor="ctr"/>
+          <a:lstStyle/>
+          <a:p>
+            <a:pPr algn="ctr"/>
+          </a:p>
+        </p:txBody>
+      </p:sp>
+      <p:sp>
+        <p:nvSpPr>
+          <p:cNvPr id="22" name="TextBox 21"/>
           <p:cNvSpPr txBox="1"/>
           <p:nvPr/>
         </p:nvSpPr>
         <p:spPr>
           <a:xfrm>
-            <a:off x="274320" y="6693408"/>
-            <a:ext cx="1828800" cy="146304"/>
+            <a:off x="4389120" y="1975104"/>
+            <a:ext cx="3511296" cy="438912"/>
           </a:xfrm>
           <a:prstGeom prst="rect">
             <a:avLst/>
@@ -6792,26 +6854,26 @@
           <a:p>
             <a:pPr algn="l"/>
             <a:r>
-              <a:rPr sz="900" b="1" i="0">
+              <a:rPr sz="2000" b="1" i="0">
                 <a:solidFill>
                   <a:srgbClr val="FFFFFF"/>
                 </a:solidFill>
               </a:rPr>
-              <a:t>• rev.io</a:t>
-            </a:r>
-          </a:p>
-        </p:txBody>
-      </p:sp>
-      <p:sp>
-        <p:nvSpPr>
-          <p:cNvPr id="58" name="TextBox 57"/>
+              <a:t>🏗️  Clay</a:t>
+            </a:r>
+          </a:p>
+        </p:txBody>
+      </p:sp>
+      <p:sp>
+        <p:nvSpPr>
+          <p:cNvPr id="23" name="TextBox 22"/>
           <p:cNvSpPr txBox="1"/>
           <p:nvPr/>
         </p:nvSpPr>
         <p:spPr>
           <a:xfrm>
-            <a:off x="8686800" y="6693408"/>
-            <a:ext cx="2011680" cy="146304"/>
+            <a:off x="4389120" y="2432304"/>
+            <a:ext cx="3511296" cy="292608"/>
           </a:xfrm>
           <a:prstGeom prst="rect">
             <a:avLst/>
@@ -6824,6 +6886,697 @@
           </a:bodyPr>
           <a:lstStyle/>
           <a:p>
+            <a:pPr algn="l"/>
+            <a:r>
+              <a:rPr sz="950" b="0" i="0">
+                <a:solidFill>
+                  <a:srgbClr val="F57C2A"/>
+                </a:solidFill>
+              </a:rPr>
+              <a:t>Custom AI for Data Intelligence</a:t>
+            </a:r>
+          </a:p>
+        </p:txBody>
+      </p:sp>
+      <p:sp>
+        <p:nvSpPr>
+          <p:cNvPr id="24" name="TextBox 23"/>
+          <p:cNvSpPr txBox="1"/>
+          <p:nvPr/>
+        </p:nvSpPr>
+        <p:spPr>
+          <a:xfrm>
+            <a:off x="4389120" y="2724912"/>
+            <a:ext cx="3511296" cy="201168"/>
+          </a:xfrm>
+          <a:prstGeom prst="rect">
+            <a:avLst/>
+          </a:prstGeom>
+          <a:noFill/>
+        </p:spPr>
+        <p:txBody>
+          <a:bodyPr wrap="square">
+            <a:spAutoFit/>
+          </a:bodyPr>
+          <a:lstStyle/>
+          <a:p>
+            <a:pPr algn="l"/>
+            <a:r>
+              <a:rPr sz="850" b="0" i="1">
+                <a:solidFill>
+                  <a:srgbClr val="8AA8C8"/>
+                </a:solidFill>
+              </a:rPr>
+              <a:t>Enrichment · CRM hygiene · Verification</a:t>
+            </a:r>
+          </a:p>
+        </p:txBody>
+      </p:sp>
+      <p:sp>
+        <p:nvSpPr>
+          <p:cNvPr id="25" name="Rectangle 24"/>
+          <p:cNvSpPr/>
+          <p:nvPr/>
+        </p:nvSpPr>
+        <p:spPr>
+          <a:xfrm>
+            <a:off x="4389120" y="2944368"/>
+            <a:ext cx="3465576" cy="18288"/>
+          </a:xfrm>
+          <a:prstGeom prst="rect">
+            <a:avLst/>
+          </a:prstGeom>
+          <a:solidFill>
+            <a:srgbClr val="1A3555"/>
+          </a:solidFill>
+          <a:ln>
+            <a:noFill/>
+          </a:ln>
+        </p:spPr>
+        <p:style>
+          <a:lnRef idx="1">
+            <a:schemeClr val="accent1"/>
+          </a:lnRef>
+          <a:fillRef idx="3">
+            <a:schemeClr val="accent1"/>
+          </a:fillRef>
+          <a:effectRef idx="2">
+            <a:schemeClr val="accent1"/>
+          </a:effectRef>
+          <a:fontRef idx="minor">
+            <a:schemeClr val="lt1"/>
+          </a:fontRef>
+        </p:style>
+        <p:txBody>
+          <a:bodyPr rtlCol="0" anchor="ctr"/>
+          <a:lstStyle/>
+          <a:p>
+            <a:pPr algn="ctr"/>
+          </a:p>
+        </p:txBody>
+      </p:sp>
+      <p:sp>
+        <p:nvSpPr>
+          <p:cNvPr id="26" name="TextBox 25"/>
+          <p:cNvSpPr txBox="1"/>
+          <p:nvPr/>
+        </p:nvSpPr>
+        <p:spPr>
+          <a:xfrm>
+            <a:off x="4389120" y="3035808"/>
+            <a:ext cx="3511296" cy="201168"/>
+          </a:xfrm>
+          <a:prstGeom prst="rect">
+            <a:avLst/>
+          </a:prstGeom>
+          <a:noFill/>
+        </p:spPr>
+        <p:txBody>
+          <a:bodyPr wrap="square">
+            <a:spAutoFit/>
+          </a:bodyPr>
+          <a:lstStyle/>
+          <a:p>
+            <a:pPr algn="l"/>
+            <a:r>
+              <a:rPr sz="850" b="1" i="0">
+                <a:solidFill>
+                  <a:srgbClr val="FFFFFF"/>
+                </a:solidFill>
+              </a:rPr>
+              <a:t>• INDUSTRY FIELD VERIFICATION</a:t>
+            </a:r>
+          </a:p>
+        </p:txBody>
+      </p:sp>
+      <p:sp>
+        <p:nvSpPr>
+          <p:cNvPr id="27" name="TextBox 26"/>
+          <p:cNvSpPr txBox="1"/>
+          <p:nvPr/>
+        </p:nvSpPr>
+        <p:spPr>
+          <a:xfrm>
+            <a:off x="4462272" y="3255264"/>
+            <a:ext cx="3447288" cy="512064"/>
+          </a:xfrm>
+          <a:prstGeom prst="rect">
+            <a:avLst/>
+          </a:prstGeom>
+          <a:noFill/>
+        </p:spPr>
+        <p:txBody>
+          <a:bodyPr wrap="square">
+            <a:spAutoFit/>
+          </a:bodyPr>
+          <a:lstStyle/>
+          <a:p>
+            <a:pPr algn="l"/>
+            <a:r>
+              <a:rPr sz="850" b="0" i="0">
+                <a:solidFill>
+                  <a:srgbClr val="8AA8C8"/>
+                </a:solidFill>
+              </a:rPr>
+              <a:t>Built a custom AI agent to verify and correct the industry field on Salesforce accounts at scale.</a:t>
+            </a:r>
+          </a:p>
+        </p:txBody>
+      </p:sp>
+      <p:sp>
+        <p:nvSpPr>
+          <p:cNvPr id="28" name="TextBox 27"/>
+          <p:cNvSpPr txBox="1"/>
+          <p:nvPr/>
+        </p:nvSpPr>
+        <p:spPr>
+          <a:xfrm>
+            <a:off x="4389120" y="3904488"/>
+            <a:ext cx="3511296" cy="201168"/>
+          </a:xfrm>
+          <a:prstGeom prst="rect">
+            <a:avLst/>
+          </a:prstGeom>
+          <a:noFill/>
+        </p:spPr>
+        <p:txBody>
+          <a:bodyPr wrap="square">
+            <a:spAutoFit/>
+          </a:bodyPr>
+          <a:lstStyle/>
+          <a:p>
+            <a:pPr algn="l"/>
+            <a:r>
+              <a:rPr sz="850" b="1" i="0">
+                <a:solidFill>
+                  <a:srgbClr val="FFFFFF"/>
+                </a:solidFill>
+              </a:rPr>
+              <a:t>• 11K INCORRECTLY TAGGED ACCOUNTS</a:t>
+            </a:r>
+          </a:p>
+        </p:txBody>
+      </p:sp>
+      <p:sp>
+        <p:nvSpPr>
+          <p:cNvPr id="29" name="TextBox 28"/>
+          <p:cNvSpPr txBox="1"/>
+          <p:nvPr/>
+        </p:nvSpPr>
+        <p:spPr>
+          <a:xfrm>
+            <a:off x="4462272" y="4123944"/>
+            <a:ext cx="3447288" cy="512064"/>
+          </a:xfrm>
+          <a:prstGeom prst="rect">
+            <a:avLst/>
+          </a:prstGeom>
+          <a:noFill/>
+        </p:spPr>
+        <p:txBody>
+          <a:bodyPr wrap="square">
+            <a:spAutoFit/>
+          </a:bodyPr>
+          <a:lstStyle/>
+          <a:p>
+            <a:pPr algn="l"/>
+            <a:r>
+              <a:rPr sz="850" b="0" i="0">
+                <a:solidFill>
+                  <a:srgbClr val="8AA8C8"/>
+                </a:solidFill>
+              </a:rPr>
+              <a:t>Identified 11,000+ accounts incorrectly marked as MSPs — cleaning the CRM foundation for better targeting and scoring.</a:t>
+            </a:r>
+          </a:p>
+        </p:txBody>
+      </p:sp>
+      <p:sp>
+        <p:nvSpPr>
+          <p:cNvPr id="30" name="Rectangle 29"/>
+          <p:cNvSpPr/>
+          <p:nvPr/>
+        </p:nvSpPr>
+        <p:spPr>
+          <a:xfrm>
+            <a:off x="8083296" y="1865376"/>
+            <a:ext cx="3739896" cy="4809744"/>
+          </a:xfrm>
+          <a:prstGeom prst="rect">
+            <a:avLst/>
+          </a:prstGeom>
+          <a:solidFill>
+            <a:srgbClr val="0A1E30"/>
+          </a:solidFill>
+          <a:ln>
+            <a:noFill/>
+          </a:ln>
+        </p:spPr>
+        <p:style>
+          <a:lnRef idx="1">
+            <a:schemeClr val="accent1"/>
+          </a:lnRef>
+          <a:fillRef idx="3">
+            <a:schemeClr val="accent1"/>
+          </a:fillRef>
+          <a:effectRef idx="2">
+            <a:schemeClr val="accent1"/>
+          </a:effectRef>
+          <a:fontRef idx="minor">
+            <a:schemeClr val="lt1"/>
+          </a:fontRef>
+        </p:style>
+        <p:txBody>
+          <a:bodyPr rtlCol="0" anchor="ctr"/>
+          <a:lstStyle/>
+          <a:p>
+            <a:pPr algn="ctr"/>
+          </a:p>
+        </p:txBody>
+      </p:sp>
+      <p:sp>
+        <p:nvSpPr>
+          <p:cNvPr id="31" name="Rectangle 30"/>
+          <p:cNvSpPr/>
+          <p:nvPr/>
+        </p:nvSpPr>
+        <p:spPr>
+          <a:xfrm>
+            <a:off x="8083296" y="1865376"/>
+            <a:ext cx="45720" cy="4809744"/>
+          </a:xfrm>
+          <a:prstGeom prst="rect">
+            <a:avLst/>
+          </a:prstGeom>
+          <a:solidFill>
+            <a:srgbClr val="0D9E8A"/>
+          </a:solidFill>
+          <a:ln>
+            <a:noFill/>
+          </a:ln>
+        </p:spPr>
+        <p:style>
+          <a:lnRef idx="1">
+            <a:schemeClr val="accent1"/>
+          </a:lnRef>
+          <a:fillRef idx="3">
+            <a:schemeClr val="accent1"/>
+          </a:fillRef>
+          <a:effectRef idx="2">
+            <a:schemeClr val="accent1"/>
+          </a:effectRef>
+          <a:fontRef idx="minor">
+            <a:schemeClr val="lt1"/>
+          </a:fontRef>
+        </p:style>
+        <p:txBody>
+          <a:bodyPr rtlCol="0" anchor="ctr"/>
+          <a:lstStyle/>
+          <a:p>
+            <a:pPr algn="ctr"/>
+          </a:p>
+        </p:txBody>
+      </p:sp>
+      <p:sp>
+        <p:nvSpPr>
+          <p:cNvPr id="32" name="TextBox 31"/>
+          <p:cNvSpPr txBox="1"/>
+          <p:nvPr/>
+        </p:nvSpPr>
+        <p:spPr>
+          <a:xfrm>
+            <a:off x="8247888" y="1975104"/>
+            <a:ext cx="3511296" cy="438912"/>
+          </a:xfrm>
+          <a:prstGeom prst="rect">
+            <a:avLst/>
+          </a:prstGeom>
+          <a:noFill/>
+        </p:spPr>
+        <p:txBody>
+          <a:bodyPr wrap="square">
+            <a:spAutoFit/>
+          </a:bodyPr>
+          <a:lstStyle/>
+          <a:p>
+            <a:pPr algn="l"/>
+            <a:r>
+              <a:rPr sz="2000" b="1" i="0">
+                <a:solidFill>
+                  <a:srgbClr val="FFFFFF"/>
+                </a:solidFill>
+              </a:rPr>
+              <a:t>📧  Outreach</a:t>
+            </a:r>
+          </a:p>
+        </p:txBody>
+      </p:sp>
+      <p:sp>
+        <p:nvSpPr>
+          <p:cNvPr id="33" name="TextBox 32"/>
+          <p:cNvSpPr txBox="1"/>
+          <p:nvPr/>
+        </p:nvSpPr>
+        <p:spPr>
+          <a:xfrm>
+            <a:off x="8247888" y="2432304"/>
+            <a:ext cx="3511296" cy="292608"/>
+          </a:xfrm>
+          <a:prstGeom prst="rect">
+            <a:avLst/>
+          </a:prstGeom>
+          <a:noFill/>
+        </p:spPr>
+        <p:txBody>
+          <a:bodyPr wrap="square">
+            <a:spAutoFit/>
+          </a:bodyPr>
+          <a:lstStyle/>
+          <a:p>
+            <a:pPr algn="l"/>
+            <a:r>
+              <a:rPr sz="950" b="0" i="0">
+                <a:solidFill>
+                  <a:srgbClr val="0D9E8A"/>
+                </a:solidFill>
+              </a:rPr>
+              <a:t>Revenue Agent — Automated Sequencing</a:t>
+            </a:r>
+          </a:p>
+        </p:txBody>
+      </p:sp>
+      <p:sp>
+        <p:nvSpPr>
+          <p:cNvPr id="34" name="TextBox 33"/>
+          <p:cNvSpPr txBox="1"/>
+          <p:nvPr/>
+        </p:nvSpPr>
+        <p:spPr>
+          <a:xfrm>
+            <a:off x="8247888" y="2724912"/>
+            <a:ext cx="3511296" cy="201168"/>
+          </a:xfrm>
+          <a:prstGeom prst="rect">
+            <a:avLst/>
+          </a:prstGeom>
+          <a:noFill/>
+        </p:spPr>
+        <p:txBody>
+          <a:bodyPr wrap="square">
+            <a:spAutoFit/>
+          </a:bodyPr>
+          <a:lstStyle/>
+          <a:p>
+            <a:pPr algn="l"/>
+            <a:r>
+              <a:rPr sz="850" b="0" i="1">
+                <a:solidFill>
+                  <a:srgbClr val="8AA8C8"/>
+                </a:solidFill>
+              </a:rPr>
+              <a:t>MSP Team · Persona-based · Always-on</a:t>
+            </a:r>
+          </a:p>
+        </p:txBody>
+      </p:sp>
+      <p:sp>
+        <p:nvSpPr>
+          <p:cNvPr id="35" name="Rectangle 34"/>
+          <p:cNvSpPr/>
+          <p:nvPr/>
+        </p:nvSpPr>
+        <p:spPr>
+          <a:xfrm>
+            <a:off x="8247888" y="2944368"/>
+            <a:ext cx="3465576" cy="18288"/>
+          </a:xfrm>
+          <a:prstGeom prst="rect">
+            <a:avLst/>
+          </a:prstGeom>
+          <a:solidFill>
+            <a:srgbClr val="1A3555"/>
+          </a:solidFill>
+          <a:ln>
+            <a:noFill/>
+          </a:ln>
+        </p:spPr>
+        <p:style>
+          <a:lnRef idx="1">
+            <a:schemeClr val="accent1"/>
+          </a:lnRef>
+          <a:fillRef idx="3">
+            <a:schemeClr val="accent1"/>
+          </a:fillRef>
+          <a:effectRef idx="2">
+            <a:schemeClr val="accent1"/>
+          </a:effectRef>
+          <a:fontRef idx="minor">
+            <a:schemeClr val="lt1"/>
+          </a:fontRef>
+        </p:style>
+        <p:txBody>
+          <a:bodyPr rtlCol="0" anchor="ctr"/>
+          <a:lstStyle/>
+          <a:p>
+            <a:pPr algn="ctr"/>
+          </a:p>
+        </p:txBody>
+      </p:sp>
+      <p:sp>
+        <p:nvSpPr>
+          <p:cNvPr id="36" name="TextBox 35"/>
+          <p:cNvSpPr txBox="1"/>
+          <p:nvPr/>
+        </p:nvSpPr>
+        <p:spPr>
+          <a:xfrm>
+            <a:off x="8247888" y="3035808"/>
+            <a:ext cx="3511296" cy="201168"/>
+          </a:xfrm>
+          <a:prstGeom prst="rect">
+            <a:avLst/>
+          </a:prstGeom>
+          <a:noFill/>
+        </p:spPr>
+        <p:txBody>
+          <a:bodyPr wrap="square">
+            <a:spAutoFit/>
+          </a:bodyPr>
+          <a:lstStyle/>
+          <a:p>
+            <a:pPr algn="l"/>
+            <a:r>
+              <a:rPr sz="850" b="1" i="0">
+                <a:solidFill>
+                  <a:srgbClr val="FFFFFF"/>
+                </a:solidFill>
+              </a:rPr>
+              <a:t>• DEDICATED REVENUE AGENTS PER PERSONA</a:t>
+            </a:r>
+          </a:p>
+        </p:txBody>
+      </p:sp>
+      <p:sp>
+        <p:nvSpPr>
+          <p:cNvPr id="37" name="TextBox 36"/>
+          <p:cNvSpPr txBox="1"/>
+          <p:nvPr/>
+        </p:nvSpPr>
+        <p:spPr>
+          <a:xfrm>
+            <a:off x="8321040" y="3255264"/>
+            <a:ext cx="3447288" cy="512064"/>
+          </a:xfrm>
+          <a:prstGeom prst="rect">
+            <a:avLst/>
+          </a:prstGeom>
+          <a:noFill/>
+        </p:spPr>
+        <p:txBody>
+          <a:bodyPr wrap="square">
+            <a:spAutoFit/>
+          </a:bodyPr>
+          <a:lstStyle/>
+          <a:p>
+            <a:pPr algn="l"/>
+            <a:r>
+              <a:rPr sz="850" b="0" i="0">
+                <a:solidFill>
+                  <a:srgbClr val="8AA8C8"/>
+                </a:solidFill>
+              </a:rPr>
+              <a:t>MSP team has dedicated agents that automatically add contacts into specific sequences daily — based on persona, industry, and time since last engagement.</a:t>
+            </a:r>
+          </a:p>
+        </p:txBody>
+      </p:sp>
+      <p:sp>
+        <p:nvSpPr>
+          <p:cNvPr id="38" name="TextBox 37"/>
+          <p:cNvSpPr txBox="1"/>
+          <p:nvPr/>
+        </p:nvSpPr>
+        <p:spPr>
+          <a:xfrm>
+            <a:off x="8247888" y="3904488"/>
+            <a:ext cx="3511296" cy="201168"/>
+          </a:xfrm>
+          <a:prstGeom prst="rect">
+            <a:avLst/>
+          </a:prstGeom>
+          <a:noFill/>
+        </p:spPr>
+        <p:txBody>
+          <a:bodyPr wrap="square">
+            <a:spAutoFit/>
+          </a:bodyPr>
+          <a:lstStyle/>
+          <a:p>
+            <a:pPr algn="l"/>
+            <a:r>
+              <a:rPr sz="850" b="1" i="0">
+                <a:solidFill>
+                  <a:srgbClr val="FFFFFF"/>
+                </a:solidFill>
+              </a:rPr>
+              <a:t>• ELIMINATED MANUAL SEQUENCE MANAGEMENT</a:t>
+            </a:r>
+          </a:p>
+        </p:txBody>
+      </p:sp>
+      <p:sp>
+        <p:nvSpPr>
+          <p:cNvPr id="39" name="TextBox 38"/>
+          <p:cNvSpPr txBox="1"/>
+          <p:nvPr/>
+        </p:nvSpPr>
+        <p:spPr>
+          <a:xfrm>
+            <a:off x="8321040" y="4123944"/>
+            <a:ext cx="3447288" cy="512064"/>
+          </a:xfrm>
+          <a:prstGeom prst="rect">
+            <a:avLst/>
+          </a:prstGeom>
+          <a:noFill/>
+        </p:spPr>
+        <p:txBody>
+          <a:bodyPr wrap="square">
+            <a:spAutoFit/>
+          </a:bodyPr>
+          <a:lstStyle/>
+          <a:p>
+            <a:pPr algn="l"/>
+            <a:r>
+              <a:rPr sz="850" b="0" i="0">
+                <a:solidFill>
+                  <a:srgbClr val="8AA8C8"/>
+                </a:solidFill>
+              </a:rPr>
+              <a:t>Removed the daily decision-making and time spent manually adding prospects to sequences. Reps focus on selling, not admin.</a:t>
+            </a:r>
+          </a:p>
+        </p:txBody>
+      </p:sp>
+      <p:sp>
+        <p:nvSpPr>
+          <p:cNvPr id="40" name="Rectangle 39"/>
+          <p:cNvSpPr/>
+          <p:nvPr/>
+        </p:nvSpPr>
+        <p:spPr>
+          <a:xfrm>
+            <a:off x="0" y="6675120"/>
+            <a:ext cx="12188952" cy="182880"/>
+          </a:xfrm>
+          <a:prstGeom prst="rect">
+            <a:avLst/>
+          </a:prstGeom>
+          <a:solidFill>
+            <a:srgbClr val="071220"/>
+          </a:solidFill>
+          <a:ln>
+            <a:noFill/>
+          </a:ln>
+        </p:spPr>
+        <p:style>
+          <a:lnRef idx="1">
+            <a:schemeClr val="accent1"/>
+          </a:lnRef>
+          <a:fillRef idx="3">
+            <a:schemeClr val="accent1"/>
+          </a:fillRef>
+          <a:effectRef idx="2">
+            <a:schemeClr val="accent1"/>
+          </a:effectRef>
+          <a:fontRef idx="minor">
+            <a:schemeClr val="lt1"/>
+          </a:fontRef>
+        </p:style>
+        <p:txBody>
+          <a:bodyPr rtlCol="0" anchor="ctr"/>
+          <a:lstStyle/>
+          <a:p>
+            <a:pPr algn="ctr"/>
+          </a:p>
+        </p:txBody>
+      </p:sp>
+      <p:sp>
+        <p:nvSpPr>
+          <p:cNvPr id="41" name="TextBox 40"/>
+          <p:cNvSpPr txBox="1"/>
+          <p:nvPr/>
+        </p:nvSpPr>
+        <p:spPr>
+          <a:xfrm>
+            <a:off x="274320" y="6693408"/>
+            <a:ext cx="1828800" cy="146304"/>
+          </a:xfrm>
+          <a:prstGeom prst="rect">
+            <a:avLst/>
+          </a:prstGeom>
+          <a:noFill/>
+        </p:spPr>
+        <p:txBody>
+          <a:bodyPr wrap="square">
+            <a:spAutoFit/>
+          </a:bodyPr>
+          <a:lstStyle/>
+          <a:p>
+            <a:pPr algn="l"/>
+            <a:r>
+              <a:rPr sz="900" b="1" i="0">
+                <a:solidFill>
+                  <a:srgbClr val="FFFFFF"/>
+                </a:solidFill>
+              </a:rPr>
+              <a:t>• rev.io</a:t>
+            </a:r>
+          </a:p>
+        </p:txBody>
+      </p:sp>
+      <p:sp>
+        <p:nvSpPr>
+          <p:cNvPr id="42" name="TextBox 41"/>
+          <p:cNvSpPr txBox="1"/>
+          <p:nvPr/>
+        </p:nvSpPr>
+        <p:spPr>
+          <a:xfrm>
+            <a:off x="8686800" y="6693408"/>
+            <a:ext cx="2011680" cy="146304"/>
+          </a:xfrm>
+          <a:prstGeom prst="rect">
+            <a:avLst/>
+          </a:prstGeom>
+          <a:noFill/>
+        </p:spPr>
+        <p:txBody>
+          <a:bodyPr wrap="square">
+            <a:spAutoFit/>
+          </a:bodyPr>
+          <a:lstStyle/>
+          <a:p>
             <a:pPr algn="r"/>
             <a:r>
               <a:rPr sz="900" b="1" i="0">
@@ -6838,7 +7591,7 @@
       </p:sp>
       <p:sp>
         <p:nvSpPr>
-          <p:cNvPr id="59" name="TextBox 58"/>
+          <p:cNvPr id="43" name="TextBox 42"/>
           <p:cNvSpPr txBox="1"/>
           <p:nvPr/>
         </p:nvSpPr>

</xml_diff>

<commit_message>
Tool stack: logos added, Clay sub-bullet for 11K result
</commit_message>
<xml_diff>
--- a/Robin-Intro-Slide.pptx
+++ b/Robin-Intro-Slide.pptx
@@ -6395,16 +6395,40 @@
           </a:p>
         </p:txBody>
       </p:sp>
-      <p:sp>
-        <p:nvSpPr>
-          <p:cNvPr id="10" name="TextBox 9"/>
+      <p:pic>
+        <p:nvPicPr>
+          <p:cNvPr id="10" name="Picture 9" descr="notion.png"/>
+          <p:cNvPicPr>
+            <a:picLocks noChangeAspect="1"/>
+          </p:cNvPicPr>
+          <p:nvPr/>
+        </p:nvPicPr>
+        <p:blipFill>
+          <a:blip r:embed="rId4"/>
+          <a:stretch>
+            <a:fillRect/>
+          </a:stretch>
+        </p:blipFill>
+        <p:spPr>
+          <a:xfrm>
+            <a:off x="530352" y="1993392"/>
+            <a:ext cx="475488" cy="475488"/>
+          </a:xfrm>
+          <a:prstGeom prst="rect">
+            <a:avLst/>
+          </a:prstGeom>
+        </p:spPr>
+      </p:pic>
+      <p:sp>
+        <p:nvSpPr>
+          <p:cNvPr id="11" name="TextBox 10"/>
           <p:cNvSpPr txBox="1"/>
           <p:nvPr/>
         </p:nvSpPr>
         <p:spPr>
           <a:xfrm>
-            <a:off x="530352" y="1975104"/>
-            <a:ext cx="3511296" cy="438912"/>
+            <a:off x="1115568" y="1993392"/>
+            <a:ext cx="2807208" cy="475488"/>
           </a:xfrm>
           <a:prstGeom prst="rect">
             <a:avLst/>
@@ -6419,26 +6443,26 @@
           <a:p>
             <a:pPr algn="l"/>
             <a:r>
-              <a:rPr sz="2000" b="1" i="0">
+              <a:rPr sz="2400" b="1" i="0">
                 <a:solidFill>
                   <a:srgbClr val="FFFFFF"/>
                 </a:solidFill>
               </a:rPr>
-              <a:t>📓  Notion</a:t>
-            </a:r>
-          </a:p>
-        </p:txBody>
-      </p:sp>
-      <p:sp>
-        <p:nvSpPr>
-          <p:cNvPr id="11" name="TextBox 10"/>
+              <a:t>Notion</a:t>
+            </a:r>
+          </a:p>
+        </p:txBody>
+      </p:sp>
+      <p:sp>
+        <p:nvSpPr>
+          <p:cNvPr id="12" name="TextBox 11"/>
           <p:cNvSpPr txBox="1"/>
           <p:nvPr/>
         </p:nvSpPr>
         <p:spPr>
           <a:xfrm>
-            <a:off x="530352" y="2432304"/>
-            <a:ext cx="3511296" cy="292608"/>
+            <a:off x="530352" y="2578608"/>
+            <a:ext cx="3511296" cy="256032"/>
           </a:xfrm>
           <a:prstGeom prst="rect">
             <a:avLst/>
@@ -6465,14 +6489,14 @@
       </p:sp>
       <p:sp>
         <p:nvSpPr>
-          <p:cNvPr id="12" name="TextBox 11"/>
+          <p:cNvPr id="13" name="TextBox 12"/>
           <p:cNvSpPr txBox="1"/>
           <p:nvPr/>
         </p:nvSpPr>
         <p:spPr>
           <a:xfrm>
-            <a:off x="530352" y="2724912"/>
-            <a:ext cx="3511296" cy="201168"/>
+            <a:off x="530352" y="2834640"/>
+            <a:ext cx="3511296" cy="182880"/>
           </a:xfrm>
           <a:prstGeom prst="rect">
             <a:avLst/>
@@ -6499,13 +6523,13 @@
       </p:sp>
       <p:sp>
         <p:nvSpPr>
-          <p:cNvPr id="13" name="Rectangle 12"/>
+          <p:cNvPr id="14" name="Rectangle 13"/>
           <p:cNvSpPr/>
           <p:nvPr/>
         </p:nvSpPr>
         <p:spPr>
           <a:xfrm>
-            <a:off x="530352" y="2944368"/>
+            <a:off x="530352" y="3035808"/>
             <a:ext cx="3465576" cy="18288"/>
           </a:xfrm>
           <a:prstGeom prst="rect">
@@ -6542,13 +6566,13 @@
       </p:sp>
       <p:sp>
         <p:nvSpPr>
-          <p:cNvPr id="14" name="TextBox 13"/>
+          <p:cNvPr id="15" name="TextBox 14"/>
           <p:cNvSpPr txBox="1"/>
           <p:nvPr/>
         </p:nvSpPr>
         <p:spPr>
           <a:xfrm>
-            <a:off x="530352" y="3035808"/>
+            <a:off x="530352" y="3127248"/>
             <a:ext cx="3511296" cy="201168"/>
           </a:xfrm>
           <a:prstGeom prst="rect">
@@ -6576,14 +6600,14 @@
       </p:sp>
       <p:sp>
         <p:nvSpPr>
-          <p:cNvPr id="15" name="TextBox 14"/>
+          <p:cNvPr id="16" name="TextBox 15"/>
           <p:cNvSpPr txBox="1"/>
           <p:nvPr/>
         </p:nvSpPr>
         <p:spPr>
           <a:xfrm>
-            <a:off x="603504" y="3255264"/>
-            <a:ext cx="3447288" cy="512064"/>
+            <a:off x="603504" y="3364991"/>
+            <a:ext cx="3447288" cy="420624"/>
           </a:xfrm>
           <a:prstGeom prst="rect">
             <a:avLst/>
@@ -6610,13 +6634,13 @@
       </p:sp>
       <p:sp>
         <p:nvSpPr>
-          <p:cNvPr id="16" name="TextBox 15"/>
+          <p:cNvPr id="17" name="TextBox 16"/>
           <p:cNvSpPr txBox="1"/>
           <p:nvPr/>
         </p:nvSpPr>
         <p:spPr>
           <a:xfrm>
-            <a:off x="530352" y="3904488"/>
+            <a:off x="530352" y="3895344"/>
             <a:ext cx="3511296" cy="201168"/>
           </a:xfrm>
           <a:prstGeom prst="rect">
@@ -6644,14 +6668,14 @@
       </p:sp>
       <p:sp>
         <p:nvSpPr>
-          <p:cNvPr id="17" name="TextBox 16"/>
+          <p:cNvPr id="18" name="TextBox 17"/>
           <p:cNvSpPr txBox="1"/>
           <p:nvPr/>
         </p:nvSpPr>
         <p:spPr>
           <a:xfrm>
-            <a:off x="603504" y="4123944"/>
-            <a:ext cx="3447288" cy="512064"/>
+            <a:off x="603504" y="4133087"/>
+            <a:ext cx="3447288" cy="420624"/>
           </a:xfrm>
           <a:prstGeom prst="rect">
             <a:avLst/>
@@ -6678,13 +6702,13 @@
       </p:sp>
       <p:sp>
         <p:nvSpPr>
-          <p:cNvPr id="18" name="TextBox 17"/>
+          <p:cNvPr id="19" name="TextBox 18"/>
           <p:cNvSpPr txBox="1"/>
           <p:nvPr/>
         </p:nvSpPr>
         <p:spPr>
           <a:xfrm>
-            <a:off x="530352" y="4773168"/>
+            <a:off x="530352" y="4663440"/>
             <a:ext cx="3511296" cy="201168"/>
           </a:xfrm>
           <a:prstGeom prst="rect">
@@ -6712,14 +6736,14 @@
       </p:sp>
       <p:sp>
         <p:nvSpPr>
-          <p:cNvPr id="19" name="TextBox 18"/>
+          <p:cNvPr id="20" name="TextBox 19"/>
           <p:cNvSpPr txBox="1"/>
           <p:nvPr/>
         </p:nvSpPr>
         <p:spPr>
           <a:xfrm>
-            <a:off x="603504" y="4992624"/>
-            <a:ext cx="3447288" cy="512064"/>
+            <a:off x="603504" y="4901183"/>
+            <a:ext cx="3447288" cy="420624"/>
           </a:xfrm>
           <a:prstGeom prst="rect">
             <a:avLst/>
@@ -6746,7 +6770,7 @@
       </p:sp>
       <p:sp>
         <p:nvSpPr>
-          <p:cNvPr id="20" name="Rectangle 19"/>
+          <p:cNvPr id="21" name="Rectangle 20"/>
           <p:cNvSpPr/>
           <p:nvPr/>
         </p:nvSpPr>
@@ -6789,7 +6813,7 @@
       </p:sp>
       <p:sp>
         <p:nvSpPr>
-          <p:cNvPr id="21" name="Rectangle 20"/>
+          <p:cNvPr id="22" name="Rectangle 21"/>
           <p:cNvSpPr/>
           <p:nvPr/>
         </p:nvSpPr>
@@ -6830,16 +6854,40 @@
           </a:p>
         </p:txBody>
       </p:sp>
-      <p:sp>
-        <p:nvSpPr>
-          <p:cNvPr id="22" name="TextBox 21"/>
+      <p:pic>
+        <p:nvPicPr>
+          <p:cNvPr id="23" name="Picture 22" descr="clay.png"/>
+          <p:cNvPicPr>
+            <a:picLocks noChangeAspect="1"/>
+          </p:cNvPicPr>
+          <p:nvPr/>
+        </p:nvPicPr>
+        <p:blipFill>
+          <a:blip r:embed="rId5"/>
+          <a:stretch>
+            <a:fillRect/>
+          </a:stretch>
+        </p:blipFill>
+        <p:spPr>
+          <a:xfrm>
+            <a:off x="4389120" y="1993392"/>
+            <a:ext cx="475488" cy="475488"/>
+          </a:xfrm>
+          <a:prstGeom prst="rect">
+            <a:avLst/>
+          </a:prstGeom>
+        </p:spPr>
+      </p:pic>
+      <p:sp>
+        <p:nvSpPr>
+          <p:cNvPr id="24" name="TextBox 23"/>
           <p:cNvSpPr txBox="1"/>
           <p:nvPr/>
         </p:nvSpPr>
         <p:spPr>
           <a:xfrm>
-            <a:off x="4389120" y="1975104"/>
-            <a:ext cx="3511296" cy="438912"/>
+            <a:off x="4974336" y="1993392"/>
+            <a:ext cx="2807208" cy="475488"/>
           </a:xfrm>
           <a:prstGeom prst="rect">
             <a:avLst/>
@@ -6854,26 +6902,26 @@
           <a:p>
             <a:pPr algn="l"/>
             <a:r>
-              <a:rPr sz="2000" b="1" i="0">
+              <a:rPr sz="2400" b="1" i="0">
                 <a:solidFill>
                   <a:srgbClr val="FFFFFF"/>
                 </a:solidFill>
               </a:rPr>
-              <a:t>🏗️  Clay</a:t>
-            </a:r>
-          </a:p>
-        </p:txBody>
-      </p:sp>
-      <p:sp>
-        <p:nvSpPr>
-          <p:cNvPr id="23" name="TextBox 22"/>
+              <a:t>Clay</a:t>
+            </a:r>
+          </a:p>
+        </p:txBody>
+      </p:sp>
+      <p:sp>
+        <p:nvSpPr>
+          <p:cNvPr id="25" name="TextBox 24"/>
           <p:cNvSpPr txBox="1"/>
           <p:nvPr/>
         </p:nvSpPr>
         <p:spPr>
           <a:xfrm>
-            <a:off x="4389120" y="2432304"/>
-            <a:ext cx="3511296" cy="292608"/>
+            <a:off x="4389120" y="2578608"/>
+            <a:ext cx="3511296" cy="256032"/>
           </a:xfrm>
           <a:prstGeom prst="rect">
             <a:avLst/>
@@ -6900,14 +6948,14 @@
       </p:sp>
       <p:sp>
         <p:nvSpPr>
-          <p:cNvPr id="24" name="TextBox 23"/>
+          <p:cNvPr id="26" name="TextBox 25"/>
           <p:cNvSpPr txBox="1"/>
           <p:nvPr/>
         </p:nvSpPr>
         <p:spPr>
           <a:xfrm>
-            <a:off x="4389120" y="2724912"/>
-            <a:ext cx="3511296" cy="201168"/>
+            <a:off x="4389120" y="2834640"/>
+            <a:ext cx="3511296" cy="182880"/>
           </a:xfrm>
           <a:prstGeom prst="rect">
             <a:avLst/>
@@ -6934,13 +6982,13 @@
       </p:sp>
       <p:sp>
         <p:nvSpPr>
-          <p:cNvPr id="25" name="Rectangle 24"/>
+          <p:cNvPr id="27" name="Rectangle 26"/>
           <p:cNvSpPr/>
           <p:nvPr/>
         </p:nvSpPr>
         <p:spPr>
           <a:xfrm>
-            <a:off x="4389120" y="2944368"/>
+            <a:off x="4389120" y="3035808"/>
             <a:ext cx="3465576" cy="18288"/>
           </a:xfrm>
           <a:prstGeom prst="rect">
@@ -6977,13 +7025,13 @@
       </p:sp>
       <p:sp>
         <p:nvSpPr>
-          <p:cNvPr id="26" name="TextBox 25"/>
+          <p:cNvPr id="28" name="TextBox 27"/>
           <p:cNvSpPr txBox="1"/>
           <p:nvPr/>
         </p:nvSpPr>
         <p:spPr>
           <a:xfrm>
-            <a:off x="4389120" y="3035808"/>
+            <a:off x="4389120" y="3127248"/>
             <a:ext cx="3511296" cy="201168"/>
           </a:xfrm>
           <a:prstGeom prst="rect">
@@ -7011,14 +7059,14 @@
       </p:sp>
       <p:sp>
         <p:nvSpPr>
-          <p:cNvPr id="27" name="TextBox 26"/>
+          <p:cNvPr id="29" name="TextBox 28"/>
           <p:cNvSpPr txBox="1"/>
           <p:nvPr/>
         </p:nvSpPr>
         <p:spPr>
           <a:xfrm>
-            <a:off x="4462272" y="3255264"/>
-            <a:ext cx="3447288" cy="512064"/>
+            <a:off x="4462272" y="3364991"/>
+            <a:ext cx="3447288" cy="420624"/>
           </a:xfrm>
           <a:prstGeom prst="rect">
             <a:avLst/>
@@ -7045,14 +7093,14 @@
       </p:sp>
       <p:sp>
         <p:nvSpPr>
-          <p:cNvPr id="28" name="TextBox 27"/>
+          <p:cNvPr id="30" name="TextBox 29"/>
           <p:cNvSpPr txBox="1"/>
           <p:nvPr/>
         </p:nvSpPr>
         <p:spPr>
           <a:xfrm>
-            <a:off x="4389120" y="3904488"/>
-            <a:ext cx="3511296" cy="201168"/>
+            <a:off x="4462272" y="3895344"/>
+            <a:ext cx="3447288" cy="420624"/>
           </a:xfrm>
           <a:prstGeom prst="rect">
             <a:avLst/>
@@ -7067,53 +7115,19 @@
           <a:p>
             <a:pPr algn="l"/>
             <a:r>
-              <a:rPr sz="850" b="1" i="0">
-                <a:solidFill>
-                  <a:srgbClr val="FFFFFF"/>
+              <a:rPr sz="800" b="0" i="1">
+                <a:solidFill>
+                  <a:srgbClr val="8AA8C8"/>
                 </a:solidFill>
               </a:rPr>
-              <a:t>• 11K INCORRECTLY TAGGED ACCOUNTS</a:t>
-            </a:r>
-          </a:p>
-        </p:txBody>
-      </p:sp>
-      <p:sp>
-        <p:nvSpPr>
-          <p:cNvPr id="29" name="TextBox 28"/>
-          <p:cNvSpPr txBox="1"/>
-          <p:nvPr/>
-        </p:nvSpPr>
-        <p:spPr>
-          <a:xfrm>
-            <a:off x="4462272" y="4123944"/>
-            <a:ext cx="3447288" cy="512064"/>
-          </a:xfrm>
-          <a:prstGeom prst="rect">
-            <a:avLst/>
-          </a:prstGeom>
-          <a:noFill/>
-        </p:spPr>
-        <p:txBody>
-          <a:bodyPr wrap="square">
-            <a:spAutoFit/>
-          </a:bodyPr>
-          <a:lstStyle/>
-          <a:p>
-            <a:pPr algn="l"/>
-            <a:r>
-              <a:rPr sz="850" b="0" i="0">
-                <a:solidFill>
-                  <a:srgbClr val="8AA8C8"/>
-                </a:solidFill>
-              </a:rPr>
-              <a:t>Identified 11,000+ accounts incorrectly marked as MSPs — cleaning the CRM foundation for better targeting and scoring.</a:t>
-            </a:r>
-          </a:p>
-        </p:txBody>
-      </p:sp>
-      <p:sp>
-        <p:nvSpPr>
-          <p:cNvPr id="30" name="Rectangle 29"/>
+              <a:t>   ↳ Result: Found 11,000+ accounts incorrectly marked as MSPs — cleaning the CRM foundation for better targeting and scoring.</a:t>
+            </a:r>
+          </a:p>
+        </p:txBody>
+      </p:sp>
+      <p:sp>
+        <p:nvSpPr>
+          <p:cNvPr id="31" name="Rectangle 30"/>
           <p:cNvSpPr/>
           <p:nvPr/>
         </p:nvSpPr>
@@ -7156,7 +7170,7 @@
       </p:sp>
       <p:sp>
         <p:nvSpPr>
-          <p:cNvPr id="31" name="Rectangle 30"/>
+          <p:cNvPr id="32" name="Rectangle 31"/>
           <p:cNvSpPr/>
           <p:nvPr/>
         </p:nvSpPr>
@@ -7197,16 +7211,40 @@
           </a:p>
         </p:txBody>
       </p:sp>
-      <p:sp>
-        <p:nvSpPr>
-          <p:cNvPr id="32" name="TextBox 31"/>
+      <p:pic>
+        <p:nvPicPr>
+          <p:cNvPr id="33" name="Picture 32" descr="outreach.png"/>
+          <p:cNvPicPr>
+            <a:picLocks noChangeAspect="1"/>
+          </p:cNvPicPr>
+          <p:nvPr/>
+        </p:nvPicPr>
+        <p:blipFill>
+          <a:blip r:embed="rId6"/>
+          <a:stretch>
+            <a:fillRect/>
+          </a:stretch>
+        </p:blipFill>
+        <p:spPr>
+          <a:xfrm>
+            <a:off x="8247888" y="1993392"/>
+            <a:ext cx="475488" cy="475488"/>
+          </a:xfrm>
+          <a:prstGeom prst="rect">
+            <a:avLst/>
+          </a:prstGeom>
+        </p:spPr>
+      </p:pic>
+      <p:sp>
+        <p:nvSpPr>
+          <p:cNvPr id="34" name="TextBox 33"/>
           <p:cNvSpPr txBox="1"/>
           <p:nvPr/>
         </p:nvSpPr>
         <p:spPr>
           <a:xfrm>
-            <a:off x="8247888" y="1975104"/>
-            <a:ext cx="3511296" cy="438912"/>
+            <a:off x="8833103" y="1993392"/>
+            <a:ext cx="2807208" cy="475488"/>
           </a:xfrm>
           <a:prstGeom prst="rect">
             <a:avLst/>
@@ -7221,26 +7259,26 @@
           <a:p>
             <a:pPr algn="l"/>
             <a:r>
-              <a:rPr sz="2000" b="1" i="0">
+              <a:rPr sz="2400" b="1" i="0">
                 <a:solidFill>
                   <a:srgbClr val="FFFFFF"/>
                 </a:solidFill>
               </a:rPr>
-              <a:t>📧  Outreach</a:t>
-            </a:r>
-          </a:p>
-        </p:txBody>
-      </p:sp>
-      <p:sp>
-        <p:nvSpPr>
-          <p:cNvPr id="33" name="TextBox 32"/>
+              <a:t>Outreach</a:t>
+            </a:r>
+          </a:p>
+        </p:txBody>
+      </p:sp>
+      <p:sp>
+        <p:nvSpPr>
+          <p:cNvPr id="35" name="TextBox 34"/>
           <p:cNvSpPr txBox="1"/>
           <p:nvPr/>
         </p:nvSpPr>
         <p:spPr>
           <a:xfrm>
-            <a:off x="8247888" y="2432304"/>
-            <a:ext cx="3511296" cy="292608"/>
+            <a:off x="8247888" y="2578608"/>
+            <a:ext cx="3511296" cy="256032"/>
           </a:xfrm>
           <a:prstGeom prst="rect">
             <a:avLst/>
@@ -7267,14 +7305,14 @@
       </p:sp>
       <p:sp>
         <p:nvSpPr>
-          <p:cNvPr id="34" name="TextBox 33"/>
+          <p:cNvPr id="36" name="TextBox 35"/>
           <p:cNvSpPr txBox="1"/>
           <p:nvPr/>
         </p:nvSpPr>
         <p:spPr>
           <a:xfrm>
-            <a:off x="8247888" y="2724912"/>
-            <a:ext cx="3511296" cy="201168"/>
+            <a:off x="8247888" y="2834640"/>
+            <a:ext cx="3511296" cy="182880"/>
           </a:xfrm>
           <a:prstGeom prst="rect">
             <a:avLst/>
@@ -7301,13 +7339,13 @@
       </p:sp>
       <p:sp>
         <p:nvSpPr>
-          <p:cNvPr id="35" name="Rectangle 34"/>
+          <p:cNvPr id="37" name="Rectangle 36"/>
           <p:cNvSpPr/>
           <p:nvPr/>
         </p:nvSpPr>
         <p:spPr>
           <a:xfrm>
-            <a:off x="8247888" y="2944368"/>
+            <a:off x="8247888" y="3035808"/>
             <a:ext cx="3465576" cy="18288"/>
           </a:xfrm>
           <a:prstGeom prst="rect">
@@ -7344,13 +7382,13 @@
       </p:sp>
       <p:sp>
         <p:nvSpPr>
-          <p:cNvPr id="36" name="TextBox 35"/>
+          <p:cNvPr id="38" name="TextBox 37"/>
           <p:cNvSpPr txBox="1"/>
           <p:nvPr/>
         </p:nvSpPr>
         <p:spPr>
           <a:xfrm>
-            <a:off x="8247888" y="3035808"/>
+            <a:off x="8247888" y="3127248"/>
             <a:ext cx="3511296" cy="201168"/>
           </a:xfrm>
           <a:prstGeom prst="rect">
@@ -7378,14 +7416,14 @@
       </p:sp>
       <p:sp>
         <p:nvSpPr>
-          <p:cNvPr id="37" name="TextBox 36"/>
+          <p:cNvPr id="39" name="TextBox 38"/>
           <p:cNvSpPr txBox="1"/>
           <p:nvPr/>
         </p:nvSpPr>
         <p:spPr>
           <a:xfrm>
-            <a:off x="8321040" y="3255264"/>
-            <a:ext cx="3447288" cy="512064"/>
+            <a:off x="8321040" y="3364991"/>
+            <a:ext cx="3447288" cy="420624"/>
           </a:xfrm>
           <a:prstGeom prst="rect">
             <a:avLst/>
@@ -7405,20 +7443,20 @@
                   <a:srgbClr val="8AA8C8"/>
                 </a:solidFill>
               </a:rPr>
-              <a:t>MSP team has dedicated agents that automatically add contacts into specific sequences daily — based on persona, industry, and time since last engagement.</a:t>
-            </a:r>
-          </a:p>
-        </p:txBody>
-      </p:sp>
-      <p:sp>
-        <p:nvSpPr>
-          <p:cNvPr id="38" name="TextBox 37"/>
+              <a:t>MSP team agents automatically add contacts into specific sequences daily — based on persona, industry, and time since last engagement.</a:t>
+            </a:r>
+          </a:p>
+        </p:txBody>
+      </p:sp>
+      <p:sp>
+        <p:nvSpPr>
+          <p:cNvPr id="40" name="TextBox 39"/>
           <p:cNvSpPr txBox="1"/>
           <p:nvPr/>
         </p:nvSpPr>
         <p:spPr>
           <a:xfrm>
-            <a:off x="8247888" y="3904488"/>
+            <a:off x="8247888" y="3895344"/>
             <a:ext cx="3511296" cy="201168"/>
           </a:xfrm>
           <a:prstGeom prst="rect">
@@ -7446,14 +7484,14 @@
       </p:sp>
       <p:sp>
         <p:nvSpPr>
-          <p:cNvPr id="39" name="TextBox 38"/>
+          <p:cNvPr id="41" name="TextBox 40"/>
           <p:cNvSpPr txBox="1"/>
           <p:nvPr/>
         </p:nvSpPr>
         <p:spPr>
           <a:xfrm>
-            <a:off x="8321040" y="4123944"/>
-            <a:ext cx="3447288" cy="512064"/>
+            <a:off x="8321040" y="4133087"/>
+            <a:ext cx="3447288" cy="420624"/>
           </a:xfrm>
           <a:prstGeom prst="rect">
             <a:avLst/>
@@ -7473,14 +7511,14 @@
                   <a:srgbClr val="8AA8C8"/>
                 </a:solidFill>
               </a:rPr>
-              <a:t>Removed the daily decision-making and time spent manually adding prospects to sequences. Reps focus on selling, not admin.</a:t>
-            </a:r>
-          </a:p>
-        </p:txBody>
-      </p:sp>
-      <p:sp>
-        <p:nvSpPr>
-          <p:cNvPr id="40" name="Rectangle 39"/>
+              <a:t>Removed daily decision-making and time spent manually adding prospects to sequences. Reps focus on selling, not admin.</a:t>
+            </a:r>
+          </a:p>
+        </p:txBody>
+      </p:sp>
+      <p:sp>
+        <p:nvSpPr>
+          <p:cNvPr id="42" name="Rectangle 41"/>
           <p:cNvSpPr/>
           <p:nvPr/>
         </p:nvSpPr>
@@ -7523,7 +7561,7 @@
       </p:sp>
       <p:sp>
         <p:nvSpPr>
-          <p:cNvPr id="41" name="TextBox 40"/>
+          <p:cNvPr id="43" name="TextBox 42"/>
           <p:cNvSpPr txBox="1"/>
           <p:nvPr/>
         </p:nvSpPr>
@@ -7557,7 +7595,7 @@
       </p:sp>
       <p:sp>
         <p:nvSpPr>
-          <p:cNvPr id="42" name="TextBox 41"/>
+          <p:cNvPr id="44" name="TextBox 43"/>
           <p:cNvSpPr txBox="1"/>
           <p:nvPr/>
         </p:nvSpPr>
@@ -7591,7 +7629,7 @@
       </p:sp>
       <p:sp>
         <p:nvSpPr>
-          <p:cNvPr id="43" name="TextBox 42"/>
+          <p:cNvPr id="45" name="TextBox 44"/>
           <p:cNvSpPr txBox="1"/>
           <p:nvPr/>
         </p:nvSpPr>

</xml_diff>

<commit_message>
Add Clay verification screenshot to tool stack
</commit_message>
<xml_diff>
--- a/Robin-Intro-Slide.pptx
+++ b/Robin-Intro-Slide.pptx
@@ -7125,9 +7125,33 @@
           </a:p>
         </p:txBody>
       </p:sp>
-      <p:sp>
-        <p:nvSpPr>
-          <p:cNvPr id="31" name="Rectangle 30"/>
+      <p:pic>
+        <p:nvPicPr>
+          <p:cNvPr id="31" name="Picture 30" descr="clay-screenshot.png"/>
+          <p:cNvPicPr>
+            <a:picLocks noChangeAspect="1"/>
+          </p:cNvPicPr>
+          <p:nvPr/>
+        </p:nvPicPr>
+        <p:blipFill>
+          <a:blip r:embed="rId6"/>
+          <a:stretch>
+            <a:fillRect/>
+          </a:stretch>
+        </p:blipFill>
+        <p:spPr>
+          <a:xfrm>
+            <a:off x="4389120" y="4462271"/>
+            <a:ext cx="3410712" cy="1856463"/>
+          </a:xfrm>
+          <a:prstGeom prst="rect">
+            <a:avLst/>
+          </a:prstGeom>
+        </p:spPr>
+      </p:pic>
+      <p:sp>
+        <p:nvSpPr>
+          <p:cNvPr id="32" name="Rectangle 31"/>
           <p:cNvSpPr/>
           <p:nvPr/>
         </p:nvSpPr>
@@ -7170,7 +7194,7 @@
       </p:sp>
       <p:sp>
         <p:nvSpPr>
-          <p:cNvPr id="32" name="Rectangle 31"/>
+          <p:cNvPr id="33" name="Rectangle 32"/>
           <p:cNvSpPr/>
           <p:nvPr/>
         </p:nvSpPr>
@@ -7213,14 +7237,14 @@
       </p:sp>
       <p:pic>
         <p:nvPicPr>
-          <p:cNvPr id="33" name="Picture 32" descr="outreach.png"/>
+          <p:cNvPr id="34" name="Picture 33" descr="outreach.png"/>
           <p:cNvPicPr>
             <a:picLocks noChangeAspect="1"/>
           </p:cNvPicPr>
           <p:nvPr/>
         </p:nvPicPr>
         <p:blipFill>
-          <a:blip r:embed="rId6"/>
+          <a:blip r:embed="rId7"/>
           <a:stretch>
             <a:fillRect/>
           </a:stretch>
@@ -7237,7 +7261,7 @@
       </p:pic>
       <p:sp>
         <p:nvSpPr>
-          <p:cNvPr id="34" name="TextBox 33"/>
+          <p:cNvPr id="35" name="TextBox 34"/>
           <p:cNvSpPr txBox="1"/>
           <p:nvPr/>
         </p:nvSpPr>
@@ -7271,7 +7295,7 @@
       </p:sp>
       <p:sp>
         <p:nvSpPr>
-          <p:cNvPr id="35" name="TextBox 34"/>
+          <p:cNvPr id="36" name="TextBox 35"/>
           <p:cNvSpPr txBox="1"/>
           <p:nvPr/>
         </p:nvSpPr>
@@ -7305,7 +7329,7 @@
       </p:sp>
       <p:sp>
         <p:nvSpPr>
-          <p:cNvPr id="36" name="TextBox 35"/>
+          <p:cNvPr id="37" name="TextBox 36"/>
           <p:cNvSpPr txBox="1"/>
           <p:nvPr/>
         </p:nvSpPr>
@@ -7339,7 +7363,7 @@
       </p:sp>
       <p:sp>
         <p:nvSpPr>
-          <p:cNvPr id="37" name="Rectangle 36"/>
+          <p:cNvPr id="38" name="Rectangle 37"/>
           <p:cNvSpPr/>
           <p:nvPr/>
         </p:nvSpPr>
@@ -7382,7 +7406,7 @@
       </p:sp>
       <p:sp>
         <p:nvSpPr>
-          <p:cNvPr id="38" name="TextBox 37"/>
+          <p:cNvPr id="39" name="TextBox 38"/>
           <p:cNvSpPr txBox="1"/>
           <p:nvPr/>
         </p:nvSpPr>
@@ -7416,7 +7440,7 @@
       </p:sp>
       <p:sp>
         <p:nvSpPr>
-          <p:cNvPr id="39" name="TextBox 38"/>
+          <p:cNvPr id="40" name="TextBox 39"/>
           <p:cNvSpPr txBox="1"/>
           <p:nvPr/>
         </p:nvSpPr>
@@ -7450,7 +7474,7 @@
       </p:sp>
       <p:sp>
         <p:nvSpPr>
-          <p:cNvPr id="40" name="TextBox 39"/>
+          <p:cNvPr id="41" name="TextBox 40"/>
           <p:cNvSpPr txBox="1"/>
           <p:nvPr/>
         </p:nvSpPr>
@@ -7484,7 +7508,7 @@
       </p:sp>
       <p:sp>
         <p:nvSpPr>
-          <p:cNvPr id="41" name="TextBox 40"/>
+          <p:cNvPr id="42" name="TextBox 41"/>
           <p:cNvSpPr txBox="1"/>
           <p:nvPr/>
         </p:nvSpPr>
@@ -7518,7 +7542,7 @@
       </p:sp>
       <p:sp>
         <p:nvSpPr>
-          <p:cNvPr id="42" name="Rectangle 41"/>
+          <p:cNvPr id="43" name="Rectangle 42"/>
           <p:cNvSpPr/>
           <p:nvPr/>
         </p:nvSpPr>
@@ -7561,7 +7585,7 @@
       </p:sp>
       <p:sp>
         <p:nvSpPr>
-          <p:cNvPr id="43" name="TextBox 42"/>
+          <p:cNvPr id="44" name="TextBox 43"/>
           <p:cNvSpPr txBox="1"/>
           <p:nvPr/>
         </p:nvSpPr>
@@ -7595,7 +7619,7 @@
       </p:sp>
       <p:sp>
         <p:nvSpPr>
-          <p:cNvPr id="44" name="TextBox 43"/>
+          <p:cNvPr id="45" name="TextBox 44"/>
           <p:cNvSpPr txBox="1"/>
           <p:nvPr/>
         </p:nvSpPr>
@@ -7629,7 +7653,7 @@
       </p:sp>
       <p:sp>
         <p:nvSpPr>
-          <p:cNvPr id="45" name="TextBox 44"/>
+          <p:cNvPr id="46" name="TextBox 45"/>
           <p:cNvSpPr txBox="1"/>
           <p:nvPr/>
         </p:nvSpPr>

</xml_diff>

<commit_message>
Slide 1: Robin + Marvin side by side - Meet Our AI Sales Team
</commit_message>
<xml_diff>
--- a/Robin-Intro-Slide.pptx
+++ b/Robin-Intro-Slide.pptx
@@ -4800,7 +4800,7 @@
         <p:spPr>
           <a:xfrm>
             <a:off x="365760" y="164592"/>
-            <a:ext cx="11430000" cy="658368"/>
+            <a:ext cx="11430000" cy="621792"/>
           </a:xfrm>
           <a:prstGeom prst="rect">
             <a:avLst/>
@@ -4815,12 +4815,12 @@
           <a:p>
             <a:pPr algn="l"/>
             <a:r>
-              <a:rPr sz="4400" b="1" i="0">
+              <a:rPr sz="4000" b="1" i="0">
                 <a:solidFill>
                   <a:srgbClr val="FFFFFF"/>
                 </a:solidFill>
               </a:rPr>
-              <a:t>Meet Robin</a:t>
+              <a:t>Meet Our AI Sales Team</a:t>
             </a:r>
           </a:p>
         </p:txBody>
@@ -4833,8 +4833,8 @@
         </p:nvSpPr>
         <p:spPr>
           <a:xfrm>
-            <a:off x="365760" y="822960"/>
-            <a:ext cx="11430000" cy="274320"/>
+            <a:off x="365760" y="804672"/>
+            <a:ext cx="11430000" cy="310896"/>
           </a:xfrm>
           <a:prstGeom prst="rect">
             <a:avLst/>
@@ -4849,12 +4849,12 @@
           <a:p>
             <a:pPr algn="l"/>
             <a:r>
-              <a:rPr sz="1250" b="0" i="0">
+              <a:rPr sz="1150" b="0" i="0">
                 <a:solidFill>
                   <a:srgbClr val="8AA8C8"/>
                 </a:solidFill>
               </a:rPr>
-              <a:t>Rev.io's AI Sales Assistant — running 24/7 to power the sales team.</a:t>
+              <a:t>Two AI agents — Robin and Marvin — running 24/7 to drive pipeline, automate intelligence, and scale execution for Rev.io's sales growth.</a:t>
             </a:r>
           </a:p>
         </p:txBody>
@@ -4868,7 +4868,7 @@
         <p:spPr>
           <a:xfrm>
             <a:off x="365760" y="1188720"/>
-            <a:ext cx="11457432" cy="566928"/>
+            <a:ext cx="11457432" cy="548640"/>
           </a:xfrm>
           <a:prstGeom prst="rect">
             <a:avLst/>
@@ -4911,7 +4911,7 @@
         <p:spPr>
           <a:xfrm>
             <a:off x="365760" y="1188720"/>
-            <a:ext cx="45720" cy="566928"/>
+            <a:ext cx="45720" cy="548640"/>
           </a:xfrm>
           <a:prstGeom prst="rect">
             <a:avLst/>
@@ -4974,7 +4974,7 @@
                   <a:srgbClr val="3DC570"/>
                 </a:solidFill>
               </a:rPr>
-              <a:t>WHAT ROBIN DOES</a:t>
+              <a:t>SHARED MANDATE</a:t>
             </a:r>
           </a:p>
         </p:txBody>
@@ -4988,7 +4988,7 @@
         <p:spPr>
           <a:xfrm>
             <a:off x="502920" y="1380744"/>
-            <a:ext cx="11155680" cy="310896"/>
+            <a:ext cx="11155680" cy="292608"/>
           </a:xfrm>
           <a:prstGeom prst="rect">
             <a:avLst/>
@@ -5003,12 +5003,12 @@
           <a:p>
             <a:pPr algn="l"/>
             <a:r>
-              <a:rPr sz="1050" b="0" i="0">
+              <a:rPr sz="1000" b="0" i="0">
                 <a:solidFill>
                   <a:srgbClr val="FFFFFF"/>
                 </a:solidFill>
               </a:rPr>
-              <a:t>Built for the Rev.io sales team — automating intelligence, research, and execution so reps spend more time selling.</a:t>
+              <a:t>Both agents are focused on two things: accelerating revenue by giving the sales and channel teams better intelligence and tools — and improving efficiency by automating work that shouldn't require a human.</a:t>
             </a:r>
           </a:p>
         </p:txBody>
@@ -5021,8 +5021,8 @@
         </p:nvSpPr>
         <p:spPr>
           <a:xfrm>
-            <a:off x="365760" y="1865376"/>
-            <a:ext cx="11457432" cy="4809744"/>
+            <a:off x="365760" y="1847088"/>
+            <a:ext cx="5655564" cy="4828032"/>
           </a:xfrm>
           <a:prstGeom prst="rect">
             <a:avLst/>
@@ -5064,8 +5064,8 @@
         </p:nvSpPr>
         <p:spPr>
           <a:xfrm>
-            <a:off x="365760" y="1865376"/>
-            <a:ext cx="45720" cy="4809744"/>
+            <a:off x="365760" y="1847088"/>
+            <a:ext cx="45720" cy="4828032"/>
           </a:xfrm>
           <a:prstGeom prst="rect">
             <a:avLst/>
@@ -5107,8 +5107,8 @@
         </p:nvSpPr>
         <p:spPr>
           <a:xfrm>
-            <a:off x="566928" y="1975104"/>
-            <a:ext cx="7315200" cy="475488"/>
+            <a:off x="530352" y="1938528"/>
+            <a:ext cx="5426964" cy="438912"/>
           </a:xfrm>
           <a:prstGeom prst="rect">
             <a:avLst/>
@@ -5123,7 +5123,7 @@
           <a:p>
             <a:pPr algn="l"/>
             <a:r>
-              <a:rPr sz="3200" b="1" i="0">
+              <a:rPr sz="2600" b="1" i="0">
                 <a:solidFill>
                   <a:srgbClr val="FFFFFF"/>
                 </a:solidFill>
@@ -5141,8 +5141,8 @@
         </p:nvSpPr>
         <p:spPr>
           <a:xfrm>
-            <a:off x="566928" y="2468880"/>
-            <a:ext cx="8229600" cy="256032"/>
+            <a:off x="530352" y="2395728"/>
+            <a:ext cx="5426964" cy="256032"/>
           </a:xfrm>
           <a:prstGeom prst="rect">
             <a:avLst/>
@@ -5157,7 +5157,7 @@
           <a:p>
             <a:pPr algn="l"/>
             <a:r>
-              <a:rPr sz="1300" b="0" i="0">
+              <a:rPr sz="1100" b="0" i="0">
                 <a:solidFill>
                   <a:srgbClr val="00D4D4"/>
                 </a:solidFill>
@@ -5175,8 +5175,8 @@
         </p:nvSpPr>
         <p:spPr>
           <a:xfrm>
-            <a:off x="566928" y="2734056"/>
-            <a:ext cx="6400800" cy="219456"/>
+            <a:off x="530352" y="2651760"/>
+            <a:ext cx="5426964" cy="201168"/>
           </a:xfrm>
           <a:prstGeom prst="rect">
             <a:avLst/>
@@ -5191,7 +5191,7 @@
           <a:p>
             <a:pPr algn="l"/>
             <a:r>
-              <a:rPr sz="1000" b="0" i="1">
+              <a:rPr sz="900" b="0" i="1">
                 <a:solidFill>
                   <a:srgbClr val="8AA8C8"/>
                 </a:solidFill>
@@ -5209,8 +5209,8 @@
         </p:nvSpPr>
         <p:spPr>
           <a:xfrm>
-            <a:off x="566928" y="2980944"/>
-            <a:ext cx="11055096" cy="18288"/>
+            <a:off x="530352" y="2871216"/>
+            <a:ext cx="5381244" cy="18288"/>
           </a:xfrm>
           <a:prstGeom prst="rect">
             <a:avLst/>
@@ -5252,8 +5252,8 @@
         </p:nvSpPr>
         <p:spPr>
           <a:xfrm>
-            <a:off x="566928" y="3054096"/>
-            <a:ext cx="5500116" cy="182880"/>
+            <a:off x="530352" y="2944368"/>
+            <a:ext cx="5381244" cy="182880"/>
           </a:xfrm>
           <a:prstGeom prst="rect">
             <a:avLst/>
@@ -5268,7 +5268,7 @@
           <a:p>
             <a:pPr algn="l"/>
             <a:r>
-              <a:rPr sz="800" b="1" i="0">
+              <a:rPr sz="750" b="1" i="0">
                 <a:solidFill>
                   <a:srgbClr val="3DC570"/>
                 </a:solidFill>
@@ -5286,8 +5286,8 @@
         </p:nvSpPr>
         <p:spPr>
           <a:xfrm>
-            <a:off x="621792" y="3255264"/>
-            <a:ext cx="5408676" cy="219456"/>
+            <a:off x="603504" y="3136391"/>
+            <a:ext cx="5308092" cy="201168"/>
           </a:xfrm>
           <a:prstGeom prst="rect">
             <a:avLst/>
@@ -5302,7 +5302,7 @@
           <a:p>
             <a:pPr algn="l"/>
             <a:r>
-              <a:rPr sz="800" b="0" i="0">
+              <a:rPr sz="780" b="0" i="0">
                 <a:solidFill>
                   <a:srgbClr val="FFFFFF"/>
                 </a:solidFill>
@@ -5320,8 +5320,8 @@
         </p:nvSpPr>
         <p:spPr>
           <a:xfrm>
-            <a:off x="621792" y="3493008"/>
-            <a:ext cx="5408676" cy="219456"/>
+            <a:off x="603504" y="3355848"/>
+            <a:ext cx="5308092" cy="201168"/>
           </a:xfrm>
           <a:prstGeom prst="rect">
             <a:avLst/>
@@ -5336,7 +5336,7 @@
           <a:p>
             <a:pPr algn="l"/>
             <a:r>
-              <a:rPr sz="800" b="0" i="0">
+              <a:rPr sz="780" b="0" i="0">
                 <a:solidFill>
                   <a:srgbClr val="FFFFFF"/>
                 </a:solidFill>
@@ -5354,8 +5354,8 @@
         </p:nvSpPr>
         <p:spPr>
           <a:xfrm>
-            <a:off x="621792" y="3730752"/>
-            <a:ext cx="5408676" cy="219456"/>
+            <a:off x="603504" y="3575304"/>
+            <a:ext cx="5308092" cy="201168"/>
           </a:xfrm>
           <a:prstGeom prst="rect">
             <a:avLst/>
@@ -5370,7 +5370,7 @@
           <a:p>
             <a:pPr algn="l"/>
             <a:r>
-              <a:rPr sz="800" b="0" i="0">
+              <a:rPr sz="780" b="0" i="0">
                 <a:solidFill>
                   <a:srgbClr val="FFFFFF"/>
                 </a:solidFill>
@@ -5388,8 +5388,8 @@
         </p:nvSpPr>
         <p:spPr>
           <a:xfrm>
-            <a:off x="566928" y="4059935"/>
-            <a:ext cx="5500116" cy="182880"/>
+            <a:off x="530352" y="3867912"/>
+            <a:ext cx="5381244" cy="182880"/>
           </a:xfrm>
           <a:prstGeom prst="rect">
             <a:avLst/>
@@ -5404,7 +5404,7 @@
           <a:p>
             <a:pPr algn="l"/>
             <a:r>
-              <a:rPr sz="800" b="1" i="0">
+              <a:rPr sz="750" b="1" i="0">
                 <a:solidFill>
                   <a:srgbClr val="3DC570"/>
                 </a:solidFill>
@@ -5422,8 +5422,8 @@
         </p:nvSpPr>
         <p:spPr>
           <a:xfrm>
-            <a:off x="621792" y="4261103"/>
-            <a:ext cx="5408676" cy="219456"/>
+            <a:off x="603504" y="4059936"/>
+            <a:ext cx="5308092" cy="201168"/>
           </a:xfrm>
           <a:prstGeom prst="rect">
             <a:avLst/>
@@ -5438,12 +5438,12 @@
           <a:p>
             <a:pPr algn="l"/>
             <a:r>
-              <a:rPr sz="800" b="0" i="0">
+              <a:rPr sz="780" b="0" i="0">
                 <a:solidFill>
                   <a:srgbClr val="FFFFFF"/>
                 </a:solidFill>
               </a:rPr>
-              <a:t>· Daily activity scorecard — calls, emails, meetings, opps sourced (Tue–Fri)</a:t>
+              <a:t>· Daily activity scorecard — calls, emails, meetings, opps sourced</a:t>
             </a:r>
           </a:p>
         </p:txBody>
@@ -5456,8 +5456,8 @@
         </p:nvSpPr>
         <p:spPr>
           <a:xfrm>
-            <a:off x="621792" y="4498847"/>
-            <a:ext cx="5408676" cy="219456"/>
+            <a:off x="603504" y="4279392"/>
+            <a:ext cx="5308092" cy="201168"/>
           </a:xfrm>
           <a:prstGeom prst="rect">
             <a:avLst/>
@@ -5472,7 +5472,7 @@
           <a:p>
             <a:pPr algn="l"/>
             <a:r>
-              <a:rPr sz="800" b="0" i="0">
+              <a:rPr sz="780" b="0" i="0">
                 <a:solidFill>
                   <a:srgbClr val="FFFFFF"/>
                 </a:solidFill>
@@ -5490,8 +5490,8 @@
         </p:nvSpPr>
         <p:spPr>
           <a:xfrm>
-            <a:off x="621792" y="4736591"/>
-            <a:ext cx="5408676" cy="219456"/>
+            <a:off x="530352" y="4572000"/>
+            <a:ext cx="5381244" cy="182880"/>
           </a:xfrm>
           <a:prstGeom prst="rect">
             <a:avLst/>
@@ -5506,12 +5506,12 @@
           <a:p>
             <a:pPr algn="l"/>
             <a:r>
-              <a:rPr sz="800" b="0" i="0">
-                <a:solidFill>
-                  <a:srgbClr val="FFFFFF"/>
+              <a:rPr sz="750" b="1" i="0">
+                <a:solidFill>
+                  <a:srgbClr val="3DC570"/>
                 </a:solidFill>
               </a:rPr>
-              <a:t>· Weekly call blitz support</a:t>
+              <a:t>PROSPECTING &amp; INTELLIGENCE</a:t>
             </a:r>
           </a:p>
         </p:txBody>
@@ -5524,8 +5524,8 @@
         </p:nvSpPr>
         <p:spPr>
           <a:xfrm>
-            <a:off x="566928" y="5065775"/>
-            <a:ext cx="5500116" cy="182880"/>
+            <a:off x="603504" y="4764024"/>
+            <a:ext cx="5308092" cy="201168"/>
           </a:xfrm>
           <a:prstGeom prst="rect">
             <a:avLst/>
@@ -5540,12 +5540,12 @@
           <a:p>
             <a:pPr algn="l"/>
             <a:r>
-              <a:rPr sz="800" b="1" i="0">
-                <a:solidFill>
-                  <a:srgbClr val="3DC570"/>
+              <a:rPr sz="780" b="0" i="0">
+                <a:solidFill>
+                  <a:srgbClr val="FFFFFF"/>
                 </a:solidFill>
               </a:rPr>
-              <a:t>PROSPECTING &amp; INTELLIGENCE</a:t>
+              <a:t>· Daily MSP prospector — 5 net-new accounts every morning not in SF</a:t>
             </a:r>
           </a:p>
         </p:txBody>
@@ -5558,8 +5558,8 @@
         </p:nvSpPr>
         <p:spPr>
           <a:xfrm>
-            <a:off x="621792" y="5266943"/>
-            <a:ext cx="5408676" cy="219456"/>
+            <a:off x="603504" y="4983480"/>
+            <a:ext cx="5308092" cy="201168"/>
           </a:xfrm>
           <a:prstGeom prst="rect">
             <a:avLst/>
@@ -5574,12 +5574,12 @@
           <a:p>
             <a:pPr algn="l"/>
             <a:r>
-              <a:rPr sz="800" b="0" i="0">
+              <a:rPr sz="780" b="0" i="0">
                 <a:solidFill>
                   <a:srgbClr val="FFFFFF"/>
                 </a:solidFill>
               </a:rPr>
-              <a:t>· Daily MSP prospector — 5 net-new accounts every morning not in SF</a:t>
+              <a:t>· Morning briefings Mon–Fri — schedule + weather</a:t>
             </a:r>
           </a:p>
         </p:txBody>
@@ -5592,8 +5592,8 @@
         </p:nvSpPr>
         <p:spPr>
           <a:xfrm>
-            <a:off x="621792" y="5504687"/>
-            <a:ext cx="5408676" cy="219456"/>
+            <a:off x="530352" y="5276088"/>
+            <a:ext cx="5381244" cy="182880"/>
           </a:xfrm>
           <a:prstGeom prst="rect">
             <a:avLst/>
@@ -5608,12 +5608,12 @@
           <a:p>
             <a:pPr algn="l"/>
             <a:r>
-              <a:rPr sz="800" b="0" i="0">
-                <a:solidFill>
-                  <a:srgbClr val="FFFFFF"/>
+              <a:rPr sz="750" b="1" i="0">
+                <a:solidFill>
+                  <a:srgbClr val="3DC570"/>
                 </a:solidFill>
               </a:rPr>
-              <a:t>· Rev.io mention monitor — daily web scan, alerts on noteworthy coverage</a:t>
+              <a:t>COACHING &amp; ANALYTICS</a:t>
             </a:r>
           </a:p>
         </p:txBody>
@@ -5626,8 +5626,8 @@
         </p:nvSpPr>
         <p:spPr>
           <a:xfrm>
-            <a:off x="621792" y="5742431"/>
-            <a:ext cx="5408676" cy="219456"/>
+            <a:off x="603504" y="5468112"/>
+            <a:ext cx="5308092" cy="201168"/>
           </a:xfrm>
           <a:prstGeom prst="rect">
             <a:avLst/>
@@ -5642,12 +5642,12 @@
           <a:p>
             <a:pPr algn="l"/>
             <a:r>
-              <a:rPr sz="800" b="0" i="0">
+              <a:rPr sz="780" b="0" i="0">
                 <a:solidFill>
                   <a:srgbClr val="FFFFFF"/>
                 </a:solidFill>
               </a:rPr>
-              <a:t>· Morning briefings Mon–Fri — schedule + weather</a:t>
+              <a:t>· Discovery call grading — BEACON framework, 6 categories, 100 pts</a:t>
             </a:r>
           </a:p>
         </p:txBody>
@@ -5660,8 +5660,8 @@
         </p:nvSpPr>
         <p:spPr>
           <a:xfrm>
-            <a:off x="6158483" y="3054096"/>
-            <a:ext cx="5500116" cy="182880"/>
+            <a:off x="603504" y="5687568"/>
+            <a:ext cx="5308092" cy="201168"/>
           </a:xfrm>
           <a:prstGeom prst="rect">
             <a:avLst/>
@@ -5676,12 +5676,12 @@
           <a:p>
             <a:pPr algn="l"/>
             <a:r>
-              <a:rPr sz="800" b="1" i="0">
-                <a:solidFill>
-                  <a:srgbClr val="3DC570"/>
+              <a:rPr sz="780" b="0" i="0">
+                <a:solidFill>
+                  <a:srgbClr val="FFFFFF"/>
                 </a:solidFill>
               </a:rPr>
-              <a:t>COACHING &amp; ANALYTICS</a:t>
+              <a:t>· Closed loss analysis — Feb vs March trends + coaching actions</a:t>
             </a:r>
           </a:p>
         </p:txBody>
@@ -5694,8 +5694,8 @@
         </p:nvSpPr>
         <p:spPr>
           <a:xfrm>
-            <a:off x="6213347" y="3255264"/>
-            <a:ext cx="5408676" cy="219456"/>
+            <a:off x="530352" y="5980176"/>
+            <a:ext cx="5381244" cy="182880"/>
           </a:xfrm>
           <a:prstGeom prst="rect">
             <a:avLst/>
@@ -5710,12 +5710,12 @@
           <a:p>
             <a:pPr algn="l"/>
             <a:r>
-              <a:rPr sz="800" b="0" i="0">
-                <a:solidFill>
-                  <a:srgbClr val="FFFFFF"/>
+              <a:rPr sz="750" b="1" i="0">
+                <a:solidFill>
+                  <a:srgbClr val="3DC570"/>
                 </a:solidFill>
               </a:rPr>
-              <a:t>· Discovery call grading — BEACON framework, 6 categories, 100 pts</a:t>
+              <a:t>RESEARCH &amp; CONTENT</a:t>
             </a:r>
           </a:p>
         </p:txBody>
@@ -5728,8 +5728,8 @@
         </p:nvSpPr>
         <p:spPr>
           <a:xfrm>
-            <a:off x="6213347" y="3493008"/>
-            <a:ext cx="5408676" cy="219456"/>
+            <a:off x="603504" y="6172200"/>
+            <a:ext cx="5308092" cy="201168"/>
           </a:xfrm>
           <a:prstGeom prst="rect">
             <a:avLst/>
@@ -5744,12 +5744,12 @@
           <a:p>
             <a:pPr algn="l"/>
             <a:r>
-              <a:rPr sz="800" b="0" i="0">
+              <a:rPr sz="780" b="0" i="0">
                 <a:solidFill>
                   <a:srgbClr val="FFFFFF"/>
                 </a:solidFill>
               </a:rPr>
-              <a:t>· Closed loss analysis — Feb vs March trends + coaching actions</a:t>
+              <a:t>· Competitive battle card dashboard  ·  MSP PSA requirements deck</a:t>
             </a:r>
           </a:p>
         </p:txBody>
@@ -5762,8 +5762,8 @@
         </p:nvSpPr>
         <p:spPr>
           <a:xfrm>
-            <a:off x="6213347" y="3730752"/>
-            <a:ext cx="5408676" cy="219456"/>
+            <a:off x="603504" y="6391656"/>
+            <a:ext cx="5308092" cy="201168"/>
           </a:xfrm>
           <a:prstGeom prst="rect">
             <a:avLst/>
@@ -5778,143 +5778,7 @@
           <a:p>
             <a:pPr algn="l"/>
             <a:r>
-              <a:rPr sz="800" b="0" i="0">
-                <a:solidFill>
-                  <a:srgbClr val="FFFFFF"/>
-                </a:solidFill>
-              </a:rPr>
-              <a:t>· Loss reason deep dives — no-show, missing capabilities</a:t>
-            </a:r>
-          </a:p>
-        </p:txBody>
-      </p:sp>
-      <p:sp>
-        <p:nvSpPr>
-          <p:cNvPr id="30" name="TextBox 29"/>
-          <p:cNvSpPr txBox="1"/>
-          <p:nvPr/>
-        </p:nvSpPr>
-        <p:spPr>
-          <a:xfrm>
-            <a:off x="6158483" y="4059935"/>
-            <a:ext cx="5500116" cy="182880"/>
-          </a:xfrm>
-          <a:prstGeom prst="rect">
-            <a:avLst/>
-          </a:prstGeom>
-          <a:noFill/>
-        </p:spPr>
-        <p:txBody>
-          <a:bodyPr wrap="square">
-            <a:spAutoFit/>
-          </a:bodyPr>
-          <a:lstStyle/>
-          <a:p>
-            <a:pPr algn="l"/>
-            <a:r>
-              <a:rPr sz="800" b="1" i="0">
-                <a:solidFill>
-                  <a:srgbClr val="3DC570"/>
-                </a:solidFill>
-              </a:rPr>
-              <a:t>RESEARCH &amp; CONTENT</a:t>
-            </a:r>
-          </a:p>
-        </p:txBody>
-      </p:sp>
-      <p:sp>
-        <p:nvSpPr>
-          <p:cNvPr id="31" name="TextBox 30"/>
-          <p:cNvSpPr txBox="1"/>
-          <p:nvPr/>
-        </p:nvSpPr>
-        <p:spPr>
-          <a:xfrm>
-            <a:off x="6213347" y="4261103"/>
-            <a:ext cx="5408676" cy="219456"/>
-          </a:xfrm>
-          <a:prstGeom prst="rect">
-            <a:avLst/>
-          </a:prstGeom>
-          <a:noFill/>
-        </p:spPr>
-        <p:txBody>
-          <a:bodyPr wrap="square">
-            <a:spAutoFit/>
-          </a:bodyPr>
-          <a:lstStyle/>
-          <a:p>
-            <a:pPr algn="l"/>
-            <a:r>
-              <a:rPr sz="800" b="0" i="0">
-                <a:solidFill>
-                  <a:srgbClr val="FFFFFF"/>
-                </a:solidFill>
-              </a:rPr>
-              <a:t>· Competitive battle card dashboard</a:t>
-            </a:r>
-          </a:p>
-        </p:txBody>
-      </p:sp>
-      <p:sp>
-        <p:nvSpPr>
-          <p:cNvPr id="32" name="TextBox 31"/>
-          <p:cNvSpPr txBox="1"/>
-          <p:nvPr/>
-        </p:nvSpPr>
-        <p:spPr>
-          <a:xfrm>
-            <a:off x="6213347" y="4498847"/>
-            <a:ext cx="5408676" cy="219456"/>
-          </a:xfrm>
-          <a:prstGeom prst="rect">
-            <a:avLst/>
-          </a:prstGeom>
-          <a:noFill/>
-        </p:spPr>
-        <p:txBody>
-          <a:bodyPr wrap="square">
-            <a:spAutoFit/>
-          </a:bodyPr>
-          <a:lstStyle/>
-          <a:p>
-            <a:pPr algn="l"/>
-            <a:r>
-              <a:rPr sz="800" b="0" i="0">
-                <a:solidFill>
-                  <a:srgbClr val="FFFFFF"/>
-                </a:solidFill>
-              </a:rPr>
-              <a:t>· MSP PSA requirements deck</a:t>
-            </a:r>
-          </a:p>
-        </p:txBody>
-      </p:sp>
-      <p:sp>
-        <p:nvSpPr>
-          <p:cNvPr id="33" name="TextBox 32"/>
-          <p:cNvSpPr txBox="1"/>
-          <p:nvPr/>
-        </p:nvSpPr>
-        <p:spPr>
-          <a:xfrm>
-            <a:off x="6213347" y="4736591"/>
-            <a:ext cx="5408676" cy="219456"/>
-          </a:xfrm>
-          <a:prstGeom prst="rect">
-            <a:avLst/>
-          </a:prstGeom>
-          <a:noFill/>
-        </p:spPr>
-        <p:txBody>
-          <a:bodyPr wrap="square">
-            <a:spAutoFit/>
-          </a:bodyPr>
-          <a:lstStyle/>
-          <a:p>
-            <a:pPr algn="l"/>
-            <a:r>
-              <a:rPr sz="800" b="0" i="0">
+              <a:rPr sz="780" b="0" i="0">
                 <a:solidFill>
                   <a:srgbClr val="FFFFFF"/>
                 </a:solidFill>
@@ -5926,20 +5790,20 @@
       </p:sp>
       <p:sp>
         <p:nvSpPr>
-          <p:cNvPr id="34" name="Rectangle 33"/>
+          <p:cNvPr id="30" name="Rectangle 29"/>
           <p:cNvSpPr/>
           <p:nvPr/>
         </p:nvSpPr>
         <p:spPr>
           <a:xfrm>
-            <a:off x="0" y="6675120"/>
-            <a:ext cx="12188952" cy="182880"/>
+            <a:off x="6167628" y="1847088"/>
+            <a:ext cx="5655564" cy="4828032"/>
           </a:xfrm>
           <a:prstGeom prst="rect">
             <a:avLst/>
           </a:prstGeom>
           <a:solidFill>
-            <a:srgbClr val="071220"/>
+            <a:srgbClr val="0A1E30"/>
           </a:solidFill>
           <a:ln>
             <a:noFill/>
@@ -5969,14 +5833,57 @@
       </p:sp>
       <p:sp>
         <p:nvSpPr>
-          <p:cNvPr id="35" name="TextBox 34"/>
+          <p:cNvPr id="31" name="Rectangle 30"/>
+          <p:cNvSpPr/>
+          <p:nvPr/>
+        </p:nvSpPr>
+        <p:spPr>
+          <a:xfrm>
+            <a:off x="6167628" y="1847088"/>
+            <a:ext cx="45720" cy="4828032"/>
+          </a:xfrm>
+          <a:prstGeom prst="rect">
+            <a:avLst/>
+          </a:prstGeom>
+          <a:solidFill>
+            <a:srgbClr val="6EE7B7"/>
+          </a:solidFill>
+          <a:ln>
+            <a:noFill/>
+          </a:ln>
+        </p:spPr>
+        <p:style>
+          <a:lnRef idx="1">
+            <a:schemeClr val="accent1"/>
+          </a:lnRef>
+          <a:fillRef idx="3">
+            <a:schemeClr val="accent1"/>
+          </a:fillRef>
+          <a:effectRef idx="2">
+            <a:schemeClr val="accent1"/>
+          </a:effectRef>
+          <a:fontRef idx="minor">
+            <a:schemeClr val="lt1"/>
+          </a:fontRef>
+        </p:style>
+        <p:txBody>
+          <a:bodyPr rtlCol="0" anchor="ctr"/>
+          <a:lstStyle/>
+          <a:p>
+            <a:pPr algn="ctr"/>
+          </a:p>
+        </p:txBody>
+      </p:sp>
+      <p:sp>
+        <p:nvSpPr>
+          <p:cNvPr id="32" name="TextBox 31"/>
           <p:cNvSpPr txBox="1"/>
           <p:nvPr/>
         </p:nvSpPr>
         <p:spPr>
           <a:xfrm>
-            <a:off x="274320" y="6693408"/>
-            <a:ext cx="1828800" cy="146304"/>
+            <a:off x="6332220" y="1938528"/>
+            <a:ext cx="5426964" cy="438912"/>
           </a:xfrm>
           <a:prstGeom prst="rect">
             <a:avLst/>
@@ -5991,26 +5898,26 @@
           <a:p>
             <a:pPr algn="l"/>
             <a:r>
-              <a:rPr sz="900" b="1" i="0">
+              <a:rPr sz="2600" b="1" i="0">
                 <a:solidFill>
                   <a:srgbClr val="FFFFFF"/>
                 </a:solidFill>
               </a:rPr>
-              <a:t>• rev.io</a:t>
-            </a:r>
-          </a:p>
-        </p:txBody>
-      </p:sp>
-      <p:sp>
-        <p:nvSpPr>
-          <p:cNvPr id="36" name="TextBox 35"/>
+              <a:t>🤖  Marvin</a:t>
+            </a:r>
+          </a:p>
+        </p:txBody>
+      </p:sp>
+      <p:sp>
+        <p:nvSpPr>
+          <p:cNvPr id="33" name="TextBox 32"/>
           <p:cNvSpPr txBox="1"/>
           <p:nvPr/>
         </p:nvSpPr>
         <p:spPr>
           <a:xfrm>
-            <a:off x="8686800" y="6693408"/>
-            <a:ext cx="2011680" cy="146304"/>
+            <a:off x="6332220" y="2395728"/>
+            <a:ext cx="5426964" cy="256032"/>
           </a:xfrm>
           <a:prstGeom prst="rect">
             <a:avLst/>
@@ -6023,6 +5930,670 @@
           </a:bodyPr>
           <a:lstStyle/>
           <a:p>
+            <a:pPr algn="l"/>
+            <a:r>
+              <a:rPr sz="1100" b="0" i="0">
+                <a:solidFill>
+                  <a:srgbClr val="6EE7B7"/>
+                </a:solidFill>
+              </a:rPr>
+              <a:t>AI Channel &amp; Community Intelligence Engine</a:t>
+            </a:r>
+          </a:p>
+        </p:txBody>
+      </p:sp>
+      <p:sp>
+        <p:nvSpPr>
+          <p:cNvPr id="34" name="TextBox 33"/>
+          <p:cNvSpPr txBox="1"/>
+          <p:nvPr/>
+        </p:nvSpPr>
+        <p:spPr>
+          <a:xfrm>
+            <a:off x="6332220" y="2651760"/>
+            <a:ext cx="5426964" cy="201168"/>
+          </a:xfrm>
+          <a:prstGeom prst="rect">
+            <a:avLst/>
+          </a:prstGeom>
+          <a:noFill/>
+        </p:spPr>
+        <p:txBody>
+          <a:bodyPr wrap="square">
+            <a:spAutoFit/>
+          </a:bodyPr>
+          <a:lstStyle/>
+          <a:p>
+            <a:pPr algn="l"/>
+            <a:r>
+              <a:rPr sz="900" b="0" i="1">
+                <a:solidFill>
+                  <a:srgbClr val="8AA8C8"/>
+                </a:solidFill>
+              </a:rPr>
+              <a:t>Built for Usman Zahoor  ·  VP Channel &amp; Community</a:t>
+            </a:r>
+          </a:p>
+        </p:txBody>
+      </p:sp>
+      <p:sp>
+        <p:nvSpPr>
+          <p:cNvPr id="35" name="Rectangle 34"/>
+          <p:cNvSpPr/>
+          <p:nvPr/>
+        </p:nvSpPr>
+        <p:spPr>
+          <a:xfrm>
+            <a:off x="6332220" y="2871216"/>
+            <a:ext cx="5381244" cy="18288"/>
+          </a:xfrm>
+          <a:prstGeom prst="rect">
+            <a:avLst/>
+          </a:prstGeom>
+          <a:solidFill>
+            <a:srgbClr val="1A3555"/>
+          </a:solidFill>
+          <a:ln>
+            <a:noFill/>
+          </a:ln>
+        </p:spPr>
+        <p:style>
+          <a:lnRef idx="1">
+            <a:schemeClr val="accent1"/>
+          </a:lnRef>
+          <a:fillRef idx="3">
+            <a:schemeClr val="accent1"/>
+          </a:fillRef>
+          <a:effectRef idx="2">
+            <a:schemeClr val="accent1"/>
+          </a:effectRef>
+          <a:fontRef idx="minor">
+            <a:schemeClr val="lt1"/>
+          </a:fontRef>
+        </p:style>
+        <p:txBody>
+          <a:bodyPr rtlCol="0" anchor="ctr"/>
+          <a:lstStyle/>
+          <a:p>
+            <a:pPr algn="ctr"/>
+          </a:p>
+        </p:txBody>
+      </p:sp>
+      <p:sp>
+        <p:nvSpPr>
+          <p:cNvPr id="36" name="TextBox 35"/>
+          <p:cNvSpPr txBox="1"/>
+          <p:nvPr/>
+        </p:nvSpPr>
+        <p:spPr>
+          <a:xfrm>
+            <a:off x="6332220" y="2944368"/>
+            <a:ext cx="5381244" cy="182880"/>
+          </a:xfrm>
+          <a:prstGeom prst="rect">
+            <a:avLst/>
+          </a:prstGeom>
+          <a:noFill/>
+        </p:spPr>
+        <p:txBody>
+          <a:bodyPr wrap="square">
+            <a:spAutoFit/>
+          </a:bodyPr>
+          <a:lstStyle/>
+          <a:p>
+            <a:pPr algn="l"/>
+            <a:r>
+              <a:rPr sz="750" b="1" i="0">
+                <a:solidFill>
+                  <a:srgbClr val="6EE7B7"/>
+                </a:solidFill>
+              </a:rPr>
+              <a:t>INTELLIGENCE &amp; MONITORING</a:t>
+            </a:r>
+          </a:p>
+        </p:txBody>
+      </p:sp>
+      <p:sp>
+        <p:nvSpPr>
+          <p:cNvPr id="37" name="TextBox 36"/>
+          <p:cNvSpPr txBox="1"/>
+          <p:nvPr/>
+        </p:nvSpPr>
+        <p:spPr>
+          <a:xfrm>
+            <a:off x="6405372" y="3136391"/>
+            <a:ext cx="5308092" cy="201168"/>
+          </a:xfrm>
+          <a:prstGeom prst="rect">
+            <a:avLst/>
+          </a:prstGeom>
+          <a:noFill/>
+        </p:spPr>
+        <p:txBody>
+          <a:bodyPr wrap="square">
+            <a:spAutoFit/>
+          </a:bodyPr>
+          <a:lstStyle/>
+          <a:p>
+            <a:pPr algn="l"/>
+            <a:r>
+              <a:rPr sz="780" b="0" i="0">
+                <a:solidFill>
+                  <a:srgbClr val="FFFFFF"/>
+                </a:solidFill>
+              </a:rPr>
+              <a:t>· Daily Channel &amp; MSP market brief — CRN, Channel Futures, Reddit r/MSP, industry newswires</a:t>
+            </a:r>
+          </a:p>
+        </p:txBody>
+      </p:sp>
+      <p:sp>
+        <p:nvSpPr>
+          <p:cNvPr id="38" name="TextBox 37"/>
+          <p:cNvSpPr txBox="1"/>
+          <p:nvPr/>
+        </p:nvSpPr>
+        <p:spPr>
+          <a:xfrm>
+            <a:off x="6405372" y="3355848"/>
+            <a:ext cx="5308092" cy="201168"/>
+          </a:xfrm>
+          <a:prstGeom prst="rect">
+            <a:avLst/>
+          </a:prstGeom>
+          <a:noFill/>
+        </p:spPr>
+        <p:txBody>
+          <a:bodyPr wrap="square">
+            <a:spAutoFit/>
+          </a:bodyPr>
+          <a:lstStyle/>
+          <a:p>
+            <a:pPr algn="l"/>
+            <a:r>
+              <a:rPr sz="780" b="0" i="0">
+                <a:solidFill>
+                  <a:srgbClr val="FFFFFF"/>
+                </a:solidFill>
+              </a:rPr>
+              <a:t>· Monitors Rev.io email, Gmail, and Teams — flags actionable messages, filters noise</a:t>
+            </a:r>
+          </a:p>
+        </p:txBody>
+      </p:sp>
+      <p:sp>
+        <p:nvSpPr>
+          <p:cNvPr id="39" name="TextBox 38"/>
+          <p:cNvSpPr txBox="1"/>
+          <p:nvPr/>
+        </p:nvSpPr>
+        <p:spPr>
+          <a:xfrm>
+            <a:off x="6332220" y="3648456"/>
+            <a:ext cx="5381244" cy="182880"/>
+          </a:xfrm>
+          <a:prstGeom prst="rect">
+            <a:avLst/>
+          </a:prstGeom>
+          <a:noFill/>
+        </p:spPr>
+        <p:txBody>
+          <a:bodyPr wrap="square">
+            <a:spAutoFit/>
+          </a:bodyPr>
+          <a:lstStyle/>
+          <a:p>
+            <a:pPr algn="l"/>
+            <a:r>
+              <a:rPr sz="750" b="1" i="0">
+                <a:solidFill>
+                  <a:srgbClr val="6EE7B7"/>
+                </a:solidFill>
+              </a:rPr>
+              <a:t>DATA &amp; RESEARCH</a:t>
+            </a:r>
+          </a:p>
+        </p:txBody>
+      </p:sp>
+      <p:sp>
+        <p:nvSpPr>
+          <p:cNvPr id="40" name="TextBox 39"/>
+          <p:cNvSpPr txBox="1"/>
+          <p:nvPr/>
+        </p:nvSpPr>
+        <p:spPr>
+          <a:xfrm>
+            <a:off x="6405372" y="3840480"/>
+            <a:ext cx="5308092" cy="201168"/>
+          </a:xfrm>
+          <a:prstGeom prst="rect">
+            <a:avLst/>
+          </a:prstGeom>
+          <a:noFill/>
+        </p:spPr>
+        <p:txBody>
+          <a:bodyPr wrap="square">
+            <a:spAutoFit/>
+          </a:bodyPr>
+          <a:lstStyle/>
+          <a:p>
+            <a:pPr algn="l"/>
+            <a:r>
+              <a:rPr sz="780" b="0" i="0">
+                <a:solidFill>
+                  <a:srgbClr val="FFFFFF"/>
+                </a:solidFill>
+              </a:rPr>
+              <a:t>· Connected to Salesforce — partner data, pipeline context, account info on demand</a:t>
+            </a:r>
+          </a:p>
+        </p:txBody>
+      </p:sp>
+      <p:sp>
+        <p:nvSpPr>
+          <p:cNvPr id="41" name="TextBox 40"/>
+          <p:cNvSpPr txBox="1"/>
+          <p:nvPr/>
+        </p:nvSpPr>
+        <p:spPr>
+          <a:xfrm>
+            <a:off x="6405372" y="4059936"/>
+            <a:ext cx="5308092" cy="201168"/>
+          </a:xfrm>
+          <a:prstGeom prst="rect">
+            <a:avLst/>
+          </a:prstGeom>
+          <a:noFill/>
+        </p:spPr>
+        <p:txBody>
+          <a:bodyPr wrap="square">
+            <a:spAutoFit/>
+          </a:bodyPr>
+          <a:lstStyle/>
+          <a:p>
+            <a:pPr algn="l"/>
+            <a:r>
+              <a:rPr sz="780" b="0" i="0">
+                <a:solidFill>
+                  <a:srgbClr val="FFFFFF"/>
+                </a:solidFill>
+              </a:rPr>
+              <a:t>· Connected to Notion — Channel &amp; Community workspace, KPI trackers, event calendars</a:t>
+            </a:r>
+          </a:p>
+        </p:txBody>
+      </p:sp>
+      <p:sp>
+        <p:nvSpPr>
+          <p:cNvPr id="42" name="TextBox 41"/>
+          <p:cNvSpPr txBox="1"/>
+          <p:nvPr/>
+        </p:nvSpPr>
+        <p:spPr>
+          <a:xfrm>
+            <a:off x="6405372" y="4279392"/>
+            <a:ext cx="5308092" cy="201168"/>
+          </a:xfrm>
+          <a:prstGeom prst="rect">
+            <a:avLst/>
+          </a:prstGeom>
+          <a:noFill/>
+        </p:spPr>
+        <p:txBody>
+          <a:bodyPr wrap="square">
+            <a:spAutoFit/>
+          </a:bodyPr>
+          <a:lstStyle/>
+          <a:p>
+            <a:pPr algn="l"/>
+            <a:r>
+              <a:rPr sz="780" b="0" i="0">
+                <a:solidFill>
+                  <a:srgbClr val="FFFFFF"/>
+                </a:solidFill>
+              </a:rPr>
+              <a:t>· Web research on demand — competitive intel, partner backgrounds, market trends</a:t>
+            </a:r>
+          </a:p>
+        </p:txBody>
+      </p:sp>
+      <p:sp>
+        <p:nvSpPr>
+          <p:cNvPr id="43" name="TextBox 42"/>
+          <p:cNvSpPr txBox="1"/>
+          <p:nvPr/>
+        </p:nvSpPr>
+        <p:spPr>
+          <a:xfrm>
+            <a:off x="6332220" y="4572000"/>
+            <a:ext cx="5381244" cy="182880"/>
+          </a:xfrm>
+          <a:prstGeom prst="rect">
+            <a:avLst/>
+          </a:prstGeom>
+          <a:noFill/>
+        </p:spPr>
+        <p:txBody>
+          <a:bodyPr wrap="square">
+            <a:spAutoFit/>
+          </a:bodyPr>
+          <a:lstStyle/>
+          <a:p>
+            <a:pPr algn="l"/>
+            <a:r>
+              <a:rPr sz="750" b="1" i="0">
+                <a:solidFill>
+                  <a:srgbClr val="6EE7B7"/>
+                </a:solidFill>
+              </a:rPr>
+              <a:t>PUBLISHING &amp; DASHBOARDS</a:t>
+            </a:r>
+          </a:p>
+        </p:txBody>
+      </p:sp>
+      <p:sp>
+        <p:nvSpPr>
+          <p:cNvPr id="44" name="TextBox 43"/>
+          <p:cNvSpPr txBox="1"/>
+          <p:nvPr/>
+        </p:nvSpPr>
+        <p:spPr>
+          <a:xfrm>
+            <a:off x="6405372" y="4764024"/>
+            <a:ext cx="5308092" cy="201168"/>
+          </a:xfrm>
+          <a:prstGeom prst="rect">
+            <a:avLst/>
+          </a:prstGeom>
+          <a:noFill/>
+        </p:spPr>
+        <p:txBody>
+          <a:bodyPr wrap="square">
+            <a:spAutoFit/>
+          </a:bodyPr>
+          <a:lstStyle/>
+          <a:p>
+            <a:pPr algn="l"/>
+            <a:r>
+              <a:rPr sz="780" b="0" i="0">
+                <a:solidFill>
+                  <a:srgbClr val="FFFFFF"/>
+                </a:solidFill>
+              </a:rPr>
+              <a:t>· Builds and maintains the Channel KPI dashboard (live SF data, auto-refreshing)</a:t>
+            </a:r>
+          </a:p>
+        </p:txBody>
+      </p:sp>
+      <p:sp>
+        <p:nvSpPr>
+          <p:cNvPr id="45" name="TextBox 44"/>
+          <p:cNvSpPr txBox="1"/>
+          <p:nvPr/>
+        </p:nvSpPr>
+        <p:spPr>
+          <a:xfrm>
+            <a:off x="6405372" y="4983480"/>
+            <a:ext cx="5308092" cy="201168"/>
+          </a:xfrm>
+          <a:prstGeom prst="rect">
+            <a:avLst/>
+          </a:prstGeom>
+          <a:noFill/>
+        </p:spPr>
+        <p:txBody>
+          <a:bodyPr wrap="square">
+            <a:spAutoFit/>
+          </a:bodyPr>
+          <a:lstStyle/>
+          <a:p>
+            <a:pPr algn="l"/>
+            <a:r>
+              <a:rPr sz="780" b="0" i="0">
+                <a:solidFill>
+                  <a:srgbClr val="FFFFFF"/>
+                </a:solidFill>
+              </a:rPr>
+              <a:t>· Publishes internal guides and reports to hosted web pipeline instantly</a:t>
+            </a:r>
+          </a:p>
+        </p:txBody>
+      </p:sp>
+      <p:sp>
+        <p:nvSpPr>
+          <p:cNvPr id="46" name="TextBox 45"/>
+          <p:cNvSpPr txBox="1"/>
+          <p:nvPr/>
+        </p:nvSpPr>
+        <p:spPr>
+          <a:xfrm>
+            <a:off x="6332220" y="5276088"/>
+            <a:ext cx="5381244" cy="182880"/>
+          </a:xfrm>
+          <a:prstGeom prst="rect">
+            <a:avLst/>
+          </a:prstGeom>
+          <a:noFill/>
+        </p:spPr>
+        <p:txBody>
+          <a:bodyPr wrap="square">
+            <a:spAutoFit/>
+          </a:bodyPr>
+          <a:lstStyle/>
+          <a:p>
+            <a:pPr algn="l"/>
+            <a:r>
+              <a:rPr sz="750" b="1" i="0">
+                <a:solidFill>
+                  <a:srgbClr val="6EE7B7"/>
+                </a:solidFill>
+              </a:rPr>
+              <a:t>AUTOMATION</a:t>
+            </a:r>
+          </a:p>
+        </p:txBody>
+      </p:sp>
+      <p:sp>
+        <p:nvSpPr>
+          <p:cNvPr id="47" name="TextBox 46"/>
+          <p:cNvSpPr txBox="1"/>
+          <p:nvPr/>
+        </p:nvSpPr>
+        <p:spPr>
+          <a:xfrm>
+            <a:off x="6405372" y="5468112"/>
+            <a:ext cx="5308092" cy="201168"/>
+          </a:xfrm>
+          <a:prstGeom prst="rect">
+            <a:avLst/>
+          </a:prstGeom>
+          <a:noFill/>
+        </p:spPr>
+        <p:txBody>
+          <a:bodyPr wrap="square">
+            <a:spAutoFit/>
+          </a:bodyPr>
+          <a:lstStyle/>
+          <a:p>
+            <a:pPr algn="l"/>
+            <a:r>
+              <a:rPr sz="780" b="0" i="0">
+                <a:solidFill>
+                  <a:srgbClr val="FFFFFF"/>
+                </a:solidFill>
+              </a:rPr>
+              <a:t>· PSA Partner Sync — seeding Rev.io PSA with partner data from Salesforce</a:t>
+            </a:r>
+          </a:p>
+        </p:txBody>
+      </p:sp>
+      <p:sp>
+        <p:nvSpPr>
+          <p:cNvPr id="48" name="TextBox 47"/>
+          <p:cNvSpPr txBox="1"/>
+          <p:nvPr/>
+        </p:nvSpPr>
+        <p:spPr>
+          <a:xfrm>
+            <a:off x="6405372" y="5687568"/>
+            <a:ext cx="5308092" cy="201168"/>
+          </a:xfrm>
+          <a:prstGeom prst="rect">
+            <a:avLst/>
+          </a:prstGeom>
+          <a:noFill/>
+        </p:spPr>
+        <p:txBody>
+          <a:bodyPr wrap="square">
+            <a:spAutoFit/>
+          </a:bodyPr>
+          <a:lstStyle/>
+          <a:p>
+            <a:pPr algn="l"/>
+            <a:r>
+              <a:rPr sz="780" b="0" i="0">
+                <a:solidFill>
+                  <a:srgbClr val="FFFFFF"/>
+                </a:solidFill>
+              </a:rPr>
+              <a:t>· Event Intelligence — monitoring 30+ 2026 industry events for opportunities</a:t>
+            </a:r>
+          </a:p>
+        </p:txBody>
+      </p:sp>
+      <p:sp>
+        <p:nvSpPr>
+          <p:cNvPr id="49" name="TextBox 48"/>
+          <p:cNvSpPr txBox="1"/>
+          <p:nvPr/>
+        </p:nvSpPr>
+        <p:spPr>
+          <a:xfrm>
+            <a:off x="6405372" y="5907024"/>
+            <a:ext cx="5308092" cy="201168"/>
+          </a:xfrm>
+          <a:prstGeom prst="rect">
+            <a:avLst/>
+          </a:prstGeom>
+          <a:noFill/>
+        </p:spPr>
+        <p:txBody>
+          <a:bodyPr wrap="square">
+            <a:spAutoFit/>
+          </a:bodyPr>
+          <a:lstStyle/>
+          <a:p>
+            <a:pPr algn="l"/>
+            <a:r>
+              <a:rPr sz="780" b="0" i="0">
+                <a:solidFill>
+                  <a:srgbClr val="FFFFFF"/>
+                </a:solidFill>
+              </a:rPr>
+              <a:t>· Competitive Monitor — tracking competitors across news, jobs, product updates</a:t>
+            </a:r>
+          </a:p>
+        </p:txBody>
+      </p:sp>
+      <p:sp>
+        <p:nvSpPr>
+          <p:cNvPr id="50" name="Rectangle 49"/>
+          <p:cNvSpPr/>
+          <p:nvPr/>
+        </p:nvSpPr>
+        <p:spPr>
+          <a:xfrm>
+            <a:off x="0" y="6675120"/>
+            <a:ext cx="12188952" cy="182880"/>
+          </a:xfrm>
+          <a:prstGeom prst="rect">
+            <a:avLst/>
+          </a:prstGeom>
+          <a:solidFill>
+            <a:srgbClr val="071220"/>
+          </a:solidFill>
+          <a:ln>
+            <a:noFill/>
+          </a:ln>
+        </p:spPr>
+        <p:style>
+          <a:lnRef idx="1">
+            <a:schemeClr val="accent1"/>
+          </a:lnRef>
+          <a:fillRef idx="3">
+            <a:schemeClr val="accent1"/>
+          </a:fillRef>
+          <a:effectRef idx="2">
+            <a:schemeClr val="accent1"/>
+          </a:effectRef>
+          <a:fontRef idx="minor">
+            <a:schemeClr val="lt1"/>
+          </a:fontRef>
+        </p:style>
+        <p:txBody>
+          <a:bodyPr rtlCol="0" anchor="ctr"/>
+          <a:lstStyle/>
+          <a:p>
+            <a:pPr algn="ctr"/>
+          </a:p>
+        </p:txBody>
+      </p:sp>
+      <p:sp>
+        <p:nvSpPr>
+          <p:cNvPr id="51" name="TextBox 50"/>
+          <p:cNvSpPr txBox="1"/>
+          <p:nvPr/>
+        </p:nvSpPr>
+        <p:spPr>
+          <a:xfrm>
+            <a:off x="274320" y="6693408"/>
+            <a:ext cx="1828800" cy="146304"/>
+          </a:xfrm>
+          <a:prstGeom prst="rect">
+            <a:avLst/>
+          </a:prstGeom>
+          <a:noFill/>
+        </p:spPr>
+        <p:txBody>
+          <a:bodyPr wrap="square">
+            <a:spAutoFit/>
+          </a:bodyPr>
+          <a:lstStyle/>
+          <a:p>
+            <a:pPr algn="l"/>
+            <a:r>
+              <a:rPr sz="900" b="1" i="0">
+                <a:solidFill>
+                  <a:srgbClr val="FFFFFF"/>
+                </a:solidFill>
+              </a:rPr>
+              <a:t>• rev.io</a:t>
+            </a:r>
+          </a:p>
+        </p:txBody>
+      </p:sp>
+      <p:sp>
+        <p:nvSpPr>
+          <p:cNvPr id="52" name="TextBox 51"/>
+          <p:cNvSpPr txBox="1"/>
+          <p:nvPr/>
+        </p:nvSpPr>
+        <p:spPr>
+          <a:xfrm>
+            <a:off x="8686800" y="6693408"/>
+            <a:ext cx="2011680" cy="146304"/>
+          </a:xfrm>
+          <a:prstGeom prst="rect">
+            <a:avLst/>
+          </a:prstGeom>
+          <a:noFill/>
+        </p:spPr>
+        <p:txBody>
+          <a:bodyPr wrap="square">
+            <a:spAutoFit/>
+          </a:bodyPr>
+          <a:lstStyle/>
+          <a:p>
             <a:pPr algn="r"/>
             <a:r>
               <a:rPr sz="900" b="1" i="0">
@@ -6037,7 +6608,7 @@
       </p:sp>
       <p:sp>
         <p:nvSpPr>
-          <p:cNvPr id="37" name="TextBox 36"/>
+          <p:cNvPr id="53" name="TextBox 52"/>
           <p:cNvSpPr txBox="1"/>
           <p:nvPr/>
         </p:nvSpPr>

</xml_diff>

<commit_message>
Tool stack: real Clay, Outreach, Notion logos
</commit_message>
<xml_diff>
--- a/Robin-Intro-Slide.pptx
+++ b/Robin-Intro-Slide.pptx
@@ -6982,8 +6982,8 @@
         </p:blipFill>
         <p:spPr>
           <a:xfrm>
-            <a:off x="530352" y="1993392"/>
-            <a:ext cx="475488" cy="475488"/>
+            <a:off x="530352" y="2011680"/>
+            <a:ext cx="457200" cy="457200"/>
           </a:xfrm>
           <a:prstGeom prst="rect">
             <a:avLst/>
@@ -6998,8 +6998,8 @@
         </p:nvSpPr>
         <p:spPr>
           <a:xfrm>
-            <a:off x="1115568" y="1993392"/>
-            <a:ext cx="2807208" cy="475488"/>
+            <a:off x="530352" y="2523744"/>
+            <a:ext cx="3511296" cy="256032"/>
           </a:xfrm>
           <a:prstGeom prst="rect">
             <a:avLst/>
@@ -7014,12 +7014,12 @@
           <a:p>
             <a:pPr algn="l"/>
             <a:r>
-              <a:rPr sz="2400" b="1" i="0">
-                <a:solidFill>
-                  <a:srgbClr val="FFFFFF"/>
+              <a:rPr sz="950" b="0" i="0">
+                <a:solidFill>
+                  <a:srgbClr val="7C3AED"/>
                 </a:solidFill>
               </a:rPr>
-              <a:t>Notion</a:t>
+              <a:t>AI Knowledge &amp; Workflow Automation</a:t>
             </a:r>
           </a:p>
         </p:txBody>
@@ -7032,8 +7032,8 @@
         </p:nvSpPr>
         <p:spPr>
           <a:xfrm>
-            <a:off x="530352" y="2578608"/>
-            <a:ext cx="3511296" cy="256032"/>
+            <a:off x="530352" y="2779776"/>
+            <a:ext cx="3511296" cy="182880"/>
           </a:xfrm>
           <a:prstGeom prst="rect">
             <a:avLst/>
@@ -7048,40 +7048,6 @@
           <a:p>
             <a:pPr algn="l"/>
             <a:r>
-              <a:rPr sz="950" b="0" i="0">
-                <a:solidFill>
-                  <a:srgbClr val="7C3AED"/>
-                </a:solidFill>
-              </a:rPr>
-              <a:t>AI Knowledge &amp; Workflow Automation</a:t>
-            </a:r>
-          </a:p>
-        </p:txBody>
-      </p:sp>
-      <p:sp>
-        <p:nvSpPr>
-          <p:cNvPr id="13" name="TextBox 12"/>
-          <p:cNvSpPr txBox="1"/>
-          <p:nvPr/>
-        </p:nvSpPr>
-        <p:spPr>
-          <a:xfrm>
-            <a:off x="530352" y="2834640"/>
-            <a:ext cx="3511296" cy="182880"/>
-          </a:xfrm>
-          <a:prstGeom prst="rect">
-            <a:avLst/>
-          </a:prstGeom>
-          <a:noFill/>
-        </p:spPr>
-        <p:txBody>
-          <a:bodyPr wrap="square">
-            <a:spAutoFit/>
-          </a:bodyPr>
-          <a:lstStyle/>
-          <a:p>
-            <a:pPr algn="l"/>
-            <a:r>
               <a:rPr sz="850" b="0" i="1">
                 <a:solidFill>
                   <a:srgbClr val="8AA8C8"/>
@@ -7094,13 +7060,13 @@
       </p:sp>
       <p:sp>
         <p:nvSpPr>
-          <p:cNvPr id="14" name="Rectangle 13"/>
+          <p:cNvPr id="13" name="Rectangle 12"/>
           <p:cNvSpPr/>
           <p:nvPr/>
         </p:nvSpPr>
         <p:spPr>
           <a:xfrm>
-            <a:off x="530352" y="3035808"/>
+            <a:off x="530352" y="2980944"/>
             <a:ext cx="3465576" cy="18288"/>
           </a:xfrm>
           <a:prstGeom prst="rect">
@@ -7137,13 +7103,13 @@
       </p:sp>
       <p:sp>
         <p:nvSpPr>
-          <p:cNvPr id="15" name="TextBox 14"/>
+          <p:cNvPr id="14" name="TextBox 13"/>
           <p:cNvSpPr txBox="1"/>
           <p:nvPr/>
         </p:nvSpPr>
         <p:spPr>
           <a:xfrm>
-            <a:off x="530352" y="3127248"/>
+            <a:off x="530352" y="3072384"/>
             <a:ext cx="3511296" cy="201168"/>
           </a:xfrm>
           <a:prstGeom prst="rect">
@@ -7171,13 +7137,13 @@
       </p:sp>
       <p:sp>
         <p:nvSpPr>
-          <p:cNvPr id="16" name="TextBox 15"/>
+          <p:cNvPr id="15" name="TextBox 14"/>
           <p:cNvSpPr txBox="1"/>
           <p:nvPr/>
         </p:nvSpPr>
         <p:spPr>
           <a:xfrm>
-            <a:off x="603504" y="3364991"/>
+            <a:off x="603504" y="3310128"/>
             <a:ext cx="3447288" cy="420624"/>
           </a:xfrm>
           <a:prstGeom prst="rect">
@@ -7205,13 +7171,13 @@
       </p:sp>
       <p:sp>
         <p:nvSpPr>
-          <p:cNvPr id="17" name="TextBox 16"/>
+          <p:cNvPr id="16" name="TextBox 15"/>
           <p:cNvSpPr txBox="1"/>
           <p:nvPr/>
         </p:nvSpPr>
         <p:spPr>
           <a:xfrm>
-            <a:off x="530352" y="3895344"/>
+            <a:off x="530352" y="3840480"/>
             <a:ext cx="3511296" cy="201168"/>
           </a:xfrm>
           <a:prstGeom prst="rect">
@@ -7239,13 +7205,13 @@
       </p:sp>
       <p:sp>
         <p:nvSpPr>
-          <p:cNvPr id="18" name="TextBox 17"/>
+          <p:cNvPr id="17" name="TextBox 16"/>
           <p:cNvSpPr txBox="1"/>
           <p:nvPr/>
         </p:nvSpPr>
         <p:spPr>
           <a:xfrm>
-            <a:off x="603504" y="4133087"/>
+            <a:off x="603504" y="4078224"/>
             <a:ext cx="3447288" cy="420624"/>
           </a:xfrm>
           <a:prstGeom prst="rect">
@@ -7273,13 +7239,13 @@
       </p:sp>
       <p:sp>
         <p:nvSpPr>
-          <p:cNvPr id="19" name="TextBox 18"/>
+          <p:cNvPr id="18" name="TextBox 17"/>
           <p:cNvSpPr txBox="1"/>
           <p:nvPr/>
         </p:nvSpPr>
         <p:spPr>
           <a:xfrm>
-            <a:off x="530352" y="4663440"/>
+            <a:off x="530352" y="4608576"/>
             <a:ext cx="3511296" cy="201168"/>
           </a:xfrm>
           <a:prstGeom prst="rect">
@@ -7307,13 +7273,13 @@
       </p:sp>
       <p:sp>
         <p:nvSpPr>
-          <p:cNvPr id="20" name="TextBox 19"/>
+          <p:cNvPr id="19" name="TextBox 18"/>
           <p:cNvSpPr txBox="1"/>
           <p:nvPr/>
         </p:nvSpPr>
         <p:spPr>
           <a:xfrm>
-            <a:off x="603504" y="4901183"/>
+            <a:off x="603504" y="4846320"/>
             <a:ext cx="3447288" cy="420624"/>
           </a:xfrm>
           <a:prstGeom prst="rect">
@@ -7341,7 +7307,7 @@
       </p:sp>
       <p:sp>
         <p:nvSpPr>
-          <p:cNvPr id="21" name="Rectangle 20"/>
+          <p:cNvPr id="20" name="Rectangle 19"/>
           <p:cNvSpPr/>
           <p:nvPr/>
         </p:nvSpPr>
@@ -7384,7 +7350,7 @@
       </p:sp>
       <p:sp>
         <p:nvSpPr>
-          <p:cNvPr id="22" name="Rectangle 21"/>
+          <p:cNvPr id="21" name="Rectangle 20"/>
           <p:cNvSpPr/>
           <p:nvPr/>
         </p:nvSpPr>
@@ -7427,7 +7393,7 @@
       </p:sp>
       <p:pic>
         <p:nvPicPr>
-          <p:cNvPr id="23" name="Picture 22" descr="clay.png"/>
+          <p:cNvPr id="22" name="Picture 21" descr="clay-logo.png"/>
           <p:cNvPicPr>
             <a:picLocks noChangeAspect="1"/>
           </p:cNvPicPr>
@@ -7441,8 +7407,8 @@
         </p:blipFill>
         <p:spPr>
           <a:xfrm>
-            <a:off x="4389120" y="1993392"/>
-            <a:ext cx="475488" cy="475488"/>
+            <a:off x="4389120" y="2011680"/>
+            <a:ext cx="1463040" cy="402336"/>
           </a:xfrm>
           <a:prstGeom prst="rect">
             <a:avLst/>
@@ -7451,14 +7417,14 @@
       </p:pic>
       <p:sp>
         <p:nvSpPr>
-          <p:cNvPr id="24" name="TextBox 23"/>
+          <p:cNvPr id="23" name="TextBox 22"/>
           <p:cNvSpPr txBox="1"/>
           <p:nvPr/>
         </p:nvSpPr>
         <p:spPr>
           <a:xfrm>
-            <a:off x="4974336" y="1993392"/>
-            <a:ext cx="2807208" cy="475488"/>
+            <a:off x="4389120" y="2523744"/>
+            <a:ext cx="3511296" cy="256032"/>
           </a:xfrm>
           <a:prstGeom prst="rect">
             <a:avLst/>
@@ -7473,26 +7439,26 @@
           <a:p>
             <a:pPr algn="l"/>
             <a:r>
-              <a:rPr sz="2400" b="1" i="0">
-                <a:solidFill>
-                  <a:srgbClr val="FFFFFF"/>
+              <a:rPr sz="950" b="0" i="0">
+                <a:solidFill>
+                  <a:srgbClr val="F57C2A"/>
                 </a:solidFill>
               </a:rPr>
-              <a:t>Clay</a:t>
-            </a:r>
-          </a:p>
-        </p:txBody>
-      </p:sp>
-      <p:sp>
-        <p:nvSpPr>
-          <p:cNvPr id="25" name="TextBox 24"/>
+              <a:t>Custom AI for Data Intelligence</a:t>
+            </a:r>
+          </a:p>
+        </p:txBody>
+      </p:sp>
+      <p:sp>
+        <p:nvSpPr>
+          <p:cNvPr id="24" name="TextBox 23"/>
           <p:cNvSpPr txBox="1"/>
           <p:nvPr/>
         </p:nvSpPr>
         <p:spPr>
           <a:xfrm>
-            <a:off x="4389120" y="2578608"/>
-            <a:ext cx="3511296" cy="256032"/>
+            <a:off x="4389120" y="2779776"/>
+            <a:ext cx="3511296" cy="182880"/>
           </a:xfrm>
           <a:prstGeom prst="rect">
             <a:avLst/>
@@ -7507,40 +7473,6 @@
           <a:p>
             <a:pPr algn="l"/>
             <a:r>
-              <a:rPr sz="950" b="0" i="0">
-                <a:solidFill>
-                  <a:srgbClr val="F57C2A"/>
-                </a:solidFill>
-              </a:rPr>
-              <a:t>Custom AI for Data Intelligence</a:t>
-            </a:r>
-          </a:p>
-        </p:txBody>
-      </p:sp>
-      <p:sp>
-        <p:nvSpPr>
-          <p:cNvPr id="26" name="TextBox 25"/>
-          <p:cNvSpPr txBox="1"/>
-          <p:nvPr/>
-        </p:nvSpPr>
-        <p:spPr>
-          <a:xfrm>
-            <a:off x="4389120" y="2834640"/>
-            <a:ext cx="3511296" cy="182880"/>
-          </a:xfrm>
-          <a:prstGeom prst="rect">
-            <a:avLst/>
-          </a:prstGeom>
-          <a:noFill/>
-        </p:spPr>
-        <p:txBody>
-          <a:bodyPr wrap="square">
-            <a:spAutoFit/>
-          </a:bodyPr>
-          <a:lstStyle/>
-          <a:p>
-            <a:pPr algn="l"/>
-            <a:r>
               <a:rPr sz="850" b="0" i="1">
                 <a:solidFill>
                   <a:srgbClr val="8AA8C8"/>
@@ -7553,13 +7485,13 @@
       </p:sp>
       <p:sp>
         <p:nvSpPr>
-          <p:cNvPr id="27" name="Rectangle 26"/>
+          <p:cNvPr id="25" name="Rectangle 24"/>
           <p:cNvSpPr/>
           <p:nvPr/>
         </p:nvSpPr>
         <p:spPr>
           <a:xfrm>
-            <a:off x="4389120" y="3035808"/>
+            <a:off x="4389120" y="2980944"/>
             <a:ext cx="3465576" cy="18288"/>
           </a:xfrm>
           <a:prstGeom prst="rect">
@@ -7596,13 +7528,13 @@
       </p:sp>
       <p:sp>
         <p:nvSpPr>
-          <p:cNvPr id="28" name="TextBox 27"/>
+          <p:cNvPr id="26" name="TextBox 25"/>
           <p:cNvSpPr txBox="1"/>
           <p:nvPr/>
         </p:nvSpPr>
         <p:spPr>
           <a:xfrm>
-            <a:off x="4389120" y="3127248"/>
+            <a:off x="4389120" y="3072384"/>
             <a:ext cx="3511296" cy="201168"/>
           </a:xfrm>
           <a:prstGeom prst="rect">
@@ -7630,13 +7562,13 @@
       </p:sp>
       <p:sp>
         <p:nvSpPr>
-          <p:cNvPr id="29" name="TextBox 28"/>
+          <p:cNvPr id="27" name="TextBox 26"/>
           <p:cNvSpPr txBox="1"/>
           <p:nvPr/>
         </p:nvSpPr>
         <p:spPr>
           <a:xfrm>
-            <a:off x="4462272" y="3364991"/>
+            <a:off x="4462272" y="3310128"/>
             <a:ext cx="3447288" cy="420624"/>
           </a:xfrm>
           <a:prstGeom prst="rect">
@@ -7664,13 +7596,13 @@
       </p:sp>
       <p:sp>
         <p:nvSpPr>
-          <p:cNvPr id="30" name="TextBox 29"/>
+          <p:cNvPr id="28" name="TextBox 27"/>
           <p:cNvSpPr txBox="1"/>
           <p:nvPr/>
         </p:nvSpPr>
         <p:spPr>
           <a:xfrm>
-            <a:off x="4462272" y="3895344"/>
+            <a:off x="4462272" y="3840480"/>
             <a:ext cx="3447288" cy="420624"/>
           </a:xfrm>
           <a:prstGeom prst="rect">
@@ -7698,7 +7630,7 @@
       </p:sp>
       <p:pic>
         <p:nvPicPr>
-          <p:cNvPr id="31" name="Picture 30" descr="clay-screenshot.png"/>
+          <p:cNvPr id="29" name="Picture 28" descr="clay-screenshot.png"/>
           <p:cNvPicPr>
             <a:picLocks noChangeAspect="1"/>
           </p:cNvPicPr>
@@ -7712,7 +7644,7 @@
         </p:blipFill>
         <p:spPr>
           <a:xfrm>
-            <a:off x="4389120" y="4462271"/>
+            <a:off x="4389120" y="4407408"/>
             <a:ext cx="3410712" cy="1856463"/>
           </a:xfrm>
           <a:prstGeom prst="rect">
@@ -7722,7 +7654,7 @@
       </p:pic>
       <p:sp>
         <p:nvSpPr>
-          <p:cNvPr id="32" name="Rectangle 31"/>
+          <p:cNvPr id="30" name="Rectangle 29"/>
           <p:cNvSpPr/>
           <p:nvPr/>
         </p:nvSpPr>
@@ -7765,7 +7697,7 @@
       </p:sp>
       <p:sp>
         <p:nvSpPr>
-          <p:cNvPr id="33" name="Rectangle 32"/>
+          <p:cNvPr id="31" name="Rectangle 30"/>
           <p:cNvSpPr/>
           <p:nvPr/>
         </p:nvSpPr>
@@ -7808,7 +7740,7 @@
       </p:sp>
       <p:pic>
         <p:nvPicPr>
-          <p:cNvPr id="34" name="Picture 33" descr="outreach.png"/>
+          <p:cNvPr id="32" name="Picture 31" descr="outreach-logo.png"/>
           <p:cNvPicPr>
             <a:picLocks noChangeAspect="1"/>
           </p:cNvPicPr>
@@ -7822,8 +7754,8 @@
         </p:blipFill>
         <p:spPr>
           <a:xfrm>
-            <a:off x="8247888" y="1993392"/>
-            <a:ext cx="475488" cy="475488"/>
+            <a:off x="8247888" y="2011680"/>
+            <a:ext cx="1645920" cy="402336"/>
           </a:xfrm>
           <a:prstGeom prst="rect">
             <a:avLst/>
@@ -7832,14 +7764,14 @@
       </p:pic>
       <p:sp>
         <p:nvSpPr>
-          <p:cNvPr id="35" name="TextBox 34"/>
+          <p:cNvPr id="33" name="TextBox 32"/>
           <p:cNvSpPr txBox="1"/>
           <p:nvPr/>
         </p:nvSpPr>
         <p:spPr>
           <a:xfrm>
-            <a:off x="8833103" y="1993392"/>
-            <a:ext cx="2807208" cy="475488"/>
+            <a:off x="8247888" y="2523744"/>
+            <a:ext cx="3511296" cy="256032"/>
           </a:xfrm>
           <a:prstGeom prst="rect">
             <a:avLst/>
@@ -7854,26 +7786,26 @@
           <a:p>
             <a:pPr algn="l"/>
             <a:r>
-              <a:rPr sz="2400" b="1" i="0">
-                <a:solidFill>
-                  <a:srgbClr val="FFFFFF"/>
+              <a:rPr sz="950" b="0" i="0">
+                <a:solidFill>
+                  <a:srgbClr val="0D9E8A"/>
                 </a:solidFill>
               </a:rPr>
-              <a:t>Outreach</a:t>
-            </a:r>
-          </a:p>
-        </p:txBody>
-      </p:sp>
-      <p:sp>
-        <p:nvSpPr>
-          <p:cNvPr id="36" name="TextBox 35"/>
+              <a:t>Revenue Agent — Automated Sequencing</a:t>
+            </a:r>
+          </a:p>
+        </p:txBody>
+      </p:sp>
+      <p:sp>
+        <p:nvSpPr>
+          <p:cNvPr id="34" name="TextBox 33"/>
           <p:cNvSpPr txBox="1"/>
           <p:nvPr/>
         </p:nvSpPr>
         <p:spPr>
           <a:xfrm>
-            <a:off x="8247888" y="2578608"/>
-            <a:ext cx="3511296" cy="256032"/>
+            <a:off x="8247888" y="2779776"/>
+            <a:ext cx="3511296" cy="182880"/>
           </a:xfrm>
           <a:prstGeom prst="rect">
             <a:avLst/>
@@ -7888,40 +7820,6 @@
           <a:p>
             <a:pPr algn="l"/>
             <a:r>
-              <a:rPr sz="950" b="0" i="0">
-                <a:solidFill>
-                  <a:srgbClr val="0D9E8A"/>
-                </a:solidFill>
-              </a:rPr>
-              <a:t>Revenue Agent — Automated Sequencing</a:t>
-            </a:r>
-          </a:p>
-        </p:txBody>
-      </p:sp>
-      <p:sp>
-        <p:nvSpPr>
-          <p:cNvPr id="37" name="TextBox 36"/>
-          <p:cNvSpPr txBox="1"/>
-          <p:nvPr/>
-        </p:nvSpPr>
-        <p:spPr>
-          <a:xfrm>
-            <a:off x="8247888" y="2834640"/>
-            <a:ext cx="3511296" cy="182880"/>
-          </a:xfrm>
-          <a:prstGeom prst="rect">
-            <a:avLst/>
-          </a:prstGeom>
-          <a:noFill/>
-        </p:spPr>
-        <p:txBody>
-          <a:bodyPr wrap="square">
-            <a:spAutoFit/>
-          </a:bodyPr>
-          <a:lstStyle/>
-          <a:p>
-            <a:pPr algn="l"/>
-            <a:r>
               <a:rPr sz="850" b="0" i="1">
                 <a:solidFill>
                   <a:srgbClr val="8AA8C8"/>
@@ -7934,13 +7832,13 @@
       </p:sp>
       <p:sp>
         <p:nvSpPr>
-          <p:cNvPr id="38" name="Rectangle 37"/>
+          <p:cNvPr id="35" name="Rectangle 34"/>
           <p:cNvSpPr/>
           <p:nvPr/>
         </p:nvSpPr>
         <p:spPr>
           <a:xfrm>
-            <a:off x="8247888" y="3035808"/>
+            <a:off x="8247888" y="2980944"/>
             <a:ext cx="3465576" cy="18288"/>
           </a:xfrm>
           <a:prstGeom prst="rect">
@@ -7977,13 +7875,13 @@
       </p:sp>
       <p:sp>
         <p:nvSpPr>
-          <p:cNvPr id="39" name="TextBox 38"/>
+          <p:cNvPr id="36" name="TextBox 35"/>
           <p:cNvSpPr txBox="1"/>
           <p:nvPr/>
         </p:nvSpPr>
         <p:spPr>
           <a:xfrm>
-            <a:off x="8247888" y="3127248"/>
+            <a:off x="8247888" y="3072384"/>
             <a:ext cx="3511296" cy="201168"/>
           </a:xfrm>
           <a:prstGeom prst="rect">
@@ -8011,13 +7909,13 @@
       </p:sp>
       <p:sp>
         <p:nvSpPr>
-          <p:cNvPr id="40" name="TextBox 39"/>
+          <p:cNvPr id="37" name="TextBox 36"/>
           <p:cNvSpPr txBox="1"/>
           <p:nvPr/>
         </p:nvSpPr>
         <p:spPr>
           <a:xfrm>
-            <a:off x="8321040" y="3364991"/>
+            <a:off x="8321040" y="3310128"/>
             <a:ext cx="3447288" cy="420624"/>
           </a:xfrm>
           <a:prstGeom prst="rect">
@@ -8045,13 +7943,13 @@
       </p:sp>
       <p:sp>
         <p:nvSpPr>
-          <p:cNvPr id="41" name="TextBox 40"/>
+          <p:cNvPr id="38" name="TextBox 37"/>
           <p:cNvSpPr txBox="1"/>
           <p:nvPr/>
         </p:nvSpPr>
         <p:spPr>
           <a:xfrm>
-            <a:off x="8247888" y="3895344"/>
+            <a:off x="8247888" y="3840480"/>
             <a:ext cx="3511296" cy="201168"/>
           </a:xfrm>
           <a:prstGeom prst="rect">
@@ -8079,13 +7977,13 @@
       </p:sp>
       <p:sp>
         <p:nvSpPr>
-          <p:cNvPr id="42" name="TextBox 41"/>
+          <p:cNvPr id="39" name="TextBox 38"/>
           <p:cNvSpPr txBox="1"/>
           <p:nvPr/>
         </p:nvSpPr>
         <p:spPr>
           <a:xfrm>
-            <a:off x="8321040" y="4133087"/>
+            <a:off x="8321040" y="4078224"/>
             <a:ext cx="3447288" cy="420624"/>
           </a:xfrm>
           <a:prstGeom prst="rect">
@@ -8111,9 +8009,33 @@
           </a:p>
         </p:txBody>
       </p:sp>
-      <p:sp>
-        <p:nvSpPr>
-          <p:cNvPr id="43" name="Rectangle 42"/>
+      <p:pic>
+        <p:nvPicPr>
+          <p:cNvPr id="40" name="Picture 39" descr="outreach-screenshot.png"/>
+          <p:cNvPicPr>
+            <a:picLocks noChangeAspect="1"/>
+          </p:cNvPicPr>
+          <p:nvPr/>
+        </p:nvPicPr>
+        <p:blipFill>
+          <a:blip r:embed="rId8"/>
+          <a:stretch>
+            <a:fillRect/>
+          </a:stretch>
+        </p:blipFill>
+        <p:spPr>
+          <a:xfrm>
+            <a:off x="8247888" y="4700016"/>
+            <a:ext cx="3410712" cy="1856463"/>
+          </a:xfrm>
+          <a:prstGeom prst="rect">
+            <a:avLst/>
+          </a:prstGeom>
+        </p:spPr>
+      </p:pic>
+      <p:sp>
+        <p:nvSpPr>
+          <p:cNvPr id="41" name="Rectangle 40"/>
           <p:cNvSpPr/>
           <p:nvPr/>
         </p:nvSpPr>
@@ -8156,7 +8078,7 @@
       </p:sp>
       <p:sp>
         <p:nvSpPr>
-          <p:cNvPr id="44" name="TextBox 43"/>
+          <p:cNvPr id="42" name="TextBox 41"/>
           <p:cNvSpPr txBox="1"/>
           <p:nvPr/>
         </p:nvSpPr>
@@ -8190,7 +8112,7 @@
       </p:sp>
       <p:sp>
         <p:nvSpPr>
-          <p:cNvPr id="45" name="TextBox 44"/>
+          <p:cNvPr id="43" name="TextBox 42"/>
           <p:cNvSpPr txBox="1"/>
           <p:nvPr/>
         </p:nvSpPr>
@@ -8224,7 +8146,7 @@
       </p:sp>
       <p:sp>
         <p:nvSpPr>
-          <p:cNvPr id="46" name="TextBox 45"/>
+          <p:cNvPr id="44" name="TextBox 43"/>
           <p:cNvSpPr txBox="1"/>
           <p:nvPr/>
         </p:nvSpPr>

</xml_diff>

<commit_message>
Add slide 3: Data Intelligence 2x2 dashboard grid
</commit_message>
<xml_diff>
--- a/Robin-Intro-Slide.pptx
+++ b/Robin-Intro-Slide.pptx
@@ -10,6 +10,7 @@
   <p:sldIdLst>
     <p:sldId id="828" r:id="rId9"/>
     <p:sldId id="829" r:id="rId10"/>
+    <p:sldId id="830" r:id="rId11"/>
   </p:sldIdLst>
   <p:sldSz cx="12192000" cy="6858000"/>
   <p:notesSz cx="6858000" cy="9144000"/>
@@ -8147,6 +8148,623 @@
       <p:sp>
         <p:nvSpPr>
           <p:cNvPr id="44" name="TextBox 43"/>
+          <p:cNvSpPr txBox="1"/>
+          <p:nvPr/>
+        </p:nvSpPr>
+        <p:spPr>
+          <a:xfrm>
+            <a:off x="10698480" y="6693408"/>
+            <a:ext cx="1371600" cy="146304"/>
+          </a:xfrm>
+          <a:prstGeom prst="rect">
+            <a:avLst/>
+          </a:prstGeom>
+          <a:noFill/>
+        </p:spPr>
+        <p:txBody>
+          <a:bodyPr wrap="square">
+            <a:spAutoFit/>
+          </a:bodyPr>
+          <a:lstStyle/>
+          <a:p>
+            <a:pPr algn="r"/>
+            <a:r>
+              <a:rPr sz="900" b="1" i="0">
+                <a:solidFill>
+                  <a:srgbClr val="3DC570"/>
+                </a:solidFill>
+              </a:rPr>
+              <a:t>READY FOR TODAY.</a:t>
+            </a:r>
+          </a:p>
+        </p:txBody>
+      </p:sp>
+    </p:spTree>
+  </p:cSld>
+  <p:clrMapOvr>
+    <a:masterClrMapping/>
+  </p:clrMapOvr>
+</p:sld>
+</file>
+
+<file path=ppt/slides/slide5.xml><?xml version="1.0" encoding="utf-8"?>
+<p:sld xmlns:a="http://schemas.openxmlformats.org/drawingml/2006/main" xmlns:p="http://schemas.openxmlformats.org/presentationml/2006/main" xmlns:r="http://schemas.openxmlformats.org/officeDocument/2006/relationships">
+  <p:cSld>
+    <p:spTree>
+      <p:nvGrpSpPr>
+        <p:cNvPr id="1" name=""/>
+        <p:cNvGrpSpPr/>
+        <p:nvPr/>
+      </p:nvGrpSpPr>
+      <p:grpSpPr/>
+      <p:sp>
+        <p:nvSpPr>
+          <p:cNvPr id="2" name="TextBox 1"/>
+          <p:cNvSpPr txBox="1"/>
+          <p:nvPr/>
+        </p:nvSpPr>
+        <p:spPr>
+          <a:xfrm>
+            <a:off x="365760" y="164592"/>
+            <a:ext cx="11430000" cy="621792"/>
+          </a:xfrm>
+          <a:prstGeom prst="rect">
+            <a:avLst/>
+          </a:prstGeom>
+          <a:noFill/>
+        </p:spPr>
+        <p:txBody>
+          <a:bodyPr wrap="square">
+            <a:spAutoFit/>
+          </a:bodyPr>
+          <a:lstStyle/>
+          <a:p>
+            <a:pPr algn="l"/>
+            <a:r>
+              <a:rPr sz="4000" b="1" i="0">
+                <a:solidFill>
+                  <a:srgbClr val="FFFFFF"/>
+                </a:solidFill>
+              </a:rPr>
+              <a:t>Data Intelligence — Built by Robin</a:t>
+            </a:r>
+          </a:p>
+        </p:txBody>
+      </p:sp>
+      <p:sp>
+        <p:nvSpPr>
+          <p:cNvPr id="3" name="TextBox 2"/>
+          <p:cNvSpPr txBox="1"/>
+          <p:nvPr/>
+        </p:nvSpPr>
+        <p:spPr>
+          <a:xfrm>
+            <a:off x="365760" y="804672"/>
+            <a:ext cx="11430000" cy="274320"/>
+          </a:xfrm>
+          <a:prstGeom prst="rect">
+            <a:avLst/>
+          </a:prstGeom>
+          <a:noFill/>
+        </p:spPr>
+        <p:txBody>
+          <a:bodyPr wrap="square">
+            <a:spAutoFit/>
+          </a:bodyPr>
+          <a:lstStyle/>
+          <a:p>
+            <a:pPr algn="l"/>
+            <a:r>
+              <a:rPr sz="1250" b="0" i="0">
+                <a:solidFill>
+                  <a:srgbClr val="8AA8C8"/>
+                </a:solidFill>
+              </a:rPr>
+              <a:t>Live dashboards powered by Salesforce — built, automated, and maintained by AI.</a:t>
+            </a:r>
+          </a:p>
+        </p:txBody>
+      </p:sp>
+      <p:sp>
+        <p:nvSpPr>
+          <p:cNvPr id="4" name="Rectangle 3"/>
+          <p:cNvSpPr/>
+          <p:nvPr/>
+        </p:nvSpPr>
+        <p:spPr>
+          <a:xfrm>
+            <a:off x="365760" y="1170432"/>
+            <a:ext cx="11457432" cy="457200"/>
+          </a:xfrm>
+          <a:prstGeom prst="rect">
+            <a:avLst/>
+          </a:prstGeom>
+          <a:solidFill>
+            <a:srgbClr val="0A1E30"/>
+          </a:solidFill>
+          <a:ln>
+            <a:noFill/>
+          </a:ln>
+        </p:spPr>
+        <p:style>
+          <a:lnRef idx="1">
+            <a:schemeClr val="accent1"/>
+          </a:lnRef>
+          <a:fillRef idx="3">
+            <a:schemeClr val="accent1"/>
+          </a:fillRef>
+          <a:effectRef idx="2">
+            <a:schemeClr val="accent1"/>
+          </a:effectRef>
+          <a:fontRef idx="minor">
+            <a:schemeClr val="lt1"/>
+          </a:fontRef>
+        </p:style>
+        <p:txBody>
+          <a:bodyPr rtlCol="0" anchor="ctr"/>
+          <a:lstStyle/>
+          <a:p>
+            <a:pPr algn="ctr"/>
+          </a:p>
+        </p:txBody>
+      </p:sp>
+      <p:sp>
+        <p:nvSpPr>
+          <p:cNvPr id="5" name="Rectangle 4"/>
+          <p:cNvSpPr/>
+          <p:nvPr/>
+        </p:nvSpPr>
+        <p:spPr>
+          <a:xfrm>
+            <a:off x="365760" y="1170432"/>
+            <a:ext cx="45720" cy="457200"/>
+          </a:xfrm>
+          <a:prstGeom prst="rect">
+            <a:avLst/>
+          </a:prstGeom>
+          <a:solidFill>
+            <a:srgbClr val="00D4D4"/>
+          </a:solidFill>
+          <a:ln>
+            <a:noFill/>
+          </a:ln>
+        </p:spPr>
+        <p:style>
+          <a:lnRef idx="1">
+            <a:schemeClr val="accent1"/>
+          </a:lnRef>
+          <a:fillRef idx="3">
+            <a:schemeClr val="accent1"/>
+          </a:fillRef>
+          <a:effectRef idx="2">
+            <a:schemeClr val="accent1"/>
+          </a:effectRef>
+          <a:fontRef idx="minor">
+            <a:schemeClr val="lt1"/>
+          </a:fontRef>
+        </p:style>
+        <p:txBody>
+          <a:bodyPr rtlCol="0" anchor="ctr"/>
+          <a:lstStyle/>
+          <a:p>
+            <a:pPr algn="ctr"/>
+          </a:p>
+        </p:txBody>
+      </p:sp>
+      <p:sp>
+        <p:nvSpPr>
+          <p:cNvPr id="6" name="TextBox 5"/>
+          <p:cNvSpPr txBox="1"/>
+          <p:nvPr/>
+        </p:nvSpPr>
+        <p:spPr>
+          <a:xfrm>
+            <a:off x="502920" y="1197864"/>
+            <a:ext cx="9144000" cy="182880"/>
+          </a:xfrm>
+          <a:prstGeom prst="rect">
+            <a:avLst/>
+          </a:prstGeom>
+          <a:noFill/>
+        </p:spPr>
+        <p:txBody>
+          <a:bodyPr wrap="square">
+            <a:spAutoFit/>
+          </a:bodyPr>
+          <a:lstStyle/>
+          <a:p>
+            <a:pPr algn="l"/>
+            <a:r>
+              <a:rPr sz="800" b="1" i="0">
+                <a:solidFill>
+                  <a:srgbClr val="3DC570"/>
+                </a:solidFill>
+              </a:rPr>
+              <a:t>ALWAYS ON  ·  ALWAYS CURRENT  ·  ZERO MANUAL UPDATES</a:t>
+            </a:r>
+          </a:p>
+        </p:txBody>
+      </p:sp>
+      <p:sp>
+        <p:nvSpPr>
+          <p:cNvPr id="7" name="TextBox 6"/>
+          <p:cNvSpPr txBox="1"/>
+          <p:nvPr/>
+        </p:nvSpPr>
+        <p:spPr>
+          <a:xfrm>
+            <a:off x="502920" y="1371600"/>
+            <a:ext cx="11155680" cy="219456"/>
+          </a:xfrm>
+          <a:prstGeom prst="rect">
+            <a:avLst/>
+          </a:prstGeom>
+          <a:noFill/>
+        </p:spPr>
+        <p:txBody>
+          <a:bodyPr wrap="square">
+            <a:spAutoFit/>
+          </a:bodyPr>
+          <a:lstStyle/>
+          <a:p>
+            <a:pPr algn="l"/>
+            <a:r>
+              <a:rPr sz="950" b="0" i="0">
+                <a:solidFill>
+                  <a:srgbClr val="FFFFFF"/>
+                </a:solidFill>
+              </a:rPr>
+              <a:t>Every dashboard below pulls live from Salesforce — rebuilt and pushed automatically. No spreadsheets. No manual refresh. No stale data.</a:t>
+            </a:r>
+          </a:p>
+        </p:txBody>
+      </p:sp>
+      <p:sp>
+        <p:nvSpPr>
+          <p:cNvPr id="8" name="TextBox 7"/>
+          <p:cNvSpPr txBox="1"/>
+          <p:nvPr/>
+        </p:nvSpPr>
+        <p:spPr>
+          <a:xfrm>
+            <a:off x="365760" y="1719072"/>
+            <a:ext cx="5577840" cy="256032"/>
+          </a:xfrm>
+          <a:prstGeom prst="rect">
+            <a:avLst/>
+          </a:prstGeom>
+          <a:noFill/>
+        </p:spPr>
+        <p:txBody>
+          <a:bodyPr wrap="square">
+            <a:spAutoFit/>
+          </a:bodyPr>
+          <a:lstStyle/>
+          <a:p>
+            <a:pPr algn="l"/>
+            <a:r>
+              <a:rPr sz="1000" b="1" i="0">
+                <a:solidFill>
+                  <a:srgbClr val="00D4D4"/>
+                </a:solidFill>
+              </a:rPr>
+              <a:t>March 2026 Forecast</a:t>
+            </a:r>
+          </a:p>
+        </p:txBody>
+      </p:sp>
+      <p:pic>
+        <p:nvPicPr>
+          <p:cNvPr id="9" name="Picture 8" descr="ss-forecast.png"/>
+          <p:cNvPicPr>
+            <a:picLocks noChangeAspect="1"/>
+          </p:cNvPicPr>
+          <p:nvPr/>
+        </p:nvPicPr>
+        <p:blipFill>
+          <a:blip r:embed="rId4"/>
+          <a:stretch>
+            <a:fillRect/>
+          </a:stretch>
+        </p:blipFill>
+        <p:spPr>
+          <a:xfrm>
+            <a:off x="365760" y="1975104"/>
+            <a:ext cx="5577840" cy="2331720"/>
+          </a:xfrm>
+          <a:prstGeom prst="rect">
+            <a:avLst/>
+          </a:prstGeom>
+        </p:spPr>
+      </p:pic>
+      <p:sp>
+        <p:nvSpPr>
+          <p:cNvPr id="10" name="TextBox 9"/>
+          <p:cNvSpPr txBox="1"/>
+          <p:nvPr/>
+        </p:nvSpPr>
+        <p:spPr>
+          <a:xfrm>
+            <a:off x="6153912" y="1719072"/>
+            <a:ext cx="5577840" cy="256032"/>
+          </a:xfrm>
+          <a:prstGeom prst="rect">
+            <a:avLst/>
+          </a:prstGeom>
+          <a:noFill/>
+        </p:spPr>
+        <p:txBody>
+          <a:bodyPr wrap="square">
+            <a:spAutoFit/>
+          </a:bodyPr>
+          <a:lstStyle/>
+          <a:p>
+            <a:pPr algn="l"/>
+            <a:r>
+              <a:rPr sz="1000" b="1" i="0">
+                <a:solidFill>
+                  <a:srgbClr val="F87171"/>
+                </a:solidFill>
+              </a:rPr>
+              <a:t>Closed Loss Analysis</a:t>
+            </a:r>
+          </a:p>
+        </p:txBody>
+      </p:sp>
+      <p:pic>
+        <p:nvPicPr>
+          <p:cNvPr id="11" name="Picture 10" descr="ss-closed-loss.png"/>
+          <p:cNvPicPr>
+            <a:picLocks noChangeAspect="1"/>
+          </p:cNvPicPr>
+          <p:nvPr/>
+        </p:nvPicPr>
+        <p:blipFill>
+          <a:blip r:embed="rId5"/>
+          <a:stretch>
+            <a:fillRect/>
+          </a:stretch>
+        </p:blipFill>
+        <p:spPr>
+          <a:xfrm>
+            <a:off x="6153912" y="1975104"/>
+            <a:ext cx="5577840" cy="2331720"/>
+          </a:xfrm>
+          <a:prstGeom prst="rect">
+            <a:avLst/>
+          </a:prstGeom>
+        </p:spPr>
+      </p:pic>
+      <p:sp>
+        <p:nvSpPr>
+          <p:cNvPr id="12" name="TextBox 11"/>
+          <p:cNvSpPr txBox="1"/>
+          <p:nvPr/>
+        </p:nvSpPr>
+        <p:spPr>
+          <a:xfrm>
+            <a:off x="365760" y="4416552"/>
+            <a:ext cx="5577840" cy="256032"/>
+          </a:xfrm>
+          <a:prstGeom prst="rect">
+            <a:avLst/>
+          </a:prstGeom>
+          <a:noFill/>
+        </p:spPr>
+        <p:txBody>
+          <a:bodyPr wrap="square">
+            <a:spAutoFit/>
+          </a:bodyPr>
+          <a:lstStyle/>
+          <a:p>
+            <a:pPr algn="l"/>
+            <a:r>
+              <a:rPr sz="1000" b="1" i="0">
+                <a:solidFill>
+                  <a:srgbClr val="3DC570"/>
+                </a:solidFill>
+              </a:rPr>
+              <a:t>AE Capacity — Prospect Meetings</a:t>
+            </a:r>
+          </a:p>
+        </p:txBody>
+      </p:sp>
+      <p:pic>
+        <p:nvPicPr>
+          <p:cNvPr id="13" name="Picture 12" descr="ss-ae-capacity.png"/>
+          <p:cNvPicPr>
+            <a:picLocks noChangeAspect="1"/>
+          </p:cNvPicPr>
+          <p:nvPr/>
+        </p:nvPicPr>
+        <p:blipFill>
+          <a:blip r:embed="rId6"/>
+          <a:stretch>
+            <a:fillRect/>
+          </a:stretch>
+        </p:blipFill>
+        <p:spPr>
+          <a:xfrm>
+            <a:off x="365760" y="4672584"/>
+            <a:ext cx="5577840" cy="2331720"/>
+          </a:xfrm>
+          <a:prstGeom prst="rect">
+            <a:avLst/>
+          </a:prstGeom>
+        </p:spPr>
+      </p:pic>
+      <p:sp>
+        <p:nvSpPr>
+          <p:cNvPr id="14" name="TextBox 13"/>
+          <p:cNvSpPr txBox="1"/>
+          <p:nvPr/>
+        </p:nvSpPr>
+        <p:spPr>
+          <a:xfrm>
+            <a:off x="6153912" y="4416552"/>
+            <a:ext cx="5577840" cy="256032"/>
+          </a:xfrm>
+          <a:prstGeom prst="rect">
+            <a:avLst/>
+          </a:prstGeom>
+          <a:noFill/>
+        </p:spPr>
+        <p:txBody>
+          <a:bodyPr wrap="square">
+            <a:spAutoFit/>
+          </a:bodyPr>
+          <a:lstStyle/>
+          <a:p>
+            <a:pPr algn="l"/>
+            <a:r>
+              <a:rPr sz="1000" b="1" i="0">
+                <a:solidFill>
+                  <a:srgbClr val="7C3AED"/>
+                </a:solidFill>
+              </a:rPr>
+              <a:t>MSP PSA Requirements</a:t>
+            </a:r>
+          </a:p>
+        </p:txBody>
+      </p:sp>
+      <p:pic>
+        <p:nvPicPr>
+          <p:cNvPr id="15" name="Picture 14" descr="ss-msp-psa.png"/>
+          <p:cNvPicPr>
+            <a:picLocks noChangeAspect="1"/>
+          </p:cNvPicPr>
+          <p:nvPr/>
+        </p:nvPicPr>
+        <p:blipFill>
+          <a:blip r:embed="rId7"/>
+          <a:stretch>
+            <a:fillRect/>
+          </a:stretch>
+        </p:blipFill>
+        <p:spPr>
+          <a:xfrm>
+            <a:off x="6153912" y="4672584"/>
+            <a:ext cx="5577840" cy="2331720"/>
+          </a:xfrm>
+          <a:prstGeom prst="rect">
+            <a:avLst/>
+          </a:prstGeom>
+        </p:spPr>
+      </p:pic>
+      <p:sp>
+        <p:nvSpPr>
+          <p:cNvPr id="16" name="Rectangle 15"/>
+          <p:cNvSpPr/>
+          <p:nvPr/>
+        </p:nvSpPr>
+        <p:spPr>
+          <a:xfrm>
+            <a:off x="0" y="6675120"/>
+            <a:ext cx="12188952" cy="182880"/>
+          </a:xfrm>
+          <a:prstGeom prst="rect">
+            <a:avLst/>
+          </a:prstGeom>
+          <a:solidFill>
+            <a:srgbClr val="071220"/>
+          </a:solidFill>
+          <a:ln>
+            <a:noFill/>
+          </a:ln>
+        </p:spPr>
+        <p:style>
+          <a:lnRef idx="1">
+            <a:schemeClr val="accent1"/>
+          </a:lnRef>
+          <a:fillRef idx="3">
+            <a:schemeClr val="accent1"/>
+          </a:fillRef>
+          <a:effectRef idx="2">
+            <a:schemeClr val="accent1"/>
+          </a:effectRef>
+          <a:fontRef idx="minor">
+            <a:schemeClr val="lt1"/>
+          </a:fontRef>
+        </p:style>
+        <p:txBody>
+          <a:bodyPr rtlCol="0" anchor="ctr"/>
+          <a:lstStyle/>
+          <a:p>
+            <a:pPr algn="ctr"/>
+          </a:p>
+        </p:txBody>
+      </p:sp>
+      <p:sp>
+        <p:nvSpPr>
+          <p:cNvPr id="17" name="TextBox 16"/>
+          <p:cNvSpPr txBox="1"/>
+          <p:nvPr/>
+        </p:nvSpPr>
+        <p:spPr>
+          <a:xfrm>
+            <a:off x="274320" y="6693408"/>
+            <a:ext cx="1828800" cy="146304"/>
+          </a:xfrm>
+          <a:prstGeom prst="rect">
+            <a:avLst/>
+          </a:prstGeom>
+          <a:noFill/>
+        </p:spPr>
+        <p:txBody>
+          <a:bodyPr wrap="square">
+            <a:spAutoFit/>
+          </a:bodyPr>
+          <a:lstStyle/>
+          <a:p>
+            <a:pPr algn="l"/>
+            <a:r>
+              <a:rPr sz="900" b="1" i="0">
+                <a:solidFill>
+                  <a:srgbClr val="FFFFFF"/>
+                </a:solidFill>
+              </a:rPr>
+              <a:t>• rev.io</a:t>
+            </a:r>
+          </a:p>
+        </p:txBody>
+      </p:sp>
+      <p:sp>
+        <p:nvSpPr>
+          <p:cNvPr id="18" name="TextBox 17"/>
+          <p:cNvSpPr txBox="1"/>
+          <p:nvPr/>
+        </p:nvSpPr>
+        <p:spPr>
+          <a:xfrm>
+            <a:off x="8686800" y="6693408"/>
+            <a:ext cx="2011680" cy="146304"/>
+          </a:xfrm>
+          <a:prstGeom prst="rect">
+            <a:avLst/>
+          </a:prstGeom>
+          <a:noFill/>
+        </p:spPr>
+        <p:txBody>
+          <a:bodyPr wrap="square">
+            <a:spAutoFit/>
+          </a:bodyPr>
+          <a:lstStyle/>
+          <a:p>
+            <a:pPr algn="r"/>
+            <a:r>
+              <a:rPr sz="900" b="1" i="0">
+                <a:solidFill>
+                  <a:srgbClr val="FFFFFF"/>
+                </a:solidFill>
+              </a:rPr>
+              <a:t>BUILT FOR TOMORROW.</a:t>
+            </a:r>
+          </a:p>
+        </p:txBody>
+      </p:sp>
+      <p:sp>
+        <p:nvSpPr>
+          <p:cNvPr id="19" name="TextBox 18"/>
           <p:cNvSpPr txBox="1"/>
           <p:nvPr/>
         </p:nvSpPr>

</xml_diff>

<commit_message>
Slide 1: remove Brent/Evan ref and weather, add Discord team access bullet
</commit_message>
<xml_diff>
--- a/Robin-Intro-Slide.pptx
+++ b/Robin-Intro-Slide.pptx
@@ -5342,7 +5342,7 @@
                   <a:srgbClr val="FFFFFF"/>
                 </a:solidFill>
               </a:rPr>
-              <a:t>· Weekly forecast emails to Evan &amp; Brent every Monday</a:t>
+              <a:t>· Automated weekly forecast report delivered to ELT every Monday</a:t>
             </a:r>
           </a:p>
         </p:txBody>
@@ -5580,7 +5580,7 @@
                   <a:srgbClr val="FFFFFF"/>
                 </a:solidFill>
               </a:rPr>
-              <a:t>· Morning briefings Mon–Fri — schedule + weather</a:t>
+              <a:t>· Real-time access on Discord — available to the entire sales team 24/7</a:t>
             </a:r>
           </a:p>
         </p:txBody>

</xml_diff>